<commit_message>
docs(ppt): clean up roadmap timeline (fix overflow + misaligned labels)
Rebuild the P0-P7 timeline SVG: fix the stage description text that
overflowed its card and remove the hardcoded '交付' labels that were
misaligned with the nodes. Correct P1 table count to 21 (was '15+').
</commit_message>
<xml_diff>
--- a/ppt/AI物业社区智能体方案/AI物业社区智能体-方案.pptx
+++ b/ppt/AI物业社区智能体方案/AI物业社区智能体-方案.pptx
@@ -6623,7 +6623,7 @@
   <p:cSld>
     <p:spTree>
       <p:nvGrpSpPr>
-        <p:cNvPr id="133" name="" descr="&lt;Slide style={{ width: '1280px', height: '720px', background: '#FBFCFA', position: 'relative', padding: '34px 64px', boxSizing: 'border-box', display: 'flex', flexDirection: 'column' }}&gt;&#10;  &lt;div style={{ flexShrink: 0 }}&gt;&#10;    &lt;div style={{ color: '#BD9B56', fontSize: 13, letterSpacing: '0.25em', marginBottom: 6 }}&gt;04 · 总结与展望&lt;/div&gt;&#10;    &lt;h2 style={{ fontSize: 30, fontWeight: 'bold', color: '#172133', margin: 0, lineHeight: 1.3 }}&gt;技术路线回顾：七个阶段 · 从 0 到上线&lt;/h2&gt;&#10;    &lt;div style={{ fontSize: 14, color: '#6b7075', marginTop: 6 }}&gt;每个阶段都有代码、测试、可运行交付，循序渐进验证&lt;/div&gt;&#10;  &lt;/div&gt;&#10;  &lt;div style={{ flex: 1, display: 'flex', alignItems: 'center', justifyContent: 'center' }}&gt;&#10;    &lt;div style={{ width: '100%', background: '#fff', borderRadius: 12, padding: '28px 30px', boxShadow: '0 6px 24px rgba(23,33,51,0.08)' }}&gt;&#10;      &lt;svg width=&quot;1090&quot; height=&quot;330&quot; viewBox=&quot;0 0 1090 330&quot;&gt;&#10;        &lt;g fontFamily=&quot;Inter, sans-serif&quot;&gt;&#10;          &lt;line x1=&quot;55&quot; y1=&quot;50&quot; x2=&quot;1045&quot; y2=&quot;50&quot; stroke=&quot;#22395E&quot; strokeWidth=&quot;2.5&quot; /&gt;&#10;          {[&#10;            ['P0', '项目初始化', '仓库 · Docker · CI'],&#10;            ['P1', '数据库', '15+ 表 + 仿真数据'],&#10;            ['P2', '后端', 'FastAPI 分层'],&#10;            ['P3', '前端', '三端 + PWA'],&#10;            ['P4', 'AI Agent', '多意图 + 状态机'],&#10;            ['P5', 'RAG', '向量化检索'],&#10;            ['P6', '评估', 'Intent/Tool/RAG'],&#10;            ['P7', '部署', '已上线'],&#10;          ].map(([p, t, d], i) =&gt; (&#10;            &lt;g key={p}&gt;&#10;              &lt;circle cx={55 + i * 140} cy={50} r=&quot;10&quot; fill=&quot;#BD9B56&quot; /&gt;&#10;              &lt;text x={55 + i * 140} y={22} textAnchor=&quot;middle&quot; fontSize=&quot;13&quot; fontWeight=&quot;bold&quot; fill=&quot;#BD9B56&quot;&gt;{p}&lt;/text&gt;&#10;              &lt;rect x={55 + i * 140 - 58} y={80} width=&quot;116&quot; height=&quot;56&quot; rx=&quot;8&quot; fill=&quot;rgba(34,57,94,0.06)&quot; stroke=&quot;#22395E&quot; strokeWidth=&quot;1.5&quot; /&gt;&#10;              &lt;text x={55 + i * 140} y={112} textAnchor=&quot;middle&quot; fontSize=&quot;14&quot; fontWeight=&quot;bold&quot; fill=&quot;#172133&quot;&gt;{t}&lt;/text&gt;&#10;              &lt;text x={55 + i * 140} y={150} textAnchor=&quot;middle&quot; fontSize=&quot;11&quot; fill=&quot;#5F5E5A&quot;&gt;{d}&lt;/text&gt;&#10;            &lt;/g&gt;&#10;          ))}&#10;          &lt;text x=&quot;55&quot; y=&quot;220&quot; fontSize=&quot;12&quot; fill=&quot;#5F5E5A&quot;&gt;交付：可运行骨架&lt;/text&gt;&#10;          &lt;text x=&quot;195&quot; y=&quot;220&quot; fontSize=&quot;12&quot; fill=&quot;#5F5E5A&quot;&gt;交付：数据就绪&lt;/text&gt;&#10;          &lt;text x=&quot;335&quot; y=&quot;220&quot; fontSize=&quot;12&quot; fill=&quot;#5F5E5A&quot;&gt;交付：API 可调用&lt;/text&gt;&#10;          &lt;text x=&quot;475&quot; y=&quot;220&quot; fontSize=&quot;12&quot; fill=&quot;#5F5E5A&quot;&gt;交付：三端成型&lt;/text&gt;&#10;          &lt;text x=&quot;615&quot; y=&quot;220&quot; fontSize=&quot;12&quot; fill=&quot;#5F5E5A&quot;&gt;交付：自然语言办事&lt;/text&gt;&#10;          &lt;text x=&quot;755&quot; y=&quot;220&quot; fontSize=&quot;12&quot; fill=&quot;#5F5E5A&quot;&gt;交付：知识问答&lt;/text&gt;&#10;          &lt;text x=&quot;895&quot; y=&quot;220&quot; fontSize=&quot;12&quot; fill=&quot;#5F5E5A&quot;&gt;交付：评估报告&lt;/text&gt;&#10;          &lt;text x=&quot;1035&quot; y=&quot;220&quot; fontSize=&quot;12&quot; fill=&quot;#5F5E5A&quot;&gt;交付：线上运行&lt;/text&gt;&#10;        &lt;/g&gt;&#10;      &lt;/svg&gt;&#10;      &lt;div style={{ marginTop: 14, display: 'flex', gap: 14 }}&gt;&#10;        &lt;div style={{ flex: 1, background: 'rgba(189,155,86,0.08)', borderRadius: 8, padding: '12px 14px' }}&gt;&#10;          &lt;div style={{ fontSize: 13, color: '#BD9B56', fontWeight: 'bold', marginBottom: 5 }}&gt;P1 数据一致性&lt;/div&gt;&#10;          &lt;p style={{ fontSize: 12, color: '#5F5E5A', margin: 0, lineHeight: 1.5 }}&gt;1664 套房源 + 746 账单，外键关联保证数据一致，8 个 SQL 可复现&lt;/p&gt;&#10;        &lt;/div&gt;&#10;        &lt;div style={{ flex: 1, background: 'rgba(189,155,86,0.08)', borderRadius: 8, padding: '12px 14px' }}&gt;&#10;          &lt;div style={{ fontSize: 13, color: '#BD9B56', fontWeight: 'bold', marginBottom: 5 }}&gt;P4 多轮状态机&lt;/div&gt;&#10;          &lt;p style={{ fontSize: 12, color: '#5F5E5A', margin: 0, lineHeight: 1.5 }}&gt;报修主动追问缺省字段，避免生成残缺工单&lt;/p&gt;&#10;        &lt;/div&gt;&#10;        &lt;div style={{ flex: 1, background: 'rgba(189,155,86,0.08)', borderRadius: 8, padding: '12px 14px' }}&gt;&#10;          &lt;div style={{ fontSize: 13, color: '#BD9B56', fontWeight: 'bold', marginBottom: 5 }}&gt;P6 评估找 bug&lt;/div&gt;&#10;          &lt;p style={{ fontSize: 12, color: '#5F5E5A', margin: 0, lineHeight: 1.5 }}&gt;意图 83%→100%、答案 50%→100%，数据驱动优化&lt;/p&gt;&#10;        &lt;/div&gt;&#10;        &lt;div style={{ flex: 1, background: 'rgba(189,155,86,0.08)', borderRadius: 8, padding: '12px 14px' }}&gt;&#10;          &lt;div style={{ fontSize: 13, color: '#BD9B56', fontWeight: 'bold', marginBottom: 5 }}&gt;P7 部署踩坑&lt;/div&gt;&#10;          &lt;p style={{ fontSize: 12, color: '#5F5E5A', margin: 0, lineHeight: 1.5 }}&gt;国内镜像源、SECRET_KEY、端口映射逐一踩平&lt;/p&gt;&#10;        &lt;/div&gt;&#10;      &lt;/div&gt;&#10;    &lt;/div&gt;&#10;  &lt;/div&gt;&#10;  &lt;div style={{ flexShrink: 0, height: 40, display: 'flex', alignItems: 'flex-end', justifyContent: 'space-between' }}&gt;&#10;    &lt;span style={{ color: '#BD9B56', fontSize: 12, letterSpacing: '0.1em' }}&gt;云溪花园 · 智慧社区&lt;/span&gt;&#10;    &lt;span style={{ color: '#a09b8c', fontSize: 12 }}&gt;13 / 15&lt;/span&gt;&#10;  &lt;/div&gt;&#10;&lt;/Slide&gt;"/>
+        <p:cNvPr id="133" name="" descr="&lt;Slide style={{ width: '1280px', height: '720px', background: '#FBFCFA', position: 'relative', padding: '36px 64px', boxSizing: 'border-box', display: 'flex', flexDirection: 'column' }}&gt;&#10;  &lt;div style={{ flexShrink: 0 }}&gt;&#10;    &lt;div style={{ color: '#BD9B56', fontSize: 13, letterSpacing: '0.25em', marginBottom: 6 }}&gt;04 · 总结与展望&lt;/div&gt;&#10;    &lt;h2 style={{ fontSize: 30, fontWeight: 'bold', color: '#172133', margin: 0, lineHeight: 1.3 }}&gt;技术路线回顾：八个阶段 · 从 0 到上线&lt;/h2&gt;&#10;    &lt;div style={{ fontSize: 14, color: '#6b7075', marginTop: 6 }}&gt;每个阶段都有代码、测试、可运行交付，循序渐进验证&lt;/div&gt;&#10;  &lt;/div&gt;&#10;  &lt;div style={{ flex: 1, display: 'flex', alignItems: 'center', justifyContent: 'center' }}&gt;&#10;    &lt;div style={{ width: '100%', background: '#fff', borderRadius: 12, padding: '30px 26px', boxShadow: '0 6px 24px rgba(23,33,51,0.08)' }}&gt;&#10;      &lt;svg width=&quot;1100&quot; height=&quot;300&quot; viewBox=&quot;0 0 1100 300&quot;&gt;&#10;        &lt;g fontFamily=&quot;Inter, sans-serif&quot;&gt;&#10;          {/* 主时间轴 */}&#10;          &lt;line x1=&quot;60&quot; y1=&quot;70&quot; x2=&quot;1060&quot; y2=&quot;70&quot; stroke=&quot;#22395E&quot; strokeWidth=&quot;2.5&quot; /&gt;&#10;          {[&#10;            ['P0', '项目初始化', '仓库 · Docker · CI'],&#10;            ['P1', '数据库', '21 表 + 仿真数据'],&#10;            ['P2', '后端', 'FastAPI 三层'],&#10;            ['P3', '前端', '三端 + PWA'],&#10;            ['P4', 'AI Agent', '多意图 + 状态机'],&#10;            ['P5', 'RAG', '向量化检索'],&#10;            ['P6', '评估', 'Intent/Tool/RAG'],&#10;            ['P7', '部署', '已上线'],&#10;          ].map(([p, t, d], i) =&gt; {&#10;            const cx = 60 + i * 143&#10;            return (&#10;              &lt;g key={p}&gt;&#10;                {/* 节点圆 */}&#10;                &lt;circle cx={cx} cy={70} r=&quot;9&quot; fill=&quot;#BD9B56&quot; /&gt;&#10;                &lt;circle cx={cx} cy={70} r=&quot;14&quot; fill=&quot;none&quot; stroke=&quot;#BD9B56&quot; strokeWidth=&quot;1.5&quot; strokeOpacity=&quot;0.35&quot; /&gt;&#10;                {/* 阶段标签 */}&#10;                &lt;text x={cx} y={46} textAnchor=&quot;middle&quot; fontSize=&quot;13&quot; fontWeight=&quot;bold&quot; fill=&quot;#BD9B56&quot;&gt;{p}&lt;/text&gt;&#10;                {/* 阶段名 */}&#10;                &lt;text x={cx} y={112} textAnchor=&quot;middle&quot; fontSize=&quot;15&quot; fontWeight=&quot;bold&quot; fill=&quot;#172133&quot;&gt;{t}&lt;/text&gt;&#10;                {/* 描述 */}&#10;                &lt;text x={cx} y={134} textAnchor=&quot;middle&quot; fontSize=&quot;11.5&quot; fill=&quot;#5F5E5A&quot;&gt;{d}&lt;/text&gt;&#10;                {/* 下方小圆点连接 */}&#10;                &lt;line x1={cx} y1={79} x2={cx} y2={100} stroke=&quot;#BD9B56&quot; strokeWidth=&quot;1.5&quot; strokeOpacity=&quot;0.5&quot; /&gt;&#10;              &lt;/g&gt;&#10;            )&#10;          })}&#10;        &lt;/g&gt;&#10;      &lt;/svg&gt;&#10;      &lt;div style={{ marginTop: 16, display: 'flex', gap: 14 }}&gt;&#10;        &lt;div style={{ flex: 1, background: 'rgba(189,155,86,0.08)', borderRadius: 8, padding: '12px 14px', borderLeft: '3px solid #BD9B56' }}&gt;&#10;          &lt;div style={{ fontSize: 13, color: '#BD9B56', fontWeight: 'bold', marginBottom: 5 }}&gt;P1 · 数据一致性&lt;/div&gt;&#10;          &lt;p style={{ fontSize: 12, color: '#5F5E5A', margin: 0, lineHeight: 1.5 }}&gt;8 栋 / 1664 套 / 746 账单，外键关联保证一致，8 个 SQL 可复现&lt;/p&gt;&#10;        &lt;/div&gt;&#10;        &lt;div style={{ flex: 1, background: 'rgba(189,155,86,0.08)', borderRadius: 8, padding: '12px 14px', borderLeft: '3px solid #BD9B56' }}&gt;&#10;          &lt;div style={{ fontSize: 13, color: '#BD9B56', fontWeight: 'bold', marginBottom: 5 }}&gt;P4 · 多轮状态机&lt;/div&gt;&#10;          &lt;p style={{ fontSize: 12, color: '#5F5E5A', margin: 0, lineHeight: 1.5 }}&gt;报修主动追问缺省字段，避免生成残缺工单&lt;/p&gt;&#10;        &lt;/div&gt;&#10;        &lt;div style={{ flex: 1, background: 'rgba(189,155,86,0.08)', borderRadius: 8, padding: '12px 14px', borderLeft: '3px solid #BD9B56' }}&gt;&#10;          &lt;div style={{ fontSize: 13, color: '#BD9B56', fontWeight: 'bold', marginBottom: 5 }}&gt;P6 · 评估找 bug&lt;/div&gt;&#10;          &lt;p style={{ fontSize: 12, color: '#5F5E5A', margin: 0, lineHeight: 1.5 }}&gt;意图 83.33%→100%、答案 50%→100%，数据驱动优化&lt;/p&gt;&#10;        &lt;/div&gt;&#10;        &lt;div style={{ flex: 1, background: 'rgba(189,155,86,0.08)', borderRadius: 8, padding: '12px 14px', borderLeft: '3px solid #BD9B56' }}&gt;&#10;          &lt;div style={{ fontSize: 13, color: '#BD9B56', fontWeight: 'bold', marginBottom: 5 }}&gt;P7 · 部署踩坑&lt;/div&gt;&#10;          &lt;p style={{ fontSize: 12, color: '#5F5E5A', margin: 0, lineHeight: 1.5 }}&gt;国内镜像源、SECRET_KEY、端口映射逐一踩平&lt;/p&gt;&#10;        &lt;/div&gt;&#10;      &lt;/div&gt;&#10;    &lt;/div&gt;&#10;  &lt;/div&gt;&#10;  &lt;div style={{ flexShrink: 0, height: 40, display: 'flex', alignItems: 'flex-end', justifyContent: 'space-between' }}&gt;&#10;    &lt;span style={{ color: '#BD9B56', fontSize: 12, letterSpacing: '0.1em' }}&gt;云溪花园 · 智慧社区&lt;/span&gt;&#10;    &lt;span style={{ color: '#a09b8c', fontSize: 12 }}&gt;13 / 15&lt;/span&gt;&#10;  &lt;/div&gt;&#10;&lt;/Slide&gt;"/>
         <p:cNvGrpSpPr/>
         <p:nvPr/>
       </p:nvGrpSpPr>
@@ -6667,7 +6667,7 @@
         </p:nvSpPr>
         <p:spPr>
           <a:xfrm rot="0" flipH="0" flipV="0">
-            <a:off x="609600" y="323850"/>
+            <a:off x="609600" y="342900"/>
             <a:ext cx="10972800" cy="152400"/>
           </a:xfrm>
           <a:prstGeom prst="rect"/>
@@ -6712,7 +6712,7 @@
         </p:nvSpPr>
         <p:spPr>
           <a:xfrm rot="0" flipH="0" flipV="0">
-            <a:off x="609600" y="533400"/>
+            <a:off x="609600" y="552450"/>
             <a:ext cx="10972800" cy="447675"/>
           </a:xfrm>
           <a:prstGeom prst="rect"/>
@@ -6733,7 +6733,7 @@
                 <a:latin typeface="Microsoft YaHei"/>
                 <a:ea typeface="Microsoft YaHei"/>
               </a:rPr>
-              <a:t>技术路线回顾：七个阶段</a:t>
+              <a:t>技术路线回顾：八个阶段</a:t>
             </a:r>
             <a:r>
               <a:rPr lang="en-US" sz="2250" b="1">
@@ -6787,7 +6787,7 @@
         </p:nvSpPr>
         <p:spPr>
           <a:xfrm rot="0" flipH="0" flipV="0">
-            <a:off x="609600" y="1038225"/>
+            <a:off x="609600" y="1057275"/>
             <a:ext cx="10972800" cy="161925"/>
           </a:xfrm>
           <a:prstGeom prst="rect"/>
@@ -6822,12 +6822,12 @@
         </p:nvSpPr>
         <p:spPr>
           <a:xfrm rot="0" flipH="0" flipV="0">
-            <a:off x="609600" y="1352550"/>
-            <a:ext cx="10972800" cy="4657725"/>
+            <a:off x="609600" y="1466850"/>
+            <a:ext cx="10972800" cy="4429125"/>
           </a:xfrm>
           <a:prstGeom prst="roundRect">
             <a:avLst>
-              <a:gd name="adj" fmla="val 2454"/>
+              <a:gd name="adj" fmla="val 2581"/>
             </a:avLst>
           </a:prstGeom>
           <a:solidFill>
@@ -6869,8 +6869,8 @@
         </p:blipFill>
         <p:spPr>
           <a:xfrm rot="0" flipH="0" flipV="0">
-            <a:off x="895350" y="1619250"/>
-            <a:ext cx="10382250" cy="3143250"/>
+            <a:off x="857250" y="1752600"/>
+            <a:ext cx="10477500" cy="2857500"/>
           </a:xfrm>
           <a:prstGeom prst="rect">
             <a:avLst/>
@@ -6886,8 +6886,8 @@
         </p:nvSpPr>
         <p:spPr>
           <a:xfrm rot="0" flipH="0" flipV="0">
-            <a:off x="895350" y="4895850"/>
-            <a:ext cx="2505075" cy="847725"/>
+            <a:off x="885825" y="4762500"/>
+            <a:ext cx="2524125" cy="847725"/>
           </a:xfrm>
           <a:prstGeom prst="roundRect">
             <a:avLst>
@@ -6908,14 +6908,71 @@
       </p:sp>
       <p:sp>
         <p:nvSpPr>
-          <p:cNvPr id="141" name="" descr="{&quot;isTemplate&quot;:true,&quot;type&quot;:&quot;text&quot;}"/>
-          <p:cNvSpPr txBox="1"/>
-          <p:nvPr/>
-        </p:nvSpPr>
-        <p:spPr>
-          <a:xfrm rot="0" flipH="0" flipV="0">
-            <a:off x="1028700" y="5010150"/>
-            <a:ext cx="2238375" cy="152400"/>
+          <p:cNvPr id="141" name=""/>
+          <p:cNvSpPr/>
+          <p:nvPr/>
+        </p:nvSpPr>
+        <p:spPr>
+          <a:xfrm rot="0" flipH="0" flipV="0">
+            <a:off x="885825" y="4762500"/>
+            <a:ext cx="2524125" cy="847725"/>
+          </a:xfrm>
+          <a:custGeom>
+            <a:pathLst>
+              <a:path w="265" h="89">
+                <a:moveTo>
+                  <a:pt x="8" y="0"/>
+                </a:moveTo>
+                <a:cubicBezTo>
+                  <a:pt x="5" y="0"/>
+                  <a:pt x="3" y="2"/>
+                  <a:pt x="3" y="5"/>
+                </a:cubicBezTo>
+                <a:lnTo>
+                  <a:pt x="3" y="84"/>
+                </a:lnTo>
+                <a:cubicBezTo>
+                  <a:pt x="3" y="86"/>
+                  <a:pt x="5" y="88"/>
+                  <a:pt x="7" y="89"/>
+                </a:cubicBezTo>
+                <a:cubicBezTo>
+                  <a:pt x="3" y="88"/>
+                  <a:pt x="0" y="85"/>
+                  <a:pt x="0" y="81"/>
+                </a:cubicBezTo>
+                <a:lnTo>
+                  <a:pt x="0" y="8"/>
+                </a:lnTo>
+                <a:cubicBezTo>
+                  <a:pt x="0" y="4"/>
+                  <a:pt x="3" y="0"/>
+                  <a:pt x="8" y="0"/>
+                </a:cubicBezTo>
+                <a:close/>
+              </a:path>
+            </a:pathLst>
+          </a:custGeom>
+          <a:solidFill>
+            <a:srgbClr val="BD9B56"/>
+          </a:solidFill>
+          <a:ln/>
+        </p:spPr>
+        <p:txBody>
+          <a:bodyPr/>
+          <a:p/>
+        </p:txBody>
+      </p:sp>
+      <p:sp>
+        <p:nvSpPr>
+          <p:cNvPr id="142" name="" descr="{&quot;isTemplate&quot;:true,&quot;type&quot;:&quot;text&quot;}"/>
+          <p:cNvSpPr txBox="1"/>
+          <p:nvPr/>
+        </p:nvSpPr>
+        <p:spPr>
+          <a:xfrm rot="0" flipH="0" flipV="0">
+            <a:off x="1019175" y="4876800"/>
+            <a:ext cx="2228850" cy="152400"/>
           </a:xfrm>
           <a:prstGeom prst="rect"/>
         </p:spPr>
@@ -6935,7 +6992,7 @@
                 <a:latin typeface="Microsoft YaHei"/>
                 <a:ea typeface="Microsoft YaHei"/>
               </a:rPr>
-              <a:t>P1 </a:t>
+              <a:t>P1 · </a:t>
             </a:r>
             <a:r>
               <a:rPr lang="zh-CN" sz="975">
@@ -6953,14 +7010,14 @@
       </p:sp>
       <p:sp>
         <p:nvSpPr>
-          <p:cNvPr id="142" name="" descr="{&quot;isTemplate&quot;:true,&quot;type&quot;:&quot;text&quot;}"/>
-          <p:cNvSpPr txBox="1"/>
-          <p:nvPr/>
-        </p:nvSpPr>
-        <p:spPr>
-          <a:xfrm rot="0" flipH="0" flipV="0">
-            <a:off x="1028700" y="5210175"/>
-            <a:ext cx="2238375" cy="419100"/>
+          <p:cNvPr id="143" name="" descr="{&quot;isTemplate&quot;:true,&quot;type&quot;:&quot;text&quot;}"/>
+          <p:cNvSpPr txBox="1"/>
+          <p:nvPr/>
+        </p:nvSpPr>
+        <p:spPr>
+          <a:xfrm rot="0" flipH="0" flipV="0">
+            <a:off x="1019175" y="5076825"/>
+            <a:ext cx="2228850" cy="419100"/>
           </a:xfrm>
           <a:prstGeom prst="rect"/>
         </p:spPr>
@@ -6982,7 +7039,7 @@
                 <a:latin typeface="Microsoft YaHei"/>
                 <a:ea typeface="Microsoft YaHei"/>
               </a:rPr>
-              <a:t>1664 </a:t>
+              <a:t>8 </a:t>
             </a:r>
             <a:r>
               <a:rPr lang="zh-CN" sz="900">
@@ -6992,7 +7049,7 @@
                 <a:latin typeface="Microsoft YaHei"/>
                 <a:ea typeface="Microsoft YaHei"/>
               </a:rPr>
-              <a:t>套房源</a:t>
+              <a:t>栋</a:t>
             </a:r>
             <a:r>
               <a:rPr lang="en-US" sz="900">
@@ -7002,7 +7059,7 @@
                 <a:latin typeface="Microsoft YaHei"/>
                 <a:ea typeface="Microsoft YaHei"/>
               </a:rPr>
-              <a:t> + 746 </a:t>
+              <a:t> / 1664 </a:t>
             </a:r>
             <a:r>
               <a:rPr lang="zh-CN" sz="900">
@@ -7012,7 +7069,7 @@
                 <a:latin typeface="Microsoft YaHei"/>
                 <a:ea typeface="Microsoft YaHei"/>
               </a:rPr>
-              <a:t>账单，外键关联保证数据一致，</a:t>
+              <a:t>套</a:t>
             </a:r>
             <a:r>
               <a:rPr lang="en-US" sz="900">
@@ -7022,6 +7079,26 @@
                 <a:latin typeface="Microsoft YaHei"/>
                 <a:ea typeface="Microsoft YaHei"/>
               </a:rPr>
+              <a:t> / 746 </a:t>
+            </a:r>
+            <a:r>
+              <a:rPr lang="zh-CN" sz="900">
+                <a:solidFill>
+                  <a:srgbClr val="5F5E5A"/>
+                </a:solidFill>
+                <a:latin typeface="Microsoft YaHei"/>
+                <a:ea typeface="Microsoft YaHei"/>
+              </a:rPr>
+              <a:t>账单，外键关联保证一致，</a:t>
+            </a:r>
+            <a:r>
+              <a:rPr lang="en-US" sz="900">
+                <a:solidFill>
+                  <a:srgbClr val="5F5E5A"/>
+                </a:solidFill>
+                <a:latin typeface="Microsoft YaHei"/>
+                <a:ea typeface="Microsoft YaHei"/>
+              </a:rPr>
               <a:t>8 </a:t>
             </a:r>
             <a:r>
@@ -7060,14 +7137,14 @@
       </p:sp>
       <p:sp>
         <p:nvSpPr>
-          <p:cNvPr id="143" name=""/>
+          <p:cNvPr id="144" name=""/>
           <p:cNvSpPr/>
           <p:nvPr/>
         </p:nvSpPr>
         <p:spPr>
           <a:xfrm rot="0" flipH="0" flipV="0">
-            <a:off x="3533775" y="4895850"/>
-            <a:ext cx="2495550" cy="847725"/>
+            <a:off x="3543300" y="4762500"/>
+            <a:ext cx="2514600" cy="847725"/>
           </a:xfrm>
           <a:prstGeom prst="roundRect">
             <a:avLst>
@@ -7088,14 +7165,71 @@
       </p:sp>
       <p:sp>
         <p:nvSpPr>
-          <p:cNvPr id="144" name="" descr="{&quot;isTemplate&quot;:true,&quot;type&quot;:&quot;text&quot;}"/>
-          <p:cNvSpPr txBox="1"/>
-          <p:nvPr/>
-        </p:nvSpPr>
-        <p:spPr>
-          <a:xfrm rot="0" flipH="0" flipV="0">
-            <a:off x="3667125" y="5010150"/>
-            <a:ext cx="2228850" cy="152400"/>
+          <p:cNvPr id="145" name=""/>
+          <p:cNvSpPr/>
+          <p:nvPr/>
+        </p:nvSpPr>
+        <p:spPr>
+          <a:xfrm rot="0" flipH="0" flipV="0">
+            <a:off x="3543300" y="4762500"/>
+            <a:ext cx="2514600" cy="847725"/>
+          </a:xfrm>
+          <a:custGeom>
+            <a:pathLst>
+              <a:path w="264" h="89">
+                <a:moveTo>
+                  <a:pt x="8" y="0"/>
+                </a:moveTo>
+                <a:cubicBezTo>
+                  <a:pt x="5" y="0"/>
+                  <a:pt x="3" y="2"/>
+                  <a:pt x="3" y="5"/>
+                </a:cubicBezTo>
+                <a:lnTo>
+                  <a:pt x="3" y="84"/>
+                </a:lnTo>
+                <a:cubicBezTo>
+                  <a:pt x="3" y="86"/>
+                  <a:pt x="5" y="88"/>
+                  <a:pt x="7" y="89"/>
+                </a:cubicBezTo>
+                <a:cubicBezTo>
+                  <a:pt x="3" y="88"/>
+                  <a:pt x="0" y="85"/>
+                  <a:pt x="0" y="81"/>
+                </a:cubicBezTo>
+                <a:lnTo>
+                  <a:pt x="0" y="8"/>
+                </a:lnTo>
+                <a:cubicBezTo>
+                  <a:pt x="0" y="4"/>
+                  <a:pt x="3" y="0"/>
+                  <a:pt x="8" y="0"/>
+                </a:cubicBezTo>
+                <a:close/>
+              </a:path>
+            </a:pathLst>
+          </a:custGeom>
+          <a:solidFill>
+            <a:srgbClr val="BD9B56"/>
+          </a:solidFill>
+          <a:ln/>
+        </p:spPr>
+        <p:txBody>
+          <a:bodyPr/>
+          <a:p/>
+        </p:txBody>
+      </p:sp>
+      <p:sp>
+        <p:nvSpPr>
+          <p:cNvPr id="146" name="" descr="{&quot;isTemplate&quot;:true,&quot;type&quot;:&quot;text&quot;}"/>
+          <p:cNvSpPr txBox="1"/>
+          <p:nvPr/>
+        </p:nvSpPr>
+        <p:spPr>
+          <a:xfrm rot="0" flipH="0" flipV="0">
+            <a:off x="3676650" y="4876800"/>
+            <a:ext cx="2219325" cy="152400"/>
           </a:xfrm>
           <a:prstGeom prst="rect"/>
         </p:spPr>
@@ -7115,7 +7249,7 @@
                 <a:latin typeface="Microsoft YaHei"/>
                 <a:ea typeface="Microsoft YaHei"/>
               </a:rPr>
-              <a:t>P4 </a:t>
+              <a:t>P4 · </a:t>
             </a:r>
             <a:r>
               <a:rPr lang="zh-CN" sz="975">
@@ -7133,14 +7267,14 @@
       </p:sp>
       <p:sp>
         <p:nvSpPr>
-          <p:cNvPr id="145" name="" descr="{&quot;isTemplate&quot;:true,&quot;type&quot;:&quot;text&quot;}"/>
-          <p:cNvSpPr txBox="1"/>
-          <p:nvPr/>
-        </p:nvSpPr>
-        <p:spPr>
-          <a:xfrm rot="0" flipH="0" flipV="0">
-            <a:off x="3667125" y="5210175"/>
-            <a:ext cx="2228850" cy="209550"/>
+          <p:cNvPr id="147" name="" descr="{&quot;isTemplate&quot;:true,&quot;type&quot;:&quot;text&quot;}"/>
+          <p:cNvSpPr txBox="1"/>
+          <p:nvPr/>
+        </p:nvSpPr>
+        <p:spPr>
+          <a:xfrm rot="0" flipH="0" flipV="0">
+            <a:off x="3676650" y="5076825"/>
+            <a:ext cx="2219325" cy="209550"/>
           </a:xfrm>
           <a:prstGeom prst="rect"/>
         </p:spPr>
@@ -7168,14 +7302,14 @@
       </p:sp>
       <p:sp>
         <p:nvSpPr>
-          <p:cNvPr id="146" name=""/>
+          <p:cNvPr id="148" name=""/>
           <p:cNvSpPr/>
           <p:nvPr/>
         </p:nvSpPr>
         <p:spPr>
           <a:xfrm rot="0" flipH="0" flipV="0">
-            <a:off x="6162675" y="4895850"/>
-            <a:ext cx="2505075" cy="847725"/>
+            <a:off x="6191250" y="4762500"/>
+            <a:ext cx="2524125" cy="847725"/>
           </a:xfrm>
           <a:prstGeom prst="roundRect">
             <a:avLst>
@@ -7196,14 +7330,71 @@
       </p:sp>
       <p:sp>
         <p:nvSpPr>
-          <p:cNvPr id="147" name="" descr="{&quot;isTemplate&quot;:true,&quot;type&quot;:&quot;text&quot;}"/>
-          <p:cNvSpPr txBox="1"/>
-          <p:nvPr/>
-        </p:nvSpPr>
-        <p:spPr>
-          <a:xfrm rot="0" flipH="0" flipV="0">
-            <a:off x="6296025" y="5010150"/>
-            <a:ext cx="2238375" cy="152400"/>
+          <p:cNvPr id="149" name=""/>
+          <p:cNvSpPr/>
+          <p:nvPr/>
+        </p:nvSpPr>
+        <p:spPr>
+          <a:xfrm rot="0" flipH="0" flipV="0">
+            <a:off x="6191250" y="4762500"/>
+            <a:ext cx="2524125" cy="847725"/>
+          </a:xfrm>
+          <a:custGeom>
+            <a:pathLst>
+              <a:path w="265" h="89">
+                <a:moveTo>
+                  <a:pt x="8" y="0"/>
+                </a:moveTo>
+                <a:cubicBezTo>
+                  <a:pt x="5" y="0"/>
+                  <a:pt x="3" y="2"/>
+                  <a:pt x="3" y="5"/>
+                </a:cubicBezTo>
+                <a:lnTo>
+                  <a:pt x="3" y="84"/>
+                </a:lnTo>
+                <a:cubicBezTo>
+                  <a:pt x="3" y="86"/>
+                  <a:pt x="5" y="88"/>
+                  <a:pt x="7" y="89"/>
+                </a:cubicBezTo>
+                <a:cubicBezTo>
+                  <a:pt x="3" y="88"/>
+                  <a:pt x="0" y="85"/>
+                  <a:pt x="0" y="81"/>
+                </a:cubicBezTo>
+                <a:lnTo>
+                  <a:pt x="0" y="8"/>
+                </a:lnTo>
+                <a:cubicBezTo>
+                  <a:pt x="0" y="4"/>
+                  <a:pt x="3" y="0"/>
+                  <a:pt x="8" y="0"/>
+                </a:cubicBezTo>
+                <a:close/>
+              </a:path>
+            </a:pathLst>
+          </a:custGeom>
+          <a:solidFill>
+            <a:srgbClr val="BD9B56"/>
+          </a:solidFill>
+          <a:ln/>
+        </p:spPr>
+        <p:txBody>
+          <a:bodyPr/>
+          <a:p/>
+        </p:txBody>
+      </p:sp>
+      <p:sp>
+        <p:nvSpPr>
+          <p:cNvPr id="150" name="" descr="{&quot;isTemplate&quot;:true,&quot;type&quot;:&quot;text&quot;}"/>
+          <p:cNvSpPr txBox="1"/>
+          <p:nvPr/>
+        </p:nvSpPr>
+        <p:spPr>
+          <a:xfrm rot="0" flipH="0" flipV="0">
+            <a:off x="6324600" y="4876800"/>
+            <a:ext cx="2228850" cy="152400"/>
           </a:xfrm>
           <a:prstGeom prst="rect"/>
         </p:spPr>
@@ -7223,7 +7414,7 @@
                 <a:latin typeface="Microsoft YaHei"/>
                 <a:ea typeface="Microsoft YaHei"/>
               </a:rPr>
-              <a:t>P6 </a:t>
+              <a:t>P6 · </a:t>
             </a:r>
             <a:r>
               <a:rPr lang="zh-CN" sz="975">
@@ -7251,14 +7442,14 @@
       </p:sp>
       <p:sp>
         <p:nvSpPr>
-          <p:cNvPr id="148" name="" descr="{&quot;isTemplate&quot;:true,&quot;type&quot;:&quot;text&quot;}"/>
-          <p:cNvSpPr txBox="1"/>
-          <p:nvPr/>
-        </p:nvSpPr>
-        <p:spPr>
-          <a:xfrm rot="0" flipH="0" flipV="0">
-            <a:off x="6296025" y="5210175"/>
-            <a:ext cx="2238375" cy="419100"/>
+          <p:cNvPr id="151" name="" descr="{&quot;isTemplate&quot;:true,&quot;type&quot;:&quot;text&quot;}"/>
+          <p:cNvSpPr txBox="1"/>
+          <p:nvPr/>
+        </p:nvSpPr>
+        <p:spPr>
+          <a:xfrm rot="0" flipH="0" flipV="0">
+            <a:off x="6324600" y="5076825"/>
+            <a:ext cx="2228850" cy="419100"/>
           </a:xfrm>
           <a:prstGeom prst="rect"/>
         </p:spPr>
@@ -7290,7 +7481,7 @@
                 <a:latin typeface="Microsoft YaHei"/>
                 <a:ea typeface="Microsoft YaHei"/>
               </a:rPr>
-              <a:t> 83%→100%</a:t>
+              <a:t> 83.33%→100%</a:t>
             </a:r>
             <a:r>
               <a:rPr lang="zh-CN" sz="900">
@@ -7328,14 +7519,14 @@
       </p:sp>
       <p:sp>
         <p:nvSpPr>
-          <p:cNvPr id="149" name=""/>
+          <p:cNvPr id="152" name=""/>
           <p:cNvSpPr/>
           <p:nvPr/>
         </p:nvSpPr>
         <p:spPr>
           <a:xfrm rot="0" flipH="0" flipV="0">
-            <a:off x="8801100" y="4895850"/>
-            <a:ext cx="2495550" cy="847725"/>
+            <a:off x="8848725" y="4762500"/>
+            <a:ext cx="2514600" cy="847725"/>
           </a:xfrm>
           <a:prstGeom prst="roundRect">
             <a:avLst>
@@ -7356,14 +7547,71 @@
       </p:sp>
       <p:sp>
         <p:nvSpPr>
-          <p:cNvPr id="150" name="" descr="{&quot;isTemplate&quot;:true,&quot;type&quot;:&quot;text&quot;}"/>
-          <p:cNvSpPr txBox="1"/>
-          <p:nvPr/>
-        </p:nvSpPr>
-        <p:spPr>
-          <a:xfrm rot="0" flipH="0" flipV="0">
-            <a:off x="8934450" y="5010150"/>
-            <a:ext cx="2228850" cy="152400"/>
+          <p:cNvPr id="153" name=""/>
+          <p:cNvSpPr/>
+          <p:nvPr/>
+        </p:nvSpPr>
+        <p:spPr>
+          <a:xfrm rot="0" flipH="0" flipV="0">
+            <a:off x="8848725" y="4762500"/>
+            <a:ext cx="2514600" cy="847725"/>
+          </a:xfrm>
+          <a:custGeom>
+            <a:pathLst>
+              <a:path w="264" h="89">
+                <a:moveTo>
+                  <a:pt x="8" y="0"/>
+                </a:moveTo>
+                <a:cubicBezTo>
+                  <a:pt x="5" y="0"/>
+                  <a:pt x="3" y="2"/>
+                  <a:pt x="3" y="5"/>
+                </a:cubicBezTo>
+                <a:lnTo>
+                  <a:pt x="3" y="84"/>
+                </a:lnTo>
+                <a:cubicBezTo>
+                  <a:pt x="3" y="86"/>
+                  <a:pt x="5" y="88"/>
+                  <a:pt x="7" y="89"/>
+                </a:cubicBezTo>
+                <a:cubicBezTo>
+                  <a:pt x="3" y="88"/>
+                  <a:pt x="0" y="85"/>
+                  <a:pt x="0" y="81"/>
+                </a:cubicBezTo>
+                <a:lnTo>
+                  <a:pt x="0" y="8"/>
+                </a:lnTo>
+                <a:cubicBezTo>
+                  <a:pt x="0" y="4"/>
+                  <a:pt x="3" y="0"/>
+                  <a:pt x="8" y="0"/>
+                </a:cubicBezTo>
+                <a:close/>
+              </a:path>
+            </a:pathLst>
+          </a:custGeom>
+          <a:solidFill>
+            <a:srgbClr val="BD9B56"/>
+          </a:solidFill>
+          <a:ln/>
+        </p:spPr>
+        <p:txBody>
+          <a:bodyPr/>
+          <a:p/>
+        </p:txBody>
+      </p:sp>
+      <p:sp>
+        <p:nvSpPr>
+          <p:cNvPr id="154" name="" descr="{&quot;isTemplate&quot;:true,&quot;type&quot;:&quot;text&quot;}"/>
+          <p:cNvSpPr txBox="1"/>
+          <p:nvPr/>
+        </p:nvSpPr>
+        <p:spPr>
+          <a:xfrm rot="0" flipH="0" flipV="0">
+            <a:off x="8982075" y="4876800"/>
+            <a:ext cx="2219325" cy="152400"/>
           </a:xfrm>
           <a:prstGeom prst="rect"/>
         </p:spPr>
@@ -7383,7 +7631,7 @@
                 <a:latin typeface="Microsoft YaHei"/>
                 <a:ea typeface="Microsoft YaHei"/>
               </a:rPr>
-              <a:t>P7 </a:t>
+              <a:t>P7 · </a:t>
             </a:r>
             <a:r>
               <a:rPr lang="zh-CN" sz="975">
@@ -7401,14 +7649,14 @@
       </p:sp>
       <p:sp>
         <p:nvSpPr>
-          <p:cNvPr id="151" name="" descr="{&quot;isTemplate&quot;:true,&quot;type&quot;:&quot;text&quot;}"/>
-          <p:cNvSpPr txBox="1"/>
-          <p:nvPr/>
-        </p:nvSpPr>
-        <p:spPr>
-          <a:xfrm rot="0" flipH="0" flipV="0">
-            <a:off x="8934450" y="5210175"/>
-            <a:ext cx="2228850" cy="419100"/>
+          <p:cNvPr id="155" name="" descr="{&quot;isTemplate&quot;:true,&quot;type&quot;:&quot;text&quot;}"/>
+          <p:cNvSpPr txBox="1"/>
+          <p:nvPr/>
+        </p:nvSpPr>
+        <p:spPr>
+          <a:xfrm rot="0" flipH="0" flipV="0">
+            <a:off x="8982075" y="5076825"/>
+            <a:ext cx="2219325" cy="419100"/>
           </a:xfrm>
           <a:prstGeom prst="rect"/>
         </p:spPr>
@@ -7458,13 +7706,13 @@
       </p:sp>
       <p:sp>
         <p:nvSpPr>
-          <p:cNvPr id="152" name="" descr="{&quot;isTemplate&quot;:true,&quot;type&quot;:&quot;text&quot;}"/>
-          <p:cNvSpPr txBox="1"/>
-          <p:nvPr/>
-        </p:nvSpPr>
-        <p:spPr>
-          <a:xfrm rot="0" flipH="0" flipV="0">
-            <a:off x="609600" y="6391275"/>
+          <p:cNvPr id="156" name="" descr="{&quot;isTemplate&quot;:true,&quot;type&quot;:&quot;text&quot;}"/>
+          <p:cNvSpPr txBox="1"/>
+          <p:nvPr/>
+        </p:nvSpPr>
+        <p:spPr>
+          <a:xfrm rot="0" flipH="0" flipV="0">
+            <a:off x="609600" y="6372225"/>
             <a:ext cx="1009650" cy="142875"/>
           </a:xfrm>
           <a:prstGeom prst="rect"/>
@@ -7513,13 +7761,13 @@
       </p:sp>
       <p:sp>
         <p:nvSpPr>
-          <p:cNvPr id="153" name="" descr="{&quot;isTemplate&quot;:true,&quot;type&quot;:&quot;text&quot;}"/>
-          <p:cNvSpPr txBox="1"/>
-          <p:nvPr/>
-        </p:nvSpPr>
-        <p:spPr>
-          <a:xfrm rot="0" flipH="0" flipV="0">
-            <a:off x="11191875" y="6391275"/>
+          <p:cNvPr id="157" name="" descr="{&quot;isTemplate&quot;:true,&quot;type&quot;:&quot;text&quot;}"/>
+          <p:cNvSpPr txBox="1"/>
+          <p:nvPr/>
+        </p:nvSpPr>
+        <p:spPr>
+          <a:xfrm rot="0" flipH="0" flipV="0">
+            <a:off x="11191875" y="6372225"/>
             <a:ext cx="390525" cy="142875"/>
           </a:xfrm>
           <a:prstGeom prst="rect"/>
@@ -7556,7 +7804,7 @@
   <p:cSld>
     <p:spTree>
       <p:nvGrpSpPr>
-        <p:cNvPr id="154" name="" descr="&lt;Slide style={{ width: '1280px', height: '720px', background: '#FBFCFA', position: 'relative', padding: '26px 52px', boxSizing: 'border-box', display: 'flex', flexDirection: 'column' }}&gt;&#10;  &lt;div style={{ flexShrink: 0 }}&gt;&#10;    &lt;div style={{ color: '#BD9B56', fontSize: 12, letterSpacing: '0.25em', marginBottom: 4 }}&gt;04 · 总结与展望&lt;/div&gt;&#10;    &lt;h2 style={{ fontSize: 25, fontWeight: 'bold', color: '#172133', margin: 0, lineHeight: 1.2 }}&gt;三端功能 × 实现技术：每个功能怎么做出来的&lt;/h2&gt;&#10;  &lt;/div&gt;&#10;  &lt;div style={{ flex: 1, display: 'flex', alignItems: 'stretch', gap: 18, marginTop: 10 }}&gt;&#10;    {/* 左栏：三端功能实现 */}&#10;    &lt;div style={{ flex: 1, display: 'flex', flexDirection: 'column', gap: 8 }}&gt;&#10;      {/* 业主端 */}&#10;      &lt;div style={{ background: '#fff', borderRadius: 10, padding: '10px 14px', boxShadow: '0 4px 16px rgba(23,33,51,0.06)' }}&gt;&#10;        &lt;div style={{ display: 'flex', alignItems: 'center', gap: 8, marginBottom: 6 }}&gt;&#10;          &lt;span style={{ fontSize: 14, fontWeight: 'bold', color: '#172133' }}&gt;业主端&lt;/span&gt;&#10;          &lt;span style={{ fontSize: 10.5, color: '#BD9B56', background: 'rgba(189,155,86,0.12)', padding: '2px 7px', borderRadius: 4 }}&gt;ToC · Owner&lt;/span&gt;&#10;        &lt;/div&gt;&#10;        &lt;div style={{ display: 'flex', flexDirection: 'column', gap: 3.5 }}&gt;&#10;          &lt;div style={{ display: 'flex', gap: 8, alignItems: 'baseline', fontSize: 11.5, lineHeight: 1.4 }}&gt;&lt;span style={{ color: '#172133', fontWeight: 'bold', minWidth: 56 }}&gt;AI 助手&lt;/span&gt;&lt;span style={{ color: '#6b7075' }}&gt;LangGraph 多 Agent：Personal 对话 → Router 意图识别 → Domain 工具调用&lt;/span&gt;&lt;/div&gt;&#10;          &lt;div style={{ display: 'flex', gap: 8, alignItems: 'baseline', fontSize: 11.5, lineHeight: 1.4 }}&gt;&lt;span style={{ color: '#172133', fontWeight: 'bold', minWidth: 56 }}&gt;对话报修&lt;/span&gt;&lt;span style={{ color: '#6b7075' }}&gt;Repair Agent · 多轮状态机补全房屋/类型 · 自动派单（技能+在岗+工号）&lt;/span&gt;&lt;/div&gt;&#10;          &lt;div style={{ display: 'flex', gap: 8, alignItems: 'baseline', fontSize: 11.5, lineHeight: 1.4 }}&gt;&lt;span style={{ color: '#172133', fontWeight: 'bold', minWidth: 56 }}&gt;缴费查询&lt;/span&gt;&lt;span style={{ color: '#6b7075' }}&gt;Fee Agent 查 fee_bills 账单表 · 返回金额/状态/截止日&lt;/span&gt;&lt;/div&gt;&#10;          &lt;div style={{ display: 'flex', gap: 8, alignItems: 'baseline', fontSize: 11.5, lineHeight: 1.4 }}&gt;&lt;span style={{ color: '#172133', fontWeight: 'bold', minWidth: 56 }}&gt;公告&lt;/span&gt;&lt;span style={{ color: '#6b7075' }}&gt;公告列表 + AI 摘要（LLM 提炼要点）&lt;/span&gt;&lt;/div&gt;&#10;          &lt;div style={{ display: 'flex', gap: 8, alignItems: 'baseline', fontSize: 11.5, lineHeight: 1.4 }}&gt;&lt;span style={{ color: '#172133', fontWeight: 'bold', minWidth: 56 }}&gt;我的工单&lt;/span&gt;&lt;span style={{ color: '#6b7075' }}&gt;repair_order 状态追踪（创建→派单→接单→完成→关闭）&lt;/span&gt;&lt;/div&gt;&#10;          &lt;div style={{ display: 'flex', gap: 8, alignItems: 'baseline', fontSize: 11.5, lineHeight: 1.4 }}&gt;&lt;span style={{ color: '#172133', fontWeight: 'bold', minWidth: 56 }}&gt;问题上报&lt;/span&gt;&lt;span style={{ color: '#6b7075' }}&gt;IssueReport 上报 · 附图片 · 物业答复&lt;/span&gt;&lt;/div&gt;&#10;        &lt;/div&gt;&#10;      &lt;/div&gt;&#10;      {/* 物业端 */}&#10;      &lt;div style={{ background: '#fff', borderRadius: 10, padding: '10px 14px', boxShadow: '0 4px 16px rgba(23,33,51,0.06)' }}&gt;&#10;        &lt;div style={{ display: 'flex', alignItems: 'center', gap: 8, marginBottom: 6 }}&gt;&#10;          &lt;span style={{ fontSize: 14, fontWeight: 'bold', color: '#172133' }}&gt;物业端&lt;/span&gt;&#10;          &lt;span style={{ fontSize: 10.5, color: '#BD9B56', background: 'rgba(189,155,86,0.12)', padding: '2px 7px', borderRadius: 4 }}&gt;ToB · Admin/Staff&lt;/span&gt;&#10;        &lt;/div&gt;&#10;        &lt;div style={{ display: 'flex', flexDirection: 'column', gap: 3.5 }}&gt;&#10;          &lt;div style={{ display: 'flex', gap: 8, alignItems: 'baseline', fontSize: 11.5, lineHeight: 1.4 }}&gt;&lt;span style={{ color: '#172133', fontWeight: 'bold', minWidth: 56 }}&gt;数据看板&lt;/span&gt;&lt;span style={{ color: '#6b7075' }}&gt;统计聚合 API · 今日报修/处理中/已完成实时汇总&lt;/span&gt;&lt;/div&gt;&#10;          &lt;div style={{ display: 'flex', gap: 8, alignItems: 'baseline', fontSize: 11.5, lineHeight: 1.4 }}&gt;&lt;span style={{ color: '#172133', fontWeight: 'bold', minWidth: 56 }}&gt;工单管理&lt;/span&gt;&lt;span style={{ color: '#6b7075' }}&gt;repair_order CRUD · 状态流转 · 人工派单/改派&lt;/span&gt;&lt;/div&gt;&#10;          &lt;div style={{ display: 'flex', gap: 8, alignItems: 'baseline', fontSize: 11.5, lineHeight: 1.4 }}&gt;&lt;span style={{ color: '#172133', fontWeight: 'bold', minWidth: 56 }}&gt;用户/房屋&lt;/span&gt;&lt;span style={{ color: '#6b7075' }}&gt;user / house / house_binding 绑定关系管理&lt;/span&gt;&lt;/div&gt;&#10;          &lt;div style={{ display: 'flex', gap: 8, alignItems: 'baseline', fontSize: 11.5, lineHeight: 1.4 }}&gt;&lt;span style={{ color: '#172133', fontWeight: 'bold', minWidth: 56 }}&gt;公告 AI 生成&lt;/span&gt;&lt;span style={{ color: '#6b7075' }}&gt;Notice Agent + LLM 生成标题/正文/影响范围 · 人工审核发布&lt;/span&gt;&lt;/div&gt;&#10;          &lt;div style={{ display: 'flex', gap: 8, alignItems: 'baseline', fontSize: 11.5, lineHeight: 1.4 }}&gt;&lt;span style={{ color: '#172133', fontWeight: 'bold', minWidth: 56 }}&gt;巡检管理&lt;/span&gt;&lt;span style={{ color: '#6b7075' }}&gt;摄像头抓拍 → 视觉模型识别异常 → 巡检记录 + 告警&lt;/span&gt;&lt;/div&gt;&#10;          &lt;div style={{ display: 'flex', gap: 8, alignItems: 'baseline', fontSize: 11.5, lineHeight: 1.4 }}&gt;&lt;span style={{ color: '#172133', fontWeight: 'bold', minWidth: 56 }}&gt;知识缺口审核&lt;/span&gt;&lt;span style={{ color: '#6b7075' }}&gt;knowledge_gap 审核 → 通过自动写入 pgvector 知识库&lt;/span&gt;&lt;/div&gt;&#10;        &lt;/div&gt;&#10;      &lt;/div&gt;&#10;      {/* 维修端 */}&#10;      &lt;div style={{ background: '#fff', borderRadius: 10, padding: '10px 14px', boxShadow: '0 4px 16px rgba(23,33,51,0.06)' }}&gt;&#10;        &lt;div style={{ display: 'flex', alignItems: 'center', gap: 8, marginBottom: 6 }}&gt;&#10;          &lt;span style={{ fontSize: 14, fontWeight: 'bold', color: '#172133' }}&gt;维修端&lt;/span&gt;&#10;          &lt;span style={{ fontSize: 10.5, color: '#BD9B56', background: 'rgba(189,155,86,0.12)', padding: '2px 7px', borderRadius: 4 }}&gt;ToC · Worker&lt;/span&gt;&#10;        &lt;/div&gt;&#10;        &lt;div style={{ display: 'flex', flexDirection: 'column', gap: 3.5 }}&gt;&#10;          &lt;div style={{ display: 'flex', gap: 8, alignItems: 'baseline', fontSize: 11.5, lineHeight: 1.4 }}&gt;&lt;span style={{ color: '#172133', fontWeight: 'bold', minWidth: 56 }}&gt;任务列表&lt;/span&gt;&lt;span style={{ color: '#6b7075' }}&gt;自动派单后查询「我的待处理」工单&lt;/span&gt;&lt;/div&gt;&#10;          &lt;div style={{ display: 'flex', gap: 8, alignItems: 'baseline', fontSize: 11.5, lineHeight: 1.4 }}&gt;&lt;span style={{ color: '#172133', fontWeight: 'bold', minWidth: 56 }}&gt;接单/处理/完成&lt;/span&gt;&lt;span style={{ color: '#6b7075' }}&gt;状态机流转 · 每步触发实时通知&lt;/span&gt;&lt;/div&gt;&#10;          &lt;div style={{ display: 'flex', gap: 8, alignItems: 'baseline', fontSize: 11.5, lineHeight: 1.4 }}&gt;&lt;span style={{ color: '#172133', fontWeight: 'bold', minWidth: 56 }}&gt;消息&lt;/span&gt;&lt;span style={{ color: '#6b7075' }}&gt;事件驱动通知（派单/答复/完成）&lt;/span&gt;&lt;/div&gt;&#10;          &lt;div style={{ display: 'flex', gap: 8, alignItems: 'baseline', fontSize: 11.5, lineHeight: 1.4 }}&gt;&lt;span style={{ color: '#172133', fontWeight: 'bold', minWidth: 56 }}&gt;巡检任务&lt;/span&gt;&lt;span style={{ color: '#6b7075' }}&gt;巡检记录查看 · 异常处理&lt;/span&gt;&lt;/div&gt;&#10;        &lt;/div&gt;&#10;      &lt;/div&gt;&#10;    &lt;/div&gt;&#10;    {/* 右栏：自维护 + Demo */}&#10;    &lt;div style={{ flex: '0 0 285px', display: 'flex', flexDirection: 'column', gap: 10 }}&gt;&#10;      &lt;div style={{ background: 'linear-gradient(135deg, #172133 0%, #22395E 100%)', borderRadius: 12, padding: '16px 18px', color: '#FBFCFA', display: 'flex', flexDirection: 'column', gap: 9 }}&gt;&#10;        &lt;div style={{ color: '#BD9B56', fontSize: 12, letterSpacing: '0.2em' }}&gt;系统自维护自更新&lt;/div&gt;&#10;        &lt;div style={{ display: 'flex', flexDirection: 'column', gap: 6, fontSize: 11.5, lineHeight: 1.45 }}&gt;&#10;          &lt;div&gt;&lt;span style={{ color: '#BD9B56', fontWeight: 'bold' }}&gt;定时清理&lt;/span&gt;&lt;span style={{ color: 'rgba(251,252,250,0.8)' }}&gt;　APScheduler 每日清过期数据/孤儿文件&lt;/span&gt;&lt;/div&gt;&#10;          &lt;div&gt;&lt;span style={{ color: '#BD9B56', fontWeight: 'bold' }}&gt;巡检自动化&lt;/span&gt;&lt;span style={{ color: 'rgba(251,252,250,0.8)' }}&gt;　定时抓拍 + 视觉识别异常&lt;/span&gt;&lt;/div&gt;&#10;          &lt;div&gt;&lt;span style={{ color: '#BD9B56', fontWeight: 'bold' }}&gt;知识自进化&lt;/span&gt;&lt;span style={{ color: 'rgba(251,252,250,0.8)' }}&gt;　反馈→知识缺口→审核→入库&lt;/span&gt;&lt;/div&gt;&#10;          &lt;div&gt;&lt;span style={{ color: '#BD9B56', fontWeight: 'bold' }}&gt;监控告警&lt;/span&gt;&lt;span style={{ color: 'rgba(251,252,250,0.8)' }}&gt;　Prometheus + Grafana&lt;/span&gt;&lt;/div&gt;&#10;          &lt;div&gt;&lt;span style={{ color: '#BD9B56', fontWeight: 'bold' }}&gt;持续交付&lt;/span&gt;&lt;span style={{ color: 'rgba(251,252,250,0.8)' }}&gt;　GitHub Actions 自动测试+发布&lt;/span&gt;&lt;/div&gt;&#10;        &lt;/div&gt;&#10;        &lt;div style={{ fontSize: 11, color: 'rgba(251,252,250,0.6)', lineHeight: 1.5, paddingTop: 7, borderTop: '1px solid rgba(189,155,86,0.3)' }}&gt;无需人工值守，越用越准、越用越稳&lt;/div&gt;&#10;      &lt;/div&gt;&#10;      &lt;div style={{ background: '#fff', borderRadius: 12, padding: '14px 16px', boxShadow: '0 4px 16px rgba(23,33,51,0.06)' }}&gt;&#10;        &lt;div style={{ color: '#BD9B56', fontSize: 11.5, letterSpacing: '0.2em', marginBottom: 8 }}&gt;ONLINE DEMO&lt;/div&gt;&#10;        &lt;div style={{ fontSize: 15, fontFamily: 'Inter, sans-serif', color: '#172133', lineHeight: 1.4 }}&gt;http://119.91.236.85&lt;/div&gt;&#10;        &lt;div style={{ fontSize: 11, color: '#6b7075', lineHeight: 1.6, marginTop: 6 }}&gt;&#10;          业主 guoyi378 · 物业 mayun420&lt;br/&gt;维修 yangfei423　&lt;span style={{ color: '#BD9B56' }}&gt;密码 123456&lt;/span&gt;&#10;        &lt;/div&gt;&#10;        &lt;div style={{ fontSize: 10.5, color: '#a09b8c', marginTop: 6, paddingTop: 6, borderTop: '1px solid rgba(34,57,94,0.1)' }}&gt;GitHub：Xuuuukkk/ai-property-community-agent · MIT&lt;/div&gt;&#10;      &lt;/div&gt;&#10;    &lt;/div&gt;&#10;  &lt;/div&gt;&#10;  &lt;div style={{ flexShrink: 0, height: 30, display: 'flex', alignItems: 'flex-end', justifyContent: 'space-between' }}&gt;&#10;    &lt;span style={{ color: '#BD9B56', fontSize: 12, letterSpacing: '0.1em' }}&gt;云溪花园 · 智慧社区&lt;/span&gt;&#10;    &lt;span style={{ color: '#a09b8c', fontSize: 12 }}&gt;14 / 15&lt;/span&gt;&#10;  &lt;/div&gt;&#10;&lt;/Slide&gt;"/>
+        <p:cNvPr id="158" name="" descr="&lt;Slide style={{ width: '1280px', height: '720px', background: '#FBFCFA', position: 'relative', padding: '26px 52px', boxSizing: 'border-box', display: 'flex', flexDirection: 'column' }}&gt;&#10;  &lt;div style={{ flexShrink: 0 }}&gt;&#10;    &lt;div style={{ color: '#BD9B56', fontSize: 12, letterSpacing: '0.25em', marginBottom: 4 }}&gt;04 · 总结与展望&lt;/div&gt;&#10;    &lt;h2 style={{ fontSize: 25, fontWeight: 'bold', color: '#172133', margin: 0, lineHeight: 1.2 }}&gt;三端功能 × 实现技术：每个功能怎么做出来的&lt;/h2&gt;&#10;  &lt;/div&gt;&#10;  &lt;div style={{ flex: 1, display: 'flex', alignItems: 'stretch', gap: 18, marginTop: 10 }}&gt;&#10;    {/* 左栏：三端功能实现 */}&#10;    &lt;div style={{ flex: 1, display: 'flex', flexDirection: 'column', gap: 8 }}&gt;&#10;      {/* 业主端 */}&#10;      &lt;div style={{ background: '#fff', borderRadius: 10, padding: '10px 14px', boxShadow: '0 4px 16px rgba(23,33,51,0.06)' }}&gt;&#10;        &lt;div style={{ display: 'flex', alignItems: 'center', gap: 8, marginBottom: 6 }}&gt;&#10;          &lt;span style={{ fontSize: 14, fontWeight: 'bold', color: '#172133' }}&gt;业主端&lt;/span&gt;&#10;          &lt;span style={{ fontSize: 10.5, color: '#BD9B56', background: 'rgba(189,155,86,0.12)', padding: '2px 7px', borderRadius: 4 }}&gt;ToC · Owner&lt;/span&gt;&#10;        &lt;/div&gt;&#10;        &lt;div style={{ display: 'flex', flexDirection: 'column', gap: 3.5 }}&gt;&#10;          &lt;div style={{ display: 'flex', gap: 8, alignItems: 'baseline', fontSize: 11.5, lineHeight: 1.4 }}&gt;&lt;span style={{ color: '#172133', fontWeight: 'bold', minWidth: 56 }}&gt;AI 助手&lt;/span&gt;&lt;span style={{ color: '#6b7075' }}&gt;LangGraph 多 Agent：Personal 对话 → Router 意图识别 → Domain 工具调用&lt;/span&gt;&lt;/div&gt;&#10;          &lt;div style={{ display: 'flex', gap: 8, alignItems: 'baseline', fontSize: 11.5, lineHeight: 1.4 }}&gt;&lt;span style={{ color: '#172133', fontWeight: 'bold', minWidth: 56 }}&gt;对话报修&lt;/span&gt;&lt;span style={{ color: '#6b7075' }}&gt;Repair Agent · 多轮状态机补全房屋/类型 · 自动派单（技能+在岗+工号）&lt;/span&gt;&lt;/div&gt;&#10;          &lt;div style={{ display: 'flex', gap: 8, alignItems: 'baseline', fontSize: 11.5, lineHeight: 1.4 }}&gt;&lt;span style={{ color: '#172133', fontWeight: 'bold', minWidth: 56 }}&gt;缴费查询&lt;/span&gt;&lt;span style={{ color: '#6b7075' }}&gt;Fee Agent 查 fee_bills 账单表 · 返回金额/状态/截止日&lt;/span&gt;&lt;/div&gt;&#10;          &lt;div style={{ display: 'flex', gap: 8, alignItems: 'baseline', fontSize: 11.5, lineHeight: 1.4 }}&gt;&lt;span style={{ color: '#172133', fontWeight: 'bold', minWidth: 56 }}&gt;公告&lt;/span&gt;&lt;span style={{ color: '#6b7075' }}&gt;公告列表 + AI 摘要（LLM 提炼要点）&lt;/span&gt;&lt;/div&gt;&#10;          &lt;div style={{ display: 'flex', gap: 8, alignItems: 'baseline', fontSize: 11.5, lineHeight: 1.4 }}&gt;&lt;span style={{ color: '#172133', fontWeight: 'bold', minWidth: 56 }}&gt;我的工单&lt;/span&gt;&lt;span style={{ color: '#6b7075' }}&gt;repair_order 状态追踪（创建→派单→接单→完成→关闭）&lt;/span&gt;&lt;/div&gt;&#10;          &lt;div style={{ display: 'flex', gap: 8, alignItems: 'baseline', fontSize: 11.5, lineHeight: 1.4 }}&gt;&lt;span style={{ color: '#172133', fontWeight: 'bold', minWidth: 56 }}&gt;问题上报&lt;/span&gt;&lt;span style={{ color: '#6b7075' }}&gt;IssueReport 上报 · 附图片 · 物业答复&lt;/span&gt;&lt;/div&gt;&#10;        &lt;/div&gt;&#10;      &lt;/div&gt;&#10;      {/* 物业端 */}&#10;      &lt;div style={{ background: '#fff', borderRadius: 10, padding: '10px 14px', boxShadow: '0 4px 16px rgba(23,33,51,0.06)' }}&gt;&#10;        &lt;div style={{ display: 'flex', alignItems: 'center', gap: 8, marginBottom: 6 }}&gt;&#10;          &lt;span style={{ fontSize: 14, fontWeight: 'bold', color: '#172133' }}&gt;物业端&lt;/span&gt;&#10;          &lt;span style={{ fontSize: 10.5, color: '#BD9B56', background: 'rgba(189,155,86,0.12)', padding: '2px 7px', borderRadius: 4 }}&gt;ToB · Admin/Staff&lt;/span&gt;&#10;        &lt;/div&gt;&#10;        &lt;div style={{ display: 'flex', flexDirection: 'column', gap: 3.5 }}&gt;&#10;          &lt;div style={{ display: 'flex', gap: 8, alignItems: 'baseline', fontSize: 11.5, lineHeight: 1.4 }}&gt;&lt;span style={{ color: '#172133', fontWeight: 'bold', minWidth: 56 }}&gt;数据看板&lt;/span&gt;&lt;span style={{ color: '#6b7075' }}&gt;统计聚合 API · 今日报修/处理中/已完成实时汇总&lt;/span&gt;&lt;/div&gt;&#10;          &lt;div style={{ display: 'flex', gap: 8, alignItems: 'baseline', fontSize: 11.5, lineHeight: 1.4 }}&gt;&lt;span style={{ color: '#172133', fontWeight: 'bold', minWidth: 56 }}&gt;工单管理&lt;/span&gt;&lt;span style={{ color: '#6b7075' }}&gt;repair_order CRUD · 状态流转 · 人工派单/改派&lt;/span&gt;&lt;/div&gt;&#10;          &lt;div style={{ display: 'flex', gap: 8, alignItems: 'baseline', fontSize: 11.5, lineHeight: 1.4 }}&gt;&lt;span style={{ color: '#172133', fontWeight: 'bold', minWidth: 56 }}&gt;用户/房屋&lt;/span&gt;&lt;span style={{ color: '#6b7075' }}&gt;user / house / house_binding 绑定关系管理&lt;/span&gt;&lt;/div&gt;&#10;          &lt;div style={{ display: 'flex', gap: 8, alignItems: 'baseline', fontSize: 11.5, lineHeight: 1.4 }}&gt;&lt;span style={{ color: '#172133', fontWeight: 'bold', minWidth: 56 }}&gt;公告 AI 生成&lt;/span&gt;&lt;span style={{ color: '#6b7075' }}&gt;Notice Agent + LLM 生成标题/正文/影响范围 · 人工审核发布&lt;/span&gt;&lt;/div&gt;&#10;          &lt;div style={{ display: 'flex', gap: 8, alignItems: 'baseline', fontSize: 11.5, lineHeight: 1.4 }}&gt;&lt;span style={{ color: '#172133', fontWeight: 'bold', minWidth: 56 }}&gt;巡检管理&lt;/span&gt;&lt;span style={{ color: '#6b7075' }}&gt;摄像头抓拍 → 视觉模型识别异常 → 巡检记录 + 告警&lt;/span&gt;&lt;/div&gt;&#10;          &lt;div style={{ display: 'flex', gap: 8, alignItems: 'baseline', fontSize: 11.5, lineHeight: 1.4 }}&gt;&lt;span style={{ color: '#172133', fontWeight: 'bold', minWidth: 56 }}&gt;知识缺口审核&lt;/span&gt;&lt;span style={{ color: '#6b7075' }}&gt;knowledge_gap 审核 → 通过自动写入 pgvector 知识库&lt;/span&gt;&lt;/div&gt;&#10;        &lt;/div&gt;&#10;      &lt;/div&gt;&#10;      {/* 维修端 */}&#10;      &lt;div style={{ background: '#fff', borderRadius: 10, padding: '10px 14px', boxShadow: '0 4px 16px rgba(23,33,51,0.06)' }}&gt;&#10;        &lt;div style={{ display: 'flex', alignItems: 'center', gap: 8, marginBottom: 6 }}&gt;&#10;          &lt;span style={{ fontSize: 14, fontWeight: 'bold', color: '#172133' }}&gt;维修端&lt;/span&gt;&#10;          &lt;span style={{ fontSize: 10.5, color: '#BD9B56', background: 'rgba(189,155,86,0.12)', padding: '2px 7px', borderRadius: 4 }}&gt;ToC · Worker&lt;/span&gt;&#10;        &lt;/div&gt;&#10;        &lt;div style={{ display: 'flex', flexDirection: 'column', gap: 3.5 }}&gt;&#10;          &lt;div style={{ display: 'flex', gap: 8, alignItems: 'baseline', fontSize: 11.5, lineHeight: 1.4 }}&gt;&lt;span style={{ color: '#172133', fontWeight: 'bold', minWidth: 56 }}&gt;任务列表&lt;/span&gt;&lt;span style={{ color: '#6b7075' }}&gt;自动派单后查询「我的待处理」工单&lt;/span&gt;&lt;/div&gt;&#10;          &lt;div style={{ display: 'flex', gap: 8, alignItems: 'baseline', fontSize: 11.5, lineHeight: 1.4 }}&gt;&lt;span style={{ color: '#172133', fontWeight: 'bold', minWidth: 56 }}&gt;接单/处理/完成&lt;/span&gt;&lt;span style={{ color: '#6b7075' }}&gt;状态机流转 · 每步触发实时通知&lt;/span&gt;&lt;/div&gt;&#10;          &lt;div style={{ display: 'flex', gap: 8, alignItems: 'baseline', fontSize: 11.5, lineHeight: 1.4 }}&gt;&lt;span style={{ color: '#172133', fontWeight: 'bold', minWidth: 56 }}&gt;消息&lt;/span&gt;&lt;span style={{ color: '#6b7075' }}&gt;事件驱动通知（派单/答复/完成）&lt;/span&gt;&lt;/div&gt;&#10;          &lt;div style={{ display: 'flex', gap: 8, alignItems: 'baseline', fontSize: 11.5, lineHeight: 1.4 }}&gt;&lt;span style={{ color: '#172133', fontWeight: 'bold', minWidth: 56 }}&gt;巡检任务&lt;/span&gt;&lt;span style={{ color: '#6b7075' }}&gt;巡检记录查看 · 异常处理&lt;/span&gt;&lt;/div&gt;&#10;        &lt;/div&gt;&#10;      &lt;/div&gt;&#10;    &lt;/div&gt;&#10;    {/* 右栏：自维护 + Demo */}&#10;    &lt;div style={{ flex: '0 0 285px', display: 'flex', flexDirection: 'column', gap: 10 }}&gt;&#10;      &lt;div style={{ background: 'linear-gradient(135deg, #172133 0%, #22395E 100%)', borderRadius: 12, padding: '16px 18px', color: '#FBFCFA', display: 'flex', flexDirection: 'column', gap: 9 }}&gt;&#10;        &lt;div style={{ color: '#BD9B56', fontSize: 12, letterSpacing: '0.2em' }}&gt;系统自维护自更新&lt;/div&gt;&#10;        &lt;div style={{ display: 'flex', flexDirection: 'column', gap: 6, fontSize: 11.5, lineHeight: 1.45 }}&gt;&#10;          &lt;div&gt;&lt;span style={{ color: '#BD9B56', fontWeight: 'bold' }}&gt;定时清理&lt;/span&gt;&lt;span style={{ color: 'rgba(251,252,250,0.8)' }}&gt;　APScheduler 每日清过期数据/孤儿文件&lt;/span&gt;&lt;/div&gt;&#10;          &lt;div&gt;&lt;span style={{ color: '#BD9B56', fontWeight: 'bold' }}&gt;巡检自动化&lt;/span&gt;&lt;span style={{ color: 'rgba(251,252,250,0.8)' }}&gt;　定时抓拍 + 视觉识别异常&lt;/span&gt;&lt;/div&gt;&#10;          &lt;div&gt;&lt;span style={{ color: '#BD9B56', fontWeight: 'bold' }}&gt;知识自进化&lt;/span&gt;&lt;span style={{ color: 'rgba(251,252,250,0.8)' }}&gt;　反馈→知识缺口→审核→入库&lt;/span&gt;&lt;/div&gt;&#10;          &lt;div&gt;&lt;span style={{ color: '#BD9B56', fontWeight: 'bold' }}&gt;监控告警&lt;/span&gt;&lt;span style={{ color: 'rgba(251,252,250,0.8)' }}&gt;　Prometheus + Grafana&lt;/span&gt;&lt;/div&gt;&#10;          &lt;div&gt;&lt;span style={{ color: '#BD9B56', fontWeight: 'bold' }}&gt;持续交付&lt;/span&gt;&lt;span style={{ color: 'rgba(251,252,250,0.8)' }}&gt;　GitHub Actions 自动测试+发布&lt;/span&gt;&lt;/div&gt;&#10;        &lt;/div&gt;&#10;        &lt;div style={{ fontSize: 11, color: 'rgba(251,252,250,0.6)', lineHeight: 1.5, paddingTop: 7, borderTop: '1px solid rgba(189,155,86,0.3)' }}&gt;无需人工值守，越用越准、越用越稳&lt;/div&gt;&#10;      &lt;/div&gt;&#10;      &lt;div style={{ background: '#fff', borderRadius: 12, padding: '14px 16px', boxShadow: '0 4px 16px rgba(23,33,51,0.06)' }}&gt;&#10;        &lt;div style={{ color: '#BD9B56', fontSize: 11.5, letterSpacing: '0.2em', marginBottom: 8 }}&gt;ONLINE DEMO&lt;/div&gt;&#10;        &lt;div style={{ fontSize: 15, fontFamily: 'Inter, sans-serif', color: '#172133', lineHeight: 1.4 }}&gt;http://119.91.236.85&lt;/div&gt;&#10;        &lt;div style={{ fontSize: 11, color: '#6b7075', lineHeight: 1.6, marginTop: 6 }}&gt;&#10;          业主 guoyi378 · 物业 mayun420&lt;br/&gt;维修 yangfei423　&lt;span style={{ color: '#BD9B56' }}&gt;密码 123456&lt;/span&gt;&#10;        &lt;/div&gt;&#10;        &lt;div style={{ fontSize: 10.5, color: '#a09b8c', marginTop: 6, paddingTop: 6, borderTop: '1px solid rgba(34,57,94,0.1)' }}&gt;GitHub：Xuuuukkk/ai-property-community-agent · MIT&lt;/div&gt;&#10;      &lt;/div&gt;&#10;    &lt;/div&gt;&#10;  &lt;/div&gt;&#10;  &lt;div style={{ flexShrink: 0, height: 30, display: 'flex', alignItems: 'flex-end', justifyContent: 'space-between' }}&gt;&#10;    &lt;span style={{ color: '#BD9B56', fontSize: 12, letterSpacing: '0.1em' }}&gt;云溪花园 · 智慧社区&lt;/span&gt;&#10;    &lt;span style={{ color: '#a09b8c', fontSize: 12 }}&gt;14 / 15&lt;/span&gt;&#10;  &lt;/div&gt;&#10;&lt;/Slide&gt;"/>
         <p:cNvGrpSpPr/>
         <p:nvPr/>
       </p:nvGrpSpPr>
@@ -7570,7 +7818,7 @@
       </p:grpSpPr>
       <p:sp>
         <p:nvSpPr>
-          <p:cNvPr id="155" name=""/>
+          <p:cNvPr id="159" name=""/>
           <p:cNvSpPr/>
           <p:nvPr/>
         </p:nvSpPr>
@@ -7594,7 +7842,7 @@
       </p:sp>
       <p:sp>
         <p:nvSpPr>
-          <p:cNvPr id="156" name="" descr="{&quot;isTemplate&quot;:true,&quot;type&quot;:&quot;text&quot;}"/>
+          <p:cNvPr id="160" name="" descr="{&quot;isTemplate&quot;:true,&quot;type&quot;:&quot;text&quot;}"/>
           <p:cNvSpPr txBox="1"/>
           <p:nvPr/>
         </p:nvSpPr>
@@ -7639,7 +7887,7 @@
       </p:sp>
       <p:sp>
         <p:nvSpPr>
-          <p:cNvPr id="157" name="" descr="{&quot;isTemplate&quot;:true,&quot;type&quot;:&quot;text&quot;}"/>
+          <p:cNvPr id="161" name="" descr="{&quot;isTemplate&quot;:true,&quot;type&quot;:&quot;text&quot;}"/>
           <p:cNvSpPr txBox="1"/>
           <p:nvPr/>
         </p:nvSpPr>
@@ -7694,7 +7942,7 @@
       </p:sp>
       <p:sp>
         <p:nvSpPr>
-          <p:cNvPr id="158" name=""/>
+          <p:cNvPr id="162" name=""/>
           <p:cNvSpPr/>
           <p:nvPr/>
         </p:nvSpPr>
@@ -7727,7 +7975,7 @@
       </p:sp>
       <p:sp>
         <p:nvSpPr>
-          <p:cNvPr id="159" name="" descr="{&quot;isTemplate&quot;:true,&quot;type&quot;:&quot;text&quot;}"/>
+          <p:cNvPr id="163" name="" descr="{&quot;isTemplate&quot;:true,&quot;type&quot;:&quot;text&quot;}"/>
           <p:cNvSpPr txBox="1"/>
           <p:nvPr/>
         </p:nvSpPr>
@@ -7762,7 +8010,7 @@
       </p:sp>
       <p:sp>
         <p:nvSpPr>
-          <p:cNvPr id="160" name=""/>
+          <p:cNvPr id="164" name=""/>
           <p:cNvSpPr/>
           <p:nvPr/>
         </p:nvSpPr>
@@ -7790,7 +8038,7 @@
       </p:sp>
       <p:sp>
         <p:nvSpPr>
-          <p:cNvPr id="161" name="" descr="{&quot;isTemplate&quot;:true,&quot;type&quot;:&quot;text&quot;}"/>
+          <p:cNvPr id="165" name="" descr="{&quot;isTemplate&quot;:true,&quot;type&quot;:&quot;text&quot;}"/>
           <p:cNvSpPr txBox="1"/>
           <p:nvPr/>
         </p:nvSpPr>
@@ -7830,7 +8078,7 @@
       </p:sp>
       <p:sp>
         <p:nvSpPr>
-          <p:cNvPr id="162" name="" descr="{&quot;isTemplate&quot;:true,&quot;type&quot;:&quot;text&quot;}"/>
+          <p:cNvPr id="166" name="" descr="{&quot;isTemplate&quot;:true,&quot;type&quot;:&quot;text&quot;}"/>
           <p:cNvSpPr txBox="1"/>
           <p:nvPr/>
         </p:nvSpPr>
@@ -7875,7 +8123,7 @@
       </p:sp>
       <p:sp>
         <p:nvSpPr>
-          <p:cNvPr id="163" name="" descr="{&quot;isTemplate&quot;:true,&quot;type&quot;:&quot;text&quot;}"/>
+          <p:cNvPr id="167" name="" descr="{&quot;isTemplate&quot;:true,&quot;type&quot;:&quot;text&quot;}"/>
           <p:cNvSpPr txBox="1"/>
           <p:nvPr/>
         </p:nvSpPr>
@@ -8000,7 +8248,7 @@
       </p:sp>
       <p:sp>
         <p:nvSpPr>
-          <p:cNvPr id="164" name="" descr="{&quot;isTemplate&quot;:true,&quot;type&quot;:&quot;text&quot;}"/>
+          <p:cNvPr id="168" name="" descr="{&quot;isTemplate&quot;:true,&quot;type&quot;:&quot;text&quot;}"/>
           <p:cNvSpPr txBox="1"/>
           <p:nvPr/>
         </p:nvSpPr>
@@ -8035,7 +8283,7 @@
       </p:sp>
       <p:sp>
         <p:nvSpPr>
-          <p:cNvPr id="165" name="" descr="{&quot;isTemplate&quot;:true,&quot;type&quot;:&quot;text&quot;}"/>
+          <p:cNvPr id="169" name="" descr="{&quot;isTemplate&quot;:true,&quot;type&quot;:&quot;text&quot;}"/>
           <p:cNvSpPr txBox="1"/>
           <p:nvPr/>
         </p:nvSpPr>
@@ -8160,7 +8408,7 @@
       </p:sp>
       <p:sp>
         <p:nvSpPr>
-          <p:cNvPr id="166" name="" descr="{&quot;isTemplate&quot;:true,&quot;type&quot;:&quot;text&quot;}"/>
+          <p:cNvPr id="170" name="" descr="{&quot;isTemplate&quot;:true,&quot;type&quot;:&quot;text&quot;}"/>
           <p:cNvSpPr txBox="1"/>
           <p:nvPr/>
         </p:nvSpPr>
@@ -8195,7 +8443,7 @@
       </p:sp>
       <p:sp>
         <p:nvSpPr>
-          <p:cNvPr id="167" name="" descr="{&quot;isTemplate&quot;:true,&quot;type&quot;:&quot;text&quot;}"/>
+          <p:cNvPr id="171" name="" descr="{&quot;isTemplate&quot;:true,&quot;type&quot;:&quot;text&quot;}"/>
           <p:cNvSpPr txBox="1"/>
           <p:nvPr/>
         </p:nvSpPr>
@@ -8320,7 +8568,7 @@
       </p:sp>
       <p:sp>
         <p:nvSpPr>
-          <p:cNvPr id="168" name="" descr="{&quot;isTemplate&quot;:true,&quot;type&quot;:&quot;text&quot;}"/>
+          <p:cNvPr id="172" name="" descr="{&quot;isTemplate&quot;:true,&quot;type&quot;:&quot;text&quot;}"/>
           <p:cNvSpPr txBox="1"/>
           <p:nvPr/>
         </p:nvSpPr>
@@ -8355,7 +8603,7 @@
       </p:sp>
       <p:sp>
         <p:nvSpPr>
-          <p:cNvPr id="169" name="" descr="{&quot;isTemplate&quot;:true,&quot;type&quot;:&quot;text&quot;}"/>
+          <p:cNvPr id="173" name="" descr="{&quot;isTemplate&quot;:true,&quot;type&quot;:&quot;text&quot;}"/>
           <p:cNvSpPr txBox="1"/>
           <p:nvPr/>
         </p:nvSpPr>
@@ -8430,7 +8678,7 @@
       </p:sp>
       <p:sp>
         <p:nvSpPr>
-          <p:cNvPr id="170" name="" descr="{&quot;isTemplate&quot;:true,&quot;type&quot;:&quot;text&quot;}"/>
+          <p:cNvPr id="174" name="" descr="{&quot;isTemplate&quot;:true,&quot;type&quot;:&quot;text&quot;}"/>
           <p:cNvSpPr txBox="1"/>
           <p:nvPr/>
         </p:nvSpPr>
@@ -8465,7 +8713,7 @@
       </p:sp>
       <p:sp>
         <p:nvSpPr>
-          <p:cNvPr id="171" name="" descr="{&quot;isTemplate&quot;:true,&quot;type&quot;:&quot;text&quot;}"/>
+          <p:cNvPr id="175" name="" descr="{&quot;isTemplate&quot;:true,&quot;type&quot;:&quot;text&quot;}"/>
           <p:cNvSpPr txBox="1"/>
           <p:nvPr/>
         </p:nvSpPr>
@@ -8510,7 +8758,7 @@
       </p:sp>
       <p:sp>
         <p:nvSpPr>
-          <p:cNvPr id="172" name="" descr="{&quot;isTemplate&quot;:true,&quot;type&quot;:&quot;text&quot;}"/>
+          <p:cNvPr id="176" name="" descr="{&quot;isTemplate&quot;:true,&quot;type&quot;:&quot;text&quot;}"/>
           <p:cNvSpPr txBox="1"/>
           <p:nvPr/>
         </p:nvSpPr>
@@ -8545,7 +8793,7 @@
       </p:sp>
       <p:sp>
         <p:nvSpPr>
-          <p:cNvPr id="173" name="" descr="{&quot;isTemplate&quot;:true,&quot;type&quot;:&quot;text&quot;}"/>
+          <p:cNvPr id="177" name="" descr="{&quot;isTemplate&quot;:true,&quot;type&quot;:&quot;text&quot;}"/>
           <p:cNvSpPr txBox="1"/>
           <p:nvPr/>
         </p:nvSpPr>
@@ -8630,7 +8878,7 @@
       </p:sp>
       <p:sp>
         <p:nvSpPr>
-          <p:cNvPr id="174" name=""/>
+          <p:cNvPr id="178" name=""/>
           <p:cNvSpPr/>
           <p:nvPr/>
         </p:nvSpPr>
@@ -8663,7 +8911,7 @@
       </p:sp>
       <p:sp>
         <p:nvSpPr>
-          <p:cNvPr id="175" name="" descr="{&quot;isTemplate&quot;:true,&quot;type&quot;:&quot;text&quot;}"/>
+          <p:cNvPr id="179" name="" descr="{&quot;isTemplate&quot;:true,&quot;type&quot;:&quot;text&quot;}"/>
           <p:cNvSpPr txBox="1"/>
           <p:nvPr/>
         </p:nvSpPr>
@@ -8698,7 +8946,7 @@
       </p:sp>
       <p:sp>
         <p:nvSpPr>
-          <p:cNvPr id="176" name=""/>
+          <p:cNvPr id="180" name=""/>
           <p:cNvSpPr/>
           <p:nvPr/>
         </p:nvSpPr>
@@ -8726,7 +8974,7 @@
       </p:sp>
       <p:sp>
         <p:nvSpPr>
-          <p:cNvPr id="177" name="" descr="{&quot;isTemplate&quot;:true,&quot;type&quot;:&quot;text&quot;}"/>
+          <p:cNvPr id="181" name="" descr="{&quot;isTemplate&quot;:true,&quot;type&quot;:&quot;text&quot;}"/>
           <p:cNvSpPr txBox="1"/>
           <p:nvPr/>
         </p:nvSpPr>
@@ -8766,7 +9014,7 @@
       </p:sp>
       <p:sp>
         <p:nvSpPr>
-          <p:cNvPr id="178" name="" descr="{&quot;isTemplate&quot;:true,&quot;type&quot;:&quot;text&quot;}"/>
+          <p:cNvPr id="182" name="" descr="{&quot;isTemplate&quot;:true,&quot;type&quot;:&quot;text&quot;}"/>
           <p:cNvSpPr txBox="1"/>
           <p:nvPr/>
         </p:nvSpPr>
@@ -8801,7 +9049,7 @@
       </p:sp>
       <p:sp>
         <p:nvSpPr>
-          <p:cNvPr id="179" name="" descr="{&quot;isTemplate&quot;:true,&quot;type&quot;:&quot;text&quot;}"/>
+          <p:cNvPr id="183" name="" descr="{&quot;isTemplate&quot;:true,&quot;type&quot;:&quot;text&quot;}"/>
           <p:cNvSpPr txBox="1"/>
           <p:nvPr/>
         </p:nvSpPr>
@@ -8896,7 +9144,7 @@
       </p:sp>
       <p:sp>
         <p:nvSpPr>
-          <p:cNvPr id="180" name="" descr="{&quot;isTemplate&quot;:true,&quot;type&quot;:&quot;text&quot;}"/>
+          <p:cNvPr id="184" name="" descr="{&quot;isTemplate&quot;:true,&quot;type&quot;:&quot;text&quot;}"/>
           <p:cNvSpPr txBox="1"/>
           <p:nvPr/>
         </p:nvSpPr>
@@ -8931,7 +9179,7 @@
       </p:sp>
       <p:sp>
         <p:nvSpPr>
-          <p:cNvPr id="181" name="" descr="{&quot;isTemplate&quot;:true,&quot;type&quot;:&quot;text&quot;}"/>
+          <p:cNvPr id="185" name="" descr="{&quot;isTemplate&quot;:true,&quot;type&quot;:&quot;text&quot;}"/>
           <p:cNvSpPr txBox="1"/>
           <p:nvPr/>
         </p:nvSpPr>
@@ -9016,7 +9264,7 @@
       </p:sp>
       <p:sp>
         <p:nvSpPr>
-          <p:cNvPr id="182" name="" descr="{&quot;isTemplate&quot;:true,&quot;type&quot;:&quot;text&quot;}"/>
+          <p:cNvPr id="186" name="" descr="{&quot;isTemplate&quot;:true,&quot;type&quot;:&quot;text&quot;}"/>
           <p:cNvSpPr txBox="1"/>
           <p:nvPr/>
         </p:nvSpPr>
@@ -9071,7 +9319,7 @@
       </p:sp>
       <p:sp>
         <p:nvSpPr>
-          <p:cNvPr id="183" name="" descr="{&quot;isTemplate&quot;:true,&quot;type&quot;:&quot;text&quot;}"/>
+          <p:cNvPr id="187" name="" descr="{&quot;isTemplate&quot;:true,&quot;type&quot;:&quot;text&quot;}"/>
           <p:cNvSpPr txBox="1"/>
           <p:nvPr/>
         </p:nvSpPr>
@@ -9116,7 +9364,7 @@
       </p:sp>
       <p:sp>
         <p:nvSpPr>
-          <p:cNvPr id="184" name="" descr="{&quot;isTemplate&quot;:true,&quot;type&quot;:&quot;text&quot;}"/>
+          <p:cNvPr id="188" name="" descr="{&quot;isTemplate&quot;:true,&quot;type&quot;:&quot;text&quot;}"/>
           <p:cNvSpPr txBox="1"/>
           <p:nvPr/>
         </p:nvSpPr>
@@ -9171,7 +9419,7 @@
       </p:sp>
       <p:sp>
         <p:nvSpPr>
-          <p:cNvPr id="185" name="" descr="{&quot;isTemplate&quot;:true,&quot;type&quot;:&quot;text&quot;}"/>
+          <p:cNvPr id="189" name="" descr="{&quot;isTemplate&quot;:true,&quot;type&quot;:&quot;text&quot;}"/>
           <p:cNvSpPr txBox="1"/>
           <p:nvPr/>
         </p:nvSpPr>
@@ -9276,7 +9524,7 @@
       </p:sp>
       <p:sp>
         <p:nvSpPr>
-          <p:cNvPr id="186" name="" descr="{&quot;isTemplate&quot;:true,&quot;type&quot;:&quot;text&quot;}"/>
+          <p:cNvPr id="190" name="" descr="{&quot;isTemplate&quot;:true,&quot;type&quot;:&quot;text&quot;}"/>
           <p:cNvSpPr txBox="1"/>
           <p:nvPr/>
         </p:nvSpPr>
@@ -9311,7 +9559,7 @@
       </p:sp>
       <p:sp>
         <p:nvSpPr>
-          <p:cNvPr id="187" name="" descr="{&quot;isTemplate&quot;:true,&quot;type&quot;:&quot;text&quot;}"/>
+          <p:cNvPr id="191" name="" descr="{&quot;isTemplate&quot;:true,&quot;type&quot;:&quot;text&quot;}"/>
           <p:cNvSpPr txBox="1"/>
           <p:nvPr/>
         </p:nvSpPr>
@@ -9406,7 +9654,7 @@
       </p:sp>
       <p:sp>
         <p:nvSpPr>
-          <p:cNvPr id="188" name="" descr="{&quot;isTemplate&quot;:true,&quot;type&quot;:&quot;text&quot;}"/>
+          <p:cNvPr id="192" name="" descr="{&quot;isTemplate&quot;:true,&quot;type&quot;:&quot;text&quot;}"/>
           <p:cNvSpPr txBox="1"/>
           <p:nvPr/>
         </p:nvSpPr>
@@ -9441,7 +9689,7 @@
       </p:sp>
       <p:sp>
         <p:nvSpPr>
-          <p:cNvPr id="189" name="" descr="{&quot;isTemplate&quot;:true,&quot;type&quot;:&quot;text&quot;}"/>
+          <p:cNvPr id="193" name="" descr="{&quot;isTemplate&quot;:true,&quot;type&quot;:&quot;text&quot;}"/>
           <p:cNvSpPr txBox="1"/>
           <p:nvPr/>
         </p:nvSpPr>
@@ -9526,7 +9774,7 @@
       </p:sp>
       <p:sp>
         <p:nvSpPr>
-          <p:cNvPr id="190" name=""/>
+          <p:cNvPr id="194" name=""/>
           <p:cNvSpPr/>
           <p:nvPr/>
         </p:nvSpPr>
@@ -9559,7 +9807,7 @@
       </p:sp>
       <p:sp>
         <p:nvSpPr>
-          <p:cNvPr id="191" name="" descr="{&quot;isTemplate&quot;:true,&quot;type&quot;:&quot;text&quot;}"/>
+          <p:cNvPr id="195" name="" descr="{&quot;isTemplate&quot;:true,&quot;type&quot;:&quot;text&quot;}"/>
           <p:cNvSpPr txBox="1"/>
           <p:nvPr/>
         </p:nvSpPr>
@@ -9594,7 +9842,7 @@
       </p:sp>
       <p:sp>
         <p:nvSpPr>
-          <p:cNvPr id="192" name=""/>
+          <p:cNvPr id="196" name=""/>
           <p:cNvSpPr/>
           <p:nvPr/>
         </p:nvSpPr>
@@ -9622,7 +9870,7 @@
       </p:sp>
       <p:sp>
         <p:nvSpPr>
-          <p:cNvPr id="193" name="" descr="{&quot;isTemplate&quot;:true,&quot;type&quot;:&quot;text&quot;}"/>
+          <p:cNvPr id="197" name="" descr="{&quot;isTemplate&quot;:true,&quot;type&quot;:&quot;text&quot;}"/>
           <p:cNvSpPr txBox="1"/>
           <p:nvPr/>
         </p:nvSpPr>
@@ -9662,7 +9910,7 @@
       </p:sp>
       <p:sp>
         <p:nvSpPr>
-          <p:cNvPr id="194" name="" descr="{&quot;isTemplate&quot;:true,&quot;type&quot;:&quot;text&quot;}"/>
+          <p:cNvPr id="198" name="" descr="{&quot;isTemplate&quot;:true,&quot;type&quot;:&quot;text&quot;}"/>
           <p:cNvSpPr txBox="1"/>
           <p:nvPr/>
         </p:nvSpPr>
@@ -9697,7 +9945,7 @@
       </p:sp>
       <p:sp>
         <p:nvSpPr>
-          <p:cNvPr id="195" name="" descr="{&quot;isTemplate&quot;:true,&quot;type&quot;:&quot;text&quot;}"/>
+          <p:cNvPr id="199" name="" descr="{&quot;isTemplate&quot;:true,&quot;type&quot;:&quot;text&quot;}"/>
           <p:cNvSpPr txBox="1"/>
           <p:nvPr/>
         </p:nvSpPr>
@@ -9732,7 +9980,7 @@
       </p:sp>
       <p:sp>
         <p:nvSpPr>
-          <p:cNvPr id="196" name="" descr="{&quot;isTemplate&quot;:true,&quot;type&quot;:&quot;text&quot;}"/>
+          <p:cNvPr id="200" name="" descr="{&quot;isTemplate&quot;:true,&quot;type&quot;:&quot;text&quot;}"/>
           <p:cNvSpPr txBox="1"/>
           <p:nvPr/>
         </p:nvSpPr>
@@ -9807,7 +10055,7 @@
       </p:sp>
       <p:sp>
         <p:nvSpPr>
-          <p:cNvPr id="197" name="" descr="{&quot;isTemplate&quot;:true,&quot;type&quot;:&quot;text&quot;}"/>
+          <p:cNvPr id="201" name="" descr="{&quot;isTemplate&quot;:true,&quot;type&quot;:&quot;text&quot;}"/>
           <p:cNvSpPr txBox="1"/>
           <p:nvPr/>
         </p:nvSpPr>
@@ -9862,7 +10110,7 @@
       </p:sp>
       <p:sp>
         <p:nvSpPr>
-          <p:cNvPr id="198" name="" descr="{&quot;isTemplate&quot;:true,&quot;type&quot;:&quot;text&quot;}"/>
+          <p:cNvPr id="202" name="" descr="{&quot;isTemplate&quot;:true,&quot;type&quot;:&quot;text&quot;}"/>
           <p:cNvSpPr txBox="1"/>
           <p:nvPr/>
         </p:nvSpPr>
@@ -9897,7 +10145,7 @@
       </p:sp>
       <p:sp>
         <p:nvSpPr>
-          <p:cNvPr id="199" name="" descr="{&quot;isTemplate&quot;:true,&quot;type&quot;:&quot;text&quot;}"/>
+          <p:cNvPr id="203" name="" descr="{&quot;isTemplate&quot;:true,&quot;type&quot;:&quot;text&quot;}"/>
           <p:cNvSpPr txBox="1"/>
           <p:nvPr/>
         </p:nvSpPr>
@@ -9972,7 +10220,7 @@
       </p:sp>
       <p:sp>
         <p:nvSpPr>
-          <p:cNvPr id="200" name="" descr="{&quot;isTemplate&quot;:true,&quot;type&quot;:&quot;text&quot;}"/>
+          <p:cNvPr id="204" name="" descr="{&quot;isTemplate&quot;:true,&quot;type&quot;:&quot;text&quot;}"/>
           <p:cNvSpPr txBox="1"/>
           <p:nvPr/>
         </p:nvSpPr>
@@ -10007,7 +10255,7 @@
       </p:sp>
       <p:sp>
         <p:nvSpPr>
-          <p:cNvPr id="201" name="" descr="{&quot;isTemplate&quot;:true,&quot;type&quot;:&quot;text&quot;}"/>
+          <p:cNvPr id="205" name="" descr="{&quot;isTemplate&quot;:true,&quot;type&quot;:&quot;text&quot;}"/>
           <p:cNvSpPr txBox="1"/>
           <p:nvPr/>
         </p:nvSpPr>
@@ -10062,7 +10310,7 @@
       </p:sp>
       <p:sp>
         <p:nvSpPr>
-          <p:cNvPr id="202" name=""/>
+          <p:cNvPr id="206" name=""/>
           <p:cNvSpPr/>
           <p:nvPr/>
         </p:nvSpPr>
@@ -10096,7 +10344,7 @@
       </p:sp>
       <p:sp>
         <p:nvSpPr>
-          <p:cNvPr id="203" name="" descr="{&quot;isTemplate&quot;:true,&quot;type&quot;:&quot;text&quot;}"/>
+          <p:cNvPr id="207" name="" descr="{&quot;isTemplate&quot;:true,&quot;type&quot;:&quot;text&quot;}"/>
           <p:cNvSpPr txBox="1"/>
           <p:nvPr/>
         </p:nvSpPr>
@@ -10131,7 +10379,7 @@
       </p:sp>
       <p:sp>
         <p:nvSpPr>
-          <p:cNvPr id="204" name="" descr="{&quot;isTemplate&quot;:true,&quot;type&quot;:&quot;text&quot;}"/>
+          <p:cNvPr id="208" name="" descr="{&quot;isTemplate&quot;:true,&quot;type&quot;:&quot;text&quot;}"/>
           <p:cNvSpPr txBox="1"/>
           <p:nvPr/>
         </p:nvSpPr>
@@ -10166,7 +10414,7 @@
       </p:sp>
       <p:sp>
         <p:nvSpPr>
-          <p:cNvPr id="205" name="" descr="{&quot;isTemplate&quot;:true,&quot;type&quot;:&quot;text&quot;}"/>
+          <p:cNvPr id="209" name="" descr="{&quot;isTemplate&quot;:true,&quot;type&quot;:&quot;text&quot;}"/>
           <p:cNvSpPr txBox="1"/>
           <p:nvPr/>
         </p:nvSpPr>
@@ -10251,7 +10499,7 @@
       </p:sp>
       <p:sp>
         <p:nvSpPr>
-          <p:cNvPr id="206" name="" descr="{&quot;isTemplate&quot;:true,&quot;type&quot;:&quot;text&quot;}"/>
+          <p:cNvPr id="210" name="" descr="{&quot;isTemplate&quot;:true,&quot;type&quot;:&quot;text&quot;}"/>
           <p:cNvSpPr txBox="1"/>
           <p:nvPr/>
         </p:nvSpPr>
@@ -10286,7 +10534,7 @@
       </p:sp>
       <p:sp>
         <p:nvSpPr>
-          <p:cNvPr id="207" name="" descr="{&quot;isTemplate&quot;:true,&quot;type&quot;:&quot;text&quot;}"/>
+          <p:cNvPr id="211" name="" descr="{&quot;isTemplate&quot;:true,&quot;type&quot;:&quot;text&quot;}"/>
           <p:cNvSpPr txBox="1"/>
           <p:nvPr/>
         </p:nvSpPr>
@@ -10347,7 +10595,7 @@
       </p:sp>
       <p:sp>
         <p:nvSpPr>
-          <p:cNvPr id="208" name="" descr="{&quot;isTemplate&quot;:true,&quot;type&quot;:&quot;text&quot;}"/>
+          <p:cNvPr id="212" name="" descr="{&quot;isTemplate&quot;:true,&quot;type&quot;:&quot;text&quot;}"/>
           <p:cNvSpPr txBox="1"/>
           <p:nvPr/>
         </p:nvSpPr>
@@ -10382,7 +10630,7 @@
       </p:sp>
       <p:sp>
         <p:nvSpPr>
-          <p:cNvPr id="209" name="" descr="{&quot;isTemplate&quot;:true,&quot;type&quot;:&quot;text&quot;}"/>
+          <p:cNvPr id="213" name="" descr="{&quot;isTemplate&quot;:true,&quot;type&quot;:&quot;text&quot;}"/>
           <p:cNvSpPr txBox="1"/>
           <p:nvPr/>
         </p:nvSpPr>
@@ -10419,7 +10667,7 @@
       </p:sp>
       <p:sp>
         <p:nvSpPr>
-          <p:cNvPr id="210" name="" descr="{&quot;isTemplate&quot;:true,&quot;type&quot;:&quot;text&quot;}"/>
+          <p:cNvPr id="214" name="" descr="{&quot;isTemplate&quot;:true,&quot;type&quot;:&quot;text&quot;}"/>
           <p:cNvSpPr txBox="1"/>
           <p:nvPr/>
         </p:nvSpPr>
@@ -10454,7 +10702,7 @@
       </p:sp>
       <p:sp>
         <p:nvSpPr>
-          <p:cNvPr id="211" name="" descr="{&quot;isTemplate&quot;:true,&quot;type&quot;:&quot;text&quot;}"/>
+          <p:cNvPr id="215" name="" descr="{&quot;isTemplate&quot;:true,&quot;type&quot;:&quot;text&quot;}"/>
           <p:cNvSpPr txBox="1"/>
           <p:nvPr/>
         </p:nvSpPr>
@@ -10503,7 +10751,7 @@
       </p:sp>
       <p:sp>
         <p:nvSpPr>
-          <p:cNvPr id="212" name="" descr="{&quot;isTemplate&quot;:true,&quot;type&quot;:&quot;text&quot;}"/>
+          <p:cNvPr id="216" name="" descr="{&quot;isTemplate&quot;:true,&quot;type&quot;:&quot;text&quot;}"/>
           <p:cNvSpPr txBox="1"/>
           <p:nvPr/>
         </p:nvSpPr>
@@ -10538,7 +10786,7 @@
       </p:sp>
       <p:sp>
         <p:nvSpPr>
-          <p:cNvPr id="213" name="" descr="{&quot;isTemplate&quot;:true,&quot;type&quot;:&quot;text&quot;}"/>
+          <p:cNvPr id="217" name="" descr="{&quot;isTemplate&quot;:true,&quot;type&quot;:&quot;text&quot;}"/>
           <p:cNvSpPr txBox="1"/>
           <p:nvPr/>
         </p:nvSpPr>
@@ -10623,7 +10871,7 @@
       </p:sp>
       <p:sp>
         <p:nvSpPr>
-          <p:cNvPr id="214" name=""/>
+          <p:cNvPr id="218" name=""/>
           <p:cNvSpPr/>
           <p:nvPr/>
         </p:nvSpPr>
@@ -10665,7 +10913,7 @@
       </p:sp>
       <p:sp>
         <p:nvSpPr>
-          <p:cNvPr id="215" name="" descr="{&quot;isTemplate&quot;:true,&quot;type&quot;:&quot;text&quot;}"/>
+          <p:cNvPr id="219" name="" descr="{&quot;isTemplate&quot;:true,&quot;type&quot;:&quot;text&quot;}"/>
           <p:cNvSpPr txBox="1"/>
           <p:nvPr/>
         </p:nvSpPr>
@@ -10702,7 +10950,7 @@
       </p:sp>
       <p:sp>
         <p:nvSpPr>
-          <p:cNvPr id="216" name=""/>
+          <p:cNvPr id="220" name=""/>
           <p:cNvSpPr/>
           <p:nvPr/>
         </p:nvSpPr>
@@ -10735,7 +10983,7 @@
       </p:sp>
       <p:sp>
         <p:nvSpPr>
-          <p:cNvPr id="217" name="" descr="{&quot;isTemplate&quot;:true,&quot;type&quot;:&quot;text&quot;}"/>
+          <p:cNvPr id="221" name="" descr="{&quot;isTemplate&quot;:true,&quot;type&quot;:&quot;text&quot;}"/>
           <p:cNvSpPr txBox="1"/>
           <p:nvPr/>
         </p:nvSpPr>
@@ -10770,7 +11018,7 @@
       </p:sp>
       <p:sp>
         <p:nvSpPr>
-          <p:cNvPr id="218" name="" descr="{&quot;isTemplate&quot;:true,&quot;type&quot;:&quot;text&quot;}"/>
+          <p:cNvPr id="222" name="" descr="{&quot;isTemplate&quot;:true,&quot;type&quot;:&quot;text&quot;}"/>
           <p:cNvSpPr txBox="1"/>
           <p:nvPr/>
         </p:nvSpPr>
@@ -10805,7 +11053,7 @@
       </p:sp>
       <p:sp>
         <p:nvSpPr>
-          <p:cNvPr id="219" name="" descr="{&quot;isTemplate&quot;:true,&quot;type&quot;:&quot;text&quot;}"/>
+          <p:cNvPr id="223" name="" descr="{&quot;isTemplate&quot;:true,&quot;type&quot;:&quot;text&quot;}"/>
           <p:cNvSpPr txBox="1"/>
           <p:nvPr/>
         </p:nvSpPr>
@@ -10826,7 +11074,7 @@
       </p:sp>
       <p:sp>
         <p:nvSpPr>
-          <p:cNvPr id="220" name="" descr="{&quot;isTemplate&quot;:true,&quot;type&quot;:&quot;text&quot;}"/>
+          <p:cNvPr id="224" name="" descr="{&quot;isTemplate&quot;:true,&quot;type&quot;:&quot;text&quot;}"/>
           <p:cNvSpPr txBox="1"/>
           <p:nvPr/>
         </p:nvSpPr>
@@ -10871,7 +11119,7 @@
       </p:sp>
       <p:sp>
         <p:nvSpPr>
-          <p:cNvPr id="221" name=""/>
+          <p:cNvPr id="225" name=""/>
           <p:cNvSpPr/>
           <p:nvPr/>
         </p:nvSpPr>
@@ -10913,7 +11161,7 @@
       </p:sp>
       <p:sp>
         <p:nvSpPr>
-          <p:cNvPr id="222" name="" descr="{&quot;isTemplate&quot;:true,&quot;type&quot;:&quot;text&quot;}"/>
+          <p:cNvPr id="226" name="" descr="{&quot;isTemplate&quot;:true,&quot;type&quot;:&quot;text&quot;}"/>
           <p:cNvSpPr txBox="1"/>
           <p:nvPr/>
         </p:nvSpPr>
@@ -10970,7 +11218,7 @@
       </p:sp>
       <p:sp>
         <p:nvSpPr>
-          <p:cNvPr id="223" name="" descr="{&quot;isTemplate&quot;:true,&quot;type&quot;:&quot;text&quot;}"/>
+          <p:cNvPr id="227" name="" descr="{&quot;isTemplate&quot;:true,&quot;type&quot;:&quot;text&quot;}"/>
           <p:cNvSpPr txBox="1"/>
           <p:nvPr/>
         </p:nvSpPr>
@@ -11025,7 +11273,7 @@
       </p:sp>
       <p:sp>
         <p:nvSpPr>
-          <p:cNvPr id="224" name="" descr="{&quot;isTemplate&quot;:true,&quot;type&quot;:&quot;text&quot;}"/>
+          <p:cNvPr id="228" name="" descr="{&quot;isTemplate&quot;:true,&quot;type&quot;:&quot;text&quot;}"/>
           <p:cNvSpPr txBox="1"/>
           <p:nvPr/>
         </p:nvSpPr>
@@ -11068,7 +11316,7 @@
   <p:cSld>
     <p:spTree>
       <p:nvGrpSpPr>
-        <p:cNvPr id="225" name="" descr="&lt;Slide style={{ width: '1280px', height: '720px', background: 'linear-gradient(135deg, #172133 0%, #22395E 100%)', position: 'relative' }}&gt;&#10;  &lt;div style={{ position: 'absolute', inset: 0, display: 'flex', flexDirection: 'column', alignItems: 'center', justifyContent: 'center', color: '#FBFCFA' }}&gt;&#10;    &lt;div style={{ color: '#BD9B56', fontSize: 26, marginBottom: 22, letterSpacing: '0.4em' }}&gt;◆&lt;/div&gt;&#10;    &lt;h1 style={{ fontSize: 56, fontWeight: 'bold', margin: 0, color: '#FBFCFA', letterSpacing: '0.12em' }}&gt;感谢聆听&lt;/h1&gt;&#10;    &lt;div style={{ width: 80, height: 3, background: '#BD9B56', marginTop: 26, marginBottom: 26 }} /&gt;&#10;    &lt;p style={{ fontSize: 20, color: 'rgba(189,155,86,0.9)', margin: 0, letterSpacing: '0.15em' }}&gt;让 AI 真正走进社区&lt;/p&gt;&#10;    &lt;div style={{ marginTop: 56, padding: '20px 40px', background: 'rgba(189,155,86,0.08)', border: '1px solid rgba(189,155,86,0.3)', borderRadius: 8, textAlign: 'center' }}&gt;&#10;      &lt;div style={{ fontSize: 12, color: '#BD9B56', letterSpacing: '0.25em', marginBottom: 10 }}&gt;ONLINE DEMO&lt;/div&gt;&#10;      &lt;div style={{ fontSize: 17, color: '#FBFCFA', fontFamily: 'Inter, sans-serif', marginBottom: 4 }}&gt;http://119.91.236.85&lt;/div&gt;&#10;      &lt;div style={{ fontSize: 12, color: 'rgba(251,252,250,0.7)' }}&gt;业主 guoyi378 · 物业 mayun420 · 维修 yangfei423（密码 123456）&lt;/div&gt;&#10;    &lt;/div&gt;&#10;  &lt;/div&gt;&#10;  &lt;div style={{ position: 'absolute', left: 64, bottom: 28, color: '#BD9B56', fontSize: 13, letterSpacing: '0.12em' }}&gt;云溪花园 · 智慧社区&lt;/div&gt;&#10;  &lt;div style={{ position: 'absolute', right: 28, bottom: 28, color: 'rgba(189,155,86,0.75)', fontSize: 13 }}&gt;15 / 15&lt;/div&gt;&#10;&lt;/Slide&gt;"/>
+        <p:cNvPr id="229" name="" descr="&lt;Slide style={{ width: '1280px', height: '720px', background: 'linear-gradient(135deg, #172133 0%, #22395E 100%)', position: 'relative' }}&gt;&#10;  &lt;div style={{ position: 'absolute', inset: 0, display: 'flex', flexDirection: 'column', alignItems: 'center', justifyContent: 'center', color: '#FBFCFA' }}&gt;&#10;    &lt;div style={{ color: '#BD9B56', fontSize: 26, marginBottom: 22, letterSpacing: '0.4em' }}&gt;◆&lt;/div&gt;&#10;    &lt;h1 style={{ fontSize: 56, fontWeight: 'bold', margin: 0, color: '#FBFCFA', letterSpacing: '0.12em' }}&gt;感谢聆听&lt;/h1&gt;&#10;    &lt;div style={{ width: 80, height: 3, background: '#BD9B56', marginTop: 26, marginBottom: 26 }} /&gt;&#10;    &lt;p style={{ fontSize: 20, color: 'rgba(189,155,86,0.9)', margin: 0, letterSpacing: '0.15em' }}&gt;让 AI 真正走进社区&lt;/p&gt;&#10;    &lt;div style={{ marginTop: 56, padding: '20px 40px', background: 'rgba(189,155,86,0.08)', border: '1px solid rgba(189,155,86,0.3)', borderRadius: 8, textAlign: 'center' }}&gt;&#10;      &lt;div style={{ fontSize: 12, color: '#BD9B56', letterSpacing: '0.25em', marginBottom: 10 }}&gt;ONLINE DEMO&lt;/div&gt;&#10;      &lt;div style={{ fontSize: 17, color: '#FBFCFA', fontFamily: 'Inter, sans-serif', marginBottom: 4 }}&gt;http://119.91.236.85&lt;/div&gt;&#10;      &lt;div style={{ fontSize: 12, color: 'rgba(251,252,250,0.7)' }}&gt;业主 guoyi378 · 物业 mayun420 · 维修 yangfei423（密码 123456）&lt;/div&gt;&#10;    &lt;/div&gt;&#10;  &lt;/div&gt;&#10;  &lt;div style={{ position: 'absolute', left: 64, bottom: 28, color: '#BD9B56', fontSize: 13, letterSpacing: '0.12em' }}&gt;云溪花园 · 智慧社区&lt;/div&gt;&#10;  &lt;div style={{ position: 'absolute', right: 28, bottom: 28, color: 'rgba(189,155,86,0.75)', fontSize: 13 }}&gt;15 / 15&lt;/div&gt;&#10;&lt;/Slide&gt;"/>
         <p:cNvGrpSpPr/>
         <p:nvPr/>
       </p:nvGrpSpPr>
@@ -11082,7 +11330,7 @@
       </p:grpSpPr>
       <p:sp>
         <p:nvSpPr>
-          <p:cNvPr id="226" name=""/>
+          <p:cNvPr id="230" name=""/>
           <p:cNvSpPr/>
           <p:nvPr/>
         </p:nvSpPr>
@@ -11114,7 +11362,7 @@
       </p:sp>
       <p:sp>
         <p:nvSpPr>
-          <p:cNvPr id="227" name="" descr="{&quot;isTemplate&quot;:true,&quot;type&quot;:&quot;text&quot;}"/>
+          <p:cNvPr id="231" name="" descr="{&quot;isTemplate&quot;:true,&quot;type&quot;:&quot;text&quot;}"/>
           <p:cNvSpPr txBox="1"/>
           <p:nvPr/>
         </p:nvSpPr>
@@ -11149,7 +11397,7 @@
       </p:sp>
       <p:sp>
         <p:nvSpPr>
-          <p:cNvPr id="228" name="" descr="{&quot;isTemplate&quot;:true,&quot;type&quot;:&quot;text&quot;}"/>
+          <p:cNvPr id="232" name="" descr="{&quot;isTemplate&quot;:true,&quot;type&quot;:&quot;text&quot;}"/>
           <p:cNvSpPr txBox="1"/>
           <p:nvPr/>
         </p:nvSpPr>
@@ -11184,7 +11432,7 @@
       </p:sp>
       <p:sp>
         <p:nvSpPr>
-          <p:cNvPr id="229" name=""/>
+          <p:cNvPr id="233" name=""/>
           <p:cNvSpPr/>
           <p:nvPr/>
         </p:nvSpPr>
@@ -11208,7 +11456,7 @@
       </p:sp>
       <p:sp>
         <p:nvSpPr>
-          <p:cNvPr id="230" name="" descr="{&quot;isTemplate&quot;:true,&quot;type&quot;:&quot;text&quot;}"/>
+          <p:cNvPr id="234" name="" descr="{&quot;isTemplate&quot;:true,&quot;type&quot;:&quot;text&quot;}"/>
           <p:cNvSpPr txBox="1"/>
           <p:nvPr/>
         </p:nvSpPr>
@@ -11269,7 +11517,7 @@
       </p:sp>
       <p:sp>
         <p:nvSpPr>
-          <p:cNvPr id="231" name=""/>
+          <p:cNvPr id="235" name=""/>
           <p:cNvSpPr/>
           <p:nvPr/>
         </p:nvSpPr>
@@ -11304,7 +11552,7 @@
       </p:sp>
       <p:sp>
         <p:nvSpPr>
-          <p:cNvPr id="232" name="" descr="{&quot;isTemplate&quot;:true,&quot;type&quot;:&quot;text&quot;}"/>
+          <p:cNvPr id="236" name="" descr="{&quot;isTemplate&quot;:true,&quot;type&quot;:&quot;text&quot;}"/>
           <p:cNvSpPr txBox="1"/>
           <p:nvPr/>
         </p:nvSpPr>
@@ -11339,7 +11587,7 @@
       </p:sp>
       <p:sp>
         <p:nvSpPr>
-          <p:cNvPr id="233" name="" descr="{&quot;isTemplate&quot;:true,&quot;type&quot;:&quot;text&quot;}"/>
+          <p:cNvPr id="237" name="" descr="{&quot;isTemplate&quot;:true,&quot;type&quot;:&quot;text&quot;}"/>
           <p:cNvSpPr txBox="1"/>
           <p:nvPr/>
         </p:nvSpPr>
@@ -11374,7 +11622,7 @@
       </p:sp>
       <p:sp>
         <p:nvSpPr>
-          <p:cNvPr id="234" name="" descr="{&quot;isTemplate&quot;:true,&quot;type&quot;:&quot;text&quot;}"/>
+          <p:cNvPr id="238" name="" descr="{&quot;isTemplate&quot;:true,&quot;type&quot;:&quot;text&quot;}"/>
           <p:cNvSpPr txBox="1"/>
           <p:nvPr/>
         </p:nvSpPr>
@@ -11507,7 +11755,7 @@
       </p:sp>
       <p:sp>
         <p:nvSpPr>
-          <p:cNvPr id="235" name="" descr="{&quot;isTemplate&quot;:true,&quot;type&quot;:&quot;text&quot;}"/>
+          <p:cNvPr id="239" name="" descr="{&quot;isTemplate&quot;:true,&quot;type&quot;:&quot;text&quot;}"/>
           <p:cNvSpPr txBox="1"/>
           <p:nvPr/>
         </p:nvSpPr>
@@ -11562,7 +11810,7 @@
       </p:sp>
       <p:sp>
         <p:nvSpPr>
-          <p:cNvPr id="236" name="" descr="{&quot;isTemplate&quot;:true,&quot;type&quot;:&quot;text&quot;}"/>
+          <p:cNvPr id="240" name="" descr="{&quot;isTemplate&quot;:true,&quot;type&quot;:&quot;text&quot;}"/>
           <p:cNvSpPr txBox="1"/>
           <p:nvPr/>
         </p:nvSpPr>
@@ -11607,7 +11855,7 @@
   <p:cSld>
     <p:spTree>
       <p:nvGrpSpPr>
-        <p:cNvPr id="237" name="" descr="&lt;Slide style={{ width: '1280px', height: '720px', background: '#FBFCFA', position: 'relative', padding: '40px 64px', boxSizing: 'border-box', display: 'flex', flexDirection: 'column' }}&gt;&#10;  &lt;div style={{ flexShrink: 0 }}&gt;&#10;    &lt;div style={{ color: '#BD9B56', fontSize: 14, letterSpacing: '0.3em', marginBottom: 10 }}&gt;CONTENTS&lt;/div&gt;&#10;    &lt;h2 style={{ fontSize: 34, fontWeight: 'bold', color: '#172133', margin: 0 }}&gt;目录&lt;/h2&gt;&#10;    &lt;div style={{ width: 64, height: 3, background: '#BD9B56', marginTop: 16 }} /&gt;&#10;  &lt;/div&gt;&#10;  &lt;div style={{ flex: 1, display: 'flex', alignItems: 'center' }}&gt;&#10;    &lt;div style={{ width: '100%', display: 'flex', flexDirection: 'column', gap: 20 }}&gt;&#10;      &lt;div style={{ display: 'flex', alignItems: 'center', gap: 28, paddingBottom: 18, borderBottom: '1px solid rgba(34,57,94,0.12)' }}&gt;&#10;        &lt;span style={{ color: '#BD9B56', fontSize: 40, fontWeight: 'bold', lineHeight: 1, minWidth: 72, fontFamily: 'Inter, sans-serif' }}&gt;01&lt;/span&gt;&#10;        &lt;div style={{ flex: 1 }}&gt;&#10;          &lt;div style={{ fontSize: 22, fontWeight: 'bold', color: '#172133' }}&gt;项目背景与规模&lt;/div&gt;&#10;          &lt;div style={{ fontSize: 14, color: '#6b7075', marginTop: 6 }}&gt;传统物业痛点 · 虚拟社区「云溪花园」数据资产&lt;/div&gt;&#10;        &lt;/div&gt;&#10;      &lt;/div&gt;&#10;      &lt;div style={{ display: 'flex', alignItems: 'center', gap: 28, paddingBottom: 18, borderBottom: '1px solid rgba(34,57,94,0.12)' }}&gt;&#10;        &lt;span style={{ color: '#BD9B56', fontSize: 40, fontWeight: 'bold', lineHeight: 1, minWidth: 72, fontFamily: 'Inter, sans-serif' }}&gt;02&lt;/span&gt;&#10;        &lt;div style={{ flex: 1 }}&gt;&#10;          &lt;div style={{ fontSize: 22, fontWeight: 'bold', color: '#172133' }}&gt;技术构建过程&lt;/div&gt;&#10;          &lt;div style={{ fontSize: 14, color: '#6b7075', marginTop: 6 }}&gt;数据库设计 → 后端 → 前端 → AI Agent → RAG 知识库&lt;/div&gt;&#10;        &lt;/div&gt;&#10;      &lt;/div&gt;&#10;      &lt;div style={{ display: 'flex', alignItems: 'center', gap: 28, paddingBottom: 18, borderBottom: '1px solid rgba(34,57,94,0.12)' }}&gt;&#10;        &lt;span style={{ color: '#BD9B56', fontSize: 40, fontWeight: 'bold', lineHeight: 1, minWidth: 72, fontFamily: 'Inter, sans-serif' }}&gt;03&lt;/span&gt;&#10;        &lt;div style={{ flex: 1 }}&gt;&#10;          &lt;div style={{ fontSize: 22, fontWeight: 'bold', color: '#172133' }}&gt;成果与验证&lt;/div&gt;&#10;          &lt;div style={{ fontSize: 14, color: '#6b7075', marginTop: 6 }}&gt;三条功能闭环 · 量化评估指标&lt;/div&gt;&#10;        &lt;/div&gt;&#10;      &lt;/div&gt;&#10;      &lt;div style={{ display: 'flex', alignItems: 'center', gap: 28 }}&gt;&#10;        &lt;span style={{ color: '#BD9B56', fontSize: 40, fontWeight: 'bold', lineHeight: 1, minWidth: 72, fontFamily: 'Inter, sans-serif' }}&gt;04&lt;/span&gt;&#10;        &lt;div style={{ flex: 1 }}&gt;&#10;          &lt;div style={{ fontSize: 22, fontWeight: 'bold', color: '#172133' }}&gt;总结与展望&lt;/div&gt;&#10;          &lt;div style={{ fontSize: 14, color: '#6b7075', marginTop: 6 }}&gt;项目价值 · 在线演示入口&lt;/div&gt;&#10;        &lt;/div&gt;&#10;      &lt;/div&gt;&#10;    &lt;/div&gt;&#10;  &lt;/div&gt;&#10;  &lt;div style={{ flexShrink: 0, height: 44, display: 'flex', alignItems: 'flex-end', justifyContent: 'space-between' }}&gt;&#10;    &lt;span style={{ color: '#BD9B56', fontSize: 12, letterSpacing: '0.1em' }}&gt;云溪花园 · 智慧社区&lt;/span&gt;&#10;    &lt;span style={{ color: '#a09b8c', fontSize: 12 }}&gt;02 / 15&lt;/span&gt;&#10;  &lt;/div&gt;&#10;&lt;/Slide&gt;"/>
+        <p:cNvPr id="241" name="" descr="&lt;Slide style={{ width: '1280px', height: '720px', background: '#FBFCFA', position: 'relative', padding: '40px 64px', boxSizing: 'border-box', display: 'flex', flexDirection: 'column' }}&gt;&#10;  &lt;div style={{ flexShrink: 0 }}&gt;&#10;    &lt;div style={{ color: '#BD9B56', fontSize: 14, letterSpacing: '0.3em', marginBottom: 10 }}&gt;CONTENTS&lt;/div&gt;&#10;    &lt;h2 style={{ fontSize: 34, fontWeight: 'bold', color: '#172133', margin: 0 }}&gt;目录&lt;/h2&gt;&#10;    &lt;div style={{ width: 64, height: 3, background: '#BD9B56', marginTop: 16 }} /&gt;&#10;  &lt;/div&gt;&#10;  &lt;div style={{ flex: 1, display: 'flex', alignItems: 'center' }}&gt;&#10;    &lt;div style={{ width: '100%', display: 'flex', flexDirection: 'column', gap: 20 }}&gt;&#10;      &lt;div style={{ display: 'flex', alignItems: 'center', gap: 28, paddingBottom: 18, borderBottom: '1px solid rgba(34,57,94,0.12)' }}&gt;&#10;        &lt;span style={{ color: '#BD9B56', fontSize: 40, fontWeight: 'bold', lineHeight: 1, minWidth: 72, fontFamily: 'Inter, sans-serif' }}&gt;01&lt;/span&gt;&#10;        &lt;div style={{ flex: 1 }}&gt;&#10;          &lt;div style={{ fontSize: 22, fontWeight: 'bold', color: '#172133' }}&gt;项目背景与规模&lt;/div&gt;&#10;          &lt;div style={{ fontSize: 14, color: '#6b7075', marginTop: 6 }}&gt;传统物业痛点 · 虚拟社区「云溪花园」数据资产&lt;/div&gt;&#10;        &lt;/div&gt;&#10;      &lt;/div&gt;&#10;      &lt;div style={{ display: 'flex', alignItems: 'center', gap: 28, paddingBottom: 18, borderBottom: '1px solid rgba(34,57,94,0.12)' }}&gt;&#10;        &lt;span style={{ color: '#BD9B56', fontSize: 40, fontWeight: 'bold', lineHeight: 1, minWidth: 72, fontFamily: 'Inter, sans-serif' }}&gt;02&lt;/span&gt;&#10;        &lt;div style={{ flex: 1 }}&gt;&#10;          &lt;div style={{ fontSize: 22, fontWeight: 'bold', color: '#172133' }}&gt;技术构建过程&lt;/div&gt;&#10;          &lt;div style={{ fontSize: 14, color: '#6b7075', marginTop: 6 }}&gt;数据库设计 → 后端 → 前端 → AI Agent → RAG 知识库&lt;/div&gt;&#10;        &lt;/div&gt;&#10;      &lt;/div&gt;&#10;      &lt;div style={{ display: 'flex', alignItems: 'center', gap: 28, paddingBottom: 18, borderBottom: '1px solid rgba(34,57,94,0.12)' }}&gt;&#10;        &lt;span style={{ color: '#BD9B56', fontSize: 40, fontWeight: 'bold', lineHeight: 1, minWidth: 72, fontFamily: 'Inter, sans-serif' }}&gt;03&lt;/span&gt;&#10;        &lt;div style={{ flex: 1 }}&gt;&#10;          &lt;div style={{ fontSize: 22, fontWeight: 'bold', color: '#172133' }}&gt;成果与验证&lt;/div&gt;&#10;          &lt;div style={{ fontSize: 14, color: '#6b7075', marginTop: 6 }}&gt;三条功能闭环 · 量化评估指标&lt;/div&gt;&#10;        &lt;/div&gt;&#10;      &lt;/div&gt;&#10;      &lt;div style={{ display: 'flex', alignItems: 'center', gap: 28 }}&gt;&#10;        &lt;span style={{ color: '#BD9B56', fontSize: 40, fontWeight: 'bold', lineHeight: 1, minWidth: 72, fontFamily: 'Inter, sans-serif' }}&gt;04&lt;/span&gt;&#10;        &lt;div style={{ flex: 1 }}&gt;&#10;          &lt;div style={{ fontSize: 22, fontWeight: 'bold', color: '#172133' }}&gt;总结与展望&lt;/div&gt;&#10;          &lt;div style={{ fontSize: 14, color: '#6b7075', marginTop: 6 }}&gt;项目价值 · 在线演示入口&lt;/div&gt;&#10;        &lt;/div&gt;&#10;      &lt;/div&gt;&#10;    &lt;/div&gt;&#10;  &lt;/div&gt;&#10;  &lt;div style={{ flexShrink: 0, height: 44, display: 'flex', alignItems: 'flex-end', justifyContent: 'space-between' }}&gt;&#10;    &lt;span style={{ color: '#BD9B56', fontSize: 12, letterSpacing: '0.1em' }}&gt;云溪花园 · 智慧社区&lt;/span&gt;&#10;    &lt;span style={{ color: '#a09b8c', fontSize: 12 }}&gt;02 / 15&lt;/span&gt;&#10;  &lt;/div&gt;&#10;&lt;/Slide&gt;"/>
         <p:cNvGrpSpPr/>
         <p:nvPr/>
       </p:nvGrpSpPr>
@@ -11621,7 +11869,7 @@
       </p:grpSpPr>
       <p:sp>
         <p:nvSpPr>
-          <p:cNvPr id="238" name=""/>
+          <p:cNvPr id="242" name=""/>
           <p:cNvSpPr/>
           <p:nvPr/>
         </p:nvSpPr>
@@ -11645,7 +11893,7 @@
       </p:sp>
       <p:sp>
         <p:nvSpPr>
-          <p:cNvPr id="239" name="" descr="{&quot;isTemplate&quot;:true,&quot;type&quot;:&quot;text&quot;}"/>
+          <p:cNvPr id="243" name="" descr="{&quot;isTemplate&quot;:true,&quot;type&quot;:&quot;text&quot;}"/>
           <p:cNvSpPr txBox="1"/>
           <p:nvPr/>
         </p:nvSpPr>
@@ -11680,7 +11928,7 @@
       </p:sp>
       <p:sp>
         <p:nvSpPr>
-          <p:cNvPr id="240" name="" descr="{&quot;isTemplate&quot;:true,&quot;type&quot;:&quot;text&quot;}"/>
+          <p:cNvPr id="244" name="" descr="{&quot;isTemplate&quot;:true,&quot;type&quot;:&quot;text&quot;}"/>
           <p:cNvSpPr txBox="1"/>
           <p:nvPr/>
         </p:nvSpPr>
@@ -11715,7 +11963,7 @@
       </p:sp>
       <p:sp>
         <p:nvSpPr>
-          <p:cNvPr id="241" name=""/>
+          <p:cNvPr id="245" name=""/>
           <p:cNvSpPr/>
           <p:nvPr/>
         </p:nvSpPr>
@@ -11739,7 +11987,7 @@
       </p:sp>
       <p:sp>
         <p:nvSpPr>
-          <p:cNvPr id="242" name=""/>
+          <p:cNvPr id="246" name=""/>
           <p:cNvSpPr/>
           <p:nvPr/>
         </p:nvSpPr>
@@ -11781,7 +12029,7 @@
       </p:sp>
       <p:sp>
         <p:nvSpPr>
-          <p:cNvPr id="243" name="" descr="{&quot;isTemplate&quot;:true,&quot;type&quot;:&quot;text&quot;}"/>
+          <p:cNvPr id="247" name="" descr="{&quot;isTemplate&quot;:true,&quot;type&quot;:&quot;text&quot;}"/>
           <p:cNvSpPr txBox="1"/>
           <p:nvPr/>
         </p:nvSpPr>
@@ -11816,7 +12064,7 @@
       </p:sp>
       <p:sp>
         <p:nvSpPr>
-          <p:cNvPr id="244" name="" descr="{&quot;isTemplate&quot;:true,&quot;type&quot;:&quot;text&quot;}"/>
+          <p:cNvPr id="248" name="" descr="{&quot;isTemplate&quot;:true,&quot;type&quot;:&quot;text&quot;}"/>
           <p:cNvSpPr txBox="1"/>
           <p:nvPr/>
         </p:nvSpPr>
@@ -11851,7 +12099,7 @@
       </p:sp>
       <p:sp>
         <p:nvSpPr>
-          <p:cNvPr id="245" name="" descr="{&quot;isTemplate&quot;:true,&quot;type&quot;:&quot;text&quot;}"/>
+          <p:cNvPr id="249" name="" descr="{&quot;isTemplate&quot;:true,&quot;type&quot;:&quot;text&quot;}"/>
           <p:cNvSpPr txBox="1"/>
           <p:nvPr/>
         </p:nvSpPr>
@@ -11906,7 +12154,7 @@
       </p:sp>
       <p:sp>
         <p:nvSpPr>
-          <p:cNvPr id="246" name=""/>
+          <p:cNvPr id="250" name=""/>
           <p:cNvSpPr/>
           <p:nvPr/>
         </p:nvSpPr>
@@ -11948,7 +12196,7 @@
       </p:sp>
       <p:sp>
         <p:nvSpPr>
-          <p:cNvPr id="247" name="" descr="{&quot;isTemplate&quot;:true,&quot;type&quot;:&quot;text&quot;}"/>
+          <p:cNvPr id="251" name="" descr="{&quot;isTemplate&quot;:true,&quot;type&quot;:&quot;text&quot;}"/>
           <p:cNvSpPr txBox="1"/>
           <p:nvPr/>
         </p:nvSpPr>
@@ -11983,7 +12231,7 @@
       </p:sp>
       <p:sp>
         <p:nvSpPr>
-          <p:cNvPr id="248" name="" descr="{&quot;isTemplate&quot;:true,&quot;type&quot;:&quot;text&quot;}"/>
+          <p:cNvPr id="252" name="" descr="{&quot;isTemplate&quot;:true,&quot;type&quot;:&quot;text&quot;}"/>
           <p:cNvSpPr txBox="1"/>
           <p:nvPr/>
         </p:nvSpPr>
@@ -12018,7 +12266,7 @@
       </p:sp>
       <p:sp>
         <p:nvSpPr>
-          <p:cNvPr id="249" name="" descr="{&quot;isTemplate&quot;:true,&quot;type&quot;:&quot;text&quot;}"/>
+          <p:cNvPr id="253" name="" descr="{&quot;isTemplate&quot;:true,&quot;type&quot;:&quot;text&quot;}"/>
           <p:cNvSpPr txBox="1"/>
           <p:nvPr/>
         </p:nvSpPr>
@@ -12113,7 +12361,7 @@
       </p:sp>
       <p:sp>
         <p:nvSpPr>
-          <p:cNvPr id="250" name=""/>
+          <p:cNvPr id="254" name=""/>
           <p:cNvSpPr/>
           <p:nvPr/>
         </p:nvSpPr>
@@ -12155,7 +12403,7 @@
       </p:sp>
       <p:sp>
         <p:nvSpPr>
-          <p:cNvPr id="251" name="" descr="{&quot;isTemplate&quot;:true,&quot;type&quot;:&quot;text&quot;}"/>
+          <p:cNvPr id="255" name="" descr="{&quot;isTemplate&quot;:true,&quot;type&quot;:&quot;text&quot;}"/>
           <p:cNvSpPr txBox="1"/>
           <p:nvPr/>
         </p:nvSpPr>
@@ -12190,7 +12438,7 @@
       </p:sp>
       <p:sp>
         <p:nvSpPr>
-          <p:cNvPr id="252" name="" descr="{&quot;isTemplate&quot;:true,&quot;type&quot;:&quot;text&quot;}"/>
+          <p:cNvPr id="256" name="" descr="{&quot;isTemplate&quot;:true,&quot;type&quot;:&quot;text&quot;}"/>
           <p:cNvSpPr txBox="1"/>
           <p:nvPr/>
         </p:nvSpPr>
@@ -12225,7 +12473,7 @@
       </p:sp>
       <p:sp>
         <p:nvSpPr>
-          <p:cNvPr id="253" name="" descr="{&quot;isTemplate&quot;:true,&quot;type&quot;:&quot;text&quot;}"/>
+          <p:cNvPr id="257" name="" descr="{&quot;isTemplate&quot;:true,&quot;type&quot;:&quot;text&quot;}"/>
           <p:cNvSpPr txBox="1"/>
           <p:nvPr/>
         </p:nvSpPr>
@@ -12280,7 +12528,7 @@
       </p:sp>
       <p:sp>
         <p:nvSpPr>
-          <p:cNvPr id="254" name="" descr="{&quot;isTemplate&quot;:true,&quot;type&quot;:&quot;text&quot;}"/>
+          <p:cNvPr id="258" name="" descr="{&quot;isTemplate&quot;:true,&quot;type&quot;:&quot;text&quot;}"/>
           <p:cNvSpPr txBox="1"/>
           <p:nvPr/>
         </p:nvSpPr>
@@ -12315,7 +12563,7 @@
       </p:sp>
       <p:sp>
         <p:nvSpPr>
-          <p:cNvPr id="255" name="" descr="{&quot;isTemplate&quot;:true,&quot;type&quot;:&quot;text&quot;}"/>
+          <p:cNvPr id="259" name="" descr="{&quot;isTemplate&quot;:true,&quot;type&quot;:&quot;text&quot;}"/>
           <p:cNvSpPr txBox="1"/>
           <p:nvPr/>
         </p:nvSpPr>
@@ -12350,7 +12598,7 @@
       </p:sp>
       <p:sp>
         <p:nvSpPr>
-          <p:cNvPr id="256" name="" descr="{&quot;isTemplate&quot;:true,&quot;type&quot;:&quot;text&quot;}"/>
+          <p:cNvPr id="260" name="" descr="{&quot;isTemplate&quot;:true,&quot;type&quot;:&quot;text&quot;}"/>
           <p:cNvSpPr txBox="1"/>
           <p:nvPr/>
         </p:nvSpPr>
@@ -12405,7 +12653,7 @@
       </p:sp>
       <p:sp>
         <p:nvSpPr>
-          <p:cNvPr id="257" name="" descr="{&quot;isTemplate&quot;:true,&quot;type&quot;:&quot;text&quot;}"/>
+          <p:cNvPr id="261" name="" descr="{&quot;isTemplate&quot;:true,&quot;type&quot;:&quot;text&quot;}"/>
           <p:cNvSpPr txBox="1"/>
           <p:nvPr/>
         </p:nvSpPr>
@@ -12460,7 +12708,7 @@
       </p:sp>
       <p:sp>
         <p:nvSpPr>
-          <p:cNvPr id="258" name="" descr="{&quot;isTemplate&quot;:true,&quot;type&quot;:&quot;text&quot;}"/>
+          <p:cNvPr id="262" name="" descr="{&quot;isTemplate&quot;:true,&quot;type&quot;:&quot;text&quot;}"/>
           <p:cNvSpPr txBox="1"/>
           <p:nvPr/>
         </p:nvSpPr>
@@ -12503,7 +12751,7 @@
   <p:cSld>
     <p:spTree>
       <p:nvGrpSpPr>
-        <p:cNvPr id="259" name="" descr="&lt;Slide style={{ width: '1280px', height: '720px', background: '#FBFCFA', position: 'relative', padding: '40px 64px', boxSizing: 'border-box', display: 'flex', flexDirection: 'column' }}&gt;&#10;  &lt;div style={{ flexShrink: 0 }}&gt;&#10;    &lt;div style={{ color: '#BD9B56', fontSize: 13, letterSpacing: '0.25em', marginBottom: 8 }}&gt;01 · 项目背景&lt;/div&gt;&#10;    &lt;h2 style={{ fontSize: 30, fontWeight: 'bold', color: '#172133', margin: 0, lineHeight: 1.3 }}&gt;传统物业的三重困境&lt;/h2&gt;&#10;    &lt;div style={{ fontSize: 14, color: '#6b7075', marginTop: 8 }}&gt;业务、数据、知识「三张皮」，需要用 AI 重新缝合&lt;/div&gt;&#10;  &lt;/div&gt;&#10;  &lt;div style={{ flex: 1, display: 'flex', alignItems: 'center' }}&gt;&#10;    &lt;div style={{ width: '100%', display: 'flex', flexDirection: 'column', gap: 18 }}&gt;&#10;      &lt;div style={{ display: 'flex', gap: 20, background: '#fff', borderRadius: 10, padding: '20px 24px', boxShadow: '0 4px 16px rgba(23,33,51,0.06)', borderLeft: '4px solid #BD9B56' }}&gt;&#10;        &lt;span style={{ color: '#BD9B56', fontSize: 22, lineHeight: 1.2, flexShrink: 0 }}&gt;!&lt;/span&gt;&#10;        &lt;div&gt;&#10;          &lt;div style={{ fontSize: 17, fontWeight: 'bold', color: '#172133', marginBottom: 6 }}&gt;信息孤岛&lt;/div&gt;&#10;          &lt;p style={{ fontSize: 14, color: '#5F5E5A', margin: 0, lineHeight: 1.6 }}&gt;业主报修、费用缴纳、巡检记录分散在多个系统，彼此不打通，物业无法掌握完整的社区运行状态，业主也看不到工单的处理进度。&lt;/p&gt;&#10;        &lt;/div&gt;&#10;      &lt;/div&gt;&#10;      &lt;div style={{ display: 'flex', gap: 20, background: '#fff', borderRadius: 10, padding: '20px 24px', boxShadow: '0 4px 16px rgba(23,33,51,0.06)', borderLeft: '4px solid #BD9B56' }}&gt;&#10;        &lt;span style={{ color: '#BD9B56', fontSize: 22, lineHeight: 1.2, flexShrink: 0 }}&gt;!&lt;/span&gt;&#10;        &lt;div&gt;&#10;          &lt;div style={{ fontSize: 17, fontWeight: 'bold', color: '#172133', marginBottom: 6 }}&gt;响应迟缓&lt;/div&gt;&#10;          &lt;p style={{ fontSize: 14, color: '#5F5E5A', margin: 0, lineHeight: 1.6 }}&gt;传统报修依赖电话和微信群，客服人工登记后再手动派单，从「业主报修」到「师傅上门」平均要数小时甚至隔天，响应效率低。&lt;/p&gt;&#10;        &lt;/div&gt;&#10;      &lt;/div&gt;&#10;      &lt;div style={{ display: 'flex', gap: 20, background: '#fff', borderRadius: 10, padding: '20px 24px', boxShadow: '0 4px 16px rgba(23,33,51,0.06)', borderLeft: '4px solid #BD9B56' }}&gt;&#10;        &lt;span style={{ color: '#BD9B56', fontSize: 22, lineHeight: 1.2, flexShrink: 0 }}&gt;!&lt;/span&gt;&#10;        &lt;div&gt;&#10;          &lt;div style={{ fontSize: 17, fontWeight: 'bold', color: '#172133', marginBottom: 6 }}&gt;隐性知识散落&lt;/div&gt;&#10;          &lt;p style={{ fontSize: 14, color: '#5F5E5A', margin: 0, lineHeight: 1.6 }}&gt;装修施工时间、停车规则、宠物管理等规定，往往只存在于物业员工的个人经验里，新人上岗难以快速掌握，业主咨询也得不到统一准确的答案。&lt;/p&gt;&#10;        &lt;/div&gt;&#10;      &lt;/div&gt;&#10;    &lt;/div&gt;&#10;  &lt;/div&gt;&#10;  &lt;div style={{ flexShrink: 0, height: 44, display: 'flex', alignItems: 'flex-end', justifyContent: 'space-between' }}&gt;&#10;    &lt;span style={{ color: '#BD9B56', fontSize: 12, letterSpacing: '0.1em' }}&gt;云溪花园 · 智慧社区&lt;/span&gt;&#10;    &lt;span style={{ color: '#a09b8c', fontSize: 12 }}&gt;03 / 15&lt;/span&gt;&#10;  &lt;/div&gt;&#10;&lt;/Slide&gt;"/>
+        <p:cNvPr id="263" name="" descr="&lt;Slide style={{ width: '1280px', height: '720px', background: '#FBFCFA', position: 'relative', padding: '40px 64px', boxSizing: 'border-box', display: 'flex', flexDirection: 'column' }}&gt;&#10;  &lt;div style={{ flexShrink: 0 }}&gt;&#10;    &lt;div style={{ color: '#BD9B56', fontSize: 13, letterSpacing: '0.25em', marginBottom: 8 }}&gt;01 · 项目背景&lt;/div&gt;&#10;    &lt;h2 style={{ fontSize: 30, fontWeight: 'bold', color: '#172133', margin: 0, lineHeight: 1.3 }}&gt;传统物业的三重困境&lt;/h2&gt;&#10;    &lt;div style={{ fontSize: 14, color: '#6b7075', marginTop: 8 }}&gt;业务、数据、知识「三张皮」，需要用 AI 重新缝合&lt;/div&gt;&#10;  &lt;/div&gt;&#10;  &lt;div style={{ flex: 1, display: 'flex', alignItems: 'center' }}&gt;&#10;    &lt;div style={{ width: '100%', display: 'flex', flexDirection: 'column', gap: 18 }}&gt;&#10;      &lt;div style={{ display: 'flex', gap: 20, background: '#fff', borderRadius: 10, padding: '20px 24px', boxShadow: '0 4px 16px rgba(23,33,51,0.06)', borderLeft: '4px solid #BD9B56' }}&gt;&#10;        &lt;span style={{ color: '#BD9B56', fontSize: 22, lineHeight: 1.2, flexShrink: 0 }}&gt;!&lt;/span&gt;&#10;        &lt;div&gt;&#10;          &lt;div style={{ fontSize: 17, fontWeight: 'bold', color: '#172133', marginBottom: 6 }}&gt;信息孤岛&lt;/div&gt;&#10;          &lt;p style={{ fontSize: 14, color: '#5F5E5A', margin: 0, lineHeight: 1.6 }}&gt;业主报修、费用缴纳、巡检记录分散在多个系统，彼此不打通，物业无法掌握完整的社区运行状态，业主也看不到工单的处理进度。&lt;/p&gt;&#10;        &lt;/div&gt;&#10;      &lt;/div&gt;&#10;      &lt;div style={{ display: 'flex', gap: 20, background: '#fff', borderRadius: 10, padding: '20px 24px', boxShadow: '0 4px 16px rgba(23,33,51,0.06)', borderLeft: '4px solid #BD9B56' }}&gt;&#10;        &lt;span style={{ color: '#BD9B56', fontSize: 22, lineHeight: 1.2, flexShrink: 0 }}&gt;!&lt;/span&gt;&#10;        &lt;div&gt;&#10;          &lt;div style={{ fontSize: 17, fontWeight: 'bold', color: '#172133', marginBottom: 6 }}&gt;响应迟缓&lt;/div&gt;&#10;          &lt;p style={{ fontSize: 14, color: '#5F5E5A', margin: 0, lineHeight: 1.6 }}&gt;传统报修依赖电话和微信群，客服人工登记后再手动派单，从「业主报修」到「师傅上门」平均要数小时甚至隔天，响应效率低。&lt;/p&gt;&#10;        &lt;/div&gt;&#10;      &lt;/div&gt;&#10;      &lt;div style={{ display: 'flex', gap: 20, background: '#fff', borderRadius: 10, padding: '20px 24px', boxShadow: '0 4px 16px rgba(23,33,51,0.06)', borderLeft: '4px solid #BD9B56' }}&gt;&#10;        &lt;span style={{ color: '#BD9B56', fontSize: 22, lineHeight: 1.2, flexShrink: 0 }}&gt;!&lt;/span&gt;&#10;        &lt;div&gt;&#10;          &lt;div style={{ fontSize: 17, fontWeight: 'bold', color: '#172133', marginBottom: 6 }}&gt;隐性知识散落&lt;/div&gt;&#10;          &lt;p style={{ fontSize: 14, color: '#5F5E5A', margin: 0, lineHeight: 1.6 }}&gt;装修施工时间、停车规则、宠物管理等规定，往往只存在于物业员工的个人经验里，新人上岗难以快速掌握，业主咨询也得不到统一准确的答案。&lt;/p&gt;&#10;        &lt;/div&gt;&#10;      &lt;/div&gt;&#10;    &lt;/div&gt;&#10;  &lt;/div&gt;&#10;  &lt;div style={{ flexShrink: 0, height: 44, display: 'flex', alignItems: 'flex-end', justifyContent: 'space-between' }}&gt;&#10;    &lt;span style={{ color: '#BD9B56', fontSize: 12, letterSpacing: '0.1em' }}&gt;云溪花园 · 智慧社区&lt;/span&gt;&#10;    &lt;span style={{ color: '#a09b8c', fontSize: 12 }}&gt;03 / 15&lt;/span&gt;&#10;  &lt;/div&gt;&#10;&lt;/Slide&gt;"/>
         <p:cNvGrpSpPr/>
         <p:nvPr/>
       </p:nvGrpSpPr>
@@ -12517,7 +12765,7 @@
       </p:grpSpPr>
       <p:sp>
         <p:nvSpPr>
-          <p:cNvPr id="260" name=""/>
+          <p:cNvPr id="264" name=""/>
           <p:cNvSpPr/>
           <p:nvPr/>
         </p:nvSpPr>
@@ -12541,7 +12789,7 @@
       </p:sp>
       <p:sp>
         <p:nvSpPr>
-          <p:cNvPr id="261" name="" descr="{&quot;isTemplate&quot;:true,&quot;type&quot;:&quot;text&quot;}"/>
+          <p:cNvPr id="265" name="" descr="{&quot;isTemplate&quot;:true,&quot;type&quot;:&quot;text&quot;}"/>
           <p:cNvSpPr txBox="1"/>
           <p:nvPr/>
         </p:nvSpPr>
@@ -12586,7 +12834,7 @@
       </p:sp>
       <p:sp>
         <p:nvSpPr>
-          <p:cNvPr id="262" name="" descr="{&quot;isTemplate&quot;:true,&quot;type&quot;:&quot;text&quot;}"/>
+          <p:cNvPr id="266" name="" descr="{&quot;isTemplate&quot;:true,&quot;type&quot;:&quot;text&quot;}"/>
           <p:cNvSpPr txBox="1"/>
           <p:nvPr/>
         </p:nvSpPr>
@@ -12621,7 +12869,7 @@
       </p:sp>
       <p:sp>
         <p:nvSpPr>
-          <p:cNvPr id="263" name="" descr="{&quot;isTemplate&quot;:true,&quot;type&quot;:&quot;text&quot;}"/>
+          <p:cNvPr id="267" name="" descr="{&quot;isTemplate&quot;:true,&quot;type&quot;:&quot;text&quot;}"/>
           <p:cNvSpPr txBox="1"/>
           <p:nvPr/>
         </p:nvSpPr>
@@ -12676,7 +12924,7 @@
       </p:sp>
       <p:sp>
         <p:nvSpPr>
-          <p:cNvPr id="264" name=""/>
+          <p:cNvPr id="268" name=""/>
           <p:cNvSpPr/>
           <p:nvPr/>
         </p:nvSpPr>
@@ -12709,7 +12957,7 @@
       </p:sp>
       <p:sp>
         <p:nvSpPr>
-          <p:cNvPr id="265" name=""/>
+          <p:cNvPr id="269" name=""/>
           <p:cNvSpPr/>
           <p:nvPr/>
         </p:nvSpPr>
@@ -12766,7 +13014,7 @@
       </p:sp>
       <p:sp>
         <p:nvSpPr>
-          <p:cNvPr id="266" name="" descr="{&quot;isTemplate&quot;:true,&quot;type&quot;:&quot;text&quot;}"/>
+          <p:cNvPr id="270" name="" descr="{&quot;isTemplate&quot;:true,&quot;type&quot;:&quot;text&quot;}"/>
           <p:cNvSpPr txBox="1"/>
           <p:nvPr/>
         </p:nvSpPr>
@@ -12801,7 +13049,7 @@
       </p:sp>
       <p:sp>
         <p:nvSpPr>
-          <p:cNvPr id="267" name="" descr="{&quot;isTemplate&quot;:true,&quot;type&quot;:&quot;text&quot;}"/>
+          <p:cNvPr id="271" name="" descr="{&quot;isTemplate&quot;:true,&quot;type&quot;:&quot;text&quot;}"/>
           <p:cNvSpPr txBox="1"/>
           <p:nvPr/>
         </p:nvSpPr>
@@ -12836,7 +13084,7 @@
       </p:sp>
       <p:sp>
         <p:nvSpPr>
-          <p:cNvPr id="268" name="" descr="{&quot;isTemplate&quot;:true,&quot;type&quot;:&quot;text&quot;}"/>
+          <p:cNvPr id="272" name="" descr="{&quot;isTemplate&quot;:true,&quot;type&quot;:&quot;text&quot;}"/>
           <p:cNvSpPr txBox="1"/>
           <p:nvPr/>
         </p:nvSpPr>
@@ -12871,7 +13119,7 @@
       </p:sp>
       <p:sp>
         <p:nvSpPr>
-          <p:cNvPr id="269" name=""/>
+          <p:cNvPr id="273" name=""/>
           <p:cNvSpPr/>
           <p:nvPr/>
         </p:nvSpPr>
@@ -12904,7 +13152,7 @@
       </p:sp>
       <p:sp>
         <p:nvSpPr>
-          <p:cNvPr id="270" name=""/>
+          <p:cNvPr id="274" name=""/>
           <p:cNvSpPr/>
           <p:nvPr/>
         </p:nvSpPr>
@@ -12961,7 +13209,7 @@
       </p:sp>
       <p:sp>
         <p:nvSpPr>
-          <p:cNvPr id="271" name="" descr="{&quot;isTemplate&quot;:true,&quot;type&quot;:&quot;text&quot;}"/>
+          <p:cNvPr id="275" name="" descr="{&quot;isTemplate&quot;:true,&quot;type&quot;:&quot;text&quot;}"/>
           <p:cNvSpPr txBox="1"/>
           <p:nvPr/>
         </p:nvSpPr>
@@ -12996,7 +13244,7 @@
       </p:sp>
       <p:sp>
         <p:nvSpPr>
-          <p:cNvPr id="272" name="" descr="{&quot;isTemplate&quot;:true,&quot;type&quot;:&quot;text&quot;}"/>
+          <p:cNvPr id="276" name="" descr="{&quot;isTemplate&quot;:true,&quot;type&quot;:&quot;text&quot;}"/>
           <p:cNvSpPr txBox="1"/>
           <p:nvPr/>
         </p:nvSpPr>
@@ -13031,7 +13279,7 @@
       </p:sp>
       <p:sp>
         <p:nvSpPr>
-          <p:cNvPr id="273" name="" descr="{&quot;isTemplate&quot;:true,&quot;type&quot;:&quot;text&quot;}"/>
+          <p:cNvPr id="277" name="" descr="{&quot;isTemplate&quot;:true,&quot;type&quot;:&quot;text&quot;}"/>
           <p:cNvSpPr txBox="1"/>
           <p:nvPr/>
         </p:nvSpPr>
@@ -13066,7 +13314,7 @@
       </p:sp>
       <p:sp>
         <p:nvSpPr>
-          <p:cNvPr id="274" name=""/>
+          <p:cNvPr id="278" name=""/>
           <p:cNvSpPr/>
           <p:nvPr/>
         </p:nvSpPr>
@@ -13099,7 +13347,7 @@
       </p:sp>
       <p:sp>
         <p:nvSpPr>
-          <p:cNvPr id="275" name=""/>
+          <p:cNvPr id="279" name=""/>
           <p:cNvSpPr/>
           <p:nvPr/>
         </p:nvSpPr>
@@ -13156,7 +13404,7 @@
       </p:sp>
       <p:sp>
         <p:nvSpPr>
-          <p:cNvPr id="276" name="" descr="{&quot;isTemplate&quot;:true,&quot;type&quot;:&quot;text&quot;}"/>
+          <p:cNvPr id="280" name="" descr="{&quot;isTemplate&quot;:true,&quot;type&quot;:&quot;text&quot;}"/>
           <p:cNvSpPr txBox="1"/>
           <p:nvPr/>
         </p:nvSpPr>
@@ -13191,7 +13439,7 @@
       </p:sp>
       <p:sp>
         <p:nvSpPr>
-          <p:cNvPr id="277" name="" descr="{&quot;isTemplate&quot;:true,&quot;type&quot;:&quot;text&quot;}"/>
+          <p:cNvPr id="281" name="" descr="{&quot;isTemplate&quot;:true,&quot;type&quot;:&quot;text&quot;}"/>
           <p:cNvSpPr txBox="1"/>
           <p:nvPr/>
         </p:nvSpPr>
@@ -13226,7 +13474,7 @@
       </p:sp>
       <p:sp>
         <p:nvSpPr>
-          <p:cNvPr id="278" name="" descr="{&quot;isTemplate&quot;:true,&quot;type&quot;:&quot;text&quot;}"/>
+          <p:cNvPr id="282" name="" descr="{&quot;isTemplate&quot;:true,&quot;type&quot;:&quot;text&quot;}"/>
           <p:cNvSpPr txBox="1"/>
           <p:nvPr/>
         </p:nvSpPr>
@@ -13261,7 +13509,7 @@
       </p:sp>
       <p:sp>
         <p:nvSpPr>
-          <p:cNvPr id="279" name="" descr="{&quot;isTemplate&quot;:true,&quot;type&quot;:&quot;text&quot;}"/>
+          <p:cNvPr id="283" name="" descr="{&quot;isTemplate&quot;:true,&quot;type&quot;:&quot;text&quot;}"/>
           <p:cNvSpPr txBox="1"/>
           <p:nvPr/>
         </p:nvSpPr>
@@ -13316,7 +13564,7 @@
       </p:sp>
       <p:sp>
         <p:nvSpPr>
-          <p:cNvPr id="280" name="" descr="{&quot;isTemplate&quot;:true,&quot;type&quot;:&quot;text&quot;}"/>
+          <p:cNvPr id="284" name="" descr="{&quot;isTemplate&quot;:true,&quot;type&quot;:&quot;text&quot;}"/>
           <p:cNvSpPr txBox="1"/>
           <p:nvPr/>
         </p:nvSpPr>
@@ -13359,7 +13607,7 @@
   <p:cSld>
     <p:spTree>
       <p:nvGrpSpPr>
-        <p:cNvPr id="281" name="" descr="&lt;Slide style={{ width: '1280px', height: '720px', background: '#FBFCFA', position: 'relative', padding: '32px 64px', boxSizing: 'border-box', display: 'flex', flexDirection: 'column' }}&gt;&#10;  &lt;div style={{ flexShrink: 0 }}&gt;&#10;    &lt;div style={{ color: '#BD9B56', fontSize: 13, letterSpacing: '0.25em', marginBottom: 6 }}&gt;01 · 项目目标&lt;/div&gt;&#10;    &lt;h2 style={{ fontSize: 30, fontWeight: 'bold', color: '#172133', margin: 0, lineHeight: 1.3 }}&gt;本项目要验证的四件事&lt;/h2&gt;&#10;  &lt;/div&gt;&#10;  &lt;div style={{ flex: 1, display: 'flex', alignItems: 'center', minHeight: 0 }}&gt;&#10;    &lt;div style={{ width: '100%', display: 'grid', gridTemplateColumns: '1fr 1fr', gap: 16 }}&gt;&#10;      &lt;div style={{ background: '#fff', borderRadius: 10, padding: '18px 22px', boxShadow: '0 4px 16px rgba(23,33,51,0.06)', borderTop: '3px solid #BD9B56' }}&gt;&#10;        &lt;div style={{ fontSize: 17, fontWeight: 'bold', color: '#172133', marginBottom: 6 }}&gt;1.  AI 能否理解业务意图&lt;/div&gt;&#10;        &lt;p style={{ fontSize: 14, color: '#5F5E5A', margin: 0, lineHeight: 1.55 }}&gt;用户说一句「厨房漏水了」，系统能否准确识别为报修需求，而非闲聊或误判。&lt;/p&gt;&#10;      &lt;/div&gt;&#10;      &lt;div style={{ background: '#fff', borderRadius: 10, padding: '18px 22px', boxShadow: '0 4px 16px rgba(23,33,51,0.06)', borderTop: '3px solid #BD9B56' }}&gt;&#10;        &lt;div style={{ fontSize: 17, fontWeight: 'bold', color: '#172133', marginBottom: 6 }}&gt;2.  Agent 能否调用业务工具&lt;/div&gt;&#10;        &lt;p style={{ fontSize: 14, color: '#5F5E5A', margin: 0, lineHeight: 1.55 }}&gt;识别意图后，能否自动创建工单、查询费用、检索知识，而不是停留在「回答」层面。&lt;/p&gt;&#10;      &lt;/div&gt;&#10;      &lt;div style={{ background: '#fff', borderRadius: 10, padding: '18px 22px', boxShadow: '0 4px 16px rgba(23,33,51,0.06)', borderTop: '3px solid #BD9B56' }}&gt;&#10;        &lt;div style={{ fontSize: 17, fontWeight: 'bold', color: '#172133', marginBottom: 6 }}&gt;3.  能否跑通业务闭环&lt;/div&gt;&#10;        &lt;p style={{ fontSize: 14, color: '#5F5E5A', margin: 0, lineHeight: 1.55 }}&gt;从报修到派单到完成，AI 是否真正参与了业务流程，而非只在前端加了一个聊天窗口。&lt;/p&gt;&#10;      &lt;/div&gt;&#10;      &lt;div style={{ background: '#fff', borderRadius: 10, padding: '18px 22px', boxShadow: '0 4px 16px rgba(23,33,51,0.06)', borderTop: '3px solid #BD9B56' }}&gt;&#10;        &lt;div style={{ fontSize: 17, fontWeight: 'bold', color: '#172133', marginBottom: 6 }}&gt;4.  RAG 能否准确回答&lt;/div&gt;&#10;        &lt;p style={{ fontSize: 14, color: '#5F5E5A', margin: 0, lineHeight: 1.55 }}&gt;对「装修几点施工」这类制度问题，能否检索到正确依据并给出准确、有出处的答案。&lt;/p&gt;&#10;      &lt;/div&gt;&#10;    &lt;/div&gt;&#10;  &lt;/div&gt;&#10;  &lt;div style={{ flexShrink: 0, height: 40, display: 'flex', alignItems: 'flex-end', justifyContent: 'space-between' }}&gt;&#10;    &lt;span style={{ color: '#BD9B56', fontSize: 12, letterSpacing: '0.1em' }}&gt;云溪花园 · 智慧社区&lt;/span&gt;&#10;    &lt;span style={{ color: '#a09b8c', fontSize: 12 }}&gt;04 / 15&lt;/span&gt;&#10;  &lt;/div&gt;&#10;&lt;/Slide&gt;"/>
+        <p:cNvPr id="285" name="" descr="&lt;Slide style={{ width: '1280px', height: '720px', background: '#FBFCFA', position: 'relative', padding: '32px 64px', boxSizing: 'border-box', display: 'flex', flexDirection: 'column' }}&gt;&#10;  &lt;div style={{ flexShrink: 0 }}&gt;&#10;    &lt;div style={{ color: '#BD9B56', fontSize: 13, letterSpacing: '0.25em', marginBottom: 6 }}&gt;01 · 项目目标&lt;/div&gt;&#10;    &lt;h2 style={{ fontSize: 30, fontWeight: 'bold', color: '#172133', margin: 0, lineHeight: 1.3 }}&gt;本项目要验证的四件事&lt;/h2&gt;&#10;  &lt;/div&gt;&#10;  &lt;div style={{ flex: 1, display: 'flex', alignItems: 'center', minHeight: 0 }}&gt;&#10;    &lt;div style={{ width: '100%', display: 'grid', gridTemplateColumns: '1fr 1fr', gap: 16 }}&gt;&#10;      &lt;div style={{ background: '#fff', borderRadius: 10, padding: '18px 22px', boxShadow: '0 4px 16px rgba(23,33,51,0.06)', borderTop: '3px solid #BD9B56' }}&gt;&#10;        &lt;div style={{ fontSize: 17, fontWeight: 'bold', color: '#172133', marginBottom: 6 }}&gt;1.  AI 能否理解业务意图&lt;/div&gt;&#10;        &lt;p style={{ fontSize: 14, color: '#5F5E5A', margin: 0, lineHeight: 1.55 }}&gt;用户说一句「厨房漏水了」，系统能否准确识别为报修需求，而非闲聊或误判。&lt;/p&gt;&#10;      &lt;/div&gt;&#10;      &lt;div style={{ background: '#fff', borderRadius: 10, padding: '18px 22px', boxShadow: '0 4px 16px rgba(23,33,51,0.06)', borderTop: '3px solid #BD9B56' }}&gt;&#10;        &lt;div style={{ fontSize: 17, fontWeight: 'bold', color: '#172133', marginBottom: 6 }}&gt;2.  Agent 能否调用业务工具&lt;/div&gt;&#10;        &lt;p style={{ fontSize: 14, color: '#5F5E5A', margin: 0, lineHeight: 1.55 }}&gt;识别意图后，能否自动创建工单、查询费用、检索知识，而不是停留在「回答」层面。&lt;/p&gt;&#10;      &lt;/div&gt;&#10;      &lt;div style={{ background: '#fff', borderRadius: 10, padding: '18px 22px', boxShadow: '0 4px 16px rgba(23,33,51,0.06)', borderTop: '3px solid #BD9B56' }}&gt;&#10;        &lt;div style={{ fontSize: 17, fontWeight: 'bold', color: '#172133', marginBottom: 6 }}&gt;3.  能否跑通业务闭环&lt;/div&gt;&#10;        &lt;p style={{ fontSize: 14, color: '#5F5E5A', margin: 0, lineHeight: 1.55 }}&gt;从报修到派单到完成，AI 是否真正参与了业务流程，而非只在前端加了一个聊天窗口。&lt;/p&gt;&#10;      &lt;/div&gt;&#10;      &lt;div style={{ background: '#fff', borderRadius: 10, padding: '18px 22px', boxShadow: '0 4px 16px rgba(23,33,51,0.06)', borderTop: '3px solid #BD9B56' }}&gt;&#10;        &lt;div style={{ fontSize: 17, fontWeight: 'bold', color: '#172133', marginBottom: 6 }}&gt;4.  RAG 能否准确回答&lt;/div&gt;&#10;        &lt;p style={{ fontSize: 14, color: '#5F5E5A', margin: 0, lineHeight: 1.55 }}&gt;对「装修几点施工」这类制度问题，能否检索到正确依据并给出准确、有出处的答案。&lt;/p&gt;&#10;      &lt;/div&gt;&#10;    &lt;/div&gt;&#10;  &lt;/div&gt;&#10;  &lt;div style={{ flexShrink: 0, height: 40, display: 'flex', alignItems: 'flex-end', justifyContent: 'space-between' }}&gt;&#10;    &lt;span style={{ color: '#BD9B56', fontSize: 12, letterSpacing: '0.1em' }}&gt;云溪花园 · 智慧社区&lt;/span&gt;&#10;    &lt;span style={{ color: '#a09b8c', fontSize: 12 }}&gt;04 / 15&lt;/span&gt;&#10;  &lt;/div&gt;&#10;&lt;/Slide&gt;"/>
         <p:cNvGrpSpPr/>
         <p:nvPr/>
       </p:nvGrpSpPr>
@@ -13373,7 +13621,7 @@
       </p:grpSpPr>
       <p:sp>
         <p:nvSpPr>
-          <p:cNvPr id="282" name=""/>
+          <p:cNvPr id="286" name=""/>
           <p:cNvSpPr/>
           <p:nvPr/>
         </p:nvSpPr>
@@ -13397,7 +13645,7 @@
       </p:sp>
       <p:sp>
         <p:nvSpPr>
-          <p:cNvPr id="283" name="" descr="{&quot;isTemplate&quot;:true,&quot;type&quot;:&quot;text&quot;}"/>
+          <p:cNvPr id="287" name="" descr="{&quot;isTemplate&quot;:true,&quot;type&quot;:&quot;text&quot;}"/>
           <p:cNvSpPr txBox="1"/>
           <p:nvPr/>
         </p:nvSpPr>
@@ -13442,7 +13690,7 @@
       </p:sp>
       <p:sp>
         <p:nvSpPr>
-          <p:cNvPr id="284" name="" descr="{&quot;isTemplate&quot;:true,&quot;type&quot;:&quot;text&quot;}"/>
+          <p:cNvPr id="288" name="" descr="{&quot;isTemplate&quot;:true,&quot;type&quot;:&quot;text&quot;}"/>
           <p:cNvSpPr txBox="1"/>
           <p:nvPr/>
         </p:nvSpPr>
@@ -13477,7 +13725,7 @@
       </p:sp>
       <p:sp>
         <p:nvSpPr>
-          <p:cNvPr id="285" name=""/>
+          <p:cNvPr id="289" name=""/>
           <p:cNvSpPr/>
           <p:nvPr/>
         </p:nvSpPr>
@@ -13510,7 +13758,7 @@
       </p:sp>
       <p:sp>
         <p:nvSpPr>
-          <p:cNvPr id="286" name=""/>
+          <p:cNvPr id="290" name=""/>
           <p:cNvSpPr/>
           <p:nvPr/>
         </p:nvSpPr>
@@ -13567,7 +13815,7 @@
       </p:sp>
       <p:sp>
         <p:nvSpPr>
-          <p:cNvPr id="287" name="" descr="{&quot;isTemplate&quot;:true,&quot;type&quot;:&quot;text&quot;}"/>
+          <p:cNvPr id="291" name="" descr="{&quot;isTemplate&quot;:true,&quot;type&quot;:&quot;text&quot;}"/>
           <p:cNvSpPr txBox="1"/>
           <p:nvPr/>
         </p:nvSpPr>
@@ -13612,7 +13860,7 @@
       </p:sp>
       <p:sp>
         <p:nvSpPr>
-          <p:cNvPr id="288" name="" descr="{&quot;isTemplate&quot;:true,&quot;type&quot;:&quot;text&quot;}"/>
+          <p:cNvPr id="292" name="" descr="{&quot;isTemplate&quot;:true,&quot;type&quot;:&quot;text&quot;}"/>
           <p:cNvSpPr txBox="1"/>
           <p:nvPr/>
         </p:nvSpPr>
@@ -13647,7 +13895,7 @@
       </p:sp>
       <p:sp>
         <p:nvSpPr>
-          <p:cNvPr id="289" name=""/>
+          <p:cNvPr id="293" name=""/>
           <p:cNvSpPr/>
           <p:nvPr/>
         </p:nvSpPr>
@@ -13680,7 +13928,7 @@
       </p:sp>
       <p:sp>
         <p:nvSpPr>
-          <p:cNvPr id="290" name=""/>
+          <p:cNvPr id="294" name=""/>
           <p:cNvSpPr/>
           <p:nvPr/>
         </p:nvSpPr>
@@ -13737,7 +13985,7 @@
       </p:sp>
       <p:sp>
         <p:nvSpPr>
-          <p:cNvPr id="291" name="" descr="{&quot;isTemplate&quot;:true,&quot;type&quot;:&quot;text&quot;}"/>
+          <p:cNvPr id="295" name="" descr="{&quot;isTemplate&quot;:true,&quot;type&quot;:&quot;text&quot;}"/>
           <p:cNvSpPr txBox="1"/>
           <p:nvPr/>
         </p:nvSpPr>
@@ -13782,7 +14030,7 @@
       </p:sp>
       <p:sp>
         <p:nvSpPr>
-          <p:cNvPr id="292" name="" descr="{&quot;isTemplate&quot;:true,&quot;type&quot;:&quot;text&quot;}"/>
+          <p:cNvPr id="296" name="" descr="{&quot;isTemplate&quot;:true,&quot;type&quot;:&quot;text&quot;}"/>
           <p:cNvSpPr txBox="1"/>
           <p:nvPr/>
         </p:nvSpPr>
@@ -13817,7 +14065,7 @@
       </p:sp>
       <p:sp>
         <p:nvSpPr>
-          <p:cNvPr id="293" name=""/>
+          <p:cNvPr id="297" name=""/>
           <p:cNvSpPr/>
           <p:nvPr/>
         </p:nvSpPr>
@@ -13850,7 +14098,7 @@
       </p:sp>
       <p:sp>
         <p:nvSpPr>
-          <p:cNvPr id="294" name=""/>
+          <p:cNvPr id="298" name=""/>
           <p:cNvSpPr/>
           <p:nvPr/>
         </p:nvSpPr>
@@ -13907,7 +14155,7 @@
       </p:sp>
       <p:sp>
         <p:nvSpPr>
-          <p:cNvPr id="295" name="" descr="{&quot;isTemplate&quot;:true,&quot;type&quot;:&quot;text&quot;}"/>
+          <p:cNvPr id="299" name="" descr="{&quot;isTemplate&quot;:true,&quot;type&quot;:&quot;text&quot;}"/>
           <p:cNvSpPr txBox="1"/>
           <p:nvPr/>
         </p:nvSpPr>
@@ -13952,7 +14200,7 @@
       </p:sp>
       <p:sp>
         <p:nvSpPr>
-          <p:cNvPr id="296" name="" descr="{&quot;isTemplate&quot;:true,&quot;type&quot;:&quot;text&quot;}"/>
+          <p:cNvPr id="300" name="" descr="{&quot;isTemplate&quot;:true,&quot;type&quot;:&quot;text&quot;}"/>
           <p:cNvSpPr txBox="1"/>
           <p:nvPr/>
         </p:nvSpPr>
@@ -14007,7 +14255,7 @@
       </p:sp>
       <p:sp>
         <p:nvSpPr>
-          <p:cNvPr id="297" name=""/>
+          <p:cNvPr id="301" name=""/>
           <p:cNvSpPr/>
           <p:nvPr/>
         </p:nvSpPr>
@@ -14040,7 +14288,7 @@
       </p:sp>
       <p:sp>
         <p:nvSpPr>
-          <p:cNvPr id="298" name=""/>
+          <p:cNvPr id="302" name=""/>
           <p:cNvSpPr/>
           <p:nvPr/>
         </p:nvSpPr>
@@ -14097,7 +14345,7 @@
       </p:sp>
       <p:sp>
         <p:nvSpPr>
-          <p:cNvPr id="299" name="" descr="{&quot;isTemplate&quot;:true,&quot;type&quot;:&quot;text&quot;}"/>
+          <p:cNvPr id="303" name="" descr="{&quot;isTemplate&quot;:true,&quot;type&quot;:&quot;text&quot;}"/>
           <p:cNvSpPr txBox="1"/>
           <p:nvPr/>
         </p:nvSpPr>
@@ -14142,7 +14390,7 @@
       </p:sp>
       <p:sp>
         <p:nvSpPr>
-          <p:cNvPr id="300" name="" descr="{&quot;isTemplate&quot;:true,&quot;type&quot;:&quot;text&quot;}"/>
+          <p:cNvPr id="304" name="" descr="{&quot;isTemplate&quot;:true,&quot;type&quot;:&quot;text&quot;}"/>
           <p:cNvSpPr txBox="1"/>
           <p:nvPr/>
         </p:nvSpPr>
@@ -14177,7 +14425,7 @@
       </p:sp>
       <p:sp>
         <p:nvSpPr>
-          <p:cNvPr id="301" name="" descr="{&quot;isTemplate&quot;:true,&quot;type&quot;:&quot;text&quot;}"/>
+          <p:cNvPr id="305" name="" descr="{&quot;isTemplate&quot;:true,&quot;type&quot;:&quot;text&quot;}"/>
           <p:cNvSpPr txBox="1"/>
           <p:nvPr/>
         </p:nvSpPr>
@@ -14232,7 +14480,7 @@
       </p:sp>
       <p:sp>
         <p:nvSpPr>
-          <p:cNvPr id="302" name="" descr="{&quot;isTemplate&quot;:true,&quot;type&quot;:&quot;text&quot;}"/>
+          <p:cNvPr id="306" name="" descr="{&quot;isTemplate&quot;:true,&quot;type&quot;:&quot;text&quot;}"/>
           <p:cNvSpPr txBox="1"/>
           <p:nvPr/>
         </p:nvSpPr>
@@ -14275,7 +14523,7 @@
   <p:cSld>
     <p:spTree>
       <p:nvGrpSpPr>
-        <p:cNvPr id="303" name="" descr="&lt;Slide style={{ width: '1280px', height: '720px', background: '#FBFCFA', position: 'relative', padding: '32px 64px', boxSizing: 'border-box', display: 'flex', flexDirection: 'column' }}&gt;&#10;  &lt;div style={{ flexShrink: 0 }}&gt;&#10;    &lt;div style={{ color: '#BD9B56', fontSize: 13, letterSpacing: '0.25em', marginBottom: 6 }}&gt;01 · 项目规模&lt;/div&gt;&#10;    &lt;h2 style={{ fontSize: 30, fontWeight: 'bold', color: '#172133', margin: 0, lineHeight: 1.3 }}&gt;虚拟社区数据资产：云溪花园&lt;/h2&gt;&#10;    &lt;div style={{ fontSize: 14, color: '#6b7075', marginTop: 6 }}&gt;以一个社区为根，向下延伸出空间、人员、业务、知识四类数据资产&lt;/div&gt;&#10;  &lt;/div&gt;&#10;  &lt;div style={{ flex: 1, display: 'flex', alignItems: 'center', justifyContent: 'center' }}&gt;&#10;    &lt;svg width=&quot;1150&quot; height=&quot;470&quot; viewBox=&quot;0 0 1150 470&quot;&gt;&#10;      &lt;g fontFamily=&quot;Inter, sans-serif&quot;&gt;&#10;        {/* 根节点 community */}&#10;        &lt;rect x=&quot;450&quot; y=&quot;14&quot; width=&quot;250&quot; height=&quot;58&quot; rx=&quot;10&quot; fill=&quot;#172133&quot; /&gt;&#10;        &lt;text x=&quot;575&quot; y=&quot;38&quot; textAnchor=&quot;middle&quot; fontSize=&quot;15&quot; fontWeight=&quot;bold&quot; fill=&quot;#FBFCFA&quot;&gt;community 云溪花园&lt;/text&gt;&#10;        &lt;text x=&quot;575&quot; y=&quot;58&quot; textAnchor=&quot;middle&quot; fontSize=&quot;11&quot; fill=&quot;#BD9B56&quot;&gt;1 个小区 · 上海浦东张江路1268号&lt;/text&gt;&#10;        {/* 根节点连接线 */}&#10;        &lt;line x1=&quot;575&quot; y1=&quot;72&quot; x2=&quot;575&quot; y2=&quot;92&quot; stroke=&quot;#BD9B56&quot; strokeWidth=&quot;1.5&quot; /&gt;&#10;        &lt;line x1=&quot;150&quot; y1=&quot;92&quot; x2=&quot;1015&quot; y2=&quot;92&quot; stroke=&quot;#BD9B56&quot; strokeWidth=&quot;1.5&quot; /&gt;&#10;        &lt;line x1=&quot;150&quot; y1=&quot;92&quot; x2=&quot;150&quot; y2=&quot;108&quot; stroke=&quot;#BD9B56&quot; strokeWidth=&quot;1.5&quot; /&gt;&#10;        &lt;line x1=&quot;438&quot; y1=&quot;92&quot; x2=&quot;438&quot; y2=&quot;108&quot; stroke=&quot;#BD9B56&quot; strokeWidth=&quot;1.5&quot; /&gt;&#10;        &lt;line x1=&quot;726&quot; y1=&quot;92&quot; x2=&quot;726&quot; y2=&quot;108&quot; stroke=&quot;#BD9B56&quot; strokeWidth=&quot;1.5&quot; /&gt;&#10;        &lt;line x1=&quot;1015&quot; y1=&quot;92&quot; x2=&quot;1015&quot; y2=&quot;108&quot; stroke=&quot;#BD9B56&quot; strokeWidth=&quot;1.5&quot; /&gt;&#10;&#10;        {/* 分组1：空间资产 */}&#10;        &lt;text x=&quot;150&quot; y=&quot;128&quot; textAnchor=&quot;middle&quot; fontSize=&quot;12&quot; fontWeight=&quot;bold&quot; fill=&quot;#BD9B56&quot;&gt;空间资产&lt;/text&gt;&#10;        &lt;rect x=&quot;20&quot; y=&quot;138&quot; width=&quot;260&quot; height=&quot;56&quot; rx=&quot;8&quot; fill=&quot;rgba(34,57,94,0.06)&quot; stroke=&quot;#22395E&quot; strokeWidth=&quot;1.5&quot; /&gt;&#10;        &lt;text x=&quot;150&quot; y=&quot;162&quot; textAnchor=&quot;middle&quot; fontSize=&quot;14&quot; fontWeight=&quot;bold&quot; fill=&quot;#172133&quot;&gt;building 楼栋 ×8&lt;/text&gt;&#10;        &lt;text x=&quot;150&quot; y=&quot;182&quot; textAnchor=&quot;middle&quot; fontSize=&quot;11&quot; fill=&quot;#5F5E5A&quot;&gt;每栋 26 层 · 2 单元 · 4 户/层&lt;/text&gt;&#10;        &lt;line x1=&quot;150&quot; y1=&quot;194&quot; x2=&quot;150&quot; y2=&quot;206&quot; stroke=&quot;#BD9B56&quot; strokeWidth=&quot;1.2&quot; /&gt;&#10;        &lt;rect x=&quot;20&quot; y=&quot;210&quot; width=&quot;260&quot; height=&quot;56&quot; rx=&quot;8&quot; fill=&quot;rgba(34,57,94,0.06)&quot; stroke=&quot;#22395E&quot; strokeWidth=&quot;1.5&quot; /&gt;&#10;        &lt;text x=&quot;150&quot; y=&quot;234&quot; textAnchor=&quot;middle&quot; fontSize=&quot;14&quot; fontWeight=&quot;bold&quot; fill=&quot;#172133&quot;&gt;house 房屋 ×1664&lt;/text&gt;&#10;        &lt;text x=&quot;150&quot; y=&quot;254&quot; textAnchor=&quot;middle&quot; fontSize=&quot;11&quot; fill=&quot;#5F5E5A&quot;&gt;入住约 1200 户 · 800 车位&lt;/text&gt;&#10;&#10;        {/* 分组2：人员资产 */}&#10;        &lt;text x=&quot;438&quot; y=&quot;128&quot; textAnchor=&quot;middle&quot; fontSize=&quot;12&quot; fontWeight=&quot;bold&quot; fill=&quot;#BD9B56&quot;&gt;人员资产&lt;/text&gt;&#10;        &lt;rect x=&quot;308&quot; y=&quot;138&quot; width=&quot;260&quot; height=&quot;56&quot; rx=&quot;8&quot; fill=&quot;rgba(189,155,86,0.10)&quot; stroke=&quot;#BD9B56&quot; strokeWidth=&quot;1.5&quot; /&gt;&#10;        &lt;text x=&quot;438&quot; y=&quot;162&quot; textAnchor=&quot;middle&quot; fontSize=&quot;14&quot; fontWeight=&quot;bold&quot; fill=&quot;#172133&quot;&gt;user 业主 ×200&lt;/text&gt;&#10;        &lt;text x=&quot;438&quot; y=&quot;182&quot; textAnchor=&quot;middle&quot; fontSize=&quot;11&quot; fill=&quot;#5F5E5A&quot;&gt;house_binding 绑定 200 套&lt;/text&gt;&#10;        &lt;line x1=&quot;438&quot; y1=&quot;194&quot; x2=&quot;438&quot; y2=&quot;206&quot; stroke=&quot;#BD9B56&quot; strokeWidth=&quot;1.2&quot; /&gt;&#10;        &lt;rect x=&quot;308&quot; y=&quot;210&quot; width=&quot;260&quot; height=&quot;56&quot; rx=&quot;8&quot; fill=&quot;rgba(189,155,86,0.10)&quot; stroke=&quot;#BD9B56&quot; strokeWidth=&quot;1.5&quot; /&gt;&#10;        &lt;text x=&quot;438&quot; y=&quot;234&quot; textAnchor=&quot;middle&quot; fontSize=&quot;14&quot; fontWeight=&quot;bold&quot; fill=&quot;#172133&quot;&gt;worker 物业 ×75&lt;/text&gt;&#10;        &lt;text x=&quot;438&quot; y=&quot;254&quot; textAnchor=&quot;middle&quot; fontSize=&quot;11&quot; fill=&quot;#5F5E5A&quot;&gt;10 管理 / 15 维修 / 50 一线&lt;/text&gt;&#10;&#10;        {/* 分组3：业务数据 */}&#10;        &lt;text x=&quot;726&quot; y=&quot;128&quot; textAnchor=&quot;middle&quot; fontSize=&quot;12&quot; fontWeight=&quot;bold&quot; fill=&quot;#BD9B56&quot;&gt;业务数据&lt;/text&gt;&#10;        &lt;rect x=&quot;596&quot; y=&quot;138&quot; width=&quot;260&quot; height=&quot;40&quot; rx=&quot;8&quot; fill=&quot;rgba(34,57,94,0.06)&quot; stroke=&quot;#22395E&quot; strokeWidth=&quot;1.5&quot; /&gt;&#10;        &lt;text x=&quot;726&quot; y=&quot;163&quot; textAnchor=&quot;middle&quot; fontSize=&quot;13&quot; fontWeight=&quot;bold&quot; fill=&quot;#172133&quot;&gt;repair_order 工单 ×50&lt;/text&gt;&#10;        &lt;rect x=&quot;596&quot; y=&quot;186&quot; width=&quot;260&quot; height=&quot;40&quot; rx=&quot;8&quot; fill=&quot;rgba(34,57,94,0.06)&quot; stroke=&quot;#22395E&quot; strokeWidth=&quot;1.5&quot; /&gt;&#10;        &lt;text x=&quot;726&quot; y=&quot;211&quot; textAnchor=&quot;middle&quot; fontSize=&quot;13&quot; fontWeight=&quot;bold&quot; fill=&quot;#172133&quot;&gt;fee_bill 账单 ×746&lt;/text&gt;&#10;        &lt;rect x=&quot;596&quot; y=&quot;234&quot; width=&quot;260&quot; height=&quot;40&quot; rx=&quot;8&quot; fill=&quot;rgba(34,57,94,0.06)&quot; stroke=&quot;#22395E&quot; strokeWidth=&quot;1.5&quot; /&gt;&#10;        &lt;text x=&quot;726&quot; y=&quot;259&quot; textAnchor=&quot;middle&quot; fontSize=&quot;13&quot; fontWeight=&quot;bold&quot; fill=&quot;#172133&quot;&gt;notice 公告 ×24&lt;/text&gt;&#10;&#10;        {/* 分组4：知识资产 */}&#10;        &lt;text x=&quot;1015&quot; y=&quot;128&quot; textAnchor=&quot;middle&quot; fontSize=&quot;12&quot; fontWeight=&quot;bold&quot; fill=&quot;#BD9B56&quot;&gt;知识资产&lt;/text&gt;&#10;        &lt;rect x=&quot;885&quot; y=&quot;138&quot; width=&quot;260&quot; height=&quot;56&quot; rx=&quot;8&quot; fill=&quot;#22395E&quot; /&gt;&#10;        &lt;text x=&quot;1015&quot; y=&quot;162&quot; textAnchor=&quot;middle&quot; fontSize=&quot;14&quot; fontWeight=&quot;bold&quot; fill=&quot;#FBFCFA&quot;&gt;knowledge 文档 ×22&lt;/text&gt;&#10;        &lt;text x=&quot;1015&quot; y=&quot;182&quot; textAnchor=&quot;middle&quot; fontSize=&quot;11&quot; fill=&quot;#BD9B56&quot;&gt;7 个分类（规约/装修/停车…）&lt;/text&gt;&#10;        &lt;line x1=&quot;1015&quot; y1=&quot;194&quot; x2=&quot;1015&quot; y2=&quot;206&quot; stroke=&quot;#BD9B56&quot; strokeWidth=&quot;1.2&quot; /&gt;&#10;        &lt;rect x=&quot;885&quot; y=&quot;210&quot; width=&quot;260&quot; height=&quot;56&quot; rx=&quot;8&quot; fill=&quot;rgba(34,57,94,0.06)&quot; stroke=&quot;#BD9B56&quot; strokeWidth=&quot;1.5&quot; /&gt;&#10;        &lt;text x=&quot;1015&quot; y=&quot;234&quot; textAnchor=&quot;middle&quot; fontSize=&quot;14&quot; fontWeight=&quot;bold&quot; fill=&quot;#172133&quot;&gt;chunk 切片 ×99&lt;/text&gt;&#10;        &lt;text x=&quot;1015&quot; y=&quot;254&quot; textAnchor=&quot;middle&quot; fontSize=&quot;11&quot; fill=&quot;#5F5E5A&quot;&gt;pgvector 1024 维向量&lt;/text&gt;&#10;&#10;        {/* 底部关系说明 */}&#10;        &lt;rect x=&quot;300&quot; y=&quot;290&quot; width=&quot;550&quot; height=&quot;48&quot; rx=&quot;8&quot; fill=&quot;rgba(189,155,86,0.10)&quot; /&gt;&#10;        &lt;text x=&quot;575&quot; y=&quot;318&quot; textAnchor=&quot;middle&quot; fontSize=&quot;12&quot; fill=&quot;#172133&quot;&gt;repair_order → user + house + worker · fee_bill → house + user · 外键关联&lt;/text&gt;&#10;        &lt;text x=&quot;575&quot; y=&quot;334&quot; textAnchor=&quot;middle&quot; fontSize=&quot;11&quot; fill=&quot;#5F5E5A&quot;&gt;8 个 SQL 种子文件 · 一键导入可复现&lt;/text&gt;&#10;      &lt;/g&gt;&#10;    &lt;/svg&gt;&#10;  &lt;/div&gt;&#10;  &lt;div style={{ flexShrink: 0, height: 40, display: 'flex', alignItems: 'flex-end', justifyContent: 'space-between' }}&gt;&#10;    &lt;span style={{ color: '#BD9B56', fontSize: 12, letterSpacing: '0.1em' }}&gt;云溪花园 · 智慧社区&lt;/span&gt;&#10;    &lt;span style={{ color: '#a09b8c', fontSize: 12 }}&gt;05 / 15&lt;/span&gt;&#10;  &lt;/div&gt;&#10;&lt;/Slide&gt;"/>
+        <p:cNvPr id="307" name="" descr="&lt;Slide style={{ width: '1280px', height: '720px', background: '#FBFCFA', position: 'relative', padding: '32px 64px', boxSizing: 'border-box', display: 'flex', flexDirection: 'column' }}&gt;&#10;  &lt;div style={{ flexShrink: 0 }}&gt;&#10;    &lt;div style={{ color: '#BD9B56', fontSize: 13, letterSpacing: '0.25em', marginBottom: 6 }}&gt;01 · 项目规模&lt;/div&gt;&#10;    &lt;h2 style={{ fontSize: 30, fontWeight: 'bold', color: '#172133', margin: 0, lineHeight: 1.3 }}&gt;虚拟社区数据资产：云溪花园&lt;/h2&gt;&#10;    &lt;div style={{ fontSize: 14, color: '#6b7075', marginTop: 6 }}&gt;以一个社区为根，向下延伸出空间、人员、业务、知识四类数据资产&lt;/div&gt;&#10;  &lt;/div&gt;&#10;  &lt;div style={{ flex: 1, display: 'flex', alignItems: 'center', justifyContent: 'center' }}&gt;&#10;    &lt;svg width=&quot;1150&quot; height=&quot;470&quot; viewBox=&quot;0 0 1150 470&quot;&gt;&#10;      &lt;g fontFamily=&quot;Inter, sans-serif&quot;&gt;&#10;        {/* 根节点 community */}&#10;        &lt;rect x=&quot;450&quot; y=&quot;14&quot; width=&quot;250&quot; height=&quot;58&quot; rx=&quot;10&quot; fill=&quot;#172133&quot; /&gt;&#10;        &lt;text x=&quot;575&quot; y=&quot;38&quot; textAnchor=&quot;middle&quot; fontSize=&quot;15&quot; fontWeight=&quot;bold&quot; fill=&quot;#FBFCFA&quot;&gt;community 云溪花园&lt;/text&gt;&#10;        &lt;text x=&quot;575&quot; y=&quot;58&quot; textAnchor=&quot;middle&quot; fontSize=&quot;11&quot; fill=&quot;#BD9B56&quot;&gt;1 个小区 · 上海浦东张江路1268号&lt;/text&gt;&#10;        {/* 根节点连接线 */}&#10;        &lt;line x1=&quot;575&quot; y1=&quot;72&quot; x2=&quot;575&quot; y2=&quot;92&quot; stroke=&quot;#BD9B56&quot; strokeWidth=&quot;1.5&quot; /&gt;&#10;        &lt;line x1=&quot;150&quot; y1=&quot;92&quot; x2=&quot;1015&quot; y2=&quot;92&quot; stroke=&quot;#BD9B56&quot; strokeWidth=&quot;1.5&quot; /&gt;&#10;        &lt;line x1=&quot;150&quot; y1=&quot;92&quot; x2=&quot;150&quot; y2=&quot;108&quot; stroke=&quot;#BD9B56&quot; strokeWidth=&quot;1.5&quot; /&gt;&#10;        &lt;line x1=&quot;438&quot; y1=&quot;92&quot; x2=&quot;438&quot; y2=&quot;108&quot; stroke=&quot;#BD9B56&quot; strokeWidth=&quot;1.5&quot; /&gt;&#10;        &lt;line x1=&quot;726&quot; y1=&quot;92&quot; x2=&quot;726&quot; y2=&quot;108&quot; stroke=&quot;#BD9B56&quot; strokeWidth=&quot;1.5&quot; /&gt;&#10;        &lt;line x1=&quot;1015&quot; y1=&quot;92&quot; x2=&quot;1015&quot; y2=&quot;108&quot; stroke=&quot;#BD9B56&quot; strokeWidth=&quot;1.5&quot; /&gt;&#10;&#10;        {/* 分组1：空间资产 */}&#10;        &lt;text x=&quot;150&quot; y=&quot;128&quot; textAnchor=&quot;middle&quot; fontSize=&quot;12&quot; fontWeight=&quot;bold&quot; fill=&quot;#BD9B56&quot;&gt;空间资产&lt;/text&gt;&#10;        &lt;rect x=&quot;20&quot; y=&quot;138&quot; width=&quot;260&quot; height=&quot;56&quot; rx=&quot;8&quot; fill=&quot;rgba(34,57,94,0.06)&quot; stroke=&quot;#22395E&quot; strokeWidth=&quot;1.5&quot; /&gt;&#10;        &lt;text x=&quot;150&quot; y=&quot;162&quot; textAnchor=&quot;middle&quot; fontSize=&quot;14&quot; fontWeight=&quot;bold&quot; fill=&quot;#172133&quot;&gt;building 楼栋 ×8&lt;/text&gt;&#10;        &lt;text x=&quot;150&quot; y=&quot;182&quot; textAnchor=&quot;middle&quot; fontSize=&quot;11&quot; fill=&quot;#5F5E5A&quot;&gt;每栋 26 层 · 2 单元 · 4 户/层&lt;/text&gt;&#10;        &lt;line x1=&quot;150&quot; y1=&quot;194&quot; x2=&quot;150&quot; y2=&quot;206&quot; stroke=&quot;#BD9B56&quot; strokeWidth=&quot;1.2&quot; /&gt;&#10;        &lt;rect x=&quot;20&quot; y=&quot;210&quot; width=&quot;260&quot; height=&quot;56&quot; rx=&quot;8&quot; fill=&quot;rgba(34,57,94,0.06)&quot; stroke=&quot;#22395E&quot; strokeWidth=&quot;1.5&quot; /&gt;&#10;        &lt;text x=&quot;150&quot; y=&quot;234&quot; textAnchor=&quot;middle&quot; fontSize=&quot;14&quot; fontWeight=&quot;bold&quot; fill=&quot;#172133&quot;&gt;house 房屋 ×1664&lt;/text&gt;&#10;        &lt;text x=&quot;150&quot; y=&quot;254&quot; textAnchor=&quot;middle&quot; fontSize=&quot;11&quot; fill=&quot;#5F5E5A&quot;&gt;入住约 1200 户 · 800 车位&lt;/text&gt;&#10;&#10;        {/* 分组2：人员资产 */}&#10;        &lt;text x=&quot;438&quot; y=&quot;128&quot; textAnchor=&quot;middle&quot; fontSize=&quot;12&quot; fontWeight=&quot;bold&quot; fill=&quot;#BD9B56&quot;&gt;人员资产&lt;/text&gt;&#10;        &lt;rect x=&quot;308&quot; y=&quot;138&quot; width=&quot;260&quot; height=&quot;56&quot; rx=&quot;8&quot; fill=&quot;rgba(189,155,86,0.10)&quot; stroke=&quot;#BD9B56&quot; strokeWidth=&quot;1.5&quot; /&gt;&#10;        &lt;text x=&quot;438&quot; y=&quot;162&quot; textAnchor=&quot;middle&quot; fontSize=&quot;14&quot; fontWeight=&quot;bold&quot; fill=&quot;#172133&quot;&gt;user 业主 ×200&lt;/text&gt;&#10;        &lt;text x=&quot;438&quot; y=&quot;182&quot; textAnchor=&quot;middle&quot; fontSize=&quot;11&quot; fill=&quot;#5F5E5A&quot;&gt;house_binding 绑定 200 套&lt;/text&gt;&#10;        &lt;line x1=&quot;438&quot; y1=&quot;194&quot; x2=&quot;438&quot; y2=&quot;206&quot; stroke=&quot;#BD9B56&quot; strokeWidth=&quot;1.2&quot; /&gt;&#10;        &lt;rect x=&quot;308&quot; y=&quot;210&quot; width=&quot;260&quot; height=&quot;56&quot; rx=&quot;8&quot; fill=&quot;rgba(189,155,86,0.10)&quot; stroke=&quot;#BD9B56&quot; strokeWidth=&quot;1.5&quot; /&gt;&#10;        &lt;text x=&quot;438&quot; y=&quot;234&quot; textAnchor=&quot;middle&quot; fontSize=&quot;14&quot; fontWeight=&quot;bold&quot; fill=&quot;#172133&quot;&gt;worker 物业 ×75&lt;/text&gt;&#10;        &lt;text x=&quot;438&quot; y=&quot;254&quot; textAnchor=&quot;middle&quot; fontSize=&quot;11&quot; fill=&quot;#5F5E5A&quot;&gt;10 管理 / 15 维修 / 50 一线&lt;/text&gt;&#10;&#10;        {/* 分组3：业务数据 */}&#10;        &lt;text x=&quot;726&quot; y=&quot;128&quot; textAnchor=&quot;middle&quot; fontSize=&quot;12&quot; fontWeight=&quot;bold&quot; fill=&quot;#BD9B56&quot;&gt;业务数据&lt;/text&gt;&#10;        &lt;rect x=&quot;596&quot; y=&quot;138&quot; width=&quot;260&quot; height=&quot;40&quot; rx=&quot;8&quot; fill=&quot;rgba(34,57,94,0.06)&quot; stroke=&quot;#22395E&quot; strokeWidth=&quot;1.5&quot; /&gt;&#10;        &lt;text x=&quot;726&quot; y=&quot;163&quot; textAnchor=&quot;middle&quot; fontSize=&quot;13&quot; fontWeight=&quot;bold&quot; fill=&quot;#172133&quot;&gt;repair_order 工单 ×50&lt;/text&gt;&#10;        &lt;rect x=&quot;596&quot; y=&quot;186&quot; width=&quot;260&quot; height=&quot;40&quot; rx=&quot;8&quot; fill=&quot;rgba(34,57,94,0.06)&quot; stroke=&quot;#22395E&quot; strokeWidth=&quot;1.5&quot; /&gt;&#10;        &lt;text x=&quot;726&quot; y=&quot;211&quot; textAnchor=&quot;middle&quot; fontSize=&quot;13&quot; fontWeight=&quot;bold&quot; fill=&quot;#172133&quot;&gt;fee_bill 账单 ×746&lt;/text&gt;&#10;        &lt;rect x=&quot;596&quot; y=&quot;234&quot; width=&quot;260&quot; height=&quot;40&quot; rx=&quot;8&quot; fill=&quot;rgba(34,57,94,0.06)&quot; stroke=&quot;#22395E&quot; strokeWidth=&quot;1.5&quot; /&gt;&#10;        &lt;text x=&quot;726&quot; y=&quot;259&quot; textAnchor=&quot;middle&quot; fontSize=&quot;13&quot; fontWeight=&quot;bold&quot; fill=&quot;#172133&quot;&gt;notice 公告 ×24&lt;/text&gt;&#10;&#10;        {/* 分组4：知识资产 */}&#10;        &lt;text x=&quot;1015&quot; y=&quot;128&quot; textAnchor=&quot;middle&quot; fontSize=&quot;12&quot; fontWeight=&quot;bold&quot; fill=&quot;#BD9B56&quot;&gt;知识资产&lt;/text&gt;&#10;        &lt;rect x=&quot;885&quot; y=&quot;138&quot; width=&quot;260&quot; height=&quot;56&quot; rx=&quot;8&quot; fill=&quot;#22395E&quot; /&gt;&#10;        &lt;text x=&quot;1015&quot; y=&quot;162&quot; textAnchor=&quot;middle&quot; fontSize=&quot;14&quot; fontWeight=&quot;bold&quot; fill=&quot;#FBFCFA&quot;&gt;knowledge 文档 ×22&lt;/text&gt;&#10;        &lt;text x=&quot;1015&quot; y=&quot;182&quot; textAnchor=&quot;middle&quot; fontSize=&quot;11&quot; fill=&quot;#BD9B56&quot;&gt;7 个分类（规约/装修/停车…）&lt;/text&gt;&#10;        &lt;line x1=&quot;1015&quot; y1=&quot;194&quot; x2=&quot;1015&quot; y2=&quot;206&quot; stroke=&quot;#BD9B56&quot; strokeWidth=&quot;1.2&quot; /&gt;&#10;        &lt;rect x=&quot;885&quot; y=&quot;210&quot; width=&quot;260&quot; height=&quot;56&quot; rx=&quot;8&quot; fill=&quot;rgba(34,57,94,0.06)&quot; stroke=&quot;#BD9B56&quot; strokeWidth=&quot;1.5&quot; /&gt;&#10;        &lt;text x=&quot;1015&quot; y=&quot;234&quot; textAnchor=&quot;middle&quot; fontSize=&quot;14&quot; fontWeight=&quot;bold&quot; fill=&quot;#172133&quot;&gt;chunk 切片 ×99&lt;/text&gt;&#10;        &lt;text x=&quot;1015&quot; y=&quot;254&quot; textAnchor=&quot;middle&quot; fontSize=&quot;11&quot; fill=&quot;#5F5E5A&quot;&gt;pgvector 1024 维向量&lt;/text&gt;&#10;&#10;        {/* 底部关系说明 */}&#10;        &lt;rect x=&quot;300&quot; y=&quot;290&quot; width=&quot;550&quot; height=&quot;48&quot; rx=&quot;8&quot; fill=&quot;rgba(189,155,86,0.10)&quot; /&gt;&#10;        &lt;text x=&quot;575&quot; y=&quot;318&quot; textAnchor=&quot;middle&quot; fontSize=&quot;12&quot; fill=&quot;#172133&quot;&gt;repair_order → user + house + worker · fee_bill → house + user · 外键关联&lt;/text&gt;&#10;        &lt;text x=&quot;575&quot; y=&quot;334&quot; textAnchor=&quot;middle&quot; fontSize=&quot;11&quot; fill=&quot;#5F5E5A&quot;&gt;8 个 SQL 种子文件 · 一键导入可复现&lt;/text&gt;&#10;      &lt;/g&gt;&#10;    &lt;/svg&gt;&#10;  &lt;/div&gt;&#10;  &lt;div style={{ flexShrink: 0, height: 40, display: 'flex', alignItems: 'flex-end', justifyContent: 'space-between' }}&gt;&#10;    &lt;span style={{ color: '#BD9B56', fontSize: 12, letterSpacing: '0.1em' }}&gt;云溪花园 · 智慧社区&lt;/span&gt;&#10;    &lt;span style={{ color: '#a09b8c', fontSize: 12 }}&gt;05 / 15&lt;/span&gt;&#10;  &lt;/div&gt;&#10;&lt;/Slide&gt;"/>
         <p:cNvGrpSpPr/>
         <p:nvPr/>
       </p:nvGrpSpPr>
@@ -14289,7 +14537,7 @@
       </p:grpSpPr>
       <p:sp>
         <p:nvSpPr>
-          <p:cNvPr id="304" name=""/>
+          <p:cNvPr id="308" name=""/>
           <p:cNvSpPr/>
           <p:nvPr/>
         </p:nvSpPr>
@@ -14313,7 +14561,7 @@
       </p:sp>
       <p:sp>
         <p:nvSpPr>
-          <p:cNvPr id="305" name="" descr="{&quot;isTemplate&quot;:true,&quot;type&quot;:&quot;text&quot;}"/>
+          <p:cNvPr id="309" name="" descr="{&quot;isTemplate&quot;:true,&quot;type&quot;:&quot;text&quot;}"/>
           <p:cNvSpPr txBox="1"/>
           <p:nvPr/>
         </p:nvSpPr>
@@ -14358,7 +14606,7 @@
       </p:sp>
       <p:sp>
         <p:nvSpPr>
-          <p:cNvPr id="306" name="" descr="{&quot;isTemplate&quot;:true,&quot;type&quot;:&quot;text&quot;}"/>
+          <p:cNvPr id="310" name="" descr="{&quot;isTemplate&quot;:true,&quot;type&quot;:&quot;text&quot;}"/>
           <p:cNvSpPr txBox="1"/>
           <p:nvPr/>
         </p:nvSpPr>
@@ -14393,7 +14641,7 @@
       </p:sp>
       <p:sp>
         <p:nvSpPr>
-          <p:cNvPr id="307" name="" descr="{&quot;isTemplate&quot;:true,&quot;type&quot;:&quot;text&quot;}"/>
+          <p:cNvPr id="311" name="" descr="{&quot;isTemplate&quot;:true,&quot;type&quot;:&quot;text&quot;}"/>
           <p:cNvSpPr txBox="1"/>
           <p:nvPr/>
         </p:nvSpPr>
@@ -14428,7 +14676,7 @@
       </p:sp>
       <p:pic>
         <p:nvPicPr>
-          <p:cNvPr id="308" name=""/>
+          <p:cNvPr id="312" name=""/>
           <p:cNvPicPr>
             <a:picLocks noChangeAspect="1"/>
           </p:cNvPicPr>
@@ -14459,7 +14707,7 @@
       </p:pic>
       <p:sp>
         <p:nvSpPr>
-          <p:cNvPr id="309" name="" descr="{&quot;isTemplate&quot;:true,&quot;type&quot;:&quot;text&quot;}"/>
+          <p:cNvPr id="313" name="" descr="{&quot;isTemplate&quot;:true,&quot;type&quot;:&quot;text&quot;}"/>
           <p:cNvSpPr txBox="1"/>
           <p:nvPr/>
         </p:nvSpPr>
@@ -14514,7 +14762,7 @@
       </p:sp>
       <p:sp>
         <p:nvSpPr>
-          <p:cNvPr id="310" name="" descr="{&quot;isTemplate&quot;:true,&quot;type&quot;:&quot;text&quot;}"/>
+          <p:cNvPr id="314" name="" descr="{&quot;isTemplate&quot;:true,&quot;type&quot;:&quot;text&quot;}"/>
           <p:cNvSpPr txBox="1"/>
           <p:nvPr/>
         </p:nvSpPr>
@@ -14557,7 +14805,7 @@
   <p:cSld>
     <p:spTree>
       <p:nvGrpSpPr>
-        <p:cNvPr id="311" name="" descr="&lt;Slide style={{ width: '1280px', height: '720px', background: '#FBFCFA', position: 'relative', padding: '40px 64px', boxSizing: 'border-box', display: 'flex', flexDirection: 'column' }}&gt;&#10;  &lt;div style={{ flexShrink: 0 }}&gt;&#10;    &lt;div style={{ color: '#BD9B56', fontSize: 13, letterSpacing: '0.25em', marginBottom: 8 }}&gt;02 · 技术构建过程&lt;/div&gt;&#10;    &lt;h2 style={{ fontSize: 30, fontWeight: 'bold', color: '#172133', margin: 0, lineHeight: 1.3 }}&gt;技术架构：六层分离的 AI Native 系统&lt;/h2&gt;&#10;  &lt;/div&gt;&#10;  &lt;div style={{ flex: 1, display: 'flex', alignItems: 'center', gap: 32 }}&gt;&#10;    &lt;div style={{ flex: '0 0 620px', background: '#fff', borderRadius: 12, padding: '22px 24px', boxShadow: '0 6px 24px rgba(23,33,51,0.08)' }}&gt;&#10;      &lt;svg width=&quot;572&quot; height=&quot;470&quot; viewBox=&quot;0 0 572 470&quot;&gt;&#10;        &lt;defs&gt;&#10;          &lt;marker id=&quot;ar6&quot; viewBox=&quot;0 0 10 10&quot; refX=&quot;9&quot; refY=&quot;5&quot; markerWidth=&quot;6&quot; markerHeight=&quot;6&quot; orient=&quot;auto&quot;&gt;&#10;            &lt;path d=&quot;M0 0L10 5L0 10z&quot; fill=&quot;#22395E&quot; /&gt;&#10;          &lt;/marker&gt;&#10;        &lt;/defs&gt;&#10;        &lt;g fontFamily=&quot;Inter, sans-serif&quot;&gt;&#10;          &lt;rect x=&quot;36&quot; y=&quot;18&quot; width=&quot;500&quot; height=&quot;52&quot; rx=&quot;6&quot; fill=&quot;#F5F8F8&quot; stroke=&quot;#22395E&quot; strokeWidth=&quot;1.5&quot; /&gt;&#10;          &lt;text x=&quot;286&quot; y=&quot;49&quot; textAnchor=&quot;middle&quot; fontSize=&quot;14&quot; fontWeight=&quot;bold&quot; fill=&quot;#172133&quot;&gt;客户端 · 业主 / 物业 / 维修 三端&lt;/text&gt;&#10;          &lt;line x1=&quot;286&quot; y1=&quot;70&quot; x2=&quot;286&quot; y2=&quot;92&quot; stroke=&quot;#22395E&quot; strokeWidth=&quot;1.2&quot; markerEnd=&quot;url(#ar6)&quot; /&gt;&#10;          &lt;rect x=&quot;36&quot; y=&quot;96&quot; width=&quot;500&quot; height=&quot;48&quot; rx=&quot;6&quot; fill=&quot;#F5F8F8&quot; stroke=&quot;#22395E&quot; strokeWidth=&quot;1.5&quot; /&gt;&#10;          &lt;text x=&quot;286&quot; y=&quot;125&quot; textAnchor=&quot;middle&quot; fontSize=&quot;14&quot; fontWeight=&quot;bold&quot; fill=&quot;#172133&quot;&gt;API 网关 · FastAPI&lt;/text&gt;&#10;          &lt;line x1=&quot;286&quot; y1=&quot;144&quot; x2=&quot;286&quot; y2=&quot;166&quot; stroke=&quot;#22395E&quot; strokeWidth=&quot;1.2&quot; markerEnd=&quot;url(#ar6)&quot; /&gt;&#10;          &lt;rect x=&quot;36&quot; y=&quot;170&quot; width=&quot;500&quot; height=&quot;70&quot; rx=&quot;6&quot; fill=&quot;rgba(34,57,94,0.08)&quot; stroke=&quot;#22395E&quot; strokeWidth=&quot;2&quot; /&gt;&#10;          &lt;text x=&quot;64&quot; y=&quot;196&quot; fontSize=&quot;13&quot; fontWeight=&quot;bold&quot; fill=&quot;#BD9B56&quot;&gt;AI Agent 层&lt;/text&gt;&#10;          &lt;text x=&quot;286&quot; y=&quot;218&quot; textAnchor=&quot;middle&quot; fontSize=&quot;14&quot; fontWeight=&quot;bold&quot; fill=&quot;#172133&quot;&gt;Router Agent + 领域 Agent + 工具调用&lt;/text&gt;&#10;          &lt;line x1=&quot;286&quot; y1=&quot;240&quot; x2=&quot;286&quot; y2=&quot;262&quot; stroke=&quot;#22395E&quot; strokeWidth=&quot;1.2&quot; markerEnd=&quot;url(#ar6)&quot; /&gt;&#10;          &lt;rect x=&quot;36&quot; y=&quot;266&quot; width=&quot;500&quot; height=&quot;56&quot; rx=&quot;6&quot; fill=&quot;rgba(189,155,86,0.08)&quot; stroke=&quot;#BD9B56&quot; strokeWidth=&quot;1.5&quot; /&gt;&#10;          &lt;text x=&quot;64&quot; y=&quot;290&quot; fontSize=&quot;13&quot; fontWeight=&quot;bold&quot; fill=&quot;#BD9B56&quot;&gt;业务服务层&lt;/text&gt;&#10;          &lt;text x=&quot;286&quot; y=&quot;312&quot; textAnchor=&quot;middle&quot; fontSize=&quot;14&quot; fontWeight=&quot;bold&quot; fill=&quot;#172133&quot;&gt;工单 · 费用 · 巡检 · 通知 · 反馈 · 知识库&lt;/text&gt;&#10;          &lt;line x1=&quot;286&quot; y1=&quot;322&quot; x2=&quot;286&quot; y2=&quot;344&quot; stroke=&quot;#22395E&quot; strokeWidth=&quot;1.2&quot; markerEnd=&quot;url(#ar6)&quot; /&gt;&#10;          &lt;rect x=&quot;36&quot; y=&quot;348&quot; width=&quot;240&quot; height=&quot;60&quot; rx=&quot;6&quot; fill=&quot;#F5F8F8&quot; stroke=&quot;#22395E&quot; strokeWidth=&quot;1.5&quot; /&gt;&#10;          &lt;text x=&quot;156&quot; y=&quot;374&quot; textAnchor=&quot;middle&quot; fontSize=&quot;13&quot; fontWeight=&quot;bold&quot; fill=&quot;#BD9B56&quot;&gt;PostgreSQL + pgvector&lt;/text&gt;&#10;          &lt;text x=&quot;156&quot; y=&quot;394&quot; textAnchor=&quot;middle&quot; fontSize=&quot;11&quot; fill=&quot;#5F5E5A&quot;&gt;事务数据 + 向量检索&lt;/text&gt;&#10;          &lt;rect x=&quot;296&quot; y=&quot;348&quot; width=&quot;240&quot; height=&quot;60&quot; rx=&quot;6&quot; fill=&quot;#F5F8F8&quot; stroke=&quot;#22395E&quot; strokeWidth=&quot;1.5&quot; /&gt;&#10;          &lt;text x=&quot;416&quot; y=&quot;374&quot; textAnchor=&quot;middle&quot; fontSize=&quot;13&quot; fontWeight=&quot;bold&quot; fill=&quot;#BD9B56&quot;&gt;Redis + 智谱 GLM&lt;/text&gt;&#10;          &lt;text x=&quot;416&quot; y=&quot;394&quot; textAnchor=&quot;middle&quot; fontSize=&quot;11&quot; fill=&quot;#5F5E5A&quot;&gt;缓存 · LLM · embedding&lt;/text&gt;&#10;        &lt;/g&gt;&#10;      &lt;/svg&gt;&#10;    &lt;/div&gt;&#10;    &lt;div style={{ flex: 1, display: 'flex', flexDirection: 'column', gap: 18 }}&gt;&#10;      &lt;div&gt;&#10;        &lt;div style={{ fontSize: 14, color: '#BD9B56', fontWeight: 'bold', letterSpacing: '0.1em', marginBottom: 6 }}&gt;1.  Agent 与业务解耦&lt;/div&gt;&#10;        &lt;p style={{ fontSize: 14, color: '#5F5E5A', margin: 0, lineHeight: 1.65 }}&gt;AI Agent 只负责理解意图、编排工具，不直接操作数据库，严守 Agent → Tool → Service → Repository → Database 分层，杜绝 LLM 直连 SQL 的风险。&lt;/p&gt;&#10;      &lt;/div&gt;&#10;      &lt;div&gt;&#10;        &lt;div style={{ fontSize: 14, color: '#BD9B56', fontWeight: 'bold', letterSpacing: '0.1em', marginBottom: 6 }}&gt;2.  pgvector 一库双角色&lt;/div&gt;&#10;        &lt;p style={{ fontSize: 14, color: '#5F5E5A', margin: 0, lineHeight: 1.65 }}&gt;PostgreSQL 同时承载业务数据（工单、费用）和向量数据（知识切片），无需额外向量数据库，降低部署与运维复杂度。&lt;/p&gt;&#10;      &lt;/div&gt;&#10;      &lt;div&gt;&#10;        &lt;div style={{ fontSize: 14, color: '#BD9B56', fontWeight: 'bold', letterSpacing: '0.1em', marginBottom: 6 }}&gt;3.  可观测可评估&lt;/div&gt;&#10;        &lt;p style={{ fontSize: 14, color: '#5F5E5A', margin: 0, lineHeight: 1.65 }}&gt;每次 AI 对话的意图、工具调用、结果全程记录，可回放、可追踪，支撑后续的量化评估与持续迭代。&lt;/p&gt;&#10;      &lt;/div&gt;&#10;    &lt;/div&gt;&#10;  &lt;/div&gt;&#10;  &lt;div style={{ flexShrink: 0, height: 40, display: 'flex', alignItems: 'flex-end', justifyContent: 'space-between' }}&gt;&#10;    &lt;span style={{ color: '#BD9B56', fontSize: 12, letterSpacing: '0.1em' }}&gt;云溪花园 · 智慧社区&lt;/span&gt;&#10;    &lt;span style={{ color: '#a09b8c', fontSize: 12 }}&gt;06 / 15&lt;/span&gt;&#10;  &lt;/div&gt;&#10;&lt;/Slide&gt;"/>
+        <p:cNvPr id="315" name="" descr="&lt;Slide style={{ width: '1280px', height: '720px', background: '#FBFCFA', position: 'relative', padding: '40px 64px', boxSizing: 'border-box', display: 'flex', flexDirection: 'column' }}&gt;&#10;  &lt;div style={{ flexShrink: 0 }}&gt;&#10;    &lt;div style={{ color: '#BD9B56', fontSize: 13, letterSpacing: '0.25em', marginBottom: 8 }}&gt;02 · 技术构建过程&lt;/div&gt;&#10;    &lt;h2 style={{ fontSize: 30, fontWeight: 'bold', color: '#172133', margin: 0, lineHeight: 1.3 }}&gt;技术架构：六层分离的 AI Native 系统&lt;/h2&gt;&#10;  &lt;/div&gt;&#10;  &lt;div style={{ flex: 1, display: 'flex', alignItems: 'center', gap: 32 }}&gt;&#10;    &lt;div style={{ flex: '0 0 620px', background: '#fff', borderRadius: 12, padding: '22px 24px', boxShadow: '0 6px 24px rgba(23,33,51,0.08)' }}&gt;&#10;      &lt;svg width=&quot;572&quot; height=&quot;470&quot; viewBox=&quot;0 0 572 470&quot;&gt;&#10;        &lt;defs&gt;&#10;          &lt;marker id=&quot;ar6&quot; viewBox=&quot;0 0 10 10&quot; refX=&quot;9&quot; refY=&quot;5&quot; markerWidth=&quot;6&quot; markerHeight=&quot;6&quot; orient=&quot;auto&quot;&gt;&#10;            &lt;path d=&quot;M0 0L10 5L0 10z&quot; fill=&quot;#22395E&quot; /&gt;&#10;          &lt;/marker&gt;&#10;        &lt;/defs&gt;&#10;        &lt;g fontFamily=&quot;Inter, sans-serif&quot;&gt;&#10;          &lt;rect x=&quot;36&quot; y=&quot;18&quot; width=&quot;500&quot; height=&quot;52&quot; rx=&quot;6&quot; fill=&quot;#F5F8F8&quot; stroke=&quot;#22395E&quot; strokeWidth=&quot;1.5&quot; /&gt;&#10;          &lt;text x=&quot;286&quot; y=&quot;49&quot; textAnchor=&quot;middle&quot; fontSize=&quot;14&quot; fontWeight=&quot;bold&quot; fill=&quot;#172133&quot;&gt;客户端 · 业主 / 物业 / 维修 三端&lt;/text&gt;&#10;          &lt;line x1=&quot;286&quot; y1=&quot;70&quot; x2=&quot;286&quot; y2=&quot;92&quot; stroke=&quot;#22395E&quot; strokeWidth=&quot;1.2&quot; markerEnd=&quot;url(#ar6)&quot; /&gt;&#10;          &lt;rect x=&quot;36&quot; y=&quot;96&quot; width=&quot;500&quot; height=&quot;48&quot; rx=&quot;6&quot; fill=&quot;#F5F8F8&quot; stroke=&quot;#22395E&quot; strokeWidth=&quot;1.5&quot; /&gt;&#10;          &lt;text x=&quot;286&quot; y=&quot;125&quot; textAnchor=&quot;middle&quot; fontSize=&quot;14&quot; fontWeight=&quot;bold&quot; fill=&quot;#172133&quot;&gt;API 网关 · FastAPI&lt;/text&gt;&#10;          &lt;line x1=&quot;286&quot; y1=&quot;144&quot; x2=&quot;286&quot; y2=&quot;166&quot; stroke=&quot;#22395E&quot; strokeWidth=&quot;1.2&quot; markerEnd=&quot;url(#ar6)&quot; /&gt;&#10;          &lt;rect x=&quot;36&quot; y=&quot;170&quot; width=&quot;500&quot; height=&quot;70&quot; rx=&quot;6&quot; fill=&quot;rgba(34,57,94,0.08)&quot; stroke=&quot;#22395E&quot; strokeWidth=&quot;2&quot; /&gt;&#10;          &lt;text x=&quot;64&quot; y=&quot;196&quot; fontSize=&quot;13&quot; fontWeight=&quot;bold&quot; fill=&quot;#BD9B56&quot;&gt;AI Agent 层&lt;/text&gt;&#10;          &lt;text x=&quot;286&quot; y=&quot;218&quot; textAnchor=&quot;middle&quot; fontSize=&quot;14&quot; fontWeight=&quot;bold&quot; fill=&quot;#172133&quot;&gt;Router Agent + 领域 Agent + 工具调用&lt;/text&gt;&#10;          &lt;line x1=&quot;286&quot; y1=&quot;240&quot; x2=&quot;286&quot; y2=&quot;262&quot; stroke=&quot;#22395E&quot; strokeWidth=&quot;1.2&quot; markerEnd=&quot;url(#ar6)&quot; /&gt;&#10;          &lt;rect x=&quot;36&quot; y=&quot;266&quot; width=&quot;500&quot; height=&quot;56&quot; rx=&quot;6&quot; fill=&quot;rgba(189,155,86,0.08)&quot; stroke=&quot;#BD9B56&quot; strokeWidth=&quot;1.5&quot; /&gt;&#10;          &lt;text x=&quot;64&quot; y=&quot;290&quot; fontSize=&quot;13&quot; fontWeight=&quot;bold&quot; fill=&quot;#BD9B56&quot;&gt;业务服务层&lt;/text&gt;&#10;          &lt;text x=&quot;286&quot; y=&quot;312&quot; textAnchor=&quot;middle&quot; fontSize=&quot;14&quot; fontWeight=&quot;bold&quot; fill=&quot;#172133&quot;&gt;工单 · 费用 · 巡检 · 通知 · 反馈 · 知识库&lt;/text&gt;&#10;          &lt;line x1=&quot;286&quot; y1=&quot;322&quot; x2=&quot;286&quot; y2=&quot;344&quot; stroke=&quot;#22395E&quot; strokeWidth=&quot;1.2&quot; markerEnd=&quot;url(#ar6)&quot; /&gt;&#10;          &lt;rect x=&quot;36&quot; y=&quot;348&quot; width=&quot;240&quot; height=&quot;60&quot; rx=&quot;6&quot; fill=&quot;#F5F8F8&quot; stroke=&quot;#22395E&quot; strokeWidth=&quot;1.5&quot; /&gt;&#10;          &lt;text x=&quot;156&quot; y=&quot;374&quot; textAnchor=&quot;middle&quot; fontSize=&quot;13&quot; fontWeight=&quot;bold&quot; fill=&quot;#BD9B56&quot;&gt;PostgreSQL + pgvector&lt;/text&gt;&#10;          &lt;text x=&quot;156&quot; y=&quot;394&quot; textAnchor=&quot;middle&quot; fontSize=&quot;11&quot; fill=&quot;#5F5E5A&quot;&gt;事务数据 + 向量检索&lt;/text&gt;&#10;          &lt;rect x=&quot;296&quot; y=&quot;348&quot; width=&quot;240&quot; height=&quot;60&quot; rx=&quot;6&quot; fill=&quot;#F5F8F8&quot; stroke=&quot;#22395E&quot; strokeWidth=&quot;1.5&quot; /&gt;&#10;          &lt;text x=&quot;416&quot; y=&quot;374&quot; textAnchor=&quot;middle&quot; fontSize=&quot;13&quot; fontWeight=&quot;bold&quot; fill=&quot;#BD9B56&quot;&gt;Redis + 智谱 GLM&lt;/text&gt;&#10;          &lt;text x=&quot;416&quot; y=&quot;394&quot; textAnchor=&quot;middle&quot; fontSize=&quot;11&quot; fill=&quot;#5F5E5A&quot;&gt;缓存 · LLM · embedding&lt;/text&gt;&#10;        &lt;/g&gt;&#10;      &lt;/svg&gt;&#10;    &lt;/div&gt;&#10;    &lt;div style={{ flex: 1, display: 'flex', flexDirection: 'column', gap: 18 }}&gt;&#10;      &lt;div&gt;&#10;        &lt;div style={{ fontSize: 14, color: '#BD9B56', fontWeight: 'bold', letterSpacing: '0.1em', marginBottom: 6 }}&gt;1.  Agent 与业务解耦&lt;/div&gt;&#10;        &lt;p style={{ fontSize: 14, color: '#5F5E5A', margin: 0, lineHeight: 1.65 }}&gt;AI Agent 只负责理解意图、编排工具，不直接操作数据库，严守 Agent → Tool → Service → Repository → Database 分层，杜绝 LLM 直连 SQL 的风险。&lt;/p&gt;&#10;      &lt;/div&gt;&#10;      &lt;div&gt;&#10;        &lt;div style={{ fontSize: 14, color: '#BD9B56', fontWeight: 'bold', letterSpacing: '0.1em', marginBottom: 6 }}&gt;2.  pgvector 一库双角色&lt;/div&gt;&#10;        &lt;p style={{ fontSize: 14, color: '#5F5E5A', margin: 0, lineHeight: 1.65 }}&gt;PostgreSQL 同时承载业务数据（工单、费用）和向量数据（知识切片），无需额外向量数据库，降低部署与运维复杂度。&lt;/p&gt;&#10;      &lt;/div&gt;&#10;      &lt;div&gt;&#10;        &lt;div style={{ fontSize: 14, color: '#BD9B56', fontWeight: 'bold', letterSpacing: '0.1em', marginBottom: 6 }}&gt;3.  可观测可评估&lt;/div&gt;&#10;        &lt;p style={{ fontSize: 14, color: '#5F5E5A', margin: 0, lineHeight: 1.65 }}&gt;每次 AI 对话的意图、工具调用、结果全程记录，可回放、可追踪，支撑后续的量化评估与持续迭代。&lt;/p&gt;&#10;      &lt;/div&gt;&#10;    &lt;/div&gt;&#10;  &lt;/div&gt;&#10;  &lt;div style={{ flexShrink: 0, height: 40, display: 'flex', alignItems: 'flex-end', justifyContent: 'space-between' }}&gt;&#10;    &lt;span style={{ color: '#BD9B56', fontSize: 12, letterSpacing: '0.1em' }}&gt;云溪花园 · 智慧社区&lt;/span&gt;&#10;    &lt;span style={{ color: '#a09b8c', fontSize: 12 }}&gt;06 / 15&lt;/span&gt;&#10;  &lt;/div&gt;&#10;&lt;/Slide&gt;"/>
         <p:cNvGrpSpPr/>
         <p:nvPr/>
       </p:nvGrpSpPr>
@@ -14571,7 +14819,7 @@
       </p:grpSpPr>
       <p:sp>
         <p:nvSpPr>
-          <p:cNvPr id="312" name=""/>
+          <p:cNvPr id="316" name=""/>
           <p:cNvSpPr/>
           <p:nvPr/>
         </p:nvSpPr>
@@ -14595,7 +14843,7 @@
       </p:sp>
       <p:sp>
         <p:nvSpPr>
-          <p:cNvPr id="313" name="" descr="{&quot;isTemplate&quot;:true,&quot;type&quot;:&quot;text&quot;}"/>
+          <p:cNvPr id="317" name="" descr="{&quot;isTemplate&quot;:true,&quot;type&quot;:&quot;text&quot;}"/>
           <p:cNvSpPr txBox="1"/>
           <p:nvPr/>
         </p:nvSpPr>
@@ -14640,7 +14888,7 @@
       </p:sp>
       <p:sp>
         <p:nvSpPr>
-          <p:cNvPr id="314" name="" descr="{&quot;isTemplate&quot;:true,&quot;type&quot;:&quot;text&quot;}"/>
+          <p:cNvPr id="318" name="" descr="{&quot;isTemplate&quot;:true,&quot;type&quot;:&quot;text&quot;}"/>
           <p:cNvSpPr txBox="1"/>
           <p:nvPr/>
         </p:nvSpPr>
@@ -14695,7 +14943,7 @@
       </p:sp>
       <p:sp>
         <p:nvSpPr>
-          <p:cNvPr id="315" name=""/>
+          <p:cNvPr id="319" name=""/>
           <p:cNvSpPr/>
           <p:nvPr/>
         </p:nvSpPr>
@@ -14728,7 +14976,7 @@
       </p:sp>
       <p:pic>
         <p:nvPicPr>
-          <p:cNvPr id="316" name=""/>
+          <p:cNvPr id="320" name=""/>
           <p:cNvPicPr>
             <a:picLocks noChangeAspect="1"/>
           </p:cNvPicPr>
@@ -14759,7 +15007,7 @@
       </p:pic>
       <p:sp>
         <p:nvSpPr>
-          <p:cNvPr id="317" name="" descr="{&quot;isTemplate&quot;:true,&quot;type&quot;:&quot;text&quot;}"/>
+          <p:cNvPr id="321" name="" descr="{&quot;isTemplate&quot;:true,&quot;type&quot;:&quot;text&quot;}"/>
           <p:cNvSpPr txBox="1"/>
           <p:nvPr/>
         </p:nvSpPr>
@@ -14804,7 +15052,7 @@
       </p:sp>
       <p:sp>
         <p:nvSpPr>
-          <p:cNvPr id="318" name="" descr="{&quot;isTemplate&quot;:true,&quot;type&quot;:&quot;text&quot;}"/>
+          <p:cNvPr id="322" name="" descr="{&quot;isTemplate&quot;:true,&quot;type&quot;:&quot;text&quot;}"/>
           <p:cNvSpPr txBox="1"/>
           <p:nvPr/>
         </p:nvSpPr>
@@ -14911,7 +15159,7 @@
       </p:sp>
       <p:sp>
         <p:nvSpPr>
-          <p:cNvPr id="319" name="" descr="{&quot;isTemplate&quot;:true,&quot;type&quot;:&quot;text&quot;}"/>
+          <p:cNvPr id="323" name="" descr="{&quot;isTemplate&quot;:true,&quot;type&quot;:&quot;text&quot;}"/>
           <p:cNvSpPr txBox="1"/>
           <p:nvPr/>
         </p:nvSpPr>
@@ -14956,7 +15204,7 @@
       </p:sp>
       <p:sp>
         <p:nvSpPr>
-          <p:cNvPr id="320" name="" descr="{&quot;isTemplate&quot;:true,&quot;type&quot;:&quot;text&quot;}"/>
+          <p:cNvPr id="324" name="" descr="{&quot;isTemplate&quot;:true,&quot;type&quot;:&quot;text&quot;}"/>
           <p:cNvSpPr txBox="1"/>
           <p:nvPr/>
         </p:nvSpPr>
@@ -15003,7 +15251,7 @@
       </p:sp>
       <p:sp>
         <p:nvSpPr>
-          <p:cNvPr id="321" name="" descr="{&quot;isTemplate&quot;:true,&quot;type&quot;:&quot;text&quot;}"/>
+          <p:cNvPr id="325" name="" descr="{&quot;isTemplate&quot;:true,&quot;type&quot;:&quot;text&quot;}"/>
           <p:cNvSpPr txBox="1"/>
           <p:nvPr/>
         </p:nvSpPr>
@@ -15048,7 +15296,7 @@
       </p:sp>
       <p:sp>
         <p:nvSpPr>
-          <p:cNvPr id="322" name="" descr="{&quot;isTemplate&quot;:true,&quot;type&quot;:&quot;text&quot;}"/>
+          <p:cNvPr id="326" name="" descr="{&quot;isTemplate&quot;:true,&quot;type&quot;:&quot;text&quot;}"/>
           <p:cNvSpPr txBox="1"/>
           <p:nvPr/>
         </p:nvSpPr>
@@ -15105,7 +15353,7 @@
       </p:sp>
       <p:sp>
         <p:nvSpPr>
-          <p:cNvPr id="323" name="" descr="{&quot;isTemplate&quot;:true,&quot;type&quot;:&quot;text&quot;}"/>
+          <p:cNvPr id="327" name="" descr="{&quot;isTemplate&quot;:true,&quot;type&quot;:&quot;text&quot;}"/>
           <p:cNvSpPr txBox="1"/>
           <p:nvPr/>
         </p:nvSpPr>
@@ -15160,7 +15408,7 @@
       </p:sp>
       <p:sp>
         <p:nvSpPr>
-          <p:cNvPr id="324" name="" descr="{&quot;isTemplate&quot;:true,&quot;type&quot;:&quot;text&quot;}"/>
+          <p:cNvPr id="328" name="" descr="{&quot;isTemplate&quot;:true,&quot;type&quot;:&quot;text&quot;}"/>
           <p:cNvSpPr txBox="1"/>
           <p:nvPr/>
         </p:nvSpPr>
@@ -15203,7 +15451,7 @@
   <p:cSld>
     <p:spTree>
       <p:nvGrpSpPr>
-        <p:cNvPr id="325" name="" descr="&lt;Slide style={{ width: '1280px', height: '720px', background: '#FBFCFA', position: 'relative', padding: '32px 64px', boxSizing: 'border-box', display: 'flex', flexDirection: 'column' }}&gt;&#10;  &lt;div style={{ flexShrink: 0 }}&gt;&#10;    &lt;div style={{ color: '#BD9B56', fontSize: 13, letterSpacing: '0.25em', marginBottom: 6 }}&gt;02 · 技术构建过程&lt;/div&gt;&#10;    &lt;h2 style={{ fontSize: 30, fontWeight: 'bold', color: '#172133', margin: 0, lineHeight: 1.3 }}&gt;数据库设计：15+ 张表承载整个社区&lt;/h2&gt;&#10;    &lt;div style={{ fontSize: 14, color: '#6b7075', marginTop: 6 }}&gt;数据库是系统地基，通过外键建立完整 ER 关系，覆盖社区到知识库的全部实体&lt;/div&gt;&#10;  &lt;/div&gt;&#10;  &lt;div style={{ flex: 1, display: 'flex', alignItems: 'center', minHeight: 0, gap: 28 }}&gt;&#10;    &lt;div style={{ flex: '0 0 320px', background: 'linear-gradient(135deg, #172133 0%, #22395E 100%)', borderRadius: 12, padding: '24px 24px', color: '#FBFCFA' }}&gt;&#10;      &lt;div style={{ color: '#BD9B56', fontSize: 12, letterSpacing: '0.25em', marginBottom: 12 }}&gt;CORE ENTITIES&lt;/div&gt;&#10;      &lt;div style={{ fontSize: 14, color: 'rgba(251,252,250,0.9)', lineHeight: 1.9 }}&gt;&#10;        community 社区&lt;br/&gt;&#10;        building 楼栋（8）&lt;br/&gt;&#10;        house 房屋（1664）&lt;br/&gt;&#10;        user 用户（275）&lt;br/&gt;&#10;        house_binding 房屋绑定&lt;br/&gt;&#10;        worker 物业人员（75）&lt;br/&gt;&#10;        repair_order 工单&lt;br/&gt;&#10;        fee_bill 账单（746）&lt;br/&gt;&#10;        notice 公告（24）&lt;br/&gt;&#10;        conversation / message&lt;br/&gt;&#10;        agent_trace 追踪&lt;br/&gt;&#10;        &lt;span style={{ color: '#BD9B56' }}&gt;knowledge_document / chunk&lt;/span&gt;&#10;      &lt;/div&gt;&#10;    &lt;/div&gt;&#10;    &lt;div style={{ flex: 1, background: '#fff', borderRadius: 12, padding: '20px 22px', boxShadow: '0 6px 24px rgba(23,33,51,0.08)' }}&gt;&#10;      &lt;svg width=&quot;560&quot; height=&quot;470&quot; viewBox=&quot;0 0 560 470&quot;&gt;&#10;        &lt;g fontFamily=&quot;Inter, sans-serif&quot;&gt;&#10;          &lt;rect x=&quot;14&quot; y=&quot;14&quot; width=&quot;150&quot; height=&quot;50&quot; rx=&quot;6&quot; fill=&quot;rgba(34,57,94,0.08)&quot; stroke=&quot;#22395E&quot; strokeWidth=&quot;1.5&quot; /&gt;&#10;          &lt;text x=&quot;89&quot; y=&quot;44&quot; textAnchor=&quot;middle&quot; fontSize=&quot;14&quot; fontWeight=&quot;bold&quot; fill=&quot;#172133&quot;&gt;community&lt;/text&gt;&#10;          &lt;line x1=&quot;164&quot; y1=&quot;39&quot; x2=&quot;206&quot; y2=&quot;39&quot; stroke=&quot;#BD9B56&quot; strokeWidth=&quot;1.5&quot; /&gt;&#10;          &lt;rect x=&quot;210&quot; y=&quot;14&quot; width=&quot;150&quot; height=&quot;50&quot; rx=&quot;6&quot; fill=&quot;rgba(34,57,94,0.08)&quot; stroke=&quot;#22395E&quot; strokeWidth=&quot;1.5&quot; /&gt;&#10;          &lt;text x=&quot;285&quot; y=&quot;44&quot; textAnchor=&quot;middle&quot; fontSize=&quot;14&quot; fontWeight=&quot;bold&quot; fill=&quot;#172133&quot;&gt;building ×8&lt;/text&gt;&#10;          &lt;line x1=&quot;360&quot; y1=&quot;39&quot; x2=&quot;402&quot; y2=&quot;39&quot; stroke=&quot;#BD9B56&quot; strokeWidth=&quot;1.5&quot; /&gt;&#10;          &lt;rect x=&quot;406&quot; y=&quot;14&quot; width=&quot;150&quot; height=&quot;50&quot; rx=&quot;6&quot; fill=&quot;rgba(34,57,94,0.08)&quot; stroke=&quot;#22395E&quot; strokeWidth=&quot;1.5&quot; /&gt;&#10;          &lt;text x=&quot;481&quot; y=&quot;44&quot; textAnchor=&quot;middle&quot; fontSize=&quot;14&quot; fontWeight=&quot;bold&quot; fill=&quot;#172133&quot;&gt;house ×1664&lt;/text&gt;&#10;          &lt;line x1=&quot;285&quot; y1=&quot;64&quot; x2=&quot;285&quot; y2=&quot;104&quot; stroke=&quot;#BD9B56&quot; strokeWidth=&quot;1.5&quot; /&gt;&#10;          &lt;rect x=&quot;210&quot; y=&quot;108&quot; width=&quot;150&quot; height=&quot;50&quot; rx=&quot;6&quot; fill=&quot;rgba(189,155,86,0.10)&quot; stroke=&quot;#BD9B56&quot; strokeWidth=&quot;1.5&quot; /&gt;&#10;          &lt;text x=&quot;285&quot; y=&quot;138&quot; textAnchor=&quot;middle&quot; fontSize=&quot;14&quot; fontWeight=&quot;bold&quot; fill=&quot;#172133&quot;&gt;user ×275&lt;/text&gt;&#10;          &lt;line x1=&quot;210&quot; y1=&quot;133&quot; x2=&quot;164&quot; y2=&quot;133&quot; stroke=&quot;#BD9B56&quot; strokeWidth=&quot;1.5&quot; /&gt;&#10;          &lt;rect x=&quot;14&quot; y=&quot;108&quot; width=&quot;150&quot; height=&quot;50&quot; rx=&quot;6&quot; fill=&quot;rgba(189,155,86,0.10)&quot; stroke=&quot;#BD9B56&quot; strokeWidth=&quot;1.5&quot; /&gt;&#10;          &lt;text x=&quot;89&quot; y=&quot;138&quot; textAnchor=&quot;middle&quot; fontSize=&quot;14&quot; fontWeight=&quot;bold&quot; fill=&quot;#172133&quot;&gt;house_binding&lt;/text&gt;&#10;          &lt;line x1=&quot;285&quot; y1=&quot;158&quot; x2=&quot;285&quot; y2=&quot;198&quot; stroke=&quot;#BD9B56&quot; strokeWidth=&quot;1.5&quot; /&gt;&#10;          &lt;rect x=&quot;210&quot; y=&quot;202&quot; width=&quot;150&quot; height=&quot;50&quot; rx=&quot;6&quot; fill=&quot;rgba(34,57,94,0.08)&quot; stroke=&quot;#22395E&quot; strokeWidth=&quot;1.5&quot; /&gt;&#10;          &lt;text x=&quot;285&quot; y=&quot;232&quot; textAnchor=&quot;middle&quot; fontSize=&quot;14&quot; fontWeight=&quot;bold&quot; fill=&quot;#172133&quot;&gt;worker ×75&lt;/text&gt;&#10;          &lt;line x1=&quot;285&quot; y1=&quot;252&quot; x2=&quot;285&quot; y2=&quot;292&quot; stroke=&quot;#BD9B56&quot; strokeWidth=&quot;1.5&quot; /&gt;&#10;          &lt;rect x=&quot;160&quot; y=&quot;296&quot; width=&quot;130&quot; height=&quot;50&quot; rx=&quot;6&quot; fill=&quot;rgba(34,57,94,0.08)&quot; stroke=&quot;#22395E&quot; strokeWidth=&quot;1.5&quot; /&gt;&#10;          &lt;text x=&quot;225&quot; y=&quot;326&quot; textAnchor=&quot;middle&quot; fontSize=&quot;13&quot; fontWeight=&quot;bold&quot; fill=&quot;#172133&quot;&gt;repair_order&lt;/text&gt;&#10;          &lt;rect x=&quot;306&quot; y=&quot;296&quot; width=&quot;130&quot; height=&quot;50&quot; rx=&quot;6&quot; fill=&quot;rgba(34,57,94,0.08)&quot; stroke=&quot;#22395E&quot; strokeWidth=&quot;1.5&quot; /&gt;&#10;          &lt;text x=&quot;371&quot; y=&quot;326&quot; textAnchor=&quot;middle&quot; fontSize=&quot;13&quot; fontWeight=&quot;bold&quot; fill=&quot;#172133&quot;&gt;fee_bill ×746&lt;/text&gt;&#10;          &lt;line x1=&quot;225&quot; y1=&quot;346&quot; x2=&quot;225&quot; y2=&quot;386&quot; stroke=&quot;#BD9B56&quot; strokeWidth=&quot;1.5&quot; /&gt;&#10;          &lt;rect x=&quot;160&quot; y=&quot;390&quot; width=&quot;130&quot; height=&quot;50&quot; rx=&quot;6&quot; fill=&quot;rgba(34,57,94,0.08)&quot; stroke=&quot;#22395E&quot; strokeWidth=&quot;1.5&quot; /&gt;&#10;          &lt;text x=&quot;225&quot; y=&quot;420&quot; textAnchor=&quot;middle&quot; fontSize=&quot;13&quot; fontWeight=&quot;bold&quot; fill=&quot;#172133&quot;&gt;notice ×24&lt;/text&gt;&#10;          &lt;rect x=&quot;306&quot; y=&quot;390&quot; width=&quot;130&quot; height=&quot;50&quot; rx=&quot;6&quot; fill=&quot;#172133&quot; stroke=&quot;#BD9B56&quot; strokeWidth=&quot;1.5&quot; /&gt;&#10;          &lt;text x=&quot;371&quot; y=&quot;416&quot; textAnchor=&quot;middle&quot; fontSize=&quot;12&quot; fontWeight=&quot;bold&quot; fill=&quot;#BD9B56&quot;&gt;knowledge&lt;/text&gt;&#10;          &lt;text x=&quot;371&quot; y=&quot;434&quot; textAnchor=&quot;middle&quot; fontSize=&quot;10&quot; fill=&quot;#FBFCFA&quot;&gt;document + chunk&lt;/text&gt;&#10;        &lt;/g&gt;&#10;      &lt;/svg&gt;&#10;    &lt;/div&gt;&#10;  &lt;/div&gt;&#10;  &lt;div style={{ flexShrink: 0, height: 40, display: 'flex', alignItems: 'flex-end', justifyContent: 'space-between' }}&gt;&#10;    &lt;span style={{ color: '#BD9B56', fontSize: 12, letterSpacing: '0.1em' }}&gt;云溪花园 · 智慧社区&lt;/span&gt;&#10;    &lt;span style={{ color: '#a09b8c', fontSize: 12 }}&gt;07 / 15&lt;/span&gt;&#10;  &lt;/div&gt;&#10;&lt;/Slide&gt;"/>
+        <p:cNvPr id="329" name="" descr="&lt;Slide style={{ width: '1280px', height: '720px', background: '#FBFCFA', position: 'relative', padding: '32px 64px', boxSizing: 'border-box', display: 'flex', flexDirection: 'column' }}&gt;&#10;  &lt;div style={{ flexShrink: 0 }}&gt;&#10;    &lt;div style={{ color: '#BD9B56', fontSize: 13, letterSpacing: '0.25em', marginBottom: 6 }}&gt;02 · 技术构建过程&lt;/div&gt;&#10;    &lt;h2 style={{ fontSize: 30, fontWeight: 'bold', color: '#172133', margin: 0, lineHeight: 1.3 }}&gt;数据库设计：15+ 张表承载整个社区&lt;/h2&gt;&#10;    &lt;div style={{ fontSize: 14, color: '#6b7075', marginTop: 6 }}&gt;数据库是系统地基，通过外键建立完整 ER 关系，覆盖社区到知识库的全部实体&lt;/div&gt;&#10;  &lt;/div&gt;&#10;  &lt;div style={{ flex: 1, display: 'flex', alignItems: 'center', minHeight: 0, gap: 28 }}&gt;&#10;    &lt;div style={{ flex: '0 0 320px', background: 'linear-gradient(135deg, #172133 0%, #22395E 100%)', borderRadius: 12, padding: '24px 24px', color: '#FBFCFA' }}&gt;&#10;      &lt;div style={{ color: '#BD9B56', fontSize: 12, letterSpacing: '0.25em', marginBottom: 12 }}&gt;CORE ENTITIES&lt;/div&gt;&#10;      &lt;div style={{ fontSize: 14, color: 'rgba(251,252,250,0.9)', lineHeight: 1.9 }}&gt;&#10;        community 社区&lt;br/&gt;&#10;        building 楼栋（8）&lt;br/&gt;&#10;        house 房屋（1664）&lt;br/&gt;&#10;        user 用户（275）&lt;br/&gt;&#10;        house_binding 房屋绑定&lt;br/&gt;&#10;        worker 物业人员（75）&lt;br/&gt;&#10;        repair_order 工单&lt;br/&gt;&#10;        fee_bill 账单（746）&lt;br/&gt;&#10;        notice 公告（24）&lt;br/&gt;&#10;        conversation / message&lt;br/&gt;&#10;        agent_trace 追踪&lt;br/&gt;&#10;        &lt;span style={{ color: '#BD9B56' }}&gt;knowledge_document / chunk&lt;/span&gt;&#10;      &lt;/div&gt;&#10;    &lt;/div&gt;&#10;    &lt;div style={{ flex: 1, background: '#fff', borderRadius: 12, padding: '20px 22px', boxShadow: '0 6px 24px rgba(23,33,51,0.08)' }}&gt;&#10;      &lt;svg width=&quot;560&quot; height=&quot;470&quot; viewBox=&quot;0 0 560 470&quot;&gt;&#10;        &lt;g fontFamily=&quot;Inter, sans-serif&quot;&gt;&#10;          &lt;rect x=&quot;14&quot; y=&quot;14&quot; width=&quot;150&quot; height=&quot;50&quot; rx=&quot;6&quot; fill=&quot;rgba(34,57,94,0.08)&quot; stroke=&quot;#22395E&quot; strokeWidth=&quot;1.5&quot; /&gt;&#10;          &lt;text x=&quot;89&quot; y=&quot;44&quot; textAnchor=&quot;middle&quot; fontSize=&quot;14&quot; fontWeight=&quot;bold&quot; fill=&quot;#172133&quot;&gt;community&lt;/text&gt;&#10;          &lt;line x1=&quot;164&quot; y1=&quot;39&quot; x2=&quot;206&quot; y2=&quot;39&quot; stroke=&quot;#BD9B56&quot; strokeWidth=&quot;1.5&quot; /&gt;&#10;          &lt;rect x=&quot;210&quot; y=&quot;14&quot; width=&quot;150&quot; height=&quot;50&quot; rx=&quot;6&quot; fill=&quot;rgba(34,57,94,0.08)&quot; stroke=&quot;#22395E&quot; strokeWidth=&quot;1.5&quot; /&gt;&#10;          &lt;text x=&quot;285&quot; y=&quot;44&quot; textAnchor=&quot;middle&quot; fontSize=&quot;14&quot; fontWeight=&quot;bold&quot; fill=&quot;#172133&quot;&gt;building ×8&lt;/text&gt;&#10;          &lt;line x1=&quot;360&quot; y1=&quot;39&quot; x2=&quot;402&quot; y2=&quot;39&quot; stroke=&quot;#BD9B56&quot; strokeWidth=&quot;1.5&quot; /&gt;&#10;          &lt;rect x=&quot;406&quot; y=&quot;14&quot; width=&quot;150&quot; height=&quot;50&quot; rx=&quot;6&quot; fill=&quot;rgba(34,57,94,0.08)&quot; stroke=&quot;#22395E&quot; strokeWidth=&quot;1.5&quot; /&gt;&#10;          &lt;text x=&quot;481&quot; y=&quot;44&quot; textAnchor=&quot;middle&quot; fontSize=&quot;14&quot; fontWeight=&quot;bold&quot; fill=&quot;#172133&quot;&gt;house ×1664&lt;/text&gt;&#10;          &lt;line x1=&quot;285&quot; y1=&quot;64&quot; x2=&quot;285&quot; y2=&quot;104&quot; stroke=&quot;#BD9B56&quot; strokeWidth=&quot;1.5&quot; /&gt;&#10;          &lt;rect x=&quot;210&quot; y=&quot;108&quot; width=&quot;150&quot; height=&quot;50&quot; rx=&quot;6&quot; fill=&quot;rgba(189,155,86,0.10)&quot; stroke=&quot;#BD9B56&quot; strokeWidth=&quot;1.5&quot; /&gt;&#10;          &lt;text x=&quot;285&quot; y=&quot;138&quot; textAnchor=&quot;middle&quot; fontSize=&quot;14&quot; fontWeight=&quot;bold&quot; fill=&quot;#172133&quot;&gt;user ×275&lt;/text&gt;&#10;          &lt;line x1=&quot;210&quot; y1=&quot;133&quot; x2=&quot;164&quot; y2=&quot;133&quot; stroke=&quot;#BD9B56&quot; strokeWidth=&quot;1.5&quot; /&gt;&#10;          &lt;rect x=&quot;14&quot; y=&quot;108&quot; width=&quot;150&quot; height=&quot;50&quot; rx=&quot;6&quot; fill=&quot;rgba(189,155,86,0.10)&quot; stroke=&quot;#BD9B56&quot; strokeWidth=&quot;1.5&quot; /&gt;&#10;          &lt;text x=&quot;89&quot; y=&quot;138&quot; textAnchor=&quot;middle&quot; fontSize=&quot;14&quot; fontWeight=&quot;bold&quot; fill=&quot;#172133&quot;&gt;house_binding&lt;/text&gt;&#10;          &lt;line x1=&quot;285&quot; y1=&quot;158&quot; x2=&quot;285&quot; y2=&quot;198&quot; stroke=&quot;#BD9B56&quot; strokeWidth=&quot;1.5&quot; /&gt;&#10;          &lt;rect x=&quot;210&quot; y=&quot;202&quot; width=&quot;150&quot; height=&quot;50&quot; rx=&quot;6&quot; fill=&quot;rgba(34,57,94,0.08)&quot; stroke=&quot;#22395E&quot; strokeWidth=&quot;1.5&quot; /&gt;&#10;          &lt;text x=&quot;285&quot; y=&quot;232&quot; textAnchor=&quot;middle&quot; fontSize=&quot;14&quot; fontWeight=&quot;bold&quot; fill=&quot;#172133&quot;&gt;worker ×75&lt;/text&gt;&#10;          &lt;line x1=&quot;285&quot; y1=&quot;252&quot; x2=&quot;285&quot; y2=&quot;292&quot; stroke=&quot;#BD9B56&quot; strokeWidth=&quot;1.5&quot; /&gt;&#10;          &lt;rect x=&quot;160&quot; y=&quot;296&quot; width=&quot;130&quot; height=&quot;50&quot; rx=&quot;6&quot; fill=&quot;rgba(34,57,94,0.08)&quot; stroke=&quot;#22395E&quot; strokeWidth=&quot;1.5&quot; /&gt;&#10;          &lt;text x=&quot;225&quot; y=&quot;326&quot; textAnchor=&quot;middle&quot; fontSize=&quot;13&quot; fontWeight=&quot;bold&quot; fill=&quot;#172133&quot;&gt;repair_order&lt;/text&gt;&#10;          &lt;rect x=&quot;306&quot; y=&quot;296&quot; width=&quot;130&quot; height=&quot;50&quot; rx=&quot;6&quot; fill=&quot;rgba(34,57,94,0.08)&quot; stroke=&quot;#22395E&quot; strokeWidth=&quot;1.5&quot; /&gt;&#10;          &lt;text x=&quot;371&quot; y=&quot;326&quot; textAnchor=&quot;middle&quot; fontSize=&quot;13&quot; fontWeight=&quot;bold&quot; fill=&quot;#172133&quot;&gt;fee_bill ×746&lt;/text&gt;&#10;          &lt;line x1=&quot;225&quot; y1=&quot;346&quot; x2=&quot;225&quot; y2=&quot;386&quot; stroke=&quot;#BD9B56&quot; strokeWidth=&quot;1.5&quot; /&gt;&#10;          &lt;rect x=&quot;160&quot; y=&quot;390&quot; width=&quot;130&quot; height=&quot;50&quot; rx=&quot;6&quot; fill=&quot;rgba(34,57,94,0.08)&quot; stroke=&quot;#22395E&quot; strokeWidth=&quot;1.5&quot; /&gt;&#10;          &lt;text x=&quot;225&quot; y=&quot;420&quot; textAnchor=&quot;middle&quot; fontSize=&quot;13&quot; fontWeight=&quot;bold&quot; fill=&quot;#172133&quot;&gt;notice ×24&lt;/text&gt;&#10;          &lt;rect x=&quot;306&quot; y=&quot;390&quot; width=&quot;130&quot; height=&quot;50&quot; rx=&quot;6&quot; fill=&quot;#172133&quot; stroke=&quot;#BD9B56&quot; strokeWidth=&quot;1.5&quot; /&gt;&#10;          &lt;text x=&quot;371&quot; y=&quot;416&quot; textAnchor=&quot;middle&quot; fontSize=&quot;12&quot; fontWeight=&quot;bold&quot; fill=&quot;#BD9B56&quot;&gt;knowledge&lt;/text&gt;&#10;          &lt;text x=&quot;371&quot; y=&quot;434&quot; textAnchor=&quot;middle&quot; fontSize=&quot;10&quot; fill=&quot;#FBFCFA&quot;&gt;document + chunk&lt;/text&gt;&#10;        &lt;/g&gt;&#10;      &lt;/svg&gt;&#10;    &lt;/div&gt;&#10;  &lt;/div&gt;&#10;  &lt;div style={{ flexShrink: 0, height: 40, display: 'flex', alignItems: 'flex-end', justifyContent: 'space-between' }}&gt;&#10;    &lt;span style={{ color: '#BD9B56', fontSize: 12, letterSpacing: '0.1em' }}&gt;云溪花园 · 智慧社区&lt;/span&gt;&#10;    &lt;span style={{ color: '#a09b8c', fontSize: 12 }}&gt;07 / 15&lt;/span&gt;&#10;  &lt;/div&gt;&#10;&lt;/Slide&gt;"/>
         <p:cNvGrpSpPr/>
         <p:nvPr/>
       </p:nvGrpSpPr>
@@ -15217,7 +15465,7 @@
       </p:grpSpPr>
       <p:sp>
         <p:nvSpPr>
-          <p:cNvPr id="326" name=""/>
+          <p:cNvPr id="330" name=""/>
           <p:cNvSpPr/>
           <p:nvPr/>
         </p:nvSpPr>
@@ -15241,7 +15489,7 @@
       </p:sp>
       <p:sp>
         <p:nvSpPr>
-          <p:cNvPr id="327" name="" descr="{&quot;isTemplate&quot;:true,&quot;type&quot;:&quot;text&quot;}"/>
+          <p:cNvPr id="331" name="" descr="{&quot;isTemplate&quot;:true,&quot;type&quot;:&quot;text&quot;}"/>
           <p:cNvSpPr txBox="1"/>
           <p:nvPr/>
         </p:nvSpPr>
@@ -15286,7 +15534,7 @@
       </p:sp>
       <p:sp>
         <p:nvSpPr>
-          <p:cNvPr id="328" name="" descr="{&quot;isTemplate&quot;:true,&quot;type&quot;:&quot;text&quot;}"/>
+          <p:cNvPr id="332" name="" descr="{&quot;isTemplate&quot;:true,&quot;type&quot;:&quot;text&quot;}"/>
           <p:cNvSpPr txBox="1"/>
           <p:nvPr/>
         </p:nvSpPr>
@@ -15341,7 +15589,7 @@
       </p:sp>
       <p:sp>
         <p:nvSpPr>
-          <p:cNvPr id="329" name="" descr="{&quot;isTemplate&quot;:true,&quot;type&quot;:&quot;text&quot;}"/>
+          <p:cNvPr id="333" name="" descr="{&quot;isTemplate&quot;:true,&quot;type&quot;:&quot;text&quot;}"/>
           <p:cNvSpPr txBox="1"/>
           <p:nvPr/>
         </p:nvSpPr>
@@ -15396,7 +15644,7 @@
       </p:sp>
       <p:sp>
         <p:nvSpPr>
-          <p:cNvPr id="330" name=""/>
+          <p:cNvPr id="334" name=""/>
           <p:cNvSpPr/>
           <p:nvPr/>
         </p:nvSpPr>
@@ -15430,7 +15678,7 @@
       </p:sp>
       <p:sp>
         <p:nvSpPr>
-          <p:cNvPr id="331" name="" descr="{&quot;isTemplate&quot;:true,&quot;type&quot;:&quot;text&quot;}"/>
+          <p:cNvPr id="335" name="" descr="{&quot;isTemplate&quot;:true,&quot;type&quot;:&quot;text&quot;}"/>
           <p:cNvSpPr txBox="1"/>
           <p:nvPr/>
         </p:nvSpPr>
@@ -15465,7 +15713,7 @@
       </p:sp>
       <p:sp>
         <p:nvSpPr>
-          <p:cNvPr id="332" name="" descr="{&quot;isTemplate&quot;:true,&quot;type&quot;:&quot;text&quot;}"/>
+          <p:cNvPr id="336" name="" descr="{&quot;isTemplate&quot;:true,&quot;type&quot;:&quot;text&quot;}"/>
           <p:cNvSpPr txBox="1"/>
           <p:nvPr/>
         </p:nvSpPr>
@@ -15486,7 +15734,7 @@
       </p:sp>
       <p:sp>
         <p:nvSpPr>
-          <p:cNvPr id="333" name="" descr="{&quot;isTemplate&quot;:true,&quot;type&quot;:&quot;text&quot;}"/>
+          <p:cNvPr id="337" name="" descr="{&quot;isTemplate&quot;:true,&quot;type&quot;:&quot;text&quot;}"/>
           <p:cNvSpPr txBox="1"/>
           <p:nvPr/>
         </p:nvSpPr>
@@ -15507,7 +15755,7 @@
       </p:sp>
       <p:sp>
         <p:nvSpPr>
-          <p:cNvPr id="334" name="" descr="{&quot;isTemplate&quot;:true,&quot;type&quot;:&quot;text&quot;}"/>
+          <p:cNvPr id="338" name="" descr="{&quot;isTemplate&quot;:true,&quot;type&quot;:&quot;text&quot;}"/>
           <p:cNvSpPr txBox="1"/>
           <p:nvPr/>
         </p:nvSpPr>
@@ -15528,7 +15776,7 @@
       </p:sp>
       <p:sp>
         <p:nvSpPr>
-          <p:cNvPr id="335" name="" descr="{&quot;isTemplate&quot;:true,&quot;type&quot;:&quot;text&quot;}"/>
+          <p:cNvPr id="339" name="" descr="{&quot;isTemplate&quot;:true,&quot;type&quot;:&quot;text&quot;}"/>
           <p:cNvSpPr txBox="1"/>
           <p:nvPr/>
         </p:nvSpPr>
@@ -15549,7 +15797,7 @@
       </p:sp>
       <p:sp>
         <p:nvSpPr>
-          <p:cNvPr id="336" name="" descr="{&quot;isTemplate&quot;:true,&quot;type&quot;:&quot;text&quot;}"/>
+          <p:cNvPr id="340" name="" descr="{&quot;isTemplate&quot;:true,&quot;type&quot;:&quot;text&quot;}"/>
           <p:cNvSpPr txBox="1"/>
           <p:nvPr/>
         </p:nvSpPr>
@@ -15570,7 +15818,7 @@
       </p:sp>
       <p:sp>
         <p:nvSpPr>
-          <p:cNvPr id="337" name="" descr="{&quot;isTemplate&quot;:true,&quot;type&quot;:&quot;text&quot;}"/>
+          <p:cNvPr id="341" name="" descr="{&quot;isTemplate&quot;:true,&quot;type&quot;:&quot;text&quot;}"/>
           <p:cNvSpPr txBox="1"/>
           <p:nvPr/>
         </p:nvSpPr>
@@ -15591,7 +15839,7 @@
       </p:sp>
       <p:sp>
         <p:nvSpPr>
-          <p:cNvPr id="338" name="" descr="{&quot;isTemplate&quot;:true,&quot;type&quot;:&quot;text&quot;}"/>
+          <p:cNvPr id="342" name="" descr="{&quot;isTemplate&quot;:true,&quot;type&quot;:&quot;text&quot;}"/>
           <p:cNvSpPr txBox="1"/>
           <p:nvPr/>
         </p:nvSpPr>
@@ -15612,7 +15860,7 @@
       </p:sp>
       <p:sp>
         <p:nvSpPr>
-          <p:cNvPr id="339" name="" descr="{&quot;isTemplate&quot;:true,&quot;type&quot;:&quot;text&quot;}"/>
+          <p:cNvPr id="343" name="" descr="{&quot;isTemplate&quot;:true,&quot;type&quot;:&quot;text&quot;}"/>
           <p:cNvSpPr txBox="1"/>
           <p:nvPr/>
         </p:nvSpPr>
@@ -15633,7 +15881,7 @@
       </p:sp>
       <p:sp>
         <p:nvSpPr>
-          <p:cNvPr id="340" name="" descr="{&quot;isTemplate&quot;:true,&quot;type&quot;:&quot;text&quot;}"/>
+          <p:cNvPr id="344" name="" descr="{&quot;isTemplate&quot;:true,&quot;type&quot;:&quot;text&quot;}"/>
           <p:cNvSpPr txBox="1"/>
           <p:nvPr/>
         </p:nvSpPr>
@@ -15654,7 +15902,7 @@
       </p:sp>
       <p:sp>
         <p:nvSpPr>
-          <p:cNvPr id="341" name="" descr="{&quot;isTemplate&quot;:true,&quot;type&quot;:&quot;text&quot;}"/>
+          <p:cNvPr id="345" name="" descr="{&quot;isTemplate&quot;:true,&quot;type&quot;:&quot;text&quot;}"/>
           <p:cNvSpPr txBox="1"/>
           <p:nvPr/>
         </p:nvSpPr>
@@ -15675,7 +15923,7 @@
       </p:sp>
       <p:sp>
         <p:nvSpPr>
-          <p:cNvPr id="342" name="" descr="{&quot;isTemplate&quot;:true,&quot;type&quot;:&quot;text&quot;}"/>
+          <p:cNvPr id="346" name="" descr="{&quot;isTemplate&quot;:true,&quot;type&quot;:&quot;text&quot;}"/>
           <p:cNvSpPr txBox="1"/>
           <p:nvPr/>
         </p:nvSpPr>
@@ -15696,7 +15944,7 @@
       </p:sp>
       <p:sp>
         <p:nvSpPr>
-          <p:cNvPr id="343" name="" descr="{&quot;isTemplate&quot;:true,&quot;type&quot;:&quot;text&quot;}"/>
+          <p:cNvPr id="347" name="" descr="{&quot;isTemplate&quot;:true,&quot;type&quot;:&quot;text&quot;}"/>
           <p:cNvSpPr txBox="1"/>
           <p:nvPr/>
         </p:nvSpPr>
@@ -15731,7 +15979,7 @@
       </p:sp>
       <p:sp>
         <p:nvSpPr>
-          <p:cNvPr id="344" name=""/>
+          <p:cNvPr id="348" name=""/>
           <p:cNvSpPr/>
           <p:nvPr/>
         </p:nvSpPr>
@@ -15764,7 +16012,7 @@
       </p:sp>
       <p:pic>
         <p:nvPicPr>
-          <p:cNvPr id="345" name=""/>
+          <p:cNvPr id="349" name=""/>
           <p:cNvPicPr>
             <a:picLocks noChangeAspect="1"/>
           </p:cNvPicPr>
@@ -15795,7 +16043,7 @@
       </p:pic>
       <p:sp>
         <p:nvSpPr>
-          <p:cNvPr id="346" name="" descr="{&quot;isTemplate&quot;:true,&quot;type&quot;:&quot;text&quot;}"/>
+          <p:cNvPr id="350" name="" descr="{&quot;isTemplate&quot;:true,&quot;type&quot;:&quot;text&quot;}"/>
           <p:cNvSpPr txBox="1"/>
           <p:nvPr/>
         </p:nvSpPr>
@@ -15850,7 +16098,7 @@
       </p:sp>
       <p:sp>
         <p:nvSpPr>
-          <p:cNvPr id="347" name="" descr="{&quot;isTemplate&quot;:true,&quot;type&quot;:&quot;text&quot;}"/>
+          <p:cNvPr id="351" name="" descr="{&quot;isTemplate&quot;:true,&quot;type&quot;:&quot;text&quot;}"/>
           <p:cNvSpPr txBox="1"/>
           <p:nvPr/>
         </p:nvSpPr>
@@ -15893,7 +16141,7 @@
   <p:cSld>
     <p:spTree>
       <p:nvGrpSpPr>
-        <p:cNvPr id="348" name="" descr="&lt;Slide style={{ width: '1280px', height: '720px', background: '#FBFCFA', position: 'relative', padding: '40px 64px', boxSizing: 'border-box', display: 'flex', flexDirection: 'column' }}&gt;&#10;  &lt;div style={{ flexShrink: 0 }}&gt;&#10;    &lt;div style={{ color: '#BD9B56', fontSize: 13, letterSpacing: '0.25em', marginBottom: 8 }}&gt;02 · 技术构建过程&lt;/div&gt;&#10;    &lt;h2 style={{ fontSize: 30, fontWeight: 'bold', color: '#172133', margin: 0, lineHeight: 1.3 }}&gt;后端分层 + 前端三端一体&lt;/h2&gt;&#10;  &lt;/div&gt;&#10;  &lt;div style={{ flex: 1, display: 'flex', alignItems: 'center', gap: 32 }}&gt;&#10;    &lt;div style={{ flex: 1, display: 'flex', flexDirection: 'column', gap: 16 }}&gt;&#10;      &lt;div style={{ background: '#fff', borderRadius: 10, padding: '18px 22px', boxShadow: '0 4px 16px rgba(23,33,51,0.06)' }}&gt;&#10;        &lt;div style={{ fontSize: 17, fontWeight: 'bold', color: '#172133', marginBottom: 6 }}&gt;后端：FastAPI 三层架构&lt;/div&gt;&#10;        &lt;p style={{ fontSize: 14, color: '#5F5E5A', margin: 0, lineHeight: 1.6 }}&gt;API 路由层 → Service 业务层 → Repository 数据层。业务与数据解耦，AI 逻辑不混入业务代码。&lt;/p&gt;&#10;      &lt;/div&gt;&#10;      &lt;div style={{ background: '#fff', borderRadius: 10, padding: '18px 22px', boxShadow: '0 4px 16px rgba(23,33,51,0.06)' }}&gt;&#10;        &lt;div style={{ fontSize: 17, fontWeight: 'bold', color: '#172133', marginBottom: 6 }}&gt;派单算法&lt;/div&gt;&#10;        &lt;p style={{ fontSize: 14, color: '#5F5E5A', margin: 0, lineHeight: 1.6 }}&gt;按「技能匹配 + 在岗状态 + 工号升序」自动选择维修师傅，无需人工指派，报修提交即自动派单。&lt;/p&gt;&#10;      &lt;/div&gt;&#10;      &lt;div style={{ background: '#fff', borderRadius: 10, padding: '18px 22px', boxShadow: '0 4px 16px rgba(23,33,51,0.06)' }}&gt;&#10;        &lt;div style={{ fontSize: 17, fontWeight: 'bold', color: '#172133', marginBottom: 6 }}&gt;消息通知&lt;/div&gt;&#10;        &lt;p style={{ fontSize: 14, color: '#5F5E5A', margin: 0, lineHeight: 1.6 }}&gt;派单、完成、答复、巡检异常等事件全链路实时通知相关角色，保证业务协同不遗漏。&lt;/p&gt;&#10;      &lt;/div&gt;&#10;    &lt;/div&gt;&#10;    &lt;div style={{ flex: 1, background: 'linear-gradient(135deg, #172133 0%, #22395E 100%)', borderRadius: 12, padding: '26px 26px', color: '#FBFCFA' }}&gt;&#10;      &lt;div style={{ color: '#BD9B56', fontSize: 13, letterSpacing: '0.25em', marginBottom: 18 }}&gt;FRONTEND · 三端&lt;/div&gt;&#10;      &lt;div style={{ display: 'flex', flexDirection: 'column', gap: 14 }}&gt;&#10;        &lt;div style={{ display: 'flex', alignItems: 'center', gap: 12, padding: '12px 16px', background: 'rgba(189,155,86,0.10)', borderRadius: 8 }}&gt;&#10;          &lt;span style={{ color: '#BD9B56', fontSize: 17, fontWeight: 'bold', minWidth: 64 }}&gt;业主端&lt;/span&gt;&#10;          &lt;span style={{ fontSize: 13, color: 'rgba(251,252,250,0.85)' }}&gt;AI 助手 · 报修 · 缴费 · 公告 · 问题上报&lt;/span&gt;&#10;        &lt;/div&gt;&#10;        &lt;div style={{ display: 'flex', alignItems: 'center', gap: 12, padding: '12px 16px', background: 'rgba(189,155,86,0.10)', borderRadius: 8 }}&gt;&#10;          &lt;span style={{ color: '#BD9B56', fontSize: 17, fontWeight: 'bold', minWidth: 64 }}&gt;物业端&lt;/span&gt;&#10;          &lt;span style={{ fontSize: 13, color: 'rgba(251,252,250,0.85)' }}&gt;工单管理 · 巡检 · 数据看板 · 知识审核&lt;/span&gt;&#10;        &lt;/div&gt;&#10;        &lt;div style={{ display: 'flex', alignItems: 'center', gap: 12, padding: '12px 16px', background: 'rgba(189,155,86,0.10)', borderRadius: 8 }}&gt;&#10;          &lt;span style={{ color: '#BD9B56', fontSize: 17, fontWeight: 'bold', minWidth: 64 }}&gt;维修端&lt;/span&gt;&#10;          &lt;span style={{ fontSize: 13, color: 'rgba(251,252,250,0.85)' }}&gt;接单 · 处理 · 消息 · 巡检任务&lt;/span&gt;&#10;        &lt;/div&gt;&#10;      &lt;/div&gt;&#10;      &lt;div style={{ marginTop: 20, paddingTop: 18, borderTop: '1px solid rgba(189,155,86,0.3)' }}&gt;&#10;        &lt;div style={{ fontSize: 13, color: 'rgba(251,252,250,0.8)', lineHeight: 1.7 }}&gt;&#10;          React + TypeScript + Tailwind&lt;br/&gt;JWT 鉴权 · 角色路由 · 支持 PWA 安装&lt;br/&gt;后端 113 测试 + 前端 30 测试全绿&#10;        &lt;/div&gt;&#10;      &lt;/div&gt;&#10;    &lt;/div&gt;&#10;  &lt;/div&gt;&#10;  &lt;div style={{ flexShrink: 0, height: 40, display: 'flex', alignItems: 'flex-end', justifyContent: 'space-between' }}&gt;&#10;    &lt;span style={{ color: '#BD9B56', fontSize: 12, letterSpacing: '0.1em' }}&gt;云溪花园 · 智慧社区&lt;/span&gt;&#10;    &lt;span style={{ color: '#a09b8c', fontSize: 12 }}&gt;08 / 15&lt;/span&gt;&#10;  &lt;/div&gt;&#10;&lt;/Slide&gt;"/>
+        <p:cNvPr id="352" name="" descr="&lt;Slide style={{ width: '1280px', height: '720px', background: '#FBFCFA', position: 'relative', padding: '40px 64px', boxSizing: 'border-box', display: 'flex', flexDirection: 'column' }}&gt;&#10;  &lt;div style={{ flexShrink: 0 }}&gt;&#10;    &lt;div style={{ color: '#BD9B56', fontSize: 13, letterSpacing: '0.25em', marginBottom: 8 }}&gt;02 · 技术构建过程&lt;/div&gt;&#10;    &lt;h2 style={{ fontSize: 30, fontWeight: 'bold', color: '#172133', margin: 0, lineHeight: 1.3 }}&gt;后端分层 + 前端三端一体&lt;/h2&gt;&#10;  &lt;/div&gt;&#10;  &lt;div style={{ flex: 1, display: 'flex', alignItems: 'center', gap: 32 }}&gt;&#10;    &lt;div style={{ flex: 1, display: 'flex', flexDirection: 'column', gap: 16 }}&gt;&#10;      &lt;div style={{ background: '#fff', borderRadius: 10, padding: '18px 22px', boxShadow: '0 4px 16px rgba(23,33,51,0.06)' }}&gt;&#10;        &lt;div style={{ fontSize: 17, fontWeight: 'bold', color: '#172133', marginBottom: 6 }}&gt;后端：FastAPI 三层架构&lt;/div&gt;&#10;        &lt;p style={{ fontSize: 14, color: '#5F5E5A', margin: 0, lineHeight: 1.6 }}&gt;API 路由层 → Service 业务层 → Repository 数据层。业务与数据解耦，AI 逻辑不混入业务代码。&lt;/p&gt;&#10;      &lt;/div&gt;&#10;      &lt;div style={{ background: '#fff', borderRadius: 10, padding: '18px 22px', boxShadow: '0 4px 16px rgba(23,33,51,0.06)' }}&gt;&#10;        &lt;div style={{ fontSize: 17, fontWeight: 'bold', color: '#172133', marginBottom: 6 }}&gt;派单算法&lt;/div&gt;&#10;        &lt;p style={{ fontSize: 14, color: '#5F5E5A', margin: 0, lineHeight: 1.6 }}&gt;按「技能匹配 + 在岗状态 + 工号升序」自动选择维修师傅，无需人工指派，报修提交即自动派单。&lt;/p&gt;&#10;      &lt;/div&gt;&#10;      &lt;div style={{ background: '#fff', borderRadius: 10, padding: '18px 22px', boxShadow: '0 4px 16px rgba(23,33,51,0.06)' }}&gt;&#10;        &lt;div style={{ fontSize: 17, fontWeight: 'bold', color: '#172133', marginBottom: 6 }}&gt;消息通知&lt;/div&gt;&#10;        &lt;p style={{ fontSize: 14, color: '#5F5E5A', margin: 0, lineHeight: 1.6 }}&gt;派单、完成、答复、巡检异常等事件全链路实时通知相关角色，保证业务协同不遗漏。&lt;/p&gt;&#10;      &lt;/div&gt;&#10;    &lt;/div&gt;&#10;    &lt;div style={{ flex: 1, background: 'linear-gradient(135deg, #172133 0%, #22395E 100%)', borderRadius: 12, padding: '26px 26px', color: '#FBFCFA' }}&gt;&#10;      &lt;div style={{ color: '#BD9B56', fontSize: 13, letterSpacing: '0.25em', marginBottom: 18 }}&gt;FRONTEND · 三端&lt;/div&gt;&#10;      &lt;div style={{ display: 'flex', flexDirection: 'column', gap: 14 }}&gt;&#10;        &lt;div style={{ display: 'flex', alignItems: 'center', gap: 12, padding: '12px 16px', background: 'rgba(189,155,86,0.10)', borderRadius: 8 }}&gt;&#10;          &lt;span style={{ color: '#BD9B56', fontSize: 17, fontWeight: 'bold', minWidth: 64 }}&gt;业主端&lt;/span&gt;&#10;          &lt;span style={{ fontSize: 13, color: 'rgba(251,252,250,0.85)' }}&gt;AI 助手 · 报修 · 缴费 · 公告 · 问题上报&lt;/span&gt;&#10;        &lt;/div&gt;&#10;        &lt;div style={{ display: 'flex', alignItems: 'center', gap: 12, padding: '12px 16px', background: 'rgba(189,155,86,0.10)', borderRadius: 8 }}&gt;&#10;          &lt;span style={{ color: '#BD9B56', fontSize: 17, fontWeight: 'bold', minWidth: 64 }}&gt;物业端&lt;/span&gt;&#10;          &lt;span style={{ fontSize: 13, color: 'rgba(251,252,250,0.85)' }}&gt;工单管理 · 巡检 · 数据看板 · 知识审核&lt;/span&gt;&#10;        &lt;/div&gt;&#10;        &lt;div style={{ display: 'flex', alignItems: 'center', gap: 12, padding: '12px 16px', background: 'rgba(189,155,86,0.10)', borderRadius: 8 }}&gt;&#10;          &lt;span style={{ color: '#BD9B56', fontSize: 17, fontWeight: 'bold', minWidth: 64 }}&gt;维修端&lt;/span&gt;&#10;          &lt;span style={{ fontSize: 13, color: 'rgba(251,252,250,0.85)' }}&gt;接单 · 处理 · 消息 · 巡检任务&lt;/span&gt;&#10;        &lt;/div&gt;&#10;      &lt;/div&gt;&#10;      &lt;div style={{ marginTop: 20, paddingTop: 18, borderTop: '1px solid rgba(189,155,86,0.3)' }}&gt;&#10;        &lt;div style={{ fontSize: 13, color: 'rgba(251,252,250,0.8)', lineHeight: 1.7 }}&gt;&#10;          React + TypeScript + Tailwind&lt;br/&gt;JWT 鉴权 · 角色路由 · 支持 PWA 安装&lt;br/&gt;后端 113 测试 + 前端 30 测试全绿&#10;        &lt;/div&gt;&#10;      &lt;/div&gt;&#10;    &lt;/div&gt;&#10;  &lt;/div&gt;&#10;  &lt;div style={{ flexShrink: 0, height: 40, display: 'flex', alignItems: 'flex-end', justifyContent: 'space-between' }}&gt;&#10;    &lt;span style={{ color: '#BD9B56', fontSize: 12, letterSpacing: '0.1em' }}&gt;云溪花园 · 智慧社区&lt;/span&gt;&#10;    &lt;span style={{ color: '#a09b8c', fontSize: 12 }}&gt;08 / 15&lt;/span&gt;&#10;  &lt;/div&gt;&#10;&lt;/Slide&gt;"/>
         <p:cNvGrpSpPr/>
         <p:nvPr/>
       </p:nvGrpSpPr>
@@ -15907,7 +16155,7 @@
       </p:grpSpPr>
       <p:sp>
         <p:nvSpPr>
-          <p:cNvPr id="349" name=""/>
+          <p:cNvPr id="353" name=""/>
           <p:cNvSpPr/>
           <p:nvPr/>
         </p:nvSpPr>
@@ -15931,7 +16179,7 @@
       </p:sp>
       <p:sp>
         <p:nvSpPr>
-          <p:cNvPr id="350" name="" descr="{&quot;isTemplate&quot;:true,&quot;type&quot;:&quot;text&quot;}"/>
+          <p:cNvPr id="354" name="" descr="{&quot;isTemplate&quot;:true,&quot;type&quot;:&quot;text&quot;}"/>
           <p:cNvSpPr txBox="1"/>
           <p:nvPr/>
         </p:nvSpPr>
@@ -15976,7 +16224,7 @@
       </p:sp>
       <p:sp>
         <p:nvSpPr>
-          <p:cNvPr id="351" name="" descr="{&quot;isTemplate&quot;:true,&quot;type&quot;:&quot;text&quot;}"/>
+          <p:cNvPr id="355" name="" descr="{&quot;isTemplate&quot;:true,&quot;type&quot;:&quot;text&quot;}"/>
           <p:cNvSpPr txBox="1"/>
           <p:nvPr/>
         </p:nvSpPr>
@@ -16031,7 +16279,7 @@
       </p:sp>
       <p:sp>
         <p:nvSpPr>
-          <p:cNvPr id="352" name=""/>
+          <p:cNvPr id="356" name=""/>
           <p:cNvSpPr/>
           <p:nvPr/>
         </p:nvSpPr>
@@ -16064,7 +16312,7 @@
       </p:sp>
       <p:sp>
         <p:nvSpPr>
-          <p:cNvPr id="353" name="" descr="{&quot;isTemplate&quot;:true,&quot;type&quot;:&quot;text&quot;}"/>
+          <p:cNvPr id="357" name="" descr="{&quot;isTemplate&quot;:true,&quot;type&quot;:&quot;text&quot;}"/>
           <p:cNvSpPr txBox="1"/>
           <p:nvPr/>
         </p:nvSpPr>
@@ -16119,7 +16367,7 @@
       </p:sp>
       <p:sp>
         <p:nvSpPr>
-          <p:cNvPr id="354" name="" descr="{&quot;isTemplate&quot;:true,&quot;type&quot;:&quot;text&quot;}"/>
+          <p:cNvPr id="358" name="" descr="{&quot;isTemplate&quot;:true,&quot;type&quot;:&quot;text&quot;}"/>
           <p:cNvSpPr txBox="1"/>
           <p:nvPr/>
         </p:nvSpPr>
@@ -16226,7 +16474,7 @@
       </p:sp>
       <p:sp>
         <p:nvSpPr>
-          <p:cNvPr id="355" name=""/>
+          <p:cNvPr id="359" name=""/>
           <p:cNvSpPr/>
           <p:nvPr/>
         </p:nvSpPr>
@@ -16259,7 +16507,7 @@
       </p:sp>
       <p:sp>
         <p:nvSpPr>
-          <p:cNvPr id="356" name="" descr="{&quot;isTemplate&quot;:true,&quot;type&quot;:&quot;text&quot;}"/>
+          <p:cNvPr id="360" name="" descr="{&quot;isTemplate&quot;:true,&quot;type&quot;:&quot;text&quot;}"/>
           <p:cNvSpPr txBox="1"/>
           <p:nvPr/>
         </p:nvSpPr>
@@ -16294,7 +16542,7 @@
       </p:sp>
       <p:sp>
         <p:nvSpPr>
-          <p:cNvPr id="357" name="" descr="{&quot;isTemplate&quot;:true,&quot;type&quot;:&quot;text&quot;}"/>
+          <p:cNvPr id="361" name="" descr="{&quot;isTemplate&quot;:true,&quot;type&quot;:&quot;text&quot;}"/>
           <p:cNvSpPr txBox="1"/>
           <p:nvPr/>
         </p:nvSpPr>
@@ -16371,7 +16619,7 @@
       </p:sp>
       <p:sp>
         <p:nvSpPr>
-          <p:cNvPr id="358" name=""/>
+          <p:cNvPr id="362" name=""/>
           <p:cNvSpPr/>
           <p:nvPr/>
         </p:nvSpPr>
@@ -16404,7 +16652,7 @@
       </p:sp>
       <p:sp>
         <p:nvSpPr>
-          <p:cNvPr id="359" name="" descr="{&quot;isTemplate&quot;:true,&quot;type&quot;:&quot;text&quot;}"/>
+          <p:cNvPr id="363" name="" descr="{&quot;isTemplate&quot;:true,&quot;type&quot;:&quot;text&quot;}"/>
           <p:cNvSpPr txBox="1"/>
           <p:nvPr/>
         </p:nvSpPr>
@@ -16439,7 +16687,7 @@
       </p:sp>
       <p:sp>
         <p:nvSpPr>
-          <p:cNvPr id="360" name="" descr="{&quot;isTemplate&quot;:true,&quot;type&quot;:&quot;text&quot;}"/>
+          <p:cNvPr id="364" name="" descr="{&quot;isTemplate&quot;:true,&quot;type&quot;:&quot;text&quot;}"/>
           <p:cNvSpPr txBox="1"/>
           <p:nvPr/>
         </p:nvSpPr>
@@ -16476,7 +16724,7 @@
       </p:sp>
       <p:sp>
         <p:nvSpPr>
-          <p:cNvPr id="361" name=""/>
+          <p:cNvPr id="365" name=""/>
           <p:cNvSpPr/>
           <p:nvPr/>
         </p:nvSpPr>
@@ -16510,7 +16758,7 @@
       </p:sp>
       <p:sp>
         <p:nvSpPr>
-          <p:cNvPr id="362" name="" descr="{&quot;isTemplate&quot;:true,&quot;type&quot;:&quot;text&quot;}"/>
+          <p:cNvPr id="366" name="" descr="{&quot;isTemplate&quot;:true,&quot;type&quot;:&quot;text&quot;}"/>
           <p:cNvSpPr txBox="1"/>
           <p:nvPr/>
         </p:nvSpPr>
@@ -16555,7 +16803,7 @@
       </p:sp>
       <p:sp>
         <p:nvSpPr>
-          <p:cNvPr id="363" name=""/>
+          <p:cNvPr id="367" name=""/>
           <p:cNvSpPr/>
           <p:nvPr/>
         </p:nvSpPr>
@@ -16583,7 +16831,7 @@
       </p:sp>
       <p:sp>
         <p:nvSpPr>
-          <p:cNvPr id="364" name="" descr="{&quot;isTemplate&quot;:true,&quot;type&quot;:&quot;text&quot;}"/>
+          <p:cNvPr id="368" name="" descr="{&quot;isTemplate&quot;:true,&quot;type&quot;:&quot;text&quot;}"/>
           <p:cNvSpPr txBox="1"/>
           <p:nvPr/>
         </p:nvSpPr>
@@ -16618,7 +16866,7 @@
       </p:sp>
       <p:sp>
         <p:nvSpPr>
-          <p:cNvPr id="365" name="" descr="{&quot;isTemplate&quot;:true,&quot;type&quot;:&quot;text&quot;}"/>
+          <p:cNvPr id="369" name="" descr="{&quot;isTemplate&quot;:true,&quot;type&quot;:&quot;text&quot;}"/>
           <p:cNvSpPr txBox="1"/>
           <p:nvPr/>
         </p:nvSpPr>
@@ -16763,7 +17011,7 @@
       </p:sp>
       <p:sp>
         <p:nvSpPr>
-          <p:cNvPr id="366" name=""/>
+          <p:cNvPr id="370" name=""/>
           <p:cNvSpPr/>
           <p:nvPr/>
         </p:nvSpPr>
@@ -16791,7 +17039,7 @@
       </p:sp>
       <p:sp>
         <p:nvSpPr>
-          <p:cNvPr id="367" name="" descr="{&quot;isTemplate&quot;:true,&quot;type&quot;:&quot;text&quot;}"/>
+          <p:cNvPr id="371" name="" descr="{&quot;isTemplate&quot;:true,&quot;type&quot;:&quot;text&quot;}"/>
           <p:cNvSpPr txBox="1"/>
           <p:nvPr/>
         </p:nvSpPr>
@@ -16826,7 +17074,7 @@
       </p:sp>
       <p:sp>
         <p:nvSpPr>
-          <p:cNvPr id="368" name="" descr="{&quot;isTemplate&quot;:true,&quot;type&quot;:&quot;text&quot;}"/>
+          <p:cNvPr id="372" name="" descr="{&quot;isTemplate&quot;:true,&quot;type&quot;:&quot;text&quot;}"/>
           <p:cNvSpPr txBox="1"/>
           <p:nvPr/>
         </p:nvSpPr>
@@ -16935,7 +17183,7 @@
       </p:sp>
       <p:sp>
         <p:nvSpPr>
-          <p:cNvPr id="369" name=""/>
+          <p:cNvPr id="373" name=""/>
           <p:cNvSpPr/>
           <p:nvPr/>
         </p:nvSpPr>
@@ -16963,7 +17211,7 @@
       </p:sp>
       <p:sp>
         <p:nvSpPr>
-          <p:cNvPr id="370" name="" descr="{&quot;isTemplate&quot;:true,&quot;type&quot;:&quot;text&quot;}"/>
+          <p:cNvPr id="374" name="" descr="{&quot;isTemplate&quot;:true,&quot;type&quot;:&quot;text&quot;}"/>
           <p:cNvSpPr txBox="1"/>
           <p:nvPr/>
         </p:nvSpPr>
@@ -16998,7 +17246,7 @@
       </p:sp>
       <p:sp>
         <p:nvSpPr>
-          <p:cNvPr id="371" name="" descr="{&quot;isTemplate&quot;:true,&quot;type&quot;:&quot;text&quot;}"/>
+          <p:cNvPr id="375" name="" descr="{&quot;isTemplate&quot;:true,&quot;type&quot;:&quot;text&quot;}"/>
           <p:cNvSpPr txBox="1"/>
           <p:nvPr/>
         </p:nvSpPr>
@@ -17107,7 +17355,7 @@
       </p:sp>
       <p:sp>
         <p:nvSpPr>
-          <p:cNvPr id="372" name=""/>
+          <p:cNvPr id="376" name=""/>
           <p:cNvSpPr/>
           <p:nvPr/>
         </p:nvSpPr>
@@ -17149,7 +17397,7 @@
       </p:sp>
       <p:sp>
         <p:nvSpPr>
-          <p:cNvPr id="373" name="" descr="{&quot;isTemplate&quot;:true,&quot;type&quot;:&quot;text&quot;}"/>
+          <p:cNvPr id="377" name="" descr="{&quot;isTemplate&quot;:true,&quot;type&quot;:&quot;text&quot;}"/>
           <p:cNvSpPr txBox="1"/>
           <p:nvPr/>
         </p:nvSpPr>
@@ -17170,7 +17418,7 @@
       </p:sp>
       <p:sp>
         <p:nvSpPr>
-          <p:cNvPr id="374" name="" descr="{&quot;isTemplate&quot;:true,&quot;type&quot;:&quot;text&quot;}"/>
+          <p:cNvPr id="378" name="" descr="{&quot;isTemplate&quot;:true,&quot;type&quot;:&quot;text&quot;}"/>
           <p:cNvSpPr txBox="1"/>
           <p:nvPr/>
         </p:nvSpPr>
@@ -17191,7 +17439,7 @@
       </p:sp>
       <p:sp>
         <p:nvSpPr>
-          <p:cNvPr id="375" name="" descr="{&quot;isTemplate&quot;:true,&quot;type&quot;:&quot;text&quot;}"/>
+          <p:cNvPr id="379" name="" descr="{&quot;isTemplate&quot;:true,&quot;type&quot;:&quot;text&quot;}"/>
           <p:cNvSpPr txBox="1"/>
           <p:nvPr/>
         </p:nvSpPr>
@@ -17246,7 +17494,7 @@
       </p:sp>
       <p:sp>
         <p:nvSpPr>
-          <p:cNvPr id="376" name="" descr="{&quot;isTemplate&quot;:true,&quot;type&quot;:&quot;text&quot;}"/>
+          <p:cNvPr id="380" name="" descr="{&quot;isTemplate&quot;:true,&quot;type&quot;:&quot;text&quot;}"/>
           <p:cNvSpPr txBox="1"/>
           <p:nvPr/>
         </p:nvSpPr>
@@ -17289,7 +17537,7 @@
   <p:cSld>
     <p:spTree>
       <p:nvGrpSpPr>
-        <p:cNvPr id="377" name="" descr="&lt;Slide style={{ width: '1280px', height: '720px', background: '#FBFCFA', position: 'relative', padding: '40px 64px', boxSizing: 'border-box', display: 'flex', flexDirection: 'column' }}&gt;&#10;  &lt;div style={{ flexShrink: 0 }}&gt;&#10;    &lt;div style={{ color: '#BD9B56', fontSize: 13, letterSpacing: '0.25em', marginBottom: 8 }}&gt;02 · 技术构建过程&lt;/div&gt;&#10;    &lt;h2 style={{ fontSize: 30, fontWeight: 'bold', color: '#172133', margin: 0, lineHeight: 1.3 }}&gt;AI Agent 架构：LangGraph 多智能体协作&lt;/h2&gt;&#10;  &lt;/div&gt;&#10;  &lt;div style={{ flex: 1, display: 'flex', alignItems: 'center', gap: 32 }}&gt;&#10;    &lt;div style={{ flex: '0 0 560px', background: '#fff', borderRadius: 12, padding: '22px 24px', boxShadow: '0 6px 24px rgba(23,33,51,0.08)' }}&gt;&#10;      &lt;svg width=&quot;512&quot; height=&quot;470&quot; viewBox=&quot;0 0 512 470&quot;&gt;&#10;        &lt;defs&gt;&#10;          &lt;marker id=&quot;ar9&quot; viewBox=&quot;0 0 10 10&quot; refX=&quot;9&quot; refY=&quot;5&quot; markerWidth=&quot;6&quot; markerHeight=&quot;6&quot; orient=&quot;auto&quot;&gt;&#10;            &lt;path d=&quot;M0 0L10 5L0 10z&quot; fill=&quot;#BD9B56&quot; /&gt;&#10;          &lt;/marker&gt;&#10;        &lt;/defs&gt;&#10;        &lt;g fontFamily=&quot;Inter, sans-serif&quot;&gt;&#10;          &lt;rect x=&quot;156&quot; y=&quot;14&quot; width=&quot;200&quot; height=&quot;50&quot; rx=&quot;8&quot; fill=&quot;rgba(34,57,94,0.08)&quot; stroke=&quot;#22395E&quot; strokeWidth=&quot;1.5&quot; /&gt;&#10;          &lt;text x=&quot;256&quot; y=&quot;36&quot; textAnchor=&quot;middle&quot; fontSize=&quot;13&quot; fontWeight=&quot;bold&quot; fill=&quot;#172133&quot;&gt;用户自然语言输入&lt;/text&gt;&#10;          &lt;text x=&quot;256&quot; y=&quot;54&quot; textAnchor=&quot;middle&quot; fontSize=&quot;11&quot; fill=&quot;#5F5E5A&quot;&gt;「我家厨房漏水了」&lt;/text&gt;&#10;          &lt;line x1=&quot;256&quot; y1=&quot;64&quot; x2=&quot;256&quot; y2=&quot;84&quot; stroke=&quot;#BD9B56&quot; strokeWidth=&quot;1.5&quot; markerEnd=&quot;url(#ar9)&quot; /&gt;&#10;          &lt;rect x=&quot;96&quot; y=&quot;88&quot; width=&quot;320&quot; height=&quot;64&quot; rx=&quot;8&quot; fill=&quot;rgba(34,57,94,0.12)&quot; stroke=&quot;#22395E&quot; strokeWidth=&quot;2&quot; /&gt;&#10;          &lt;text x=&quot;256&quot; y=&quot;114&quot; textAnchor=&quot;middle&quot; fontSize=&quot;13&quot; fontWeight=&quot;bold&quot; fill=&quot;#BD9B56&quot;&gt;Router Agent · 意图分类&lt;/text&gt;&#10;          &lt;text x=&quot;256&quot; y=&quot;136&quot; textAnchor=&quot;middle&quot; fontSize=&quot;11&quot; fill=&quot;#172133&quot;&gt;报修 / 费用 / 公告 / 知识 / 上报&lt;/text&gt;&#10;          &lt;line x1=&quot;256&quot; y1=&quot;152&quot; x2=&quot;256&quot; y2=&quot;172&quot; stroke=&quot;#BD9B56&quot; strokeWidth=&quot;1.5&quot; markerEnd=&quot;url(#ar9)&quot; /&gt;&#10;          &lt;rect x=&quot;96&quot; y=&quot;176&quot; width=&quot;320&quot; height=&quot;64&quot; rx=&quot;8&quot; fill=&quot;rgba(189,155,86,0.10)&quot; stroke=&quot;#BD9B56&quot; strokeWidth=&quot;1.5&quot; /&gt;&#10;          &lt;text x=&quot;256&quot; y=&quot;202&quot; textAnchor=&quot;middle&quot; fontSize=&quot;13&quot; fontWeight=&quot;bold&quot; fill=&quot;#172133&quot;&gt;领域 Agent + 多轮状态机&lt;/text&gt;&#10;          &lt;text x=&quot;256&quot; y=&quot;224&quot; textAnchor=&quot;middle&quot; fontSize=&quot;11&quot; fill=&quot;#5F5E5A&quot;&gt;报修缺「位置/类型」→ 主动反问补全&lt;/text&gt;&#10;          &lt;line x1=&quot;256&quot; y1=&quot;240&quot; x2=&quot;256&quot; y2=&quot;260&quot; stroke=&quot;#BD9B56&quot; strokeWidth=&quot;1.5&quot; markerEnd=&quot;url(#ar9)&quot; /&gt;&#10;          &lt;rect x=&quot;16&quot; y=&quot;264&quot; width=&quot;140&quot; height=&quot;48&quot; rx=&quot;6&quot; fill=&quot;rgba(34,57,94,0.06)&quot; stroke=&quot;#22395E&quot; strokeWidth=&quot;1.5&quot; /&gt;&#10;          &lt;text x=&quot;86&quot; y=&quot;284&quot; textAnchor=&quot;middle&quot; fontSize=&quot;12&quot; fontWeight=&quot;bold&quot; fill=&quot;#172133&quot;&gt;create_repair&lt;/text&gt;&#10;          &lt;text x=&quot;86&quot; y=&quot;302&quot; textAnchor=&quot;middle&quot; fontSize=&quot;10&quot; fill=&quot;#5F5E5A&quot;&gt;创建工单&lt;/text&gt;&#10;          &lt;rect x=&quot;176&quot; y=&quot;264&quot; width=&quot;140&quot; height=&quot;48&quot; rx=&quot;6&quot; fill=&quot;rgba(34,57,94,0.06)&quot; stroke=&quot;#22395E&quot; strokeWidth=&quot;1.5&quot; /&gt;&#10;          &lt;text x=&quot;246&quot; y=&quot;284&quot; textAnchor=&quot;middle&quot; fontSize=&quot;12&quot; fontWeight=&quot;bold&quot; fill=&quot;#172133&quot;&gt;query_fee&lt;/text&gt;&#10;          &lt;text x=&quot;246&quot; y=&quot;302&quot; textAnchor=&quot;middle&quot; fontSize=&quot;10&quot; fill=&quot;#5F5E5A&quot;&gt;查询费用&lt;/text&gt;&#10;          &lt;rect x=&quot;336&quot; y=&quot;264&quot; width=&quot;160&quot; height=&quot;48&quot; rx=&quot;6&quot; fill=&quot;rgba(34,57,94,0.06)&quot; stroke=&quot;#22395E&quot; strokeWidth=&quot;1.5&quot; /&gt;&#10;          &lt;text x=&quot;416&quot; y=&quot;284&quot; textAnchor=&quot;middle&quot; fontSize=&quot;12&quot; fontWeight=&quot;bold&quot; fill=&quot;#172133&quot;&gt;search_knowledge&lt;/text&gt;&#10;          &lt;text x=&quot;416&quot; y=&quot;302&quot; textAnchor=&quot;middle&quot; fontSize=&quot;10&quot; fill=&quot;#5F5E5A&quot;&gt;检索知识&lt;/text&gt;&#10;          &lt;line x1=&quot;256&quot; y1=&quot;260&quot; x2=&quot;256&quot; y2=&quot;288&quot; stroke=&quot;#22395E&quot; strokeWidth=&quot;1.2&quot; /&gt;&#10;          &lt;line x1=&quot;256&quot; y1=&quot;288&quot; x2=&quot;86&quot; y2=&quot;288&quot; stroke=&quot;#22395E&quot; strokeWidth=&quot;1.2&quot; /&gt;&#10;          &lt;line x1=&quot;256&quot; y1=&quot;288&quot; x2=&quot;246&quot; y2=&quot;288&quot; stroke=&quot;#22395E&quot; strokeWidth=&quot;1.2&quot; /&gt;&#10;          &lt;line x1=&quot;256&quot; y1=&quot;288&quot; x2=&quot;416&quot; y2=&quot;288&quot; stroke=&quot;#22395E&quot; strokeWidth=&quot;1.2&quot; /&gt;&#10;          &lt;line x1=&quot;86&quot; y1=&quot;312&quot; x2=&quot;86&quot; y2=&quot;332&quot; stroke=&quot;#22395E&quot; strokeWidth=&quot;1.2&quot; /&gt;&#10;          &lt;line x1=&quot;246&quot; y1=&quot;312&quot; x2=&quot;246&quot; y2=&quot;332&quot; stroke=&quot;#22395E&quot; strokeWidth=&quot;1.2&quot; /&gt;&#10;          &lt;line x1=&quot;416&quot; y1=&quot;312&quot; x2=&quot;416&quot; y2=&quot;332&quot; stroke=&quot;#22395E&quot; strokeWidth=&quot;1.2&quot; /&gt;&#10;          &lt;rect x=&quot;16&quot; y=&quot;336&quot; width=&quot;480&quot; height=&quot;42&quot; rx=&quot;6&quot; fill=&quot;#172133&quot; /&gt;&#10;          &lt;text x=&quot;256&quot; y=&quot;362&quot; textAnchor=&quot;middle&quot; fontSize=&quot;12&quot; fontWeight=&quot;bold&quot; fill=&quot;#BD9B56&quot;&gt;业务 API 层 · 工具执行 · Trace 全程记录可评估&lt;/text&gt;&#10;          &lt;text x=&quot;256&quot; y=&quot;410&quot; textAnchor=&quot;middle&quot; fontSize=&quot;12&quot; fill=&quot;#5F5E5A&quot;&gt;驱动模型：智谱 GLM-4-Flash · 编排框架：LangGraph&lt;/text&gt;&#10;        &lt;/g&gt;&#10;      &lt;/svg&gt;&#10;    &lt;/div&gt;&#10;    &lt;div style={{ flex: 1, display: 'flex', flexDirection: 'column', gap: 18 }}&gt;&#10;      &lt;div&gt;&#10;        &lt;div style={{ fontSize: 14, color: '#BD9B56', fontWeight: 'bold', letterSpacing: '0.1em', marginBottom: 6 }}&gt;1.  多轮状态机&lt;/div&gt;&#10;        &lt;p style={{ fontSize: 14, color: '#5F5E5A', margin: 0, lineHeight: 1.65 }}&gt;报修不是单轮问答——业主只说「厨房漏水」时，Agent 会主动追问房屋位置、故障类型，把信息补全后才创建工单，避免生成残缺工单。&lt;/p&gt;&#10;      &lt;/div&gt;&#10;      &lt;div&gt;&#10;        &lt;div style={{ fontSize: 14, color: '#BD9B56', fontWeight: 'bold', letterSpacing: '0.1em', marginBottom: 6 }}&gt;2.  五类意图&lt;/div&gt;&#10;        &lt;p style={{ fontSize: 14, color: '#5F5E5A', margin: 0, lineHeight: 1.65 }}&gt;报修、费用、公告、知识咨询、问题上报，自然语言直达对应业务工具，实测意图识别准确率 100%。&lt;/p&gt;&#10;      &lt;/div&gt;&#10;      &lt;div&gt;&#10;        &lt;div style={{ fontSize: 14, color: '#BD9B56', fontWeight: 'bold', letterSpacing: '0.1em', marginBottom: 6 }}&gt;3.  可观测可评估&lt;/div&gt;&#10;        &lt;p style={{ fontSize: 14, color: '#5F5E5A', margin: 0, lineHeight: 1.65 }}&gt;每次对话的意图、工具、结果全程记录 Trace，可回放、可评估，是量化评估体系的数据基础。&lt;/p&gt;&#10;      &lt;/div&gt;&#10;    &lt;/div&gt;&#10;  &lt;/div&gt;&#10;  &lt;div style={{ flexShrink: 0, height: 40, display: 'flex', alignItems: 'flex-end', justifyContent: 'space-between' }}&gt;&#10;    &lt;span style={{ color: '#BD9B56', fontSize: 12, letterSpacing: '0.1em' }}&gt;云溪花园 · 智慧社区&lt;/span&gt;&#10;    &lt;span style={{ color: '#a09b8c', fontSize: 12 }}&gt;09 / 15&lt;/span&gt;&#10;  &lt;/div&gt;&#10;&lt;/Slide&gt;"/>
+        <p:cNvPr id="381" name="" descr="&lt;Slide style={{ width: '1280px', height: '720px', background: '#FBFCFA', position: 'relative', padding: '40px 64px', boxSizing: 'border-box', display: 'flex', flexDirection: 'column' }}&gt;&#10;  &lt;div style={{ flexShrink: 0 }}&gt;&#10;    &lt;div style={{ color: '#BD9B56', fontSize: 13, letterSpacing: '0.25em', marginBottom: 8 }}&gt;02 · 技术构建过程&lt;/div&gt;&#10;    &lt;h2 style={{ fontSize: 30, fontWeight: 'bold', color: '#172133', margin: 0, lineHeight: 1.3 }}&gt;AI Agent 架构：LangGraph 多智能体协作&lt;/h2&gt;&#10;  &lt;/div&gt;&#10;  &lt;div style={{ flex: 1, display: 'flex', alignItems: 'center', gap: 32 }}&gt;&#10;    &lt;div style={{ flex: '0 0 560px', background: '#fff', borderRadius: 12, padding: '22px 24px', boxShadow: '0 6px 24px rgba(23,33,51,0.08)' }}&gt;&#10;      &lt;svg width=&quot;512&quot; height=&quot;470&quot; viewBox=&quot;0 0 512 470&quot;&gt;&#10;        &lt;defs&gt;&#10;          &lt;marker id=&quot;ar9&quot; viewBox=&quot;0 0 10 10&quot; refX=&quot;9&quot; refY=&quot;5&quot; markerWidth=&quot;6&quot; markerHeight=&quot;6&quot; orient=&quot;auto&quot;&gt;&#10;            &lt;path d=&quot;M0 0L10 5L0 10z&quot; fill=&quot;#BD9B56&quot; /&gt;&#10;          &lt;/marker&gt;&#10;        &lt;/defs&gt;&#10;        &lt;g fontFamily=&quot;Inter, sans-serif&quot;&gt;&#10;          &lt;rect x=&quot;156&quot; y=&quot;14&quot; width=&quot;200&quot; height=&quot;50&quot; rx=&quot;8&quot; fill=&quot;rgba(34,57,94,0.08)&quot; stroke=&quot;#22395E&quot; strokeWidth=&quot;1.5&quot; /&gt;&#10;          &lt;text x=&quot;256&quot; y=&quot;36&quot; textAnchor=&quot;middle&quot; fontSize=&quot;13&quot; fontWeight=&quot;bold&quot; fill=&quot;#172133&quot;&gt;用户自然语言输入&lt;/text&gt;&#10;          &lt;text x=&quot;256&quot; y=&quot;54&quot; textAnchor=&quot;middle&quot; fontSize=&quot;11&quot; fill=&quot;#5F5E5A&quot;&gt;「我家厨房漏水了」&lt;/text&gt;&#10;          &lt;line x1=&quot;256&quot; y1=&quot;64&quot; x2=&quot;256&quot; y2=&quot;84&quot; stroke=&quot;#BD9B56&quot; strokeWidth=&quot;1.5&quot; markerEnd=&quot;url(#ar9)&quot; /&gt;&#10;          &lt;rect x=&quot;96&quot; y=&quot;88&quot; width=&quot;320&quot; height=&quot;64&quot; rx=&quot;8&quot; fill=&quot;rgba(34,57,94,0.12)&quot; stroke=&quot;#22395E&quot; strokeWidth=&quot;2&quot; /&gt;&#10;          &lt;text x=&quot;256&quot; y=&quot;114&quot; textAnchor=&quot;middle&quot; fontSize=&quot;13&quot; fontWeight=&quot;bold&quot; fill=&quot;#BD9B56&quot;&gt;Router Agent · 意图分类&lt;/text&gt;&#10;          &lt;text x=&quot;256&quot; y=&quot;136&quot; textAnchor=&quot;middle&quot; fontSize=&quot;11&quot; fill=&quot;#172133&quot;&gt;报修 / 费用 / 公告 / 知识 / 上报&lt;/text&gt;&#10;          &lt;line x1=&quot;256&quot; y1=&quot;152&quot; x2=&quot;256&quot; y2=&quot;172&quot; stroke=&quot;#BD9B56&quot; strokeWidth=&quot;1.5&quot; markerEnd=&quot;url(#ar9)&quot; /&gt;&#10;          &lt;rect x=&quot;96&quot; y=&quot;176&quot; width=&quot;320&quot; height=&quot;64&quot; rx=&quot;8&quot; fill=&quot;rgba(189,155,86,0.10)&quot; stroke=&quot;#BD9B56&quot; strokeWidth=&quot;1.5&quot; /&gt;&#10;          &lt;text x=&quot;256&quot; y=&quot;202&quot; textAnchor=&quot;middle&quot; fontSize=&quot;13&quot; fontWeight=&quot;bold&quot; fill=&quot;#172133&quot;&gt;领域 Agent + 多轮状态机&lt;/text&gt;&#10;          &lt;text x=&quot;256&quot; y=&quot;224&quot; textAnchor=&quot;middle&quot; fontSize=&quot;11&quot; fill=&quot;#5F5E5A&quot;&gt;报修缺「位置/类型」→ 主动反问补全&lt;/text&gt;&#10;          &lt;line x1=&quot;256&quot; y1=&quot;240&quot; x2=&quot;256&quot; y2=&quot;260&quot; stroke=&quot;#BD9B56&quot; strokeWidth=&quot;1.5&quot; markerEnd=&quot;url(#ar9)&quot; /&gt;&#10;          &lt;rect x=&quot;16&quot; y=&quot;264&quot; width=&quot;140&quot; height=&quot;48&quot; rx=&quot;6&quot; fill=&quot;rgba(34,57,94,0.06)&quot; stroke=&quot;#22395E&quot; strokeWidth=&quot;1.5&quot; /&gt;&#10;          &lt;text x=&quot;86&quot; y=&quot;284&quot; textAnchor=&quot;middle&quot; fontSize=&quot;12&quot; fontWeight=&quot;bold&quot; fill=&quot;#172133&quot;&gt;create_repair&lt;/text&gt;&#10;          &lt;text x=&quot;86&quot; y=&quot;302&quot; textAnchor=&quot;middle&quot; fontSize=&quot;10&quot; fill=&quot;#5F5E5A&quot;&gt;创建工单&lt;/text&gt;&#10;          &lt;rect x=&quot;176&quot; y=&quot;264&quot; width=&quot;140&quot; height=&quot;48&quot; rx=&quot;6&quot; fill=&quot;rgba(34,57,94,0.06)&quot; stroke=&quot;#22395E&quot; strokeWidth=&quot;1.5&quot; /&gt;&#10;          &lt;text x=&quot;246&quot; y=&quot;284&quot; textAnchor=&quot;middle&quot; fontSize=&quot;12&quot; fontWeight=&quot;bold&quot; fill=&quot;#172133&quot;&gt;query_fee&lt;/text&gt;&#10;          &lt;text x=&quot;246&quot; y=&quot;302&quot; textAnchor=&quot;middle&quot; fontSize=&quot;10&quot; fill=&quot;#5F5E5A&quot;&gt;查询费用&lt;/text&gt;&#10;          &lt;rect x=&quot;336&quot; y=&quot;264&quot; width=&quot;160&quot; height=&quot;48&quot; rx=&quot;6&quot; fill=&quot;rgba(34,57,94,0.06)&quot; stroke=&quot;#22395E&quot; strokeWidth=&quot;1.5&quot; /&gt;&#10;          &lt;text x=&quot;416&quot; y=&quot;284&quot; textAnchor=&quot;middle&quot; fontSize=&quot;12&quot; fontWeight=&quot;bold&quot; fill=&quot;#172133&quot;&gt;search_knowledge&lt;/text&gt;&#10;          &lt;text x=&quot;416&quot; y=&quot;302&quot; textAnchor=&quot;middle&quot; fontSize=&quot;10&quot; fill=&quot;#5F5E5A&quot;&gt;检索知识&lt;/text&gt;&#10;          &lt;line x1=&quot;256&quot; y1=&quot;260&quot; x2=&quot;256&quot; y2=&quot;288&quot; stroke=&quot;#22395E&quot; strokeWidth=&quot;1.2&quot; /&gt;&#10;          &lt;line x1=&quot;256&quot; y1=&quot;288&quot; x2=&quot;86&quot; y2=&quot;288&quot; stroke=&quot;#22395E&quot; strokeWidth=&quot;1.2&quot; /&gt;&#10;          &lt;line x1=&quot;256&quot; y1=&quot;288&quot; x2=&quot;246&quot; y2=&quot;288&quot; stroke=&quot;#22395E&quot; strokeWidth=&quot;1.2&quot; /&gt;&#10;          &lt;line x1=&quot;256&quot; y1=&quot;288&quot; x2=&quot;416&quot; y2=&quot;288&quot; stroke=&quot;#22395E&quot; strokeWidth=&quot;1.2&quot; /&gt;&#10;          &lt;line x1=&quot;86&quot; y1=&quot;312&quot; x2=&quot;86&quot; y2=&quot;332&quot; stroke=&quot;#22395E&quot; strokeWidth=&quot;1.2&quot; /&gt;&#10;          &lt;line x1=&quot;246&quot; y1=&quot;312&quot; x2=&quot;246&quot; y2=&quot;332&quot; stroke=&quot;#22395E&quot; strokeWidth=&quot;1.2&quot; /&gt;&#10;          &lt;line x1=&quot;416&quot; y1=&quot;312&quot; x2=&quot;416&quot; y2=&quot;332&quot; stroke=&quot;#22395E&quot; strokeWidth=&quot;1.2&quot; /&gt;&#10;          &lt;rect x=&quot;16&quot; y=&quot;336&quot; width=&quot;480&quot; height=&quot;42&quot; rx=&quot;6&quot; fill=&quot;#172133&quot; /&gt;&#10;          &lt;text x=&quot;256&quot; y=&quot;362&quot; textAnchor=&quot;middle&quot; fontSize=&quot;12&quot; fontWeight=&quot;bold&quot; fill=&quot;#BD9B56&quot;&gt;业务 API 层 · 工具执行 · Trace 全程记录可评估&lt;/text&gt;&#10;          &lt;text x=&quot;256&quot; y=&quot;410&quot; textAnchor=&quot;middle&quot; fontSize=&quot;12&quot; fill=&quot;#5F5E5A&quot;&gt;驱动模型：智谱 GLM-4-Flash · 编排框架：LangGraph&lt;/text&gt;&#10;        &lt;/g&gt;&#10;      &lt;/svg&gt;&#10;    &lt;/div&gt;&#10;    &lt;div style={{ flex: 1, display: 'flex', flexDirection: 'column', gap: 18 }}&gt;&#10;      &lt;div&gt;&#10;        &lt;div style={{ fontSize: 14, color: '#BD9B56', fontWeight: 'bold', letterSpacing: '0.1em', marginBottom: 6 }}&gt;1.  多轮状态机&lt;/div&gt;&#10;        &lt;p style={{ fontSize: 14, color: '#5F5E5A', margin: 0, lineHeight: 1.65 }}&gt;报修不是单轮问答——业主只说「厨房漏水」时，Agent 会主动追问房屋位置、故障类型，把信息补全后才创建工单，避免生成残缺工单。&lt;/p&gt;&#10;      &lt;/div&gt;&#10;      &lt;div&gt;&#10;        &lt;div style={{ fontSize: 14, color: '#BD9B56', fontWeight: 'bold', letterSpacing: '0.1em', marginBottom: 6 }}&gt;2.  五类意图&lt;/div&gt;&#10;        &lt;p style={{ fontSize: 14, color: '#5F5E5A', margin: 0, lineHeight: 1.65 }}&gt;报修、费用、公告、知识咨询、问题上报，自然语言直达对应业务工具，实测意图识别准确率 100%。&lt;/p&gt;&#10;      &lt;/div&gt;&#10;      &lt;div&gt;&#10;        &lt;div style={{ fontSize: 14, color: '#BD9B56', fontWeight: 'bold', letterSpacing: '0.1em', marginBottom: 6 }}&gt;3.  可观测可评估&lt;/div&gt;&#10;        &lt;p style={{ fontSize: 14, color: '#5F5E5A', margin: 0, lineHeight: 1.65 }}&gt;每次对话的意图、工具、结果全程记录 Trace，可回放、可评估，是量化评估体系的数据基础。&lt;/p&gt;&#10;      &lt;/div&gt;&#10;    &lt;/div&gt;&#10;  &lt;/div&gt;&#10;  &lt;div style={{ flexShrink: 0, height: 40, display: 'flex', alignItems: 'flex-end', justifyContent: 'space-between' }}&gt;&#10;    &lt;span style={{ color: '#BD9B56', fontSize: 12, letterSpacing: '0.1em' }}&gt;云溪花园 · 智慧社区&lt;/span&gt;&#10;    &lt;span style={{ color: '#a09b8c', fontSize: 12 }}&gt;09 / 15&lt;/span&gt;&#10;  &lt;/div&gt;&#10;&lt;/Slide&gt;"/>
         <p:cNvGrpSpPr/>
         <p:nvPr/>
       </p:nvGrpSpPr>
@@ -17303,7 +17551,7 @@
       </p:grpSpPr>
       <p:sp>
         <p:nvSpPr>
-          <p:cNvPr id="378" name=""/>
+          <p:cNvPr id="382" name=""/>
           <p:cNvSpPr/>
           <p:nvPr/>
         </p:nvSpPr>
@@ -17327,7 +17575,7 @@
       </p:sp>
       <p:sp>
         <p:nvSpPr>
-          <p:cNvPr id="379" name="" descr="{&quot;isTemplate&quot;:true,&quot;type&quot;:&quot;text&quot;}"/>
+          <p:cNvPr id="383" name="" descr="{&quot;isTemplate&quot;:true,&quot;type&quot;:&quot;text&quot;}"/>
           <p:cNvSpPr txBox="1"/>
           <p:nvPr/>
         </p:nvSpPr>
@@ -17372,7 +17620,7 @@
       </p:sp>
       <p:sp>
         <p:nvSpPr>
-          <p:cNvPr id="380" name="" descr="{&quot;isTemplate&quot;:true,&quot;type&quot;:&quot;text&quot;}"/>
+          <p:cNvPr id="384" name="" descr="{&quot;isTemplate&quot;:true,&quot;type&quot;:&quot;text&quot;}"/>
           <p:cNvSpPr txBox="1"/>
           <p:nvPr/>
         </p:nvSpPr>
@@ -17437,7 +17685,7 @@
       </p:sp>
       <p:sp>
         <p:nvSpPr>
-          <p:cNvPr id="381" name=""/>
+          <p:cNvPr id="385" name=""/>
           <p:cNvSpPr/>
           <p:nvPr/>
         </p:nvSpPr>
@@ -17470,7 +17718,7 @@
       </p:sp>
       <p:pic>
         <p:nvPicPr>
-          <p:cNvPr id="382" name=""/>
+          <p:cNvPr id="386" name=""/>
           <p:cNvPicPr>
             <a:picLocks noChangeAspect="1"/>
           </p:cNvPicPr>
@@ -17501,7 +17749,7 @@
       </p:pic>
       <p:sp>
         <p:nvSpPr>
-          <p:cNvPr id="383" name="" descr="{&quot;isTemplate&quot;:true,&quot;type&quot;:&quot;text&quot;}"/>
+          <p:cNvPr id="387" name="" descr="{&quot;isTemplate&quot;:true,&quot;type&quot;:&quot;text&quot;}"/>
           <p:cNvSpPr txBox="1"/>
           <p:nvPr/>
         </p:nvSpPr>
@@ -17546,7 +17794,7 @@
       </p:sp>
       <p:sp>
         <p:nvSpPr>
-          <p:cNvPr id="384" name="" descr="{&quot;isTemplate&quot;:true,&quot;type&quot;:&quot;text&quot;}"/>
+          <p:cNvPr id="388" name="" descr="{&quot;isTemplate&quot;:true,&quot;type&quot;:&quot;text&quot;}"/>
           <p:cNvSpPr txBox="1"/>
           <p:nvPr/>
         </p:nvSpPr>
@@ -17603,7 +17851,7 @@
       </p:sp>
       <p:sp>
         <p:nvSpPr>
-          <p:cNvPr id="385" name="" descr="{&quot;isTemplate&quot;:true,&quot;type&quot;:&quot;text&quot;}"/>
+          <p:cNvPr id="389" name="" descr="{&quot;isTemplate&quot;:true,&quot;type&quot;:&quot;text&quot;}"/>
           <p:cNvSpPr txBox="1"/>
           <p:nvPr/>
         </p:nvSpPr>
@@ -17648,7 +17896,7 @@
       </p:sp>
       <p:sp>
         <p:nvSpPr>
-          <p:cNvPr id="386" name="" descr="{&quot;isTemplate&quot;:true,&quot;type&quot;:&quot;text&quot;}"/>
+          <p:cNvPr id="390" name="" descr="{&quot;isTemplate&quot;:true,&quot;type&quot;:&quot;text&quot;}"/>
           <p:cNvSpPr txBox="1"/>
           <p:nvPr/>
         </p:nvSpPr>
@@ -17705,7 +17953,7 @@
       </p:sp>
       <p:sp>
         <p:nvSpPr>
-          <p:cNvPr id="387" name="" descr="{&quot;isTemplate&quot;:true,&quot;type&quot;:&quot;text&quot;}"/>
+          <p:cNvPr id="391" name="" descr="{&quot;isTemplate&quot;:true,&quot;type&quot;:&quot;text&quot;}"/>
           <p:cNvSpPr txBox="1"/>
           <p:nvPr/>
         </p:nvSpPr>
@@ -17750,7 +17998,7 @@
       </p:sp>
       <p:sp>
         <p:nvSpPr>
-          <p:cNvPr id="388" name="" descr="{&quot;isTemplate&quot;:true,&quot;type&quot;:&quot;text&quot;}"/>
+          <p:cNvPr id="392" name="" descr="{&quot;isTemplate&quot;:true,&quot;type&quot;:&quot;text&quot;}"/>
           <p:cNvSpPr txBox="1"/>
           <p:nvPr/>
         </p:nvSpPr>
@@ -17807,7 +18055,7 @@
       </p:sp>
       <p:sp>
         <p:nvSpPr>
-          <p:cNvPr id="389" name="" descr="{&quot;isTemplate&quot;:true,&quot;type&quot;:&quot;text&quot;}"/>
+          <p:cNvPr id="393" name="" descr="{&quot;isTemplate&quot;:true,&quot;type&quot;:&quot;text&quot;}"/>
           <p:cNvSpPr txBox="1"/>
           <p:nvPr/>
         </p:nvSpPr>
@@ -17862,7 +18110,7 @@
       </p:sp>
       <p:sp>
         <p:nvSpPr>
-          <p:cNvPr id="390" name="" descr="{&quot;isTemplate&quot;:true,&quot;type&quot;:&quot;text&quot;}"/>
+          <p:cNvPr id="394" name="" descr="{&quot;isTemplate&quot;:true,&quot;type&quot;:&quot;text&quot;}"/>
           <p:cNvSpPr txBox="1"/>
           <p:nvPr/>
         </p:nvSpPr>

</xml_diff>

<commit_message>
docs(ppt): redesign section dividers (bigger, cleaner, no garbled glyphs)
Replace the plain dividers with a bolder full-bleed layout: solid-gold
160px chapter number, 50px title, English subtitle, gold rule, and
chapter-content pill tags. Removed the semi-transparent Inter numerals
and out-of-canvas SVG rings that rendered garbled / triggered overflow.
</commit_message>
<xml_diff>
--- a/ppt/AI物业社区智能体方案/AI物业社区智能体-方案.pptx
+++ b/ppt/AI物业社区智能体方案/AI物业社区智能体-方案.pptx
@@ -5444,7 +5444,7 @@
   <p:cSld>
     <p:spTree>
       <p:nvGrpSpPr>
-        <p:cNvPr id="110" name="" descr="&lt;Slide style={{ width: '1280px', height: '720px', background: 'linear-gradient(135deg, #172133 0%, #22395E 100%)', position: 'relative', display: 'flex', flexDirection: 'column', justifyContent: 'center', padding: '0 96px' }}&gt;&#10;  &lt;div style={{ color: '#BD9B56', fontSize: 15, letterSpacing: '0.35em', marginBottom: 24 }}&gt;SECTION 03&lt;/div&gt;&#10;  &lt;div style={{ display: 'flex', alignItems: 'baseline', gap: 28 }}&gt;&#10;    &lt;span style={{ fontSize: 110, fontWeight: 'bold', color: 'rgba(189,155,86,0.28)', fontFamily: 'Inter, sans-serif', lineHeight: 1 }}&gt;03&lt;/span&gt;&#10;    &lt;span style={{ fontSize: 46, fontWeight: 'bold', color: '#FBFCFA', letterSpacing: '0.02em' }}&gt;成果与验证&lt;/span&gt;&#10;  &lt;/div&gt;&#10;  &lt;div style={{ width: 72, height: 3, background: '#BD9B56', margin: '28px 0 20px' }} /&gt;&#10;  &lt;div style={{ fontSize: 16, color: 'rgba(251,252,250,0.72)', letterSpacing: '0.04em' }}&gt;三条功能闭环 · 量化评估指标&lt;/div&gt;&#10;  &lt;div style={{ position: 'absolute', bottom: 42, right: 96, color: 'rgba(251,252,250,0.4)', fontSize: 13, fontFamily: 'Inter, sans-serif' }}&gt;13 / 19&lt;/div&gt;&#10;&lt;/Slide&gt;"/>
+        <p:cNvPr id="110" name="" descr="&lt;Slide style={{ width: '1280px', height: '720px', background: 'linear-gradient(135deg, #172133 0%, #22395E 100%)', position: 'relative', display: 'flex', flexDirection: 'column', justifyContent: 'center', padding: '0 96px' }}&gt;&#10;  &lt;div style={{ color: '#BD9B56', fontSize: 15, letterSpacing: '0.35em', marginBottom: 24 }}&gt;SECTION 03&lt;/div&gt;&#10;  &lt;div style={{ display: 'flex', alignItems: 'center', gap: 36 }}&gt;&#10;    &lt;span style={{ fontSize: 160, fontWeight: 'bold', color: '#BD9B56', lineHeight: 1 }}&gt;03&lt;/span&gt;&#10;    &lt;div&gt;&#10;      &lt;div style={{ fontSize: 50, fontWeight: 'bold', color: '#FBFCFA', letterSpacing: '0.02em', lineHeight: 1.15 }}&gt;成果与验证&lt;/div&gt;&#10;      &lt;div style={{ fontSize: 17, color: 'rgba(251,252,250,0.55)', marginTop: 12, letterSpacing: '0.06em' }}&gt;RESULTS &amp;amp; VALIDATION&lt;/div&gt;&#10;    &lt;/div&gt;&#10;  &lt;/div&gt;&#10;  &lt;div style={{ width: 80, height: 3, background: '#BD9B56', margin: '32px 0 24px' }} /&gt;&#10;  &lt;div style={{ display: 'flex', gap: 14 }}&gt;&#10;    &lt;span style={{ fontSize: 15, color: 'rgba(251,252,250,0.88)', border: '1px solid rgba(189,155,86,0.65)', padding: '9px 20px', borderRadius: 22 }}&gt;三条功能闭环&lt;/span&gt;&#10;    &lt;span style={{ fontSize: 15, color: 'rgba(251,252,250,0.88)', border: '1px solid rgba(189,155,86,0.65)', padding: '9px 20px', borderRadius: 22 }}&gt;量化评估指标&lt;/span&gt;&#10;  &lt;/div&gt;&#10;  &lt;div style={{ position: 'absolute', bottom: 42, right: 96, color: 'rgba(251,252,250,0.4)', fontSize: 13 }}&gt;13 / 19&lt;/div&gt;&#10;&lt;/Slide&gt;"/>
         <p:cNvGrpSpPr/>
         <p:nvPr/>
       </p:nvGrpSpPr>
@@ -5496,8 +5496,43 @@
         </p:nvSpPr>
         <p:spPr>
           <a:xfrm rot="0" flipH="0" flipV="0">
+            <a:off x="914400" y="1866900"/>
+            <a:ext cx="10363200" cy="171450"/>
+          </a:xfrm>
+          <a:prstGeom prst="rect"/>
+        </p:spPr>
+        <p:txBody>
+          <a:bodyPr wrap="none" lIns="0" tIns="0" rIns="0" bIns="0"/>
+          <a:p>
+            <a:pPr>
+              <a:lnSpc>
+                <a:spcPct val="100000"/>
+              </a:lnSpc>
+            </a:pPr>
+            <a:r>
+              <a:rPr lang="en-US" sz="1125" spc="-9223372036854775808">
+                <a:solidFill>
+                  <a:srgbClr val="BD9B56"/>
+                </a:solidFill>
+                <a:latin typeface="Microsoft YaHei"/>
+                <a:ea typeface="Microsoft YaHei"/>
+              </a:rPr>
+              <a:t>SECTION 03</a:t>
+            </a:r>
+            <a:endParaRPr/>
+          </a:p>
+        </p:txBody>
+      </p:sp>
+      <p:sp>
+        <p:nvSpPr>
+          <p:cNvPr id="113" name="" descr="{&quot;isTemplate&quot;:true,&quot;type&quot;:&quot;text&quot;}"/>
+          <p:cNvSpPr txBox="1"/>
+          <p:nvPr/>
+        </p:nvSpPr>
+        <p:spPr>
+          <a:xfrm rot="0" flipH="0" flipV="0">
             <a:off x="914400" y="2266950"/>
-            <a:ext cx="10363200" cy="171450"/>
+            <a:ext cx="1885950" cy="1828800"/>
           </a:xfrm>
           <a:prstGeom prst="rect"/>
         </p:spPr>
@@ -5510,29 +5545,64 @@
               </a:lnSpc>
             </a:pPr>
             <a:r>
-              <a:rPr lang="en-US" sz="1125" spc="-9223372036854775808">
+              <a:rPr lang="en-US" sz="12000" b="1">
                 <a:solidFill>
                   <a:srgbClr val="BD9B56"/>
                 </a:solidFill>
                 <a:latin typeface="Microsoft YaHei"/>
                 <a:ea typeface="Microsoft YaHei"/>
               </a:rPr>
-              <a:t>SECTION 03</a:t>
-            </a:r>
-            <a:endParaRPr/>
-          </a:p>
-        </p:txBody>
-      </p:sp>
-      <p:sp>
-        <p:nvSpPr>
-          <p:cNvPr id="113" name="" descr="{&quot;isTemplate&quot;:true,&quot;type&quot;:&quot;text&quot;}"/>
-          <p:cNvSpPr txBox="1"/>
-          <p:nvPr/>
-        </p:nvSpPr>
-        <p:spPr>
-          <a:xfrm rot="0" flipH="0" flipV="0">
-            <a:off x="914400" y="2667000"/>
-            <a:ext cx="1343025" cy="1257300"/>
+              <a:t>03</a:t>
+            </a:r>
+            <a:endParaRPr/>
+          </a:p>
+        </p:txBody>
+      </p:sp>
+      <p:sp>
+        <p:nvSpPr>
+          <p:cNvPr id="114" name="" descr="{&quot;isTemplate&quot;:true,&quot;type&quot;:&quot;text&quot;}"/>
+          <p:cNvSpPr txBox="1"/>
+          <p:nvPr/>
+        </p:nvSpPr>
+        <p:spPr>
+          <a:xfrm rot="0" flipH="0" flipV="0">
+            <a:off x="3143250" y="2695575"/>
+            <a:ext cx="2381250" cy="657225"/>
+          </a:xfrm>
+          <a:prstGeom prst="rect"/>
+        </p:spPr>
+        <p:txBody>
+          <a:bodyPr wrap="none" lIns="0" tIns="0" rIns="0" bIns="0"/>
+          <a:p>
+            <a:pPr>
+              <a:lnSpc>
+                <a:spcPct val="114999"/>
+              </a:lnSpc>
+            </a:pPr>
+            <a:r>
+              <a:rPr lang="zh-CN" sz="3750" spc="-9223372036854775808">
+                <a:solidFill>
+                  <a:srgbClr val="FBFCFA"/>
+                </a:solidFill>
+                <a:latin typeface="Microsoft YaHei"/>
+                <a:ea typeface="Microsoft YaHei"/>
+              </a:rPr>
+              <a:t>成果与验证</a:t>
+            </a:r>
+            <a:endParaRPr/>
+          </a:p>
+        </p:txBody>
+      </p:sp>
+      <p:sp>
+        <p:nvSpPr>
+          <p:cNvPr id="115" name="" descr="{&quot;isTemplate&quot;:true,&quot;type&quot;:&quot;text&quot;}"/>
+          <p:cNvSpPr txBox="1"/>
+          <p:nvPr/>
+        </p:nvSpPr>
+        <p:spPr>
+          <a:xfrm rot="0" flipH="0" flipV="0">
+            <a:off x="3143250" y="3467100"/>
+            <a:ext cx="2381250" cy="200025"/>
           </a:xfrm>
           <a:prstGeom prst="rect"/>
         </p:spPr>
@@ -5545,66 +5615,31 @@
               </a:lnSpc>
             </a:pPr>
             <a:r>
-              <a:rPr lang="en-US" sz="8250" b="1">
-                <a:solidFill>
-                  <a:srgbClr val="BD9B56">
-                    <a:alpha val="28000"/>
+              <a:rPr lang="en-US" sz="1275" spc="-9223372036854775808">
+                <a:solidFill>
+                  <a:srgbClr val="FBFCFA">
+                    <a:alpha val="55000"/>
                   </a:srgbClr>
                 </a:solidFill>
-                <a:latin typeface="Inter"/>
-                <a:ea typeface="Inter"/>
-              </a:rPr>
-              <a:t>03</a:t>
-            </a:r>
-            <a:endParaRPr/>
-          </a:p>
-        </p:txBody>
-      </p:sp>
-      <p:sp>
-        <p:nvSpPr>
-          <p:cNvPr id="114" name="" descr="{&quot;isTemplate&quot;:true,&quot;type&quot;:&quot;text&quot;}"/>
-          <p:cNvSpPr txBox="1"/>
-          <p:nvPr/>
-        </p:nvSpPr>
-        <p:spPr>
-          <a:xfrm rot="0" flipH="0" flipV="0">
-            <a:off x="2524125" y="2667000"/>
-            <a:ext cx="2190750" cy="1257300"/>
-          </a:xfrm>
-          <a:prstGeom prst="rect"/>
-        </p:spPr>
-        <p:txBody>
-          <a:bodyPr wrap="none" lIns="0" tIns="0" rIns="0" bIns="0"/>
-          <a:p>
-            <a:pPr>
-              <a:lnSpc>
-                <a:spcPct val="100000"/>
-              </a:lnSpc>
-            </a:pPr>
-            <a:r>
-              <a:rPr lang="zh-CN" sz="3450" b="1">
-                <a:solidFill>
-                  <a:srgbClr val="FBFCFA"/>
-                </a:solidFill>
-                <a:latin typeface="Microsoft YaHei"/>
-                <a:ea typeface="Microsoft YaHei"/>
-              </a:rPr>
-              <a:t>成果与验证</a:t>
-            </a:r>
-            <a:endParaRPr/>
-          </a:p>
-        </p:txBody>
-      </p:sp>
-      <p:sp>
-        <p:nvSpPr>
-          <p:cNvPr id="115" name=""/>
+                <a:latin typeface="Microsoft YaHei"/>
+                <a:ea typeface="Microsoft YaHei"/>
+              </a:rPr>
+              <a:t>RESULTS &amp; VALIDATION</a:t>
+            </a:r>
+            <a:endParaRPr/>
+          </a:p>
+        </p:txBody>
+      </p:sp>
+      <p:sp>
+        <p:nvSpPr>
+          <p:cNvPr id="116" name=""/>
           <p:cNvSpPr/>
           <p:nvPr/>
         </p:nvSpPr>
         <p:spPr>
           <a:xfrm rot="0" flipH="0" flipV="0">
-            <a:off x="914400" y="4191000"/>
-            <a:ext cx="685800" cy="28575"/>
+            <a:off x="914400" y="4400550"/>
+            <a:ext cx="762000" cy="28575"/>
           </a:xfrm>
           <a:prstGeom prst="rect">
             <a:avLst/>
@@ -5621,19 +5656,49 @@
       </p:sp>
       <p:sp>
         <p:nvSpPr>
-          <p:cNvPr id="116" name="" descr="{&quot;isTemplate&quot;:true,&quot;type&quot;:&quot;text&quot;}"/>
-          <p:cNvSpPr txBox="1"/>
-          <p:nvPr/>
-        </p:nvSpPr>
-        <p:spPr>
-          <a:xfrm rot="0" flipH="0" flipV="0">
-            <a:off x="914400" y="4410075"/>
-            <a:ext cx="10363200" cy="190500"/>
-          </a:xfrm>
-          <a:prstGeom prst="rect"/>
-        </p:spPr>
-        <p:txBody>
-          <a:bodyPr wrap="none" lIns="0" tIns="0" rIns="0" bIns="0"/>
+          <p:cNvPr id="117" name=""/>
+          <p:cNvSpPr/>
+          <p:nvPr/>
+        </p:nvSpPr>
+        <p:spPr>
+          <a:xfrm rot="0" flipH="0" flipV="0">
+            <a:off x="914400" y="4657725"/>
+            <a:ext cx="1238250" cy="342900"/>
+          </a:xfrm>
+          <a:prstGeom prst="roundRect">
+            <a:avLst>
+              <a:gd name="adj" fmla="val 61111"/>
+            </a:avLst>
+          </a:prstGeom>
+          <a:ln w="12700">
+            <a:solidFill>
+              <a:srgbClr val="BD9B56">
+                <a:alpha val="65000"/>
+              </a:srgbClr>
+            </a:solidFill>
+            <a:prstDash val="solid"/>
+          </a:ln>
+        </p:spPr>
+        <p:txBody>
+          <a:bodyPr/>
+          <a:p/>
+        </p:txBody>
+      </p:sp>
+      <p:sp>
+        <p:nvSpPr>
+          <p:cNvPr id="118" name="" descr="{&quot;isTemplate&quot;:true,&quot;type&quot;:&quot;text&quot;}"/>
+          <p:cNvSpPr txBox="1"/>
+          <p:nvPr/>
+        </p:nvSpPr>
+        <p:spPr>
+          <a:xfrm rot="0" flipH="0" flipV="0">
+            <a:off x="914400" y="4657725"/>
+            <a:ext cx="1238250" cy="342900"/>
+          </a:xfrm>
+          <a:prstGeom prst="rect"/>
+        </p:spPr>
+        <p:txBody>
+          <a:bodyPr wrap="none" lIns="142875" tIns="64294" rIns="142875" bIns="64294"/>
           <a:p>
             <a:pPr>
               <a:lnSpc>
@@ -5641,10 +5706,10 @@
               </a:lnSpc>
             </a:pPr>
             <a:r>
-              <a:rPr lang="zh-CN" sz="1200" spc="-9223372036854775808">
+              <a:rPr lang="zh-CN" sz="1125">
                 <a:solidFill>
                   <a:srgbClr val="FBFCFA">
-                    <a:alpha val="72000"/>
+                    <a:alpha val="88000"/>
                   </a:srgbClr>
                 </a:solidFill>
                 <a:latin typeface="Microsoft YaHei"/>
@@ -5652,28 +5717,71 @@
               </a:rPr>
               <a:t>三条功能闭环</a:t>
             </a:r>
-            <a:r>
-              <a:rPr lang="en-US" sz="1200" spc="-9223372036854775808">
+            <a:endParaRPr/>
+          </a:p>
+        </p:txBody>
+      </p:sp>
+      <p:sp>
+        <p:nvSpPr>
+          <p:cNvPr id="119" name=""/>
+          <p:cNvSpPr/>
+          <p:nvPr/>
+        </p:nvSpPr>
+        <p:spPr>
+          <a:xfrm rot="0" flipH="0" flipV="0">
+            <a:off x="2286000" y="4657725"/>
+            <a:ext cx="1238250" cy="342900"/>
+          </a:xfrm>
+          <a:prstGeom prst="roundRect">
+            <a:avLst>
+              <a:gd name="adj" fmla="val 61111"/>
+            </a:avLst>
+          </a:prstGeom>
+          <a:ln w="12700">
+            <a:solidFill>
+              <a:srgbClr val="BD9B56">
+                <a:alpha val="65000"/>
+              </a:srgbClr>
+            </a:solidFill>
+            <a:prstDash val="solid"/>
+          </a:ln>
+        </p:spPr>
+        <p:txBody>
+          <a:bodyPr/>
+          <a:p/>
+        </p:txBody>
+      </p:sp>
+      <p:sp>
+        <p:nvSpPr>
+          <p:cNvPr id="120" name="" descr="{&quot;isTemplate&quot;:true,&quot;type&quot;:&quot;text&quot;}"/>
+          <p:cNvSpPr txBox="1"/>
+          <p:nvPr/>
+        </p:nvSpPr>
+        <p:spPr>
+          <a:xfrm rot="0" flipH="0" flipV="0">
+            <a:off x="2286000" y="4657725"/>
+            <a:ext cx="1238250" cy="342900"/>
+          </a:xfrm>
+          <a:prstGeom prst="rect"/>
+        </p:spPr>
+        <p:txBody>
+          <a:bodyPr wrap="none" lIns="142875" tIns="64294" rIns="142875" bIns="64294"/>
+          <a:p>
+            <a:pPr>
+              <a:lnSpc>
+                <a:spcPct val="100000"/>
+              </a:lnSpc>
+            </a:pPr>
+            <a:r>
+              <a:rPr lang="zh-CN" sz="1125">
                 <a:solidFill>
                   <a:srgbClr val="FBFCFA">
-                    <a:alpha val="72000"/>
+                    <a:alpha val="88000"/>
                   </a:srgbClr>
                 </a:solidFill>
                 <a:latin typeface="Microsoft YaHei"/>
                 <a:ea typeface="Microsoft YaHei"/>
               </a:rPr>
-              <a:t> · </a:t>
-            </a:r>
-            <a:r>
-              <a:rPr lang="zh-CN" sz="1200" spc="-9223372036854775808">
-                <a:solidFill>
-                  <a:srgbClr val="FBFCFA">
-                    <a:alpha val="72000"/>
-                  </a:srgbClr>
-                </a:solidFill>
-                <a:latin typeface="Microsoft YaHei"/>
-                <a:ea typeface="Microsoft YaHei"/>
-              </a:rPr>
               <a:t>量化评估指标</a:t>
             </a:r>
             <a:endParaRPr/>
@@ -5682,14 +5790,14 @@
       </p:sp>
       <p:sp>
         <p:nvSpPr>
-          <p:cNvPr id="117" name="" descr="{&quot;isTemplate&quot;:true,&quot;type&quot;:&quot;text&quot;}"/>
-          <p:cNvSpPr txBox="1"/>
-          <p:nvPr/>
-        </p:nvSpPr>
-        <p:spPr>
-          <a:xfrm rot="0" flipH="0" flipV="0">
-            <a:off x="10877550" y="6305550"/>
-            <a:ext cx="400050" cy="152400"/>
+          <p:cNvPr id="121" name="" descr="{&quot;isTemplate&quot;:true,&quot;type&quot;:&quot;text&quot;}"/>
+          <p:cNvSpPr txBox="1"/>
+          <p:nvPr/>
+        </p:nvSpPr>
+        <p:spPr>
+          <a:xfrm rot="0" flipH="0" flipV="0">
+            <a:off x="10858500" y="6305550"/>
+            <a:ext cx="419100" cy="152400"/>
           </a:xfrm>
           <a:prstGeom prst="rect"/>
         </p:spPr>
@@ -5708,8 +5816,8 @@
                     <a:alpha val="40000"/>
                   </a:srgbClr>
                 </a:solidFill>
-                <a:latin typeface="Inter"/>
-                <a:ea typeface="Inter"/>
+                <a:latin typeface="Microsoft YaHei"/>
+                <a:ea typeface="Microsoft YaHei"/>
               </a:rPr>
               <a:t>13 / 19</a:t>
             </a:r>
@@ -5727,7 +5835,7 @@
   <p:cSld>
     <p:spTree>
       <p:nvGrpSpPr>
-        <p:cNvPr id="118" name="" descr="&lt;Slide style={{ width: '1280px', height: '720px', background: '#FBFCFA', position: 'relative', padding: '40px 64px', boxSizing: 'border-box', display: 'flex', flexDirection: 'column' }}&gt;&#13;&#10;  &lt;div style={{ flexShrink: 0 }}&gt;&#13;&#10;    &lt;div style={{ color: '#BD9B56', fontSize: 13, letterSpacing: '0.25em', marginBottom: 8 }}&gt;03 · 成果与验证&lt;/div&gt;&#13;&#10;    &lt;h2 style={{ fontSize: 30, fontWeight: 'bold', color: '#172133', margin: 0, lineHeight: 1.3 }}&gt;功能闭环：AI 走完完整业务流程&lt;/h2&gt;&#13;&#10;    &lt;div style={{ fontSize: 14, color: '#6b7075', marginTop: 8 }}&gt;三条闭环验证「AI 不是聊天框，而是真正参与业务」——每条都真实写入数据库、流转状态、发出通知&lt;/div&gt;&#13;&#10;  &lt;/div&gt;&#13;&#10;  &lt;div style={{ flex: 1, display: 'flex', alignItems: 'center' }}&gt;&#13;&#10;    &lt;div style={{ width: '100%', display: 'flex', gap: 18 }}&gt;&#13;&#10;      &lt;div style={{ flex: 1, background: '#fff', borderRadius: 10, padding: '18px 18px', boxShadow: '0 4px 16px rgba(23,33,51,0.06)', display: 'flex', flexDirection: 'column' }}&gt;&#13;&#10;        &lt;div style={{ display: 'flex', alignItems: 'center', gap: 8, marginBottom: 10 }}&gt;&#13;&#10;          &lt;span style={{ fontSize: 17, fontWeight: 'bold', color: '#172133' }}&gt;1.  报修闭环&lt;/span&gt;&#13;&#10;          &lt;span style={{ fontSize: 12, color: '#BD9B56', background: 'rgba(189,155,86,0.12)', padding: '2px 8px', borderRadius: 4 }}&gt;业主 → 师傅&lt;/span&gt;&#13;&#10;        &lt;/div&gt;&#13;&#10;        &lt;p style={{ fontSize: 13, color: '#5F5E5A', margin: 0, lineHeight: 1.6, marginBottom: 12 }}&gt;对话报修 → 多轮补全位置/类型 → 技能+在岗自动派单 → 师傅接单处理 → 业主确认完成，全流程真实建单、流转状态、发通知。&lt;/p&gt;&#13;&#10;        &lt;div style={{ marginTop: 'auto', height: 130, border: '2px dashed #BD9B56', borderRadius: 8, background: 'rgba(189,155,86,0.05)', display: 'flex', alignItems: 'center', justifyContent: 'center', color: '#BD9B56', fontSize: 12 }}&gt;此处放「AI 报修对话」截图&lt;/div&gt;&#13;&#10;      &lt;/div&gt;&#13;&#10;      &lt;div style={{ flex: 1, background: '#fff', borderRadius: 10, padding: '18px 18px', boxShadow: '0 4px 16px rgba(23,33,51,0.06)', display: 'flex', flexDirection: 'column' }}&gt;&#13;&#10;        &lt;div style={{ display: 'flex', alignItems: 'center', gap: 8, marginBottom: 10 }}&gt;&#13;&#10;          &lt;span style={{ fontSize: 17, fontWeight: 'bold', color: '#172133' }}&gt;2.  巡检告警&lt;/span&gt;&#13;&#10;          &lt;span style={{ fontSize: 12, color: '#BD9B56', background: 'rgba(189,155,86,0.12)', padding: '2px 8px', borderRadius: 4 }}&gt;摄像头 → 物业&lt;/span&gt;&#13;&#10;        &lt;/div&gt;&#13;&#10;        &lt;p style={{ fontSize: 13, color: '#5F5E5A', margin: 0, lineHeight: 1.6, marginBottom: 12 }}&gt;摄像头抓拍社区画面 → 视觉模型识别异常（垃圾堆积、车辆违停、消防堵塞）→ 生成巡检记录并实时通知物业负责人。&lt;/p&gt;&#13;&#10;        &lt;div style={{ marginTop: 'auto', height: 130, border: '2px dashed #BD9B56', borderRadius: 8, background: 'rgba(189,155,86,0.05)', display: 'flex', alignItems: 'center', justifyContent: 'center', color: '#BD9B56', fontSize: 12 }}&gt;此处放「巡检异常识别」截图&lt;/div&gt;&#13;&#10;      &lt;/div&gt;&#13;&#10;      &lt;div style={{ flex: 1, background: '#fff', borderRadius: 10, padding: '18px 18px', boxShadow: '0 4px 16px rgba(23,33,51,0.06)', display: 'flex', flexDirection: 'column' }}&gt;&#13;&#10;        &lt;div style={{ display: 'flex', alignItems: 'center', gap: 8, marginBottom: 10 }}&gt;&#13;&#10;          &lt;span style={{ fontSize: 17, fontWeight: 'bold', color: '#172133' }}&gt;3.  反馈自进化&lt;/span&gt;&#13;&#10;          &lt;span style={{ fontSize: 12, color: '#BD9B56', background: 'rgba(189,155,86,0.12)', padding: '2px 8px', borderRadius: 4 }}&gt;对话 → 知识库&lt;/span&gt;&#13;&#10;        &lt;/div&gt;&#13;&#10;        &lt;p style={{ fontSize: 13, color: '#5F5E5A', margin: 0, lineHeight: 1.6, marginBottom: 12 }}&gt;业主对 AI 答案点赞/纠错 → 沉淀「知识缺口」→ 物业人员人工审核 → 审核通过自动写入知识库，越用越准。&lt;/p&gt;&#13;&#10;        &lt;div style={{ marginTop: 'auto', height: 130, border: '2px dashed #BD9B56', borderRadius: 8, background: 'rgba(189,155,86,0.05)', display: 'flex', alignItems: 'center', justifyContent: 'center', color: '#BD9B56', fontSize: 12 }}&gt;此处放「知识缺口审核」截图&lt;/div&gt;&#13;&#10;      &lt;/div&gt;&#13;&#10;    &lt;/div&gt;&#13;&#10;  &lt;/div&gt;&#13;&#10;  &lt;div style={{ flexShrink: 0, height: 40, display: 'flex', alignItems: 'flex-end', justifyContent: 'space-between' }}&gt;&#13;&#10;    &lt;span style={{ color: '#BD9B56', fontSize: 12, letterSpacing: '0.1em' }}&gt;云溪花园 · 智慧社区&lt;/span&gt;&#13;&#10;    &lt;span style={{ color: '#a09b8c', fontSize: 12 }}&gt;14 / 19&lt;/span&gt;&#13;&#10;  &lt;/div&gt;&#13;&#10;&lt;/Slide&gt;"/>
+        <p:cNvPr id="122" name="" descr="&lt;Slide style={{ width: '1280px', height: '720px', background: '#FBFCFA', position: 'relative', padding: '40px 64px', boxSizing: 'border-box', display: 'flex', flexDirection: 'column' }}&gt;&#13;&#10;  &lt;div style={{ flexShrink: 0 }}&gt;&#13;&#10;    &lt;div style={{ color: '#BD9B56', fontSize: 13, letterSpacing: '0.25em', marginBottom: 8 }}&gt;03 · 成果与验证&lt;/div&gt;&#13;&#10;    &lt;h2 style={{ fontSize: 30, fontWeight: 'bold', color: '#172133', margin: 0, lineHeight: 1.3 }}&gt;功能闭环：AI 走完完整业务流程&lt;/h2&gt;&#13;&#10;    &lt;div style={{ fontSize: 14, color: '#6b7075', marginTop: 8 }}&gt;三条闭环验证「AI 不是聊天框，而是真正参与业务」——每条都真实写入数据库、流转状态、发出通知&lt;/div&gt;&#13;&#10;  &lt;/div&gt;&#13;&#10;  &lt;div style={{ flex: 1, display: 'flex', alignItems: 'center' }}&gt;&#13;&#10;    &lt;div style={{ width: '100%', display: 'flex', gap: 18 }}&gt;&#13;&#10;      &lt;div style={{ flex: 1, background: '#fff', borderRadius: 10, padding: '18px 18px', boxShadow: '0 4px 16px rgba(23,33,51,0.06)', display: 'flex', flexDirection: 'column' }}&gt;&#13;&#10;        &lt;div style={{ display: 'flex', alignItems: 'center', gap: 8, marginBottom: 10 }}&gt;&#13;&#10;          &lt;span style={{ fontSize: 17, fontWeight: 'bold', color: '#172133' }}&gt;1.  报修闭环&lt;/span&gt;&#13;&#10;          &lt;span style={{ fontSize: 12, color: '#BD9B56', background: 'rgba(189,155,86,0.12)', padding: '2px 8px', borderRadius: 4 }}&gt;业主 → 师傅&lt;/span&gt;&#13;&#10;        &lt;/div&gt;&#13;&#10;        &lt;p style={{ fontSize: 13, color: '#5F5E5A', margin: 0, lineHeight: 1.6, marginBottom: 12 }}&gt;对话报修 → 多轮补全位置/类型 → 技能+在岗自动派单 → 师傅接单处理 → 业主确认完成，全流程真实建单、流转状态、发通知。&lt;/p&gt;&#13;&#10;        &lt;div style={{ marginTop: 'auto', height: 130, border: '2px dashed #BD9B56', borderRadius: 8, background: 'rgba(189,155,86,0.05)', display: 'flex', alignItems: 'center', justifyContent: 'center', color: '#BD9B56', fontSize: 12 }}&gt;此处放「AI 报修对话」截图&lt;/div&gt;&#13;&#10;      &lt;/div&gt;&#13;&#10;      &lt;div style={{ flex: 1, background: '#fff', borderRadius: 10, padding: '18px 18px', boxShadow: '0 4px 16px rgba(23,33,51,0.06)', display: 'flex', flexDirection: 'column' }}&gt;&#13;&#10;        &lt;div style={{ display: 'flex', alignItems: 'center', gap: 8, marginBottom: 10 }}&gt;&#13;&#10;          &lt;span style={{ fontSize: 17, fontWeight: 'bold', color: '#172133' }}&gt;2.  巡检告警&lt;/span&gt;&#13;&#10;          &lt;span style={{ fontSize: 12, color: '#BD9B56', background: 'rgba(189,155,86,0.12)', padding: '2px 8px', borderRadius: 4 }}&gt;摄像头 → 物业&lt;/span&gt;&#13;&#10;        &lt;/div&gt;&#13;&#10;        &lt;p style={{ fontSize: 13, color: '#5F5E5A', margin: 0, lineHeight: 1.6, marginBottom: 12 }}&gt;摄像头抓拍社区画面 → 视觉模型识别异常（垃圾堆积、车辆违停、消防堵塞）→ 生成巡检记录并实时通知物业负责人。&lt;/p&gt;&#13;&#10;        &lt;div style={{ marginTop: 'auto', height: 130, border: '2px dashed #BD9B56', borderRadius: 8, background: 'rgba(189,155,86,0.05)', display: 'flex', alignItems: 'center', justifyContent: 'center', color: '#BD9B56', fontSize: 12 }}&gt;此处放「巡检异常识别」截图&lt;/div&gt;&#13;&#10;      &lt;/div&gt;&#13;&#10;      &lt;div style={{ flex: 1, background: '#fff', borderRadius: 10, padding: '18px 18px', boxShadow: '0 4px 16px rgba(23,33,51,0.06)', display: 'flex', flexDirection: 'column' }}&gt;&#13;&#10;        &lt;div style={{ display: 'flex', alignItems: 'center', gap: 8, marginBottom: 10 }}&gt;&#13;&#10;          &lt;span style={{ fontSize: 17, fontWeight: 'bold', color: '#172133' }}&gt;3.  反馈自进化&lt;/span&gt;&#13;&#10;          &lt;span style={{ fontSize: 12, color: '#BD9B56', background: 'rgba(189,155,86,0.12)', padding: '2px 8px', borderRadius: 4 }}&gt;对话 → 知识库&lt;/span&gt;&#13;&#10;        &lt;/div&gt;&#13;&#10;        &lt;p style={{ fontSize: 13, color: '#5F5E5A', margin: 0, lineHeight: 1.6, marginBottom: 12 }}&gt;业主对 AI 答案点赞/纠错 → 沉淀「知识缺口」→ 物业人员人工审核 → 审核通过自动写入知识库，越用越准。&lt;/p&gt;&#13;&#10;        &lt;div style={{ marginTop: 'auto', height: 130, border: '2px dashed #BD9B56', borderRadius: 8, background: 'rgba(189,155,86,0.05)', display: 'flex', alignItems: 'center', justifyContent: 'center', color: '#BD9B56', fontSize: 12 }}&gt;此处放「知识缺口审核」截图&lt;/div&gt;&#13;&#10;      &lt;/div&gt;&#13;&#10;    &lt;/div&gt;&#13;&#10;  &lt;/div&gt;&#13;&#10;  &lt;div style={{ flexShrink: 0, height: 40, display: 'flex', alignItems: 'flex-end', justifyContent: 'space-between' }}&gt;&#13;&#10;    &lt;span style={{ color: '#BD9B56', fontSize: 12, letterSpacing: '0.1em' }}&gt;云溪花园 · 智慧社区&lt;/span&gt;&#13;&#10;    &lt;span style={{ color: '#a09b8c', fontSize: 12 }}&gt;14 / 19&lt;/span&gt;&#13;&#10;  &lt;/div&gt;&#13;&#10;&lt;/Slide&gt;"/>
         <p:cNvGrpSpPr/>
         <p:nvPr/>
       </p:nvGrpSpPr>
@@ -5741,7 +5849,7 @@
       </p:grpSpPr>
       <p:sp>
         <p:nvSpPr>
-          <p:cNvPr id="119" name=""/>
+          <p:cNvPr id="123" name=""/>
           <p:cNvSpPr/>
           <p:nvPr/>
         </p:nvSpPr>
@@ -5765,7 +5873,7 @@
       </p:sp>
       <p:sp>
         <p:nvSpPr>
-          <p:cNvPr id="120" name="" descr="{&quot;isTemplate&quot;:true,&quot;type&quot;:&quot;text&quot;}"/>
+          <p:cNvPr id="124" name="" descr="{&quot;isTemplate&quot;:true,&quot;type&quot;:&quot;text&quot;}"/>
           <p:cNvSpPr txBox="1"/>
           <p:nvPr/>
         </p:nvSpPr>
@@ -5810,7 +5918,7 @@
       </p:sp>
       <p:sp>
         <p:nvSpPr>
-          <p:cNvPr id="121" name="" descr="{&quot;isTemplate&quot;:true,&quot;type&quot;:&quot;text&quot;}"/>
+          <p:cNvPr id="125" name="" descr="{&quot;isTemplate&quot;:true,&quot;type&quot;:&quot;text&quot;}"/>
           <p:cNvSpPr txBox="1"/>
           <p:nvPr/>
         </p:nvSpPr>
@@ -5865,7 +5973,7 @@
       </p:sp>
       <p:sp>
         <p:nvSpPr>
-          <p:cNvPr id="122" name="" descr="{&quot;isTemplate&quot;:true,&quot;type&quot;:&quot;text&quot;}"/>
+          <p:cNvPr id="126" name="" descr="{&quot;isTemplate&quot;:true,&quot;type&quot;:&quot;text&quot;}"/>
           <p:cNvSpPr txBox="1"/>
           <p:nvPr/>
         </p:nvSpPr>
@@ -5920,7 +6028,7 @@
       </p:sp>
       <p:sp>
         <p:nvSpPr>
-          <p:cNvPr id="123" name=""/>
+          <p:cNvPr id="127" name=""/>
           <p:cNvSpPr/>
           <p:nvPr/>
         </p:nvSpPr>
@@ -5953,7 +6061,7 @@
       </p:sp>
       <p:sp>
         <p:nvSpPr>
-          <p:cNvPr id="124" name="" descr="{&quot;isTemplate&quot;:true,&quot;type&quot;:&quot;text&quot;}"/>
+          <p:cNvPr id="128" name="" descr="{&quot;isTemplate&quot;:true,&quot;type&quot;:&quot;text&quot;}"/>
           <p:cNvSpPr txBox="1"/>
           <p:nvPr/>
         </p:nvSpPr>
@@ -5998,7 +6106,7 @@
       </p:sp>
       <p:sp>
         <p:nvSpPr>
-          <p:cNvPr id="125" name=""/>
+          <p:cNvPr id="129" name=""/>
           <p:cNvSpPr/>
           <p:nvPr/>
         </p:nvSpPr>
@@ -6026,7 +6134,7 @@
       </p:sp>
       <p:sp>
         <p:nvSpPr>
-          <p:cNvPr id="126" name="" descr="{&quot;isTemplate&quot;:true,&quot;type&quot;:&quot;text&quot;}"/>
+          <p:cNvPr id="130" name="" descr="{&quot;isTemplate&quot;:true,&quot;type&quot;:&quot;text&quot;}"/>
           <p:cNvSpPr txBox="1"/>
           <p:nvPr/>
         </p:nvSpPr>
@@ -6096,7 +6204,7 @@
       </p:sp>
       <p:sp>
         <p:nvSpPr>
-          <p:cNvPr id="127" name="" descr="{&quot;isTemplate&quot;:true,&quot;type&quot;:&quot;text&quot;}"/>
+          <p:cNvPr id="131" name="" descr="{&quot;isTemplate&quot;:true,&quot;type&quot;:&quot;text&quot;}"/>
           <p:cNvSpPr txBox="1"/>
           <p:nvPr/>
         </p:nvSpPr>
@@ -6253,7 +6361,7 @@
       </p:sp>
       <p:sp>
         <p:nvSpPr>
-          <p:cNvPr id="128" name=""/>
+          <p:cNvPr id="132" name=""/>
           <p:cNvSpPr/>
           <p:nvPr/>
         </p:nvSpPr>
@@ -6286,7 +6394,7 @@
       </p:sp>
       <p:sp>
         <p:nvSpPr>
-          <p:cNvPr id="129" name="" descr="{&quot;isTemplate&quot;:true,&quot;type&quot;:&quot;text&quot;}"/>
+          <p:cNvPr id="133" name="" descr="{&quot;isTemplate&quot;:true,&quot;type&quot;:&quot;text&quot;}"/>
           <p:cNvSpPr txBox="1"/>
           <p:nvPr/>
         </p:nvSpPr>
@@ -6341,7 +6449,7 @@
       </p:sp>
       <p:sp>
         <p:nvSpPr>
-          <p:cNvPr id="130" name=""/>
+          <p:cNvPr id="134" name=""/>
           <p:cNvSpPr/>
           <p:nvPr/>
         </p:nvSpPr>
@@ -6374,7 +6482,7 @@
       </p:sp>
       <p:sp>
         <p:nvSpPr>
-          <p:cNvPr id="131" name="" descr="{&quot;isTemplate&quot;:true,&quot;type&quot;:&quot;text&quot;}"/>
+          <p:cNvPr id="135" name="" descr="{&quot;isTemplate&quot;:true,&quot;type&quot;:&quot;text&quot;}"/>
           <p:cNvSpPr txBox="1"/>
           <p:nvPr/>
         </p:nvSpPr>
@@ -6419,7 +6527,7 @@
       </p:sp>
       <p:sp>
         <p:nvSpPr>
-          <p:cNvPr id="132" name=""/>
+          <p:cNvPr id="136" name=""/>
           <p:cNvSpPr/>
           <p:nvPr/>
         </p:nvSpPr>
@@ -6447,7 +6555,7 @@
       </p:sp>
       <p:sp>
         <p:nvSpPr>
-          <p:cNvPr id="133" name="" descr="{&quot;isTemplate&quot;:true,&quot;type&quot;:&quot;text&quot;}"/>
+          <p:cNvPr id="137" name="" descr="{&quot;isTemplate&quot;:true,&quot;type&quot;:&quot;text&quot;}"/>
           <p:cNvSpPr txBox="1"/>
           <p:nvPr/>
         </p:nvSpPr>
@@ -6517,7 +6625,7 @@
       </p:sp>
       <p:sp>
         <p:nvSpPr>
-          <p:cNvPr id="134" name="" descr="{&quot;isTemplate&quot;:true,&quot;type&quot;:&quot;text&quot;}"/>
+          <p:cNvPr id="138" name="" descr="{&quot;isTemplate&quot;:true,&quot;type&quot;:&quot;text&quot;}"/>
           <p:cNvSpPr txBox="1"/>
           <p:nvPr/>
         </p:nvSpPr>
@@ -6594,7 +6702,7 @@
       </p:sp>
       <p:sp>
         <p:nvSpPr>
-          <p:cNvPr id="135" name=""/>
+          <p:cNvPr id="139" name=""/>
           <p:cNvSpPr/>
           <p:nvPr/>
         </p:nvSpPr>
@@ -6627,7 +6735,7 @@
       </p:sp>
       <p:sp>
         <p:nvSpPr>
-          <p:cNvPr id="136" name="" descr="{&quot;isTemplate&quot;:true,&quot;type&quot;:&quot;text&quot;}"/>
+          <p:cNvPr id="140" name="" descr="{&quot;isTemplate&quot;:true,&quot;type&quot;:&quot;text&quot;}"/>
           <p:cNvSpPr txBox="1"/>
           <p:nvPr/>
         </p:nvSpPr>
@@ -6662,7 +6770,7 @@
       </p:sp>
       <p:sp>
         <p:nvSpPr>
-          <p:cNvPr id="137" name=""/>
+          <p:cNvPr id="141" name=""/>
           <p:cNvSpPr/>
           <p:nvPr/>
         </p:nvSpPr>
@@ -6695,7 +6803,7 @@
       </p:sp>
       <p:sp>
         <p:nvSpPr>
-          <p:cNvPr id="138" name="" descr="{&quot;isTemplate&quot;:true,&quot;type&quot;:&quot;text&quot;}"/>
+          <p:cNvPr id="142" name="" descr="{&quot;isTemplate&quot;:true,&quot;type&quot;:&quot;text&quot;}"/>
           <p:cNvSpPr txBox="1"/>
           <p:nvPr/>
         </p:nvSpPr>
@@ -6740,7 +6848,7 @@
       </p:sp>
       <p:sp>
         <p:nvSpPr>
-          <p:cNvPr id="139" name=""/>
+          <p:cNvPr id="143" name=""/>
           <p:cNvSpPr/>
           <p:nvPr/>
         </p:nvSpPr>
@@ -6768,7 +6876,7 @@
       </p:sp>
       <p:sp>
         <p:nvSpPr>
-          <p:cNvPr id="140" name="" descr="{&quot;isTemplate&quot;:true,&quot;type&quot;:&quot;text&quot;}"/>
+          <p:cNvPr id="144" name="" descr="{&quot;isTemplate&quot;:true,&quot;type&quot;:&quot;text&quot;}"/>
           <p:cNvSpPr txBox="1"/>
           <p:nvPr/>
         </p:nvSpPr>
@@ -6838,7 +6946,7 @@
       </p:sp>
       <p:sp>
         <p:nvSpPr>
-          <p:cNvPr id="141" name="" descr="{&quot;isTemplate&quot;:true,&quot;type&quot;:&quot;text&quot;}"/>
+          <p:cNvPr id="145" name="" descr="{&quot;isTemplate&quot;:true,&quot;type&quot;:&quot;text&quot;}"/>
           <p:cNvSpPr txBox="1"/>
           <p:nvPr/>
         </p:nvSpPr>
@@ -6975,7 +7083,7 @@
       </p:sp>
       <p:sp>
         <p:nvSpPr>
-          <p:cNvPr id="142" name=""/>
+          <p:cNvPr id="146" name=""/>
           <p:cNvSpPr/>
           <p:nvPr/>
         </p:nvSpPr>
@@ -7008,7 +7116,7 @@
       </p:sp>
       <p:sp>
         <p:nvSpPr>
-          <p:cNvPr id="143" name="" descr="{&quot;isTemplate&quot;:true,&quot;type&quot;:&quot;text&quot;}"/>
+          <p:cNvPr id="147" name="" descr="{&quot;isTemplate&quot;:true,&quot;type&quot;:&quot;text&quot;}"/>
           <p:cNvSpPr txBox="1"/>
           <p:nvPr/>
         </p:nvSpPr>
@@ -7043,7 +7151,7 @@
       </p:sp>
       <p:sp>
         <p:nvSpPr>
-          <p:cNvPr id="144" name="" descr="{&quot;isTemplate&quot;:true,&quot;type&quot;:&quot;text&quot;}"/>
+          <p:cNvPr id="148" name="" descr="{&quot;isTemplate&quot;:true,&quot;type&quot;:&quot;text&quot;}"/>
           <p:cNvSpPr txBox="1"/>
           <p:nvPr/>
         </p:nvSpPr>
@@ -7098,7 +7206,7 @@
       </p:sp>
       <p:sp>
         <p:nvSpPr>
-          <p:cNvPr id="145" name="" descr="{&quot;isTemplate&quot;:true,&quot;type&quot;:&quot;text&quot;}"/>
+          <p:cNvPr id="149" name="" descr="{&quot;isTemplate&quot;:true,&quot;type&quot;:&quot;text&quot;}"/>
           <p:cNvSpPr txBox="1"/>
           <p:nvPr/>
         </p:nvSpPr>
@@ -7141,7 +7249,7 @@
   <p:cSld>
     <p:spTree>
       <p:nvGrpSpPr>
-        <p:cNvPr id="146" name="" descr="&lt;Slide style={{ width: '1280px', height: '720px', background: '#FBFCFA', position: 'relative', padding: '30px 56px', boxSizing: 'border-box', display: 'flex', flexDirection: 'column' }}&gt;&#13;&#10;  &lt;div style={{ flexShrink: 0 }}&gt;&#13;&#10;    &lt;div style={{ color: '#BD9B56', fontSize: 12, letterSpacing: '0.25em', marginBottom: 5 }}&gt;03 · 成果与验证&lt;/div&gt;&#13;&#10;    &lt;h2 style={{ fontSize: 27, fontWeight: 'bold', color: '#172133', margin: 0, lineHeight: 1.25 }}&gt;量化评估：方法 · 流程 · 指标判定&lt;/h2&gt;&#13;&#10;  &lt;/div&gt;&#13;&#10;  &lt;div style={{ flex: 1, display: 'flex', alignItems: 'stretch', gap: 18, marginTop: 12 }}&gt;&#13;&#10;    {/* 左栏：方法 + 流程 */}&#13;&#10;    &lt;div style={{ flex: 1, display: 'flex', flexDirection: 'column', gap: 10 }}&gt;&#13;&#10;      {/* 评估方法（前情） */}&#13;&#10;      &lt;div style={{ background: '#fff', borderRadius: 10, padding: '14px 18px', boxShadow: '0 4px 16px rgba(23,33,51,0.06)' }}&gt;&#13;&#10;        &lt;div style={{ fontSize: 13, color: '#BD9B56', fontWeight: 'bold', letterSpacing: '0.1em', marginBottom: 8 }}&gt;为什么要额外评估 AI&lt;/div&gt;&#13;&#10;        &lt;div style={{ fontSize: 12, color: '#5F5E5A', lineHeight: 1.65, marginBottom: 8 }}&gt;传统软件只验证「输入 → 输出」；AI Agent 还必须验证中间链路，否则「答得对」不等于「办得成」：&lt;/div&gt;&#13;&#10;        &lt;div style={{ display: 'flex', alignItems: 'center', gap: 6, flexWrap: 'wrap', fontSize: 11.5 }}&gt;&#13;&#10;          &lt;span style={{ color: '#172133', fontWeight: 'bold' }}&gt;输入&lt;/span&gt;&lt;span style={{ color: '#a09b8c' }}&gt;→&lt;/span&gt;&#13;&#10;          &lt;span style={{ color: '#172133', fontWeight: 'bold' }}&gt;理解&lt;/span&gt;&lt;span style={{ color: '#a09b8c' }}&gt;→&lt;/span&gt;&#13;&#10;          &lt;span style={{ color: '#172133', fontWeight: 'bold' }}&gt;决策&lt;/span&gt;&lt;span style={{ color: '#a09b8c' }}&gt;→&lt;/span&gt;&#13;&#10;          &lt;span style={{ color: '#172133', fontWeight: 'bold' }}&gt;工具选择&lt;/span&gt;&lt;span style={{ color: '#a09b8c' }}&gt;→&lt;/span&gt;&#13;&#10;          &lt;span style={{ color: '#172133', fontWeight: 'bold' }}&gt;知识检索&lt;/span&gt;&lt;span style={{ color: '#a09b8c' }}&gt;→&lt;/span&gt;&#13;&#10;          &lt;span style={{ color: '#172133', fontWeight: 'bold' }}&gt;最终答案&lt;/span&gt;&#13;&#10;        &lt;/div&gt;&#13;&#10;        &lt;div style={{ fontSize: 12, color: '#6b7075', lineHeight: 1.6, marginTop: 8, paddingTop: 8, borderTop: '1px solid rgba(34,57,94,0.08)' }}&gt;对应建立三层评估：&lt;span style={{ color: '#172133', fontWeight: 'bold' }}&gt;Agent 评估&lt;/span&gt;（意图 / 工具 / 工作流）＋ &lt;span style={{ color: '#172133', fontWeight: 'bold' }}&gt;RAG 评估&lt;/span&gt;（检索 / 答案）＋ &lt;span style={{ color: '#172133', fontWeight: 'bold' }}&gt;端到端评估&lt;/span&gt;（完整业务闭环）。&lt;/div&gt;&#13;&#10;      &lt;/div&gt;&#13;&#10;      {/* 测试流程 */}&#13;&#10;      &lt;div style={{ background: '#fff', borderRadius: 10, padding: '14px 18px', boxShadow: '0 4px 16px rgba(23,33,51,0.06)' }}&gt;&#13;&#10;        &lt;div style={{ fontSize: 13, color: '#BD9B56', fontWeight: 'bold', letterSpacing: '0.1em', marginBottom: 8 }}&gt;测试怎么进行&lt;/div&gt;&#13;&#10;        &lt;div style={{ display: 'flex', gap: 8 }}&gt;&#13;&#10;          {[&#13;&#10;            ['① 构建数据集', '意图 / 工具 / 工作流 / 知识问答 4 类用例'],&#13;&#10;            ['② 运行 Agent', 'python 跑评估，收集 trace'],&#13;&#10;            ['③ 比对期望', '预测值 vs 标注期望值'],&#13;&#10;            ['④ 生成报告', '指标 + 失败用例定位'],&#13;&#10;          ].map(([t, d]) =&gt; (&#13;&#10;            &lt;div key={t} style={{ flex: 1, background: 'rgba(189,155,86,0.07)', borderRadius: 8, padding: '8px 10px' }}&gt;&#13;&#10;              &lt;div style={{ fontSize: 11.5, color: '#172133', fontWeight: 'bold', marginBottom: 3 }}&gt;{t}&lt;/div&gt;&#13;&#10;              &lt;div style={{ fontSize: 10.5, color: '#6b7075', lineHeight: 1.4 }}&gt;{d}&lt;/div&gt;&#13;&#10;            &lt;/div&gt;&#13;&#10;          ))}&#13;&#10;        &lt;/div&gt;&#13;&#10;      &lt;/div&gt;&#13;&#10;    &lt;/div&gt;&#13;&#10;    {/* 右栏：指标判定 + 结果 */}&#13;&#10;    &lt;div style={{ flex: '0 0 440px', display: 'flex', flexDirection: 'column', gap: 8 }}&gt;&#13;&#10;      {[&#13;&#10;        ['意图识别', '100%', '预测意图 = 期望意图，正确数 / 总用例', '83.33% → 100%'],&#13;&#10;        ['RAG 召回 Recall@5', '100%', 'top-5 检索结果是否包含正确文档', '检索质量稳定达标'],&#13;&#10;        ['RAG 答案准确率', '100%', '期望关键词全部覆盖（关键词覆盖度）', '50% → 100%'],&#13;&#10;      ].map(([name, val, judge, note]) =&gt; (&#13;&#10;        &lt;div key={name} style={{ background: '#fff', borderRadius: 10, padding: '10px 16px', boxShadow: '0 4px 16px rgba(23,33,51,0.06)', display: 'flex', alignItems: 'center', gap: 14 }}&gt;&#13;&#10;          &lt;div style={{ flex: 1 }}&gt;&#13;&#10;            &lt;div style={{ fontSize: 13.5, color: '#172133', fontWeight: 'bold' }}&gt;{name}&lt;/div&gt;&#13;&#10;            &lt;div style={{ fontSize: 11, color: '#6b7075', marginTop: 3, lineHeight: 1.5 }}&gt;判定：{judge}&lt;/div&gt;&#13;&#10;            &lt;div style={{ fontSize: 10.5, color: '#a09b8c', marginTop: 2 }}&gt;{note}&lt;/div&gt;&#13;&#10;          &lt;/div&gt;&#13;&#10;          &lt;div style={{ fontSize: 30, fontWeight: 'bold', color: '#BD9B56', fontFamily: 'Inter, sans-serif', minWidth: 78, textAlign: 'right' }}&gt;{val}&lt;/div&gt;&#13;&#10;        &lt;/div&gt;&#13;&#10;      ))}&#13;&#10;      &lt;div style={{ background: 'linear-gradient(135deg, #172133 0%, #22395E 100%)', borderRadius: 10, padding: '10px 16px', display: 'flex', alignItems: 'center', gap: 14 }}&gt;&#13;&#10;        &lt;div style={{ flex: 1 }}&gt;&#13;&#10;          &lt;div style={{ fontSize: 13.5, color: '#FBFCFA', fontWeight: 'bold' }}&gt;单元测试 · CI 全绿&lt;/div&gt;&#13;&#10;          &lt;div style={{ fontSize: 11, color: 'rgba(251,252,250,0.75)', marginTop: 3, lineHeight: 1.5 }}&gt;判定：pytest 单测 + GitHub Actions 每次 push 自动跑&lt;/div&gt;&#13;&#10;        &lt;/div&gt;&#13;&#10;        &lt;div style={{ fontSize: 28, fontWeight: 'bold', color: '#BD9B56', fontFamily: 'Inter, sans-serif', minWidth: 78, textAlign: 'right' }}&gt;113+30&lt;/div&gt;&#13;&#10;      &lt;/div&gt;&#13;&#10;    &lt;/div&gt;&#13;&#10;  &lt;/div&gt;&#13;&#10;  &lt;div style={{ flexShrink: 0, background: 'rgba(189,155,86,0.10)', borderLeft: '4px solid #BD9B56', borderRadius: '0 8px 8px 0', padding: '10px 18px', marginTop: 10 }}&gt;&#13;&#10;    &lt;p style={{ fontSize: 12.5, color: '#172133', margin: 0, lineHeight: 1.55 }}&gt;&lt;span style={{ color: '#BD9B56', fontWeight: 'bold' }}&gt;评估驱动优化：&lt;/span&gt;RAG 答案 50% → 100% 源于发现「评估指标用脆弱子串匹配」并改为「关键词覆盖度」、同时优化答案生成 prompt。工具选择 / 参数提取 / 工作流三项受「报修多轮交互」设计影响（用例按单轮设计、实际走 pending_repair 多轮），已定位为评估框架升级项，而非 Agent 缺陷。&lt;/p&gt;&#13;&#10;  &lt;/div&gt;&#13;&#10;  &lt;div style={{ flexShrink: 0, height: 32, display: 'flex', alignItems: 'flex-end', justifyContent: 'space-between' }}&gt;&#13;&#10;    &lt;span style={{ color: '#BD9B56', fontSize: 12, letterSpacing: '0.1em' }}&gt;云溪花园 · 智慧社区&lt;/span&gt;&#13;&#10;    &lt;span style={{ color: '#a09b8c', fontSize: 12 }}&gt;15 / 19&lt;/span&gt;&#13;&#10;  &lt;/div&gt;&#13;&#10;&lt;/Slide&gt;"/>
+        <p:cNvPr id="150" name="" descr="&lt;Slide style={{ width: '1280px', height: '720px', background: '#FBFCFA', position: 'relative', padding: '30px 56px', boxSizing: 'border-box', display: 'flex', flexDirection: 'column' }}&gt;&#13;&#10;  &lt;div style={{ flexShrink: 0 }}&gt;&#13;&#10;    &lt;div style={{ color: '#BD9B56', fontSize: 12, letterSpacing: '0.25em', marginBottom: 5 }}&gt;03 · 成果与验证&lt;/div&gt;&#13;&#10;    &lt;h2 style={{ fontSize: 27, fontWeight: 'bold', color: '#172133', margin: 0, lineHeight: 1.25 }}&gt;量化评估：方法 · 流程 · 指标判定&lt;/h2&gt;&#13;&#10;  &lt;/div&gt;&#13;&#10;  &lt;div style={{ flex: 1, display: 'flex', alignItems: 'stretch', gap: 18, marginTop: 12 }}&gt;&#13;&#10;    {/* 左栏：方法 + 流程 */}&#13;&#10;    &lt;div style={{ flex: 1, display: 'flex', flexDirection: 'column', gap: 10 }}&gt;&#13;&#10;      {/* 评估方法（前情） */}&#13;&#10;      &lt;div style={{ background: '#fff', borderRadius: 10, padding: '14px 18px', boxShadow: '0 4px 16px rgba(23,33,51,0.06)' }}&gt;&#13;&#10;        &lt;div style={{ fontSize: 13, color: '#BD9B56', fontWeight: 'bold', letterSpacing: '0.1em', marginBottom: 8 }}&gt;为什么要额外评估 AI&lt;/div&gt;&#13;&#10;        &lt;div style={{ fontSize: 12, color: '#5F5E5A', lineHeight: 1.65, marginBottom: 8 }}&gt;传统软件只验证「输入 → 输出」；AI Agent 还必须验证中间链路，否则「答得对」不等于「办得成」：&lt;/div&gt;&#13;&#10;        &lt;div style={{ display: 'flex', alignItems: 'center', gap: 6, flexWrap: 'wrap', fontSize: 11.5 }}&gt;&#13;&#10;          &lt;span style={{ color: '#172133', fontWeight: 'bold' }}&gt;输入&lt;/span&gt;&lt;span style={{ color: '#a09b8c' }}&gt;→&lt;/span&gt;&#13;&#10;          &lt;span style={{ color: '#172133', fontWeight: 'bold' }}&gt;理解&lt;/span&gt;&lt;span style={{ color: '#a09b8c' }}&gt;→&lt;/span&gt;&#13;&#10;          &lt;span style={{ color: '#172133', fontWeight: 'bold' }}&gt;决策&lt;/span&gt;&lt;span style={{ color: '#a09b8c' }}&gt;→&lt;/span&gt;&#13;&#10;          &lt;span style={{ color: '#172133', fontWeight: 'bold' }}&gt;工具选择&lt;/span&gt;&lt;span style={{ color: '#a09b8c' }}&gt;→&lt;/span&gt;&#13;&#10;          &lt;span style={{ color: '#172133', fontWeight: 'bold' }}&gt;知识检索&lt;/span&gt;&lt;span style={{ color: '#a09b8c' }}&gt;→&lt;/span&gt;&#13;&#10;          &lt;span style={{ color: '#172133', fontWeight: 'bold' }}&gt;最终答案&lt;/span&gt;&#13;&#10;        &lt;/div&gt;&#13;&#10;        &lt;div style={{ fontSize: 12, color: '#6b7075', lineHeight: 1.6, marginTop: 8, paddingTop: 8, borderTop: '1px solid rgba(34,57,94,0.08)' }}&gt;对应建立三层评估：&lt;span style={{ color: '#172133', fontWeight: 'bold' }}&gt;Agent 评估&lt;/span&gt;（意图 / 工具 / 工作流）＋ &lt;span style={{ color: '#172133', fontWeight: 'bold' }}&gt;RAG 评估&lt;/span&gt;（检索 / 答案）＋ &lt;span style={{ color: '#172133', fontWeight: 'bold' }}&gt;端到端评估&lt;/span&gt;（完整业务闭环）。&lt;/div&gt;&#13;&#10;      &lt;/div&gt;&#13;&#10;      {/* 测试流程 */}&#13;&#10;      &lt;div style={{ background: '#fff', borderRadius: 10, padding: '14px 18px', boxShadow: '0 4px 16px rgba(23,33,51,0.06)' }}&gt;&#13;&#10;        &lt;div style={{ fontSize: 13, color: '#BD9B56', fontWeight: 'bold', letterSpacing: '0.1em', marginBottom: 8 }}&gt;测试怎么进行&lt;/div&gt;&#13;&#10;        &lt;div style={{ display: 'flex', gap: 8 }}&gt;&#13;&#10;          {[&#13;&#10;            ['① 构建数据集', '意图 / 工具 / 工作流 / 知识问答 4 类用例'],&#13;&#10;            ['② 运行 Agent', 'python 跑评估，收集 trace'],&#13;&#10;            ['③ 比对期望', '预测值 vs 标注期望值'],&#13;&#10;            ['④ 生成报告', '指标 + 失败用例定位'],&#13;&#10;          ].map(([t, d]) =&gt; (&#13;&#10;            &lt;div key={t} style={{ flex: 1, background: 'rgba(189,155,86,0.07)', borderRadius: 8, padding: '8px 10px' }}&gt;&#13;&#10;              &lt;div style={{ fontSize: 11.5, color: '#172133', fontWeight: 'bold', marginBottom: 3 }}&gt;{t}&lt;/div&gt;&#13;&#10;              &lt;div style={{ fontSize: 10.5, color: '#6b7075', lineHeight: 1.4 }}&gt;{d}&lt;/div&gt;&#13;&#10;            &lt;/div&gt;&#13;&#10;          ))}&#13;&#10;        &lt;/div&gt;&#13;&#10;      &lt;/div&gt;&#13;&#10;    &lt;/div&gt;&#13;&#10;    {/* 右栏：指标判定 + 结果 */}&#13;&#10;    &lt;div style={{ flex: '0 0 440px', display: 'flex', flexDirection: 'column', gap: 8 }}&gt;&#13;&#10;      {[&#13;&#10;        ['意图识别', '100%', '预测意图 = 期望意图，正确数 / 总用例', '83.33% → 100%'],&#13;&#10;        ['RAG 召回 Recall@5', '100%', 'top-5 检索结果是否包含正确文档', '检索质量稳定达标'],&#13;&#10;        ['RAG 答案准确率', '100%', '期望关键词全部覆盖（关键词覆盖度）', '50% → 100%'],&#13;&#10;      ].map(([name, val, judge, note]) =&gt; (&#13;&#10;        &lt;div key={name} style={{ background: '#fff', borderRadius: 10, padding: '10px 16px', boxShadow: '0 4px 16px rgba(23,33,51,0.06)', display: 'flex', alignItems: 'center', gap: 14 }}&gt;&#13;&#10;          &lt;div style={{ flex: 1 }}&gt;&#13;&#10;            &lt;div style={{ fontSize: 13.5, color: '#172133', fontWeight: 'bold' }}&gt;{name}&lt;/div&gt;&#13;&#10;            &lt;div style={{ fontSize: 11, color: '#6b7075', marginTop: 3, lineHeight: 1.5 }}&gt;判定：{judge}&lt;/div&gt;&#13;&#10;            &lt;div style={{ fontSize: 10.5, color: '#a09b8c', marginTop: 2 }}&gt;{note}&lt;/div&gt;&#13;&#10;          &lt;/div&gt;&#13;&#10;          &lt;div style={{ fontSize: 30, fontWeight: 'bold', color: '#BD9B56', fontFamily: 'Inter, sans-serif', minWidth: 78, textAlign: 'right' }}&gt;{val}&lt;/div&gt;&#13;&#10;        &lt;/div&gt;&#13;&#10;      ))}&#13;&#10;      &lt;div style={{ background: 'linear-gradient(135deg, #172133 0%, #22395E 100%)', borderRadius: 10, padding: '10px 16px', display: 'flex', alignItems: 'center', gap: 14 }}&gt;&#13;&#10;        &lt;div style={{ flex: 1 }}&gt;&#13;&#10;          &lt;div style={{ fontSize: 13.5, color: '#FBFCFA', fontWeight: 'bold' }}&gt;单元测试 · CI 全绿&lt;/div&gt;&#13;&#10;          &lt;div style={{ fontSize: 11, color: 'rgba(251,252,250,0.75)', marginTop: 3, lineHeight: 1.5 }}&gt;判定：pytest 单测 + GitHub Actions 每次 push 自动跑&lt;/div&gt;&#13;&#10;        &lt;/div&gt;&#13;&#10;        &lt;div style={{ fontSize: 28, fontWeight: 'bold', color: '#BD9B56', fontFamily: 'Inter, sans-serif', minWidth: 78, textAlign: 'right' }}&gt;113+30&lt;/div&gt;&#13;&#10;      &lt;/div&gt;&#13;&#10;    &lt;/div&gt;&#13;&#10;  &lt;/div&gt;&#13;&#10;  &lt;div style={{ flexShrink: 0, background: 'rgba(189,155,86,0.10)', borderLeft: '4px solid #BD9B56', borderRadius: '0 8px 8px 0', padding: '10px 18px', marginTop: 10 }}&gt;&#13;&#10;    &lt;p style={{ fontSize: 12.5, color: '#172133', margin: 0, lineHeight: 1.55 }}&gt;&lt;span style={{ color: '#BD9B56', fontWeight: 'bold' }}&gt;评估驱动优化：&lt;/span&gt;RAG 答案 50% → 100% 源于发现「评估指标用脆弱子串匹配」并改为「关键词覆盖度」、同时优化答案生成 prompt。工具选择 / 参数提取 / 工作流三项受「报修多轮交互」设计影响（用例按单轮设计、实际走 pending_repair 多轮），已定位为评估框架升级项，而非 Agent 缺陷。&lt;/p&gt;&#13;&#10;  &lt;/div&gt;&#13;&#10;  &lt;div style={{ flexShrink: 0, height: 32, display: 'flex', alignItems: 'flex-end', justifyContent: 'space-between' }}&gt;&#13;&#10;    &lt;span style={{ color: '#BD9B56', fontSize: 12, letterSpacing: '0.1em' }}&gt;云溪花园 · 智慧社区&lt;/span&gt;&#13;&#10;    &lt;span style={{ color: '#a09b8c', fontSize: 12 }}&gt;15 / 19&lt;/span&gt;&#13;&#10;  &lt;/div&gt;&#13;&#10;&lt;/Slide&gt;"/>
         <p:cNvGrpSpPr/>
         <p:nvPr/>
       </p:nvGrpSpPr>
@@ -7155,7 +7263,7 @@
       </p:grpSpPr>
       <p:sp>
         <p:nvSpPr>
-          <p:cNvPr id="147" name=""/>
+          <p:cNvPr id="151" name=""/>
           <p:cNvSpPr/>
           <p:nvPr/>
         </p:nvSpPr>
@@ -7179,7 +7287,7 @@
       </p:sp>
       <p:sp>
         <p:nvSpPr>
-          <p:cNvPr id="148" name="" descr="{&quot;isTemplate&quot;:true,&quot;type&quot;:&quot;text&quot;}"/>
+          <p:cNvPr id="152" name="" descr="{&quot;isTemplate&quot;:true,&quot;type&quot;:&quot;text&quot;}"/>
           <p:cNvSpPr txBox="1"/>
           <p:nvPr/>
         </p:nvSpPr>
@@ -7224,7 +7332,7 @@
       </p:sp>
       <p:sp>
         <p:nvSpPr>
-          <p:cNvPr id="149" name="" descr="{&quot;isTemplate&quot;:true,&quot;type&quot;:&quot;text&quot;}"/>
+          <p:cNvPr id="153" name="" descr="{&quot;isTemplate&quot;:true,&quot;type&quot;:&quot;text&quot;}"/>
           <p:cNvSpPr txBox="1"/>
           <p:nvPr/>
         </p:nvSpPr>
@@ -7299,7 +7407,7 @@
       </p:sp>
       <p:sp>
         <p:nvSpPr>
-          <p:cNvPr id="150" name=""/>
+          <p:cNvPr id="154" name=""/>
           <p:cNvSpPr/>
           <p:nvPr/>
         </p:nvSpPr>
@@ -7332,7 +7440,7 @@
       </p:sp>
       <p:sp>
         <p:nvSpPr>
-          <p:cNvPr id="151" name="" descr="{&quot;isTemplate&quot;:true,&quot;type&quot;:&quot;text&quot;}"/>
+          <p:cNvPr id="155" name="" descr="{&quot;isTemplate&quot;:true,&quot;type&quot;:&quot;text&quot;}"/>
           <p:cNvSpPr txBox="1"/>
           <p:nvPr/>
         </p:nvSpPr>
@@ -7377,7 +7485,7 @@
       </p:sp>
       <p:sp>
         <p:nvSpPr>
-          <p:cNvPr id="152" name="" descr="{&quot;isTemplate&quot;:true,&quot;type&quot;:&quot;text&quot;}"/>
+          <p:cNvPr id="156" name="" descr="{&quot;isTemplate&quot;:true,&quot;type&quot;:&quot;text&quot;}"/>
           <p:cNvSpPr txBox="1"/>
           <p:nvPr/>
         </p:nvSpPr>
@@ -7452,7 +7560,7 @@
       </p:sp>
       <p:sp>
         <p:nvSpPr>
-          <p:cNvPr id="153" name="" descr="{&quot;isTemplate&quot;:true,&quot;type&quot;:&quot;text&quot;}"/>
+          <p:cNvPr id="157" name="" descr="{&quot;isTemplate&quot;:true,&quot;type&quot;:&quot;text&quot;}"/>
           <p:cNvSpPr txBox="1"/>
           <p:nvPr/>
         </p:nvSpPr>
@@ -7487,7 +7595,7 @@
       </p:sp>
       <p:sp>
         <p:nvSpPr>
-          <p:cNvPr id="154" name="" descr="{&quot;isTemplate&quot;:true,&quot;type&quot;:&quot;text&quot;}"/>
+          <p:cNvPr id="158" name="" descr="{&quot;isTemplate&quot;:true,&quot;type&quot;:&quot;text&quot;}"/>
           <p:cNvSpPr txBox="1"/>
           <p:nvPr/>
         </p:nvSpPr>
@@ -7522,7 +7630,7 @@
       </p:sp>
       <p:sp>
         <p:nvSpPr>
-          <p:cNvPr id="155" name="" descr="{&quot;isTemplate&quot;:true,&quot;type&quot;:&quot;text&quot;}"/>
+          <p:cNvPr id="159" name="" descr="{&quot;isTemplate&quot;:true,&quot;type&quot;:&quot;text&quot;}"/>
           <p:cNvSpPr txBox="1"/>
           <p:nvPr/>
         </p:nvSpPr>
@@ -7557,7 +7665,7 @@
       </p:sp>
       <p:sp>
         <p:nvSpPr>
-          <p:cNvPr id="156" name="" descr="{&quot;isTemplate&quot;:true,&quot;type&quot;:&quot;text&quot;}"/>
+          <p:cNvPr id="160" name="" descr="{&quot;isTemplate&quot;:true,&quot;type&quot;:&quot;text&quot;}"/>
           <p:cNvSpPr txBox="1"/>
           <p:nvPr/>
         </p:nvSpPr>
@@ -7592,7 +7700,7 @@
       </p:sp>
       <p:sp>
         <p:nvSpPr>
-          <p:cNvPr id="157" name="" descr="{&quot;isTemplate&quot;:true,&quot;type&quot;:&quot;text&quot;}"/>
+          <p:cNvPr id="161" name="" descr="{&quot;isTemplate&quot;:true,&quot;type&quot;:&quot;text&quot;}"/>
           <p:cNvSpPr txBox="1"/>
           <p:nvPr/>
         </p:nvSpPr>
@@ -7627,7 +7735,7 @@
       </p:sp>
       <p:sp>
         <p:nvSpPr>
-          <p:cNvPr id="158" name="" descr="{&quot;isTemplate&quot;:true,&quot;type&quot;:&quot;text&quot;}"/>
+          <p:cNvPr id="162" name="" descr="{&quot;isTemplate&quot;:true,&quot;type&quot;:&quot;text&quot;}"/>
           <p:cNvSpPr txBox="1"/>
           <p:nvPr/>
         </p:nvSpPr>
@@ -7662,7 +7770,7 @@
       </p:sp>
       <p:sp>
         <p:nvSpPr>
-          <p:cNvPr id="159" name="" descr="{&quot;isTemplate&quot;:true,&quot;type&quot;:&quot;text&quot;}"/>
+          <p:cNvPr id="163" name="" descr="{&quot;isTemplate&quot;:true,&quot;type&quot;:&quot;text&quot;}"/>
           <p:cNvSpPr txBox="1"/>
           <p:nvPr/>
         </p:nvSpPr>
@@ -7697,7 +7805,7 @@
       </p:sp>
       <p:sp>
         <p:nvSpPr>
-          <p:cNvPr id="160" name="" descr="{&quot;isTemplate&quot;:true,&quot;type&quot;:&quot;text&quot;}"/>
+          <p:cNvPr id="164" name="" descr="{&quot;isTemplate&quot;:true,&quot;type&quot;:&quot;text&quot;}"/>
           <p:cNvSpPr txBox="1"/>
           <p:nvPr/>
         </p:nvSpPr>
@@ -7732,7 +7840,7 @@
       </p:sp>
       <p:sp>
         <p:nvSpPr>
-          <p:cNvPr id="161" name="" descr="{&quot;isTemplate&quot;:true,&quot;type&quot;:&quot;text&quot;}"/>
+          <p:cNvPr id="165" name="" descr="{&quot;isTemplate&quot;:true,&quot;type&quot;:&quot;text&quot;}"/>
           <p:cNvSpPr txBox="1"/>
           <p:nvPr/>
         </p:nvSpPr>
@@ -7767,7 +7875,7 @@
       </p:sp>
       <p:sp>
         <p:nvSpPr>
-          <p:cNvPr id="162" name="" descr="{&quot;isTemplate&quot;:true,&quot;type&quot;:&quot;text&quot;}"/>
+          <p:cNvPr id="166" name="" descr="{&quot;isTemplate&quot;:true,&quot;type&quot;:&quot;text&quot;}"/>
           <p:cNvSpPr txBox="1"/>
           <p:nvPr/>
         </p:nvSpPr>
@@ -7802,7 +7910,7 @@
       </p:sp>
       <p:sp>
         <p:nvSpPr>
-          <p:cNvPr id="163" name="" descr="{&quot;isTemplate&quot;:true,&quot;type&quot;:&quot;text&quot;}"/>
+          <p:cNvPr id="167" name="" descr="{&quot;isTemplate&quot;:true,&quot;type&quot;:&quot;text&quot;}"/>
           <p:cNvSpPr txBox="1"/>
           <p:nvPr/>
         </p:nvSpPr>
@@ -7837,7 +7945,7 @@
       </p:sp>
       <p:sp>
         <p:nvSpPr>
-          <p:cNvPr id="164" name=""/>
+          <p:cNvPr id="168" name=""/>
           <p:cNvSpPr/>
           <p:nvPr/>
         </p:nvSpPr>
@@ -7879,7 +7987,7 @@
       </p:sp>
       <p:sp>
         <p:nvSpPr>
-          <p:cNvPr id="165" name="" descr="{&quot;isTemplate&quot;:true,&quot;type&quot;:&quot;text&quot;}"/>
+          <p:cNvPr id="169" name="" descr="{&quot;isTemplate&quot;:true,&quot;type&quot;:&quot;text&quot;}"/>
           <p:cNvSpPr txBox="1"/>
           <p:nvPr/>
         </p:nvSpPr>
@@ -7924,7 +8032,7 @@
       </p:sp>
       <p:sp>
         <p:nvSpPr>
-          <p:cNvPr id="166" name="" descr="{&quot;isTemplate&quot;:true,&quot;type&quot;:&quot;text&quot;}"/>
+          <p:cNvPr id="170" name="" descr="{&quot;isTemplate&quot;:true,&quot;type&quot;:&quot;text&quot;}"/>
           <p:cNvSpPr txBox="1"/>
           <p:nvPr/>
         </p:nvSpPr>
@@ -7969,7 +8077,7 @@
       </p:sp>
       <p:sp>
         <p:nvSpPr>
-          <p:cNvPr id="167" name="" descr="{&quot;isTemplate&quot;:true,&quot;type&quot;:&quot;text&quot;}"/>
+          <p:cNvPr id="171" name="" descr="{&quot;isTemplate&quot;:true,&quot;type&quot;:&quot;text&quot;}"/>
           <p:cNvSpPr txBox="1"/>
           <p:nvPr/>
         </p:nvSpPr>
@@ -8004,7 +8112,7 @@
       </p:sp>
       <p:sp>
         <p:nvSpPr>
-          <p:cNvPr id="168" name=""/>
+          <p:cNvPr id="172" name=""/>
           <p:cNvSpPr/>
           <p:nvPr/>
         </p:nvSpPr>
@@ -8037,7 +8145,7 @@
       </p:sp>
       <p:sp>
         <p:nvSpPr>
-          <p:cNvPr id="169" name="" descr="{&quot;isTemplate&quot;:true,&quot;type&quot;:&quot;text&quot;}"/>
+          <p:cNvPr id="173" name="" descr="{&quot;isTemplate&quot;:true,&quot;type&quot;:&quot;text&quot;}"/>
           <p:cNvSpPr txBox="1"/>
           <p:nvPr/>
         </p:nvSpPr>
@@ -8072,7 +8180,7 @@
       </p:sp>
       <p:sp>
         <p:nvSpPr>
-          <p:cNvPr id="170" name=""/>
+          <p:cNvPr id="174" name=""/>
           <p:cNvSpPr/>
           <p:nvPr/>
         </p:nvSpPr>
@@ -8100,7 +8208,7 @@
       </p:sp>
       <p:sp>
         <p:nvSpPr>
-          <p:cNvPr id="171" name="" descr="{&quot;isTemplate&quot;:true,&quot;type&quot;:&quot;text&quot;}"/>
+          <p:cNvPr id="175" name="" descr="{&quot;isTemplate&quot;:true,&quot;type&quot;:&quot;text&quot;}"/>
           <p:cNvSpPr txBox="1"/>
           <p:nvPr/>
         </p:nvSpPr>
@@ -8145,7 +8253,7 @@
       </p:sp>
       <p:sp>
         <p:nvSpPr>
-          <p:cNvPr id="172" name="" descr="{&quot;isTemplate&quot;:true,&quot;type&quot;:&quot;text&quot;}"/>
+          <p:cNvPr id="176" name="" descr="{&quot;isTemplate&quot;:true,&quot;type&quot;:&quot;text&quot;}"/>
           <p:cNvSpPr txBox="1"/>
           <p:nvPr/>
         </p:nvSpPr>
@@ -8262,7 +8370,7 @@
       </p:sp>
       <p:sp>
         <p:nvSpPr>
-          <p:cNvPr id="173" name=""/>
+          <p:cNvPr id="177" name=""/>
           <p:cNvSpPr/>
           <p:nvPr/>
         </p:nvSpPr>
@@ -8290,7 +8398,7 @@
       </p:sp>
       <p:sp>
         <p:nvSpPr>
-          <p:cNvPr id="174" name="" descr="{&quot;isTemplate&quot;:true,&quot;type&quot;:&quot;text&quot;}"/>
+          <p:cNvPr id="178" name="" descr="{&quot;isTemplate&quot;:true,&quot;type&quot;:&quot;text&quot;}"/>
           <p:cNvSpPr txBox="1"/>
           <p:nvPr/>
         </p:nvSpPr>
@@ -8345,7 +8453,7 @@
       </p:sp>
       <p:sp>
         <p:nvSpPr>
-          <p:cNvPr id="175" name="" descr="{&quot;isTemplate&quot;:true,&quot;type&quot;:&quot;text&quot;}"/>
+          <p:cNvPr id="179" name="" descr="{&quot;isTemplate&quot;:true,&quot;type&quot;:&quot;text&quot;}"/>
           <p:cNvSpPr txBox="1"/>
           <p:nvPr/>
         </p:nvSpPr>
@@ -8400,7 +8508,7 @@
       </p:sp>
       <p:sp>
         <p:nvSpPr>
-          <p:cNvPr id="176" name=""/>
+          <p:cNvPr id="180" name=""/>
           <p:cNvSpPr/>
           <p:nvPr/>
         </p:nvSpPr>
@@ -8428,7 +8536,7 @@
       </p:sp>
       <p:sp>
         <p:nvSpPr>
-          <p:cNvPr id="177" name="" descr="{&quot;isTemplate&quot;:true,&quot;type&quot;:&quot;text&quot;}"/>
+          <p:cNvPr id="181" name="" descr="{&quot;isTemplate&quot;:true,&quot;type&quot;:&quot;text&quot;}"/>
           <p:cNvSpPr txBox="1"/>
           <p:nvPr/>
         </p:nvSpPr>
@@ -8473,7 +8581,7 @@
       </p:sp>
       <p:sp>
         <p:nvSpPr>
-          <p:cNvPr id="178" name="" descr="{&quot;isTemplate&quot;:true,&quot;type&quot;:&quot;text&quot;}"/>
+          <p:cNvPr id="182" name="" descr="{&quot;isTemplate&quot;:true,&quot;type&quot;:&quot;text&quot;}"/>
           <p:cNvSpPr txBox="1"/>
           <p:nvPr/>
         </p:nvSpPr>
@@ -8528,7 +8636,7 @@
       </p:sp>
       <p:sp>
         <p:nvSpPr>
-          <p:cNvPr id="179" name=""/>
+          <p:cNvPr id="183" name=""/>
           <p:cNvSpPr/>
           <p:nvPr/>
         </p:nvSpPr>
@@ -8556,7 +8664,7 @@
       </p:sp>
       <p:sp>
         <p:nvSpPr>
-          <p:cNvPr id="180" name="" descr="{&quot;isTemplate&quot;:true,&quot;type&quot;:&quot;text&quot;}"/>
+          <p:cNvPr id="184" name="" descr="{&quot;isTemplate&quot;:true,&quot;type&quot;:&quot;text&quot;}"/>
           <p:cNvSpPr txBox="1"/>
           <p:nvPr/>
         </p:nvSpPr>
@@ -8601,7 +8709,7 @@
       </p:sp>
       <p:sp>
         <p:nvSpPr>
-          <p:cNvPr id="181" name="" descr="{&quot;isTemplate&quot;:true,&quot;type&quot;:&quot;text&quot;}"/>
+          <p:cNvPr id="185" name="" descr="{&quot;isTemplate&quot;:true,&quot;type&quot;:&quot;text&quot;}"/>
           <p:cNvSpPr txBox="1"/>
           <p:nvPr/>
         </p:nvSpPr>
@@ -8656,7 +8764,7 @@
       </p:sp>
       <p:sp>
         <p:nvSpPr>
-          <p:cNvPr id="182" name=""/>
+          <p:cNvPr id="186" name=""/>
           <p:cNvSpPr/>
           <p:nvPr/>
         </p:nvSpPr>
@@ -8689,7 +8797,7 @@
       </p:sp>
       <p:sp>
         <p:nvSpPr>
-          <p:cNvPr id="183" name="" descr="{&quot;isTemplate&quot;:true,&quot;type&quot;:&quot;text&quot;}"/>
+          <p:cNvPr id="187" name="" descr="{&quot;isTemplate&quot;:true,&quot;type&quot;:&quot;text&quot;}"/>
           <p:cNvSpPr txBox="1"/>
           <p:nvPr/>
         </p:nvSpPr>
@@ -8724,7 +8832,7 @@
       </p:sp>
       <p:sp>
         <p:nvSpPr>
-          <p:cNvPr id="184" name="" descr="{&quot;isTemplate&quot;:true,&quot;type&quot;:&quot;text&quot;}"/>
+          <p:cNvPr id="188" name="" descr="{&quot;isTemplate&quot;:true,&quot;type&quot;:&quot;text&quot;}"/>
           <p:cNvSpPr txBox="1"/>
           <p:nvPr/>
         </p:nvSpPr>
@@ -8759,7 +8867,7 @@
       </p:sp>
       <p:sp>
         <p:nvSpPr>
-          <p:cNvPr id="185" name="" descr="{&quot;isTemplate&quot;:true,&quot;type&quot;:&quot;text&quot;}"/>
+          <p:cNvPr id="189" name="" descr="{&quot;isTemplate&quot;:true,&quot;type&quot;:&quot;text&quot;}"/>
           <p:cNvSpPr txBox="1"/>
           <p:nvPr/>
         </p:nvSpPr>
@@ -8794,7 +8902,7 @@
       </p:sp>
       <p:sp>
         <p:nvSpPr>
-          <p:cNvPr id="186" name=""/>
+          <p:cNvPr id="190" name=""/>
           <p:cNvSpPr/>
           <p:nvPr/>
         </p:nvSpPr>
@@ -8827,7 +8935,7 @@
       </p:sp>
       <p:sp>
         <p:nvSpPr>
-          <p:cNvPr id="187" name="" descr="{&quot;isTemplate&quot;:true,&quot;type&quot;:&quot;text&quot;}"/>
+          <p:cNvPr id="191" name="" descr="{&quot;isTemplate&quot;:true,&quot;type&quot;:&quot;text&quot;}"/>
           <p:cNvSpPr txBox="1"/>
           <p:nvPr/>
         </p:nvSpPr>
@@ -8882,7 +8990,7 @@
       </p:sp>
       <p:sp>
         <p:nvSpPr>
-          <p:cNvPr id="188" name="" descr="{&quot;isTemplate&quot;:true,&quot;type&quot;:&quot;text&quot;}"/>
+          <p:cNvPr id="192" name="" descr="{&quot;isTemplate&quot;:true,&quot;type&quot;:&quot;text&quot;}"/>
           <p:cNvSpPr txBox="1"/>
           <p:nvPr/>
         </p:nvSpPr>
@@ -8917,7 +9025,7 @@
       </p:sp>
       <p:sp>
         <p:nvSpPr>
-          <p:cNvPr id="189" name="" descr="{&quot;isTemplate&quot;:true,&quot;type&quot;:&quot;text&quot;}"/>
+          <p:cNvPr id="193" name="" descr="{&quot;isTemplate&quot;:true,&quot;type&quot;:&quot;text&quot;}"/>
           <p:cNvSpPr txBox="1"/>
           <p:nvPr/>
         </p:nvSpPr>
@@ -8952,7 +9060,7 @@
       </p:sp>
       <p:sp>
         <p:nvSpPr>
-          <p:cNvPr id="190" name=""/>
+          <p:cNvPr id="194" name=""/>
           <p:cNvSpPr/>
           <p:nvPr/>
         </p:nvSpPr>
@@ -8985,7 +9093,7 @@
       </p:sp>
       <p:sp>
         <p:nvSpPr>
-          <p:cNvPr id="191" name="" descr="{&quot;isTemplate&quot;:true,&quot;type&quot;:&quot;text&quot;}"/>
+          <p:cNvPr id="195" name="" descr="{&quot;isTemplate&quot;:true,&quot;type&quot;:&quot;text&quot;}"/>
           <p:cNvSpPr txBox="1"/>
           <p:nvPr/>
         </p:nvSpPr>
@@ -9030,7 +9138,7 @@
       </p:sp>
       <p:sp>
         <p:nvSpPr>
-          <p:cNvPr id="192" name="" descr="{&quot;isTemplate&quot;:true,&quot;type&quot;:&quot;text&quot;}"/>
+          <p:cNvPr id="196" name="" descr="{&quot;isTemplate&quot;:true,&quot;type&quot;:&quot;text&quot;}"/>
           <p:cNvSpPr txBox="1"/>
           <p:nvPr/>
         </p:nvSpPr>
@@ -9065,7 +9173,7 @@
       </p:sp>
       <p:sp>
         <p:nvSpPr>
-          <p:cNvPr id="193" name="" descr="{&quot;isTemplate&quot;:true,&quot;type&quot;:&quot;text&quot;}"/>
+          <p:cNvPr id="197" name="" descr="{&quot;isTemplate&quot;:true,&quot;type&quot;:&quot;text&quot;}"/>
           <p:cNvSpPr txBox="1"/>
           <p:nvPr/>
         </p:nvSpPr>
@@ -9100,7 +9208,7 @@
       </p:sp>
       <p:sp>
         <p:nvSpPr>
-          <p:cNvPr id="194" name=""/>
+          <p:cNvPr id="198" name=""/>
           <p:cNvSpPr/>
           <p:nvPr/>
         </p:nvSpPr>
@@ -9134,7 +9242,7 @@
       </p:sp>
       <p:sp>
         <p:nvSpPr>
-          <p:cNvPr id="195" name="" descr="{&quot;isTemplate&quot;:true,&quot;type&quot;:&quot;text&quot;}"/>
+          <p:cNvPr id="199" name="" descr="{&quot;isTemplate&quot;:true,&quot;type&quot;:&quot;text&quot;}"/>
           <p:cNvSpPr txBox="1"/>
           <p:nvPr/>
         </p:nvSpPr>
@@ -9189,7 +9297,7 @@
       </p:sp>
       <p:sp>
         <p:nvSpPr>
-          <p:cNvPr id="196" name="" descr="{&quot;isTemplate&quot;:true,&quot;type&quot;:&quot;text&quot;}"/>
+          <p:cNvPr id="200" name="" descr="{&quot;isTemplate&quot;:true,&quot;type&quot;:&quot;text&quot;}"/>
           <p:cNvSpPr txBox="1"/>
           <p:nvPr/>
         </p:nvSpPr>
@@ -9298,7 +9406,7 @@
       </p:sp>
       <p:sp>
         <p:nvSpPr>
-          <p:cNvPr id="197" name="" descr="{&quot;isTemplate&quot;:true,&quot;type&quot;:&quot;text&quot;}"/>
+          <p:cNvPr id="201" name="" descr="{&quot;isTemplate&quot;:true,&quot;type&quot;:&quot;text&quot;}"/>
           <p:cNvSpPr txBox="1"/>
           <p:nvPr/>
         </p:nvSpPr>
@@ -9333,7 +9441,7 @@
       </p:sp>
       <p:sp>
         <p:nvSpPr>
-          <p:cNvPr id="198" name=""/>
+          <p:cNvPr id="202" name=""/>
           <p:cNvSpPr/>
           <p:nvPr/>
         </p:nvSpPr>
@@ -9394,7 +9502,7 @@
       </p:sp>
       <p:sp>
         <p:nvSpPr>
-          <p:cNvPr id="199" name=""/>
+          <p:cNvPr id="203" name=""/>
           <p:cNvSpPr/>
           <p:nvPr/>
         </p:nvSpPr>
@@ -9434,7 +9542,7 @@
       </p:sp>
       <p:sp>
         <p:nvSpPr>
-          <p:cNvPr id="200" name="" descr="{&quot;isTemplate&quot;:true,&quot;type&quot;:&quot;text&quot;}"/>
+          <p:cNvPr id="204" name="" descr="{&quot;isTemplate&quot;:true,&quot;type&quot;:&quot;text&quot;}"/>
           <p:cNvSpPr txBox="1"/>
           <p:nvPr/>
         </p:nvSpPr>
@@ -9611,7 +9719,7 @@
       </p:sp>
       <p:sp>
         <p:nvSpPr>
-          <p:cNvPr id="201" name="" descr="{&quot;isTemplate&quot;:true,&quot;type&quot;:&quot;text&quot;}"/>
+          <p:cNvPr id="205" name="" descr="{&quot;isTemplate&quot;:true,&quot;type&quot;:&quot;text&quot;}"/>
           <p:cNvSpPr txBox="1"/>
           <p:nvPr/>
         </p:nvSpPr>
@@ -9666,7 +9774,7 @@
       </p:sp>
       <p:sp>
         <p:nvSpPr>
-          <p:cNvPr id="202" name="" descr="{&quot;isTemplate&quot;:true,&quot;type&quot;:&quot;text&quot;}"/>
+          <p:cNvPr id="206" name="" descr="{&quot;isTemplate&quot;:true,&quot;type&quot;:&quot;text&quot;}"/>
           <p:cNvSpPr txBox="1"/>
           <p:nvPr/>
         </p:nvSpPr>
@@ -9709,7 +9817,7 @@
   <p:cSld>
     <p:spTree>
       <p:nvGrpSpPr>
-        <p:cNvPr id="203" name="" descr="&lt;Slide style={{ width: '1280px', height: '720px', background: 'linear-gradient(135deg, #172133 0%, #22395E 100%)', position: 'relative', display: 'flex', flexDirection: 'column', justifyContent: 'center', padding: '0 96px' }}&gt;&#10;  &lt;div style={{ color: '#BD9B56', fontSize: 15, letterSpacing: '0.35em', marginBottom: 24 }}&gt;SECTION 04&lt;/div&gt;&#10;  &lt;div style={{ display: 'flex', alignItems: 'baseline', gap: 28 }}&gt;&#10;    &lt;span style={{ fontSize: 110, fontWeight: 'bold', color: 'rgba(189,155,86,0.28)', fontFamily: 'Inter, sans-serif', lineHeight: 1 }}&gt;04&lt;/span&gt;&#10;    &lt;span style={{ fontSize: 46, fontWeight: 'bold', color: '#FBFCFA', letterSpacing: '0.02em' }}&gt;总结与展望&lt;/span&gt;&#10;  &lt;/div&gt;&#10;  &lt;div style={{ width: 72, height: 3, background: '#BD9B56', margin: '28px 0 20px' }} /&gt;&#10;  &lt;div style={{ fontSize: 16, color: 'rgba(251,252,250,0.72)', letterSpacing: '0.04em' }}&gt;项目价值 · 技术路线回顾 · 在线演示&lt;/div&gt;&#10;  &lt;div style={{ position: 'absolute', bottom: 42, right: 96, color: 'rgba(251,252,250,0.4)', fontSize: 13, fontFamily: 'Inter, sans-serif' }}&gt;16 / 19&lt;/div&gt;&#10;&lt;/Slide&gt;"/>
+        <p:cNvPr id="207" name="" descr="&lt;Slide style={{ width: '1280px', height: '720px', background: 'linear-gradient(135deg, #172133 0%, #22395E 100%)', position: 'relative', display: 'flex', flexDirection: 'column', justifyContent: 'center', padding: '0 96px' }}&gt;&#10;  &lt;div style={{ color: '#BD9B56', fontSize: 15, letterSpacing: '0.35em', marginBottom: 24 }}&gt;SECTION 04&lt;/div&gt;&#10;  &lt;div style={{ display: 'flex', alignItems: 'center', gap: 36 }}&gt;&#10;    &lt;span style={{ fontSize: 160, fontWeight: 'bold', color: '#BD9B56', lineHeight: 1 }}&gt;04&lt;/span&gt;&#10;    &lt;div&gt;&#10;      &lt;div style={{ fontSize: 50, fontWeight: 'bold', color: '#FBFCFA', letterSpacing: '0.02em', lineHeight: 1.15 }}&gt;总结与展望&lt;/div&gt;&#10;      &lt;div style={{ fontSize: 17, color: 'rgba(251,252,250,0.55)', marginTop: 12, letterSpacing: '0.06em' }}&gt;SUMMARY &amp;amp; OUTLOOK&lt;/div&gt;&#10;    &lt;/div&gt;&#10;  &lt;/div&gt;&#10;  &lt;div style={{ width: 80, height: 3, background: '#BD9B56', margin: '32px 0 24px' }} /&gt;&#10;  &lt;div style={{ display: 'flex', gap: 14 }}&gt;&#10;    &lt;span style={{ fontSize: 15, color: 'rgba(251,252,250,0.88)', border: '1px solid rgba(189,155,86,0.65)', padding: '9px 20px', borderRadius: 22 }}&gt;技术路线回顾&lt;/span&gt;&#10;    &lt;span style={{ fontSize: 15, color: 'rgba(251,252,250,0.88)', border: '1px solid rgba(189,155,86,0.65)', padding: '9px 20px', borderRadius: 22 }}&gt;三端功能实现&lt;/span&gt;&#10;    &lt;span style={{ fontSize: 15, color: 'rgba(251,252,250,0.88)', border: '1px solid rgba(189,155,86,0.65)', padding: '9px 20px', borderRadius: 22 }}&gt;在线演示&lt;/span&gt;&#10;  &lt;/div&gt;&#10;  &lt;div style={{ position: 'absolute', bottom: 42, right: 96, color: 'rgba(251,252,250,0.4)', fontSize: 13 }}&gt;16 / 19&lt;/div&gt;&#10;&lt;/Slide&gt;"/>
         <p:cNvGrpSpPr/>
         <p:nvPr/>
       </p:nvGrpSpPr>
@@ -9723,7 +9831,7 @@
       </p:grpSpPr>
       <p:sp>
         <p:nvSpPr>
-          <p:cNvPr id="204" name=""/>
+          <p:cNvPr id="208" name=""/>
           <p:cNvSpPr/>
           <p:nvPr/>
         </p:nvSpPr>
@@ -9755,14 +9863,49 @@
       </p:sp>
       <p:sp>
         <p:nvSpPr>
-          <p:cNvPr id="205" name="" descr="{&quot;isTemplate&quot;:true,&quot;type&quot;:&quot;text&quot;}"/>
+          <p:cNvPr id="209" name="" descr="{&quot;isTemplate&quot;:true,&quot;type&quot;:&quot;text&quot;}"/>
+          <p:cNvSpPr txBox="1"/>
+          <p:nvPr/>
+        </p:nvSpPr>
+        <p:spPr>
+          <a:xfrm rot="0" flipH="0" flipV="0">
+            <a:off x="914400" y="1866900"/>
+            <a:ext cx="10363200" cy="171450"/>
+          </a:xfrm>
+          <a:prstGeom prst="rect"/>
+        </p:spPr>
+        <p:txBody>
+          <a:bodyPr wrap="none" lIns="0" tIns="0" rIns="0" bIns="0"/>
+          <a:p>
+            <a:pPr>
+              <a:lnSpc>
+                <a:spcPct val="100000"/>
+              </a:lnSpc>
+            </a:pPr>
+            <a:r>
+              <a:rPr lang="en-US" sz="1125" spc="-9223372036854775808">
+                <a:solidFill>
+                  <a:srgbClr val="BD9B56"/>
+                </a:solidFill>
+                <a:latin typeface="Microsoft YaHei"/>
+                <a:ea typeface="Microsoft YaHei"/>
+              </a:rPr>
+              <a:t>SECTION 04</a:t>
+            </a:r>
+            <a:endParaRPr/>
+          </a:p>
+        </p:txBody>
+      </p:sp>
+      <p:sp>
+        <p:nvSpPr>
+          <p:cNvPr id="210" name="" descr="{&quot;isTemplate&quot;:true,&quot;type&quot;:&quot;text&quot;}"/>
           <p:cNvSpPr txBox="1"/>
           <p:nvPr/>
         </p:nvSpPr>
         <p:spPr>
           <a:xfrm rot="0" flipH="0" flipV="0">
             <a:off x="914400" y="2266950"/>
-            <a:ext cx="10363200" cy="171450"/>
+            <a:ext cx="1885950" cy="1828800"/>
           </a:xfrm>
           <a:prstGeom prst="rect"/>
         </p:spPr>
@@ -9775,29 +9918,64 @@
               </a:lnSpc>
             </a:pPr>
             <a:r>
-              <a:rPr lang="en-US" sz="1125" spc="-9223372036854775808">
+              <a:rPr lang="en-US" sz="12000" b="1">
                 <a:solidFill>
                   <a:srgbClr val="BD9B56"/>
                 </a:solidFill>
                 <a:latin typeface="Microsoft YaHei"/>
                 <a:ea typeface="Microsoft YaHei"/>
               </a:rPr>
-              <a:t>SECTION 04</a:t>
-            </a:r>
-            <a:endParaRPr/>
-          </a:p>
-        </p:txBody>
-      </p:sp>
-      <p:sp>
-        <p:nvSpPr>
-          <p:cNvPr id="206" name="" descr="{&quot;isTemplate&quot;:true,&quot;type&quot;:&quot;text&quot;}"/>
-          <p:cNvSpPr txBox="1"/>
-          <p:nvPr/>
-        </p:nvSpPr>
-        <p:spPr>
-          <a:xfrm rot="0" flipH="0" flipV="0">
-            <a:off x="914400" y="2667000"/>
-            <a:ext cx="1343025" cy="1257300"/>
+              <a:t>04</a:t>
+            </a:r>
+            <a:endParaRPr/>
+          </a:p>
+        </p:txBody>
+      </p:sp>
+      <p:sp>
+        <p:nvSpPr>
+          <p:cNvPr id="211" name="" descr="{&quot;isTemplate&quot;:true,&quot;type&quot;:&quot;text&quot;}"/>
+          <p:cNvSpPr txBox="1"/>
+          <p:nvPr/>
+        </p:nvSpPr>
+        <p:spPr>
+          <a:xfrm rot="0" flipH="0" flipV="0">
+            <a:off x="3143250" y="2695575"/>
+            <a:ext cx="2381250" cy="657225"/>
+          </a:xfrm>
+          <a:prstGeom prst="rect"/>
+        </p:spPr>
+        <p:txBody>
+          <a:bodyPr wrap="none" lIns="0" tIns="0" rIns="0" bIns="0"/>
+          <a:p>
+            <a:pPr>
+              <a:lnSpc>
+                <a:spcPct val="114999"/>
+              </a:lnSpc>
+            </a:pPr>
+            <a:r>
+              <a:rPr lang="zh-CN" sz="3750" spc="-9223372036854775808">
+                <a:solidFill>
+                  <a:srgbClr val="FBFCFA"/>
+                </a:solidFill>
+                <a:latin typeface="Microsoft YaHei"/>
+                <a:ea typeface="Microsoft YaHei"/>
+              </a:rPr>
+              <a:t>总结与展望</a:t>
+            </a:r>
+            <a:endParaRPr/>
+          </a:p>
+        </p:txBody>
+      </p:sp>
+      <p:sp>
+        <p:nvSpPr>
+          <p:cNvPr id="212" name="" descr="{&quot;isTemplate&quot;:true,&quot;type&quot;:&quot;text&quot;}"/>
+          <p:cNvSpPr txBox="1"/>
+          <p:nvPr/>
+        </p:nvSpPr>
+        <p:spPr>
+          <a:xfrm rot="0" flipH="0" flipV="0">
+            <a:off x="3143250" y="3467100"/>
+            <a:ext cx="2381250" cy="200025"/>
           </a:xfrm>
           <a:prstGeom prst="rect"/>
         </p:spPr>
@@ -9810,66 +9988,31 @@
               </a:lnSpc>
             </a:pPr>
             <a:r>
-              <a:rPr lang="en-US" sz="8250" b="1">
-                <a:solidFill>
-                  <a:srgbClr val="BD9B56">
-                    <a:alpha val="28000"/>
+              <a:rPr lang="en-US" sz="1275" spc="-9223372036854775808">
+                <a:solidFill>
+                  <a:srgbClr val="FBFCFA">
+                    <a:alpha val="55000"/>
                   </a:srgbClr>
                 </a:solidFill>
-                <a:latin typeface="Inter"/>
-                <a:ea typeface="Inter"/>
-              </a:rPr>
-              <a:t>04</a:t>
-            </a:r>
-            <a:endParaRPr/>
-          </a:p>
-        </p:txBody>
-      </p:sp>
-      <p:sp>
-        <p:nvSpPr>
-          <p:cNvPr id="207" name="" descr="{&quot;isTemplate&quot;:true,&quot;type&quot;:&quot;text&quot;}"/>
-          <p:cNvSpPr txBox="1"/>
-          <p:nvPr/>
-        </p:nvSpPr>
-        <p:spPr>
-          <a:xfrm rot="0" flipH="0" flipV="0">
-            <a:off x="2524125" y="2667000"/>
-            <a:ext cx="2190750" cy="1257300"/>
-          </a:xfrm>
-          <a:prstGeom prst="rect"/>
-        </p:spPr>
-        <p:txBody>
-          <a:bodyPr wrap="none" lIns="0" tIns="0" rIns="0" bIns="0"/>
-          <a:p>
-            <a:pPr>
-              <a:lnSpc>
-                <a:spcPct val="100000"/>
-              </a:lnSpc>
-            </a:pPr>
-            <a:r>
-              <a:rPr lang="zh-CN" sz="3450" b="1">
-                <a:solidFill>
-                  <a:srgbClr val="FBFCFA"/>
-                </a:solidFill>
-                <a:latin typeface="Microsoft YaHei"/>
-                <a:ea typeface="Microsoft YaHei"/>
-              </a:rPr>
-              <a:t>总结与展望</a:t>
-            </a:r>
-            <a:endParaRPr/>
-          </a:p>
-        </p:txBody>
-      </p:sp>
-      <p:sp>
-        <p:nvSpPr>
-          <p:cNvPr id="208" name=""/>
+                <a:latin typeface="Microsoft YaHei"/>
+                <a:ea typeface="Microsoft YaHei"/>
+              </a:rPr>
+              <a:t>SUMMARY &amp; OUTLOOK</a:t>
+            </a:r>
+            <a:endParaRPr/>
+          </a:p>
+        </p:txBody>
+      </p:sp>
+      <p:sp>
+        <p:nvSpPr>
+          <p:cNvPr id="213" name=""/>
           <p:cNvSpPr/>
           <p:nvPr/>
         </p:nvSpPr>
         <p:spPr>
           <a:xfrm rot="0" flipH="0" flipV="0">
-            <a:off x="914400" y="4191000"/>
-            <a:ext cx="685800" cy="28575"/>
+            <a:off x="914400" y="4400550"/>
+            <a:ext cx="762000" cy="28575"/>
           </a:xfrm>
           <a:prstGeom prst="rect">
             <a:avLst/>
@@ -9886,19 +10029,49 @@
       </p:sp>
       <p:sp>
         <p:nvSpPr>
-          <p:cNvPr id="209" name="" descr="{&quot;isTemplate&quot;:true,&quot;type&quot;:&quot;text&quot;}"/>
-          <p:cNvSpPr txBox="1"/>
-          <p:nvPr/>
-        </p:nvSpPr>
-        <p:spPr>
-          <a:xfrm rot="0" flipH="0" flipV="0">
-            <a:off x="914400" y="4410075"/>
-            <a:ext cx="10363200" cy="190500"/>
-          </a:xfrm>
-          <a:prstGeom prst="rect"/>
-        </p:spPr>
-        <p:txBody>
-          <a:bodyPr wrap="none" lIns="0" tIns="0" rIns="0" bIns="0"/>
+          <p:cNvPr id="214" name=""/>
+          <p:cNvSpPr/>
+          <p:nvPr/>
+        </p:nvSpPr>
+        <p:spPr>
+          <a:xfrm rot="0" flipH="0" flipV="0">
+            <a:off x="914400" y="4657725"/>
+            <a:ext cx="1238250" cy="342900"/>
+          </a:xfrm>
+          <a:prstGeom prst="roundRect">
+            <a:avLst>
+              <a:gd name="adj" fmla="val 61111"/>
+            </a:avLst>
+          </a:prstGeom>
+          <a:ln w="12700">
+            <a:solidFill>
+              <a:srgbClr val="BD9B56">
+                <a:alpha val="65000"/>
+              </a:srgbClr>
+            </a:solidFill>
+            <a:prstDash val="solid"/>
+          </a:ln>
+        </p:spPr>
+        <p:txBody>
+          <a:bodyPr/>
+          <a:p/>
+        </p:txBody>
+      </p:sp>
+      <p:sp>
+        <p:nvSpPr>
+          <p:cNvPr id="215" name="" descr="{&quot;isTemplate&quot;:true,&quot;type&quot;:&quot;text&quot;}"/>
+          <p:cNvSpPr txBox="1"/>
+          <p:nvPr/>
+        </p:nvSpPr>
+        <p:spPr>
+          <a:xfrm rot="0" flipH="0" flipV="0">
+            <a:off x="914400" y="4657725"/>
+            <a:ext cx="1238250" cy="342900"/>
+          </a:xfrm>
+          <a:prstGeom prst="rect"/>
+        </p:spPr>
+        <p:txBody>
+          <a:bodyPr wrap="none" lIns="142875" tIns="64294" rIns="142875" bIns="64294"/>
           <a:p>
             <a:pPr>
               <a:lnSpc>
@@ -9906,63 +10079,149 @@
               </a:lnSpc>
             </a:pPr>
             <a:r>
-              <a:rPr lang="zh-CN" sz="1200" spc="-9223372036854775808">
+              <a:rPr lang="zh-CN" sz="1125">
                 <a:solidFill>
                   <a:srgbClr val="FBFCFA">
-                    <a:alpha val="72000"/>
+                    <a:alpha val="88000"/>
                   </a:srgbClr>
                 </a:solidFill>
                 <a:latin typeface="Microsoft YaHei"/>
                 <a:ea typeface="Microsoft YaHei"/>
               </a:rPr>
-              <a:t>项目价值</a:t>
-            </a:r>
-            <a:r>
-              <a:rPr lang="en-US" sz="1200" spc="-9223372036854775808">
+              <a:t>技术路线回顾</a:t>
+            </a:r>
+            <a:endParaRPr/>
+          </a:p>
+        </p:txBody>
+      </p:sp>
+      <p:sp>
+        <p:nvSpPr>
+          <p:cNvPr id="216" name=""/>
+          <p:cNvSpPr/>
+          <p:nvPr/>
+        </p:nvSpPr>
+        <p:spPr>
+          <a:xfrm rot="0" flipH="0" flipV="0">
+            <a:off x="2286000" y="4657725"/>
+            <a:ext cx="1238250" cy="342900"/>
+          </a:xfrm>
+          <a:prstGeom prst="roundRect">
+            <a:avLst>
+              <a:gd name="adj" fmla="val 61111"/>
+            </a:avLst>
+          </a:prstGeom>
+          <a:ln w="12700">
+            <a:solidFill>
+              <a:srgbClr val="BD9B56">
+                <a:alpha val="65000"/>
+              </a:srgbClr>
+            </a:solidFill>
+            <a:prstDash val="solid"/>
+          </a:ln>
+        </p:spPr>
+        <p:txBody>
+          <a:bodyPr/>
+          <a:p/>
+        </p:txBody>
+      </p:sp>
+      <p:sp>
+        <p:nvSpPr>
+          <p:cNvPr id="217" name="" descr="{&quot;isTemplate&quot;:true,&quot;type&quot;:&quot;text&quot;}"/>
+          <p:cNvSpPr txBox="1"/>
+          <p:nvPr/>
+        </p:nvSpPr>
+        <p:spPr>
+          <a:xfrm rot="0" flipH="0" flipV="0">
+            <a:off x="2286000" y="4657725"/>
+            <a:ext cx="1238250" cy="342900"/>
+          </a:xfrm>
+          <a:prstGeom prst="rect"/>
+        </p:spPr>
+        <p:txBody>
+          <a:bodyPr wrap="none" lIns="142875" tIns="64294" rIns="142875" bIns="64294"/>
+          <a:p>
+            <a:pPr>
+              <a:lnSpc>
+                <a:spcPct val="100000"/>
+              </a:lnSpc>
+            </a:pPr>
+            <a:r>
+              <a:rPr lang="zh-CN" sz="1125">
                 <a:solidFill>
                   <a:srgbClr val="FBFCFA">
-                    <a:alpha val="72000"/>
+                    <a:alpha val="88000"/>
                   </a:srgbClr>
                 </a:solidFill>
                 <a:latin typeface="Microsoft YaHei"/>
                 <a:ea typeface="Microsoft YaHei"/>
               </a:rPr>
-              <a:t> · </a:t>
-            </a:r>
-            <a:r>
-              <a:rPr lang="zh-CN" sz="1200" spc="-9223372036854775808">
+              <a:t>三端功能实现</a:t>
+            </a:r>
+            <a:endParaRPr/>
+          </a:p>
+        </p:txBody>
+      </p:sp>
+      <p:sp>
+        <p:nvSpPr>
+          <p:cNvPr id="218" name=""/>
+          <p:cNvSpPr/>
+          <p:nvPr/>
+        </p:nvSpPr>
+        <p:spPr>
+          <a:xfrm rot="0" flipH="0" flipV="0">
+            <a:off x="3657600" y="4657725"/>
+            <a:ext cx="952500" cy="342900"/>
+          </a:xfrm>
+          <a:prstGeom prst="roundRect">
+            <a:avLst>
+              <a:gd name="adj" fmla="val 61111"/>
+            </a:avLst>
+          </a:prstGeom>
+          <a:ln w="12700">
+            <a:solidFill>
+              <a:srgbClr val="BD9B56">
+                <a:alpha val="65000"/>
+              </a:srgbClr>
+            </a:solidFill>
+            <a:prstDash val="solid"/>
+          </a:ln>
+        </p:spPr>
+        <p:txBody>
+          <a:bodyPr/>
+          <a:p/>
+        </p:txBody>
+      </p:sp>
+      <p:sp>
+        <p:nvSpPr>
+          <p:cNvPr id="219" name="" descr="{&quot;isTemplate&quot;:true,&quot;type&quot;:&quot;text&quot;}"/>
+          <p:cNvSpPr txBox="1"/>
+          <p:nvPr/>
+        </p:nvSpPr>
+        <p:spPr>
+          <a:xfrm rot="0" flipH="0" flipV="0">
+            <a:off x="3657600" y="4657725"/>
+            <a:ext cx="952500" cy="342900"/>
+          </a:xfrm>
+          <a:prstGeom prst="rect"/>
+        </p:spPr>
+        <p:txBody>
+          <a:bodyPr wrap="none" lIns="142875" tIns="64294" rIns="142875" bIns="64294"/>
+          <a:p>
+            <a:pPr>
+              <a:lnSpc>
+                <a:spcPct val="100000"/>
+              </a:lnSpc>
+            </a:pPr>
+            <a:r>
+              <a:rPr lang="zh-CN" sz="1125">
                 <a:solidFill>
                   <a:srgbClr val="FBFCFA">
-                    <a:alpha val="72000"/>
+                    <a:alpha val="88000"/>
                   </a:srgbClr>
                 </a:solidFill>
                 <a:latin typeface="Microsoft YaHei"/>
                 <a:ea typeface="Microsoft YaHei"/>
               </a:rPr>
-              <a:t>技术路线回顾</a:t>
-            </a:r>
-            <a:r>
-              <a:rPr lang="en-US" sz="1200" spc="-9223372036854775808">
-                <a:solidFill>
-                  <a:srgbClr val="FBFCFA">
-                    <a:alpha val="72000"/>
-                  </a:srgbClr>
-                </a:solidFill>
-                <a:latin typeface="Microsoft YaHei"/>
-                <a:ea typeface="Microsoft YaHei"/>
-              </a:rPr>
-              <a:t> · </a:t>
-            </a:r>
-            <a:r>
-              <a:rPr lang="zh-CN" sz="1200" spc="-9223372036854775808">
-                <a:solidFill>
-                  <a:srgbClr val="FBFCFA">
-                    <a:alpha val="72000"/>
-                  </a:srgbClr>
-                </a:solidFill>
-                <a:latin typeface="Microsoft YaHei"/>
-                <a:ea typeface="Microsoft YaHei"/>
-              </a:rPr>
               <a:t>在线演示</a:t>
             </a:r>
             <a:endParaRPr/>
@@ -9971,14 +10230,14 @@
       </p:sp>
       <p:sp>
         <p:nvSpPr>
-          <p:cNvPr id="210" name="" descr="{&quot;isTemplate&quot;:true,&quot;type&quot;:&quot;text&quot;}"/>
-          <p:cNvSpPr txBox="1"/>
-          <p:nvPr/>
-        </p:nvSpPr>
-        <p:spPr>
-          <a:xfrm rot="0" flipH="0" flipV="0">
-            <a:off x="10877550" y="6305550"/>
-            <a:ext cx="400050" cy="152400"/>
+          <p:cNvPr id="220" name="" descr="{&quot;isTemplate&quot;:true,&quot;type&quot;:&quot;text&quot;}"/>
+          <p:cNvSpPr txBox="1"/>
+          <p:nvPr/>
+        </p:nvSpPr>
+        <p:spPr>
+          <a:xfrm rot="0" flipH="0" flipV="0">
+            <a:off x="10858500" y="6305550"/>
+            <a:ext cx="419100" cy="152400"/>
           </a:xfrm>
           <a:prstGeom prst="rect"/>
         </p:spPr>
@@ -9997,8 +10256,8 @@
                     <a:alpha val="40000"/>
                   </a:srgbClr>
                 </a:solidFill>
-                <a:latin typeface="Inter"/>
-                <a:ea typeface="Inter"/>
+                <a:latin typeface="Microsoft YaHei"/>
+                <a:ea typeface="Microsoft YaHei"/>
               </a:rPr>
               <a:t>16 / 19</a:t>
             </a:r>
@@ -10016,7 +10275,7 @@
   <p:cSld>
     <p:spTree>
       <p:nvGrpSpPr>
-        <p:cNvPr id="211" name="" descr="&lt;Slide style={{ width: '1280px', height: '720px', background: '#FBFCFA', position: 'relative', padding: '36px 64px', boxSizing: 'border-box', display: 'flex', flexDirection: 'column' }}&gt;&#13;&#10;  &lt;div style={{ flexShrink: 0 }}&gt;&#13;&#10;    &lt;div style={{ color: '#BD9B56', fontSize: 13, letterSpacing: '0.25em', marginBottom: 6 }}&gt;04 · 总结与展望&lt;/div&gt;&#13;&#10;    &lt;h2 style={{ fontSize: 30, fontWeight: 'bold', color: '#172133', margin: 0, lineHeight: 1.3 }}&gt;技术路线回顾：八个阶段 · 从 0 到上线&lt;/h2&gt;&#13;&#10;    &lt;div style={{ fontSize: 14, color: '#6b7075', marginTop: 6 }}&gt;每个阶段都有代码、测试、可运行交付，循序渐进验证&lt;/div&gt;&#13;&#10;  &lt;/div&gt;&#13;&#10;  &lt;div style={{ flex: 1, display: 'flex', alignItems: 'center', justifyContent: 'center' }}&gt;&#13;&#10;    &lt;div style={{ width: '100%', background: '#fff', borderRadius: 12, padding: '30px 26px', boxShadow: '0 6px 24px rgba(23,33,51,0.08)' }}&gt;&#13;&#10;      &lt;svg width=&quot;1100&quot; height=&quot;300&quot; viewBox=&quot;0 0 1100 300&quot;&gt;&#13;&#10;        &lt;g fontFamily=&quot;Inter, sans-serif&quot;&gt;&#13;&#10;          {/* 主时间轴 */}&#13;&#10;          &lt;line x1=&quot;60&quot; y1=&quot;70&quot; x2=&quot;1060&quot; y2=&quot;70&quot; stroke=&quot;#22395E&quot; strokeWidth=&quot;2.5&quot; /&gt;&#13;&#10;          {[&#13;&#10;            ['P0', '项目初始化', '仓库 · Docker · CI'],&#13;&#10;            ['P1', '数据库', '21 表 + 仿真数据'],&#13;&#10;            ['P2', '后端', 'FastAPI 三层'],&#13;&#10;            ['P3', '前端', '三端 + PWA'],&#13;&#10;            ['P4', 'AI Agent', '多意图 + 状态机'],&#13;&#10;            ['P5', 'RAG', '向量化检索'],&#13;&#10;            ['P6', '评估', 'Intent/Tool/RAG'],&#13;&#10;            ['P7', '部署', '已上线'],&#13;&#10;          ].map(([p, t, d], i) =&gt; {&#13;&#10;            const cx = 60 + i * 143&#13;&#10;            return (&#13;&#10;              &lt;g key={p}&gt;&#13;&#10;                {/* 节点圆 */}&#13;&#10;                &lt;circle cx={cx} cy={70} r=&quot;9&quot; fill=&quot;#BD9B56&quot; /&gt;&#13;&#10;                &lt;circle cx={cx} cy={70} r=&quot;14&quot; fill=&quot;none&quot; stroke=&quot;#BD9B56&quot; strokeWidth=&quot;1.5&quot; strokeOpacity=&quot;0.35&quot; /&gt;&#13;&#10;                {/* 阶段标签 */}&#13;&#10;                &lt;text x={cx} y={46} textAnchor=&quot;middle&quot; fontSize=&quot;13&quot; fontWeight=&quot;bold&quot; fill=&quot;#BD9B56&quot;&gt;{p}&lt;/text&gt;&#13;&#10;                {/* 阶段名 */}&#13;&#10;                &lt;text x={cx} y={112} textAnchor=&quot;middle&quot; fontSize=&quot;15&quot; fontWeight=&quot;bold&quot; fill=&quot;#172133&quot;&gt;{t}&lt;/text&gt;&#13;&#10;                {/* 描述 */}&#13;&#10;                &lt;text x={cx} y={134} textAnchor=&quot;middle&quot; fontSize=&quot;11.5&quot; fill=&quot;#5F5E5A&quot;&gt;{d}&lt;/text&gt;&#13;&#10;                {/* 下方小圆点连接 */}&#13;&#10;                &lt;line x1={cx} y1={79} x2={cx} y2={100} stroke=&quot;#BD9B56&quot; strokeWidth=&quot;1.5&quot; strokeOpacity=&quot;0.5&quot; /&gt;&#13;&#10;              &lt;/g&gt;&#13;&#10;            )&#13;&#10;          })}&#13;&#10;        &lt;/g&gt;&#13;&#10;      &lt;/svg&gt;&#13;&#10;      &lt;div style={{ marginTop: 16, display: 'flex', gap: 14 }}&gt;&#13;&#10;        &lt;div style={{ flex: 1, background: 'rgba(189,155,86,0.08)', borderRadius: 8, padding: '12px 14px', borderLeft: '3px solid #BD9B56' }}&gt;&#13;&#10;          &lt;div style={{ fontSize: 13, color: '#BD9B56', fontWeight: 'bold', marginBottom: 5 }}&gt;P1 · 数据一致性&lt;/div&gt;&#13;&#10;          &lt;p style={{ fontSize: 12, color: '#5F5E5A', margin: 0, lineHeight: 1.5 }}&gt;8 栋 / 1664 套 / 746 账单，外键关联保证一致，8 个 SQL 可复现&lt;/p&gt;&#13;&#10;        &lt;/div&gt;&#13;&#10;        &lt;div style={{ flex: 1, background: 'rgba(189,155,86,0.08)', borderRadius: 8, padding: '12px 14px', borderLeft: '3px solid #BD9B56' }}&gt;&#13;&#10;          &lt;div style={{ fontSize: 13, color: '#BD9B56', fontWeight: 'bold', marginBottom: 5 }}&gt;P4 · 多轮状态机&lt;/div&gt;&#13;&#10;          &lt;p style={{ fontSize: 12, color: '#5F5E5A', margin: 0, lineHeight: 1.5 }}&gt;报修主动追问缺省字段，避免生成残缺工单&lt;/p&gt;&#13;&#10;        &lt;/div&gt;&#13;&#10;        &lt;div style={{ flex: 1, background: 'rgba(189,155,86,0.08)', borderRadius: 8, padding: '12px 14px', borderLeft: '3px solid #BD9B56' }}&gt;&#13;&#10;          &lt;div style={{ fontSize: 13, color: '#BD9B56', fontWeight: 'bold', marginBottom: 5 }}&gt;P6 · 评估找 bug&lt;/div&gt;&#13;&#10;          &lt;p style={{ fontSize: 12, color: '#5F5E5A', margin: 0, lineHeight: 1.5 }}&gt;意图 83.33%→100%、答案 50%→100%，数据驱动优化&lt;/p&gt;&#13;&#10;        &lt;/div&gt;&#13;&#10;        &lt;div style={{ flex: 1, background: 'rgba(189,155,86,0.08)', borderRadius: 8, padding: '12px 14px', borderLeft: '3px solid #BD9B56' }}&gt;&#13;&#10;          &lt;div style={{ fontSize: 13, color: '#BD9B56', fontWeight: 'bold', marginBottom: 5 }}&gt;P7 · 部署踩坑&lt;/div&gt;&#13;&#10;          &lt;p style={{ fontSize: 12, color: '#5F5E5A', margin: 0, lineHeight: 1.5 }}&gt;国内镜像源、SECRET_KEY、端口映射逐一踩平&lt;/p&gt;&#13;&#10;        &lt;/div&gt;&#13;&#10;      &lt;/div&gt;&#13;&#10;    &lt;/div&gt;&#13;&#10;  &lt;/div&gt;&#13;&#10;  &lt;div style={{ flexShrink: 0, height: 40, display: 'flex', alignItems: 'flex-end', justifyContent: 'space-between' }}&gt;&#13;&#10;    &lt;span style={{ color: '#BD9B56', fontSize: 12, letterSpacing: '0.1em' }}&gt;云溪花园 · 智慧社区&lt;/span&gt;&#13;&#10;    &lt;span style={{ color: '#a09b8c', fontSize: 12 }}&gt;17 / 19&lt;/span&gt;&#13;&#10;  &lt;/div&gt;&#13;&#10;&lt;/Slide&gt;"/>
+        <p:cNvPr id="221" name="" descr="&lt;Slide style={{ width: '1280px', height: '720px', background: '#FBFCFA', position: 'relative', padding: '36px 64px', boxSizing: 'border-box', display: 'flex', flexDirection: 'column' }}&gt;&#13;&#10;  &lt;div style={{ flexShrink: 0 }}&gt;&#13;&#10;    &lt;div style={{ color: '#BD9B56', fontSize: 13, letterSpacing: '0.25em', marginBottom: 6 }}&gt;04 · 总结与展望&lt;/div&gt;&#13;&#10;    &lt;h2 style={{ fontSize: 30, fontWeight: 'bold', color: '#172133', margin: 0, lineHeight: 1.3 }}&gt;技术路线回顾：八个阶段 · 从 0 到上线&lt;/h2&gt;&#13;&#10;    &lt;div style={{ fontSize: 14, color: '#6b7075', marginTop: 6 }}&gt;每个阶段都有代码、测试、可运行交付，循序渐进验证&lt;/div&gt;&#13;&#10;  &lt;/div&gt;&#13;&#10;  &lt;div style={{ flex: 1, display: 'flex', alignItems: 'center', justifyContent: 'center' }}&gt;&#13;&#10;    &lt;div style={{ width: '100%', background: '#fff', borderRadius: 12, padding: '30px 26px', boxShadow: '0 6px 24px rgba(23,33,51,0.08)' }}&gt;&#13;&#10;      &lt;svg width=&quot;1100&quot; height=&quot;300&quot; viewBox=&quot;0 0 1100 300&quot;&gt;&#13;&#10;        &lt;g fontFamily=&quot;Inter, sans-serif&quot;&gt;&#13;&#10;          {/* 主时间轴 */}&#13;&#10;          &lt;line x1=&quot;60&quot; y1=&quot;70&quot; x2=&quot;1060&quot; y2=&quot;70&quot; stroke=&quot;#22395E&quot; strokeWidth=&quot;2.5&quot; /&gt;&#13;&#10;          {[&#13;&#10;            ['P0', '项目初始化', '仓库 · Docker · CI'],&#13;&#10;            ['P1', '数据库', '21 表 + 仿真数据'],&#13;&#10;            ['P2', '后端', 'FastAPI 三层'],&#13;&#10;            ['P3', '前端', '三端 + PWA'],&#13;&#10;            ['P4', 'AI Agent', '多意图 + 状态机'],&#13;&#10;            ['P5', 'RAG', '向量化检索'],&#13;&#10;            ['P6', '评估', 'Intent/Tool/RAG'],&#13;&#10;            ['P7', '部署', '已上线'],&#13;&#10;          ].map(([p, t, d], i) =&gt; {&#13;&#10;            const cx = 60 + i * 143&#13;&#10;            return (&#13;&#10;              &lt;g key={p}&gt;&#13;&#10;                {/* 节点圆 */}&#13;&#10;                &lt;circle cx={cx} cy={70} r=&quot;9&quot; fill=&quot;#BD9B56&quot; /&gt;&#13;&#10;                &lt;circle cx={cx} cy={70} r=&quot;14&quot; fill=&quot;none&quot; stroke=&quot;#BD9B56&quot; strokeWidth=&quot;1.5&quot; strokeOpacity=&quot;0.35&quot; /&gt;&#13;&#10;                {/* 阶段标签 */}&#13;&#10;                &lt;text x={cx} y={46} textAnchor=&quot;middle&quot; fontSize=&quot;13&quot; fontWeight=&quot;bold&quot; fill=&quot;#BD9B56&quot;&gt;{p}&lt;/text&gt;&#13;&#10;                {/* 阶段名 */}&#13;&#10;                &lt;text x={cx} y={112} textAnchor=&quot;middle&quot; fontSize=&quot;15&quot; fontWeight=&quot;bold&quot; fill=&quot;#172133&quot;&gt;{t}&lt;/text&gt;&#13;&#10;                {/* 描述 */}&#13;&#10;                &lt;text x={cx} y={134} textAnchor=&quot;middle&quot; fontSize=&quot;11.5&quot; fill=&quot;#5F5E5A&quot;&gt;{d}&lt;/text&gt;&#13;&#10;                {/* 下方小圆点连接 */}&#13;&#10;                &lt;line x1={cx} y1={79} x2={cx} y2={100} stroke=&quot;#BD9B56&quot; strokeWidth=&quot;1.5&quot; strokeOpacity=&quot;0.5&quot; /&gt;&#13;&#10;              &lt;/g&gt;&#13;&#10;            )&#13;&#10;          })}&#13;&#10;        &lt;/g&gt;&#13;&#10;      &lt;/svg&gt;&#13;&#10;      &lt;div style={{ marginTop: 16, display: 'flex', gap: 14 }}&gt;&#13;&#10;        &lt;div style={{ flex: 1, background: 'rgba(189,155,86,0.08)', borderRadius: 8, padding: '12px 14px', borderLeft: '3px solid #BD9B56' }}&gt;&#13;&#10;          &lt;div style={{ fontSize: 13, color: '#BD9B56', fontWeight: 'bold', marginBottom: 5 }}&gt;P1 · 数据一致性&lt;/div&gt;&#13;&#10;          &lt;p style={{ fontSize: 12, color: '#5F5E5A', margin: 0, lineHeight: 1.5 }}&gt;8 栋 / 1664 套 / 746 账单，外键关联保证一致，8 个 SQL 可复现&lt;/p&gt;&#13;&#10;        &lt;/div&gt;&#13;&#10;        &lt;div style={{ flex: 1, background: 'rgba(189,155,86,0.08)', borderRadius: 8, padding: '12px 14px', borderLeft: '3px solid #BD9B56' }}&gt;&#13;&#10;          &lt;div style={{ fontSize: 13, color: '#BD9B56', fontWeight: 'bold', marginBottom: 5 }}&gt;P4 · 多轮状态机&lt;/div&gt;&#13;&#10;          &lt;p style={{ fontSize: 12, color: '#5F5E5A', margin: 0, lineHeight: 1.5 }}&gt;报修主动追问缺省字段，避免生成残缺工单&lt;/p&gt;&#13;&#10;        &lt;/div&gt;&#13;&#10;        &lt;div style={{ flex: 1, background: 'rgba(189,155,86,0.08)', borderRadius: 8, padding: '12px 14px', borderLeft: '3px solid #BD9B56' }}&gt;&#13;&#10;          &lt;div style={{ fontSize: 13, color: '#BD9B56', fontWeight: 'bold', marginBottom: 5 }}&gt;P6 · 评估找 bug&lt;/div&gt;&#13;&#10;          &lt;p style={{ fontSize: 12, color: '#5F5E5A', margin: 0, lineHeight: 1.5 }}&gt;意图 83.33%→100%、答案 50%→100%，数据驱动优化&lt;/p&gt;&#13;&#10;        &lt;/div&gt;&#13;&#10;        &lt;div style={{ flex: 1, background: 'rgba(189,155,86,0.08)', borderRadius: 8, padding: '12px 14px', borderLeft: '3px solid #BD9B56' }}&gt;&#13;&#10;          &lt;div style={{ fontSize: 13, color: '#BD9B56', fontWeight: 'bold', marginBottom: 5 }}&gt;P7 · 部署踩坑&lt;/div&gt;&#13;&#10;          &lt;p style={{ fontSize: 12, color: '#5F5E5A', margin: 0, lineHeight: 1.5 }}&gt;国内镜像源、SECRET_KEY、端口映射逐一踩平&lt;/p&gt;&#13;&#10;        &lt;/div&gt;&#13;&#10;      &lt;/div&gt;&#13;&#10;    &lt;/div&gt;&#13;&#10;  &lt;/div&gt;&#13;&#10;  &lt;div style={{ flexShrink: 0, height: 40, display: 'flex', alignItems: 'flex-end', justifyContent: 'space-between' }}&gt;&#13;&#10;    &lt;span style={{ color: '#BD9B56', fontSize: 12, letterSpacing: '0.1em' }}&gt;云溪花园 · 智慧社区&lt;/span&gt;&#13;&#10;    &lt;span style={{ color: '#a09b8c', fontSize: 12 }}&gt;17 / 19&lt;/span&gt;&#13;&#10;  &lt;/div&gt;&#13;&#10;&lt;/Slide&gt;"/>
         <p:cNvGrpSpPr/>
         <p:nvPr/>
       </p:nvGrpSpPr>
@@ -10030,7 +10289,7 @@
       </p:grpSpPr>
       <p:sp>
         <p:nvSpPr>
-          <p:cNvPr id="212" name=""/>
+          <p:cNvPr id="222" name=""/>
           <p:cNvSpPr/>
           <p:nvPr/>
         </p:nvSpPr>
@@ -10054,7 +10313,7 @@
       </p:sp>
       <p:sp>
         <p:nvSpPr>
-          <p:cNvPr id="213" name="" descr="{&quot;isTemplate&quot;:true,&quot;type&quot;:&quot;text&quot;}"/>
+          <p:cNvPr id="223" name="" descr="{&quot;isTemplate&quot;:true,&quot;type&quot;:&quot;text&quot;}"/>
           <p:cNvSpPr txBox="1"/>
           <p:nvPr/>
         </p:nvSpPr>
@@ -10099,7 +10358,7 @@
       </p:sp>
       <p:sp>
         <p:nvSpPr>
-          <p:cNvPr id="214" name="" descr="{&quot;isTemplate&quot;:true,&quot;type&quot;:&quot;text&quot;}"/>
+          <p:cNvPr id="224" name="" descr="{&quot;isTemplate&quot;:true,&quot;type&quot;:&quot;text&quot;}"/>
           <p:cNvSpPr txBox="1"/>
           <p:nvPr/>
         </p:nvSpPr>
@@ -10174,7 +10433,7 @@
       </p:sp>
       <p:sp>
         <p:nvSpPr>
-          <p:cNvPr id="215" name="" descr="{&quot;isTemplate&quot;:true,&quot;type&quot;:&quot;text&quot;}"/>
+          <p:cNvPr id="225" name="" descr="{&quot;isTemplate&quot;:true,&quot;type&quot;:&quot;text&quot;}"/>
           <p:cNvSpPr txBox="1"/>
           <p:nvPr/>
         </p:nvSpPr>
@@ -10209,7 +10468,7 @@
       </p:sp>
       <p:sp>
         <p:nvSpPr>
-          <p:cNvPr id="216" name=""/>
+          <p:cNvPr id="226" name=""/>
           <p:cNvSpPr/>
           <p:nvPr/>
         </p:nvSpPr>
@@ -10242,7 +10501,7 @@
       </p:sp>
       <p:pic>
         <p:nvPicPr>
-          <p:cNvPr id="217" name=""/>
+          <p:cNvPr id="227" name=""/>
           <p:cNvPicPr>
             <a:picLocks noChangeAspect="1"/>
           </p:cNvPicPr>
@@ -10273,7 +10532,7 @@
       </p:pic>
       <p:sp>
         <p:nvSpPr>
-          <p:cNvPr id="218" name=""/>
+          <p:cNvPr id="228" name=""/>
           <p:cNvSpPr/>
           <p:nvPr/>
         </p:nvSpPr>
@@ -10301,7 +10560,7 @@
       </p:sp>
       <p:sp>
         <p:nvSpPr>
-          <p:cNvPr id="219" name=""/>
+          <p:cNvPr id="229" name=""/>
           <p:cNvSpPr/>
           <p:nvPr/>
         </p:nvSpPr>
@@ -10358,7 +10617,7 @@
       </p:sp>
       <p:sp>
         <p:nvSpPr>
-          <p:cNvPr id="220" name="" descr="{&quot;isTemplate&quot;:true,&quot;type&quot;:&quot;text&quot;}"/>
+          <p:cNvPr id="230" name="" descr="{&quot;isTemplate&quot;:true,&quot;type&quot;:&quot;text&quot;}"/>
           <p:cNvSpPr txBox="1"/>
           <p:nvPr/>
         </p:nvSpPr>
@@ -10403,7 +10662,7 @@
       </p:sp>
       <p:sp>
         <p:nvSpPr>
-          <p:cNvPr id="221" name="" descr="{&quot;isTemplate&quot;:true,&quot;type&quot;:&quot;text&quot;}"/>
+          <p:cNvPr id="231" name="" descr="{&quot;isTemplate&quot;:true,&quot;type&quot;:&quot;text&quot;}"/>
           <p:cNvSpPr txBox="1"/>
           <p:nvPr/>
         </p:nvSpPr>
@@ -10530,7 +10789,7 @@
       </p:sp>
       <p:sp>
         <p:nvSpPr>
-          <p:cNvPr id="222" name=""/>
+          <p:cNvPr id="232" name=""/>
           <p:cNvSpPr/>
           <p:nvPr/>
         </p:nvSpPr>
@@ -10558,7 +10817,7 @@
       </p:sp>
       <p:sp>
         <p:nvSpPr>
-          <p:cNvPr id="223" name=""/>
+          <p:cNvPr id="233" name=""/>
           <p:cNvSpPr/>
           <p:nvPr/>
         </p:nvSpPr>
@@ -10615,7 +10874,7 @@
       </p:sp>
       <p:sp>
         <p:nvSpPr>
-          <p:cNvPr id="224" name="" descr="{&quot;isTemplate&quot;:true,&quot;type&quot;:&quot;text&quot;}"/>
+          <p:cNvPr id="234" name="" descr="{&quot;isTemplate&quot;:true,&quot;type&quot;:&quot;text&quot;}"/>
           <p:cNvSpPr txBox="1"/>
           <p:nvPr/>
         </p:nvSpPr>
@@ -10660,7 +10919,7 @@
       </p:sp>
       <p:sp>
         <p:nvSpPr>
-          <p:cNvPr id="225" name="" descr="{&quot;isTemplate&quot;:true,&quot;type&quot;:&quot;text&quot;}"/>
+          <p:cNvPr id="235" name="" descr="{&quot;isTemplate&quot;:true,&quot;type&quot;:&quot;text&quot;}"/>
           <p:cNvSpPr txBox="1"/>
           <p:nvPr/>
         </p:nvSpPr>
@@ -10695,7 +10954,7 @@
       </p:sp>
       <p:sp>
         <p:nvSpPr>
-          <p:cNvPr id="226" name=""/>
+          <p:cNvPr id="236" name=""/>
           <p:cNvSpPr/>
           <p:nvPr/>
         </p:nvSpPr>
@@ -10723,7 +10982,7 @@
       </p:sp>
       <p:sp>
         <p:nvSpPr>
-          <p:cNvPr id="227" name=""/>
+          <p:cNvPr id="237" name=""/>
           <p:cNvSpPr/>
           <p:nvPr/>
         </p:nvSpPr>
@@ -10780,7 +11039,7 @@
       </p:sp>
       <p:sp>
         <p:nvSpPr>
-          <p:cNvPr id="228" name="" descr="{&quot;isTemplate&quot;:true,&quot;type&quot;:&quot;text&quot;}"/>
+          <p:cNvPr id="238" name="" descr="{&quot;isTemplate&quot;:true,&quot;type&quot;:&quot;text&quot;}"/>
           <p:cNvSpPr txBox="1"/>
           <p:nvPr/>
         </p:nvSpPr>
@@ -10835,7 +11094,7 @@
       </p:sp>
       <p:sp>
         <p:nvSpPr>
-          <p:cNvPr id="229" name="" descr="{&quot;isTemplate&quot;:true,&quot;type&quot;:&quot;text&quot;}"/>
+          <p:cNvPr id="239" name="" descr="{&quot;isTemplate&quot;:true,&quot;type&quot;:&quot;text&quot;}"/>
           <p:cNvSpPr txBox="1"/>
           <p:nvPr/>
         </p:nvSpPr>
@@ -10912,7 +11171,7 @@
       </p:sp>
       <p:sp>
         <p:nvSpPr>
-          <p:cNvPr id="230" name=""/>
+          <p:cNvPr id="240" name=""/>
           <p:cNvSpPr/>
           <p:nvPr/>
         </p:nvSpPr>
@@ -10940,7 +11199,7 @@
       </p:sp>
       <p:sp>
         <p:nvSpPr>
-          <p:cNvPr id="231" name=""/>
+          <p:cNvPr id="241" name=""/>
           <p:cNvSpPr/>
           <p:nvPr/>
         </p:nvSpPr>
@@ -10997,7 +11256,7 @@
       </p:sp>
       <p:sp>
         <p:nvSpPr>
-          <p:cNvPr id="232" name="" descr="{&quot;isTemplate&quot;:true,&quot;type&quot;:&quot;text&quot;}"/>
+          <p:cNvPr id="242" name="" descr="{&quot;isTemplate&quot;:true,&quot;type&quot;:&quot;text&quot;}"/>
           <p:cNvSpPr txBox="1"/>
           <p:nvPr/>
         </p:nvSpPr>
@@ -11042,7 +11301,7 @@
       </p:sp>
       <p:sp>
         <p:nvSpPr>
-          <p:cNvPr id="233" name="" descr="{&quot;isTemplate&quot;:true,&quot;type&quot;:&quot;text&quot;}"/>
+          <p:cNvPr id="243" name="" descr="{&quot;isTemplate&quot;:true,&quot;type&quot;:&quot;text&quot;}"/>
           <p:cNvSpPr txBox="1"/>
           <p:nvPr/>
         </p:nvSpPr>
@@ -11099,7 +11358,7 @@
       </p:sp>
       <p:sp>
         <p:nvSpPr>
-          <p:cNvPr id="234" name="" descr="{&quot;isTemplate&quot;:true,&quot;type&quot;:&quot;text&quot;}"/>
+          <p:cNvPr id="244" name="" descr="{&quot;isTemplate&quot;:true,&quot;type&quot;:&quot;text&quot;}"/>
           <p:cNvSpPr txBox="1"/>
           <p:nvPr/>
         </p:nvSpPr>
@@ -11154,7 +11413,7 @@
       </p:sp>
       <p:sp>
         <p:nvSpPr>
-          <p:cNvPr id="235" name="" descr="{&quot;isTemplate&quot;:true,&quot;type&quot;:&quot;text&quot;}"/>
+          <p:cNvPr id="245" name="" descr="{&quot;isTemplate&quot;:true,&quot;type&quot;:&quot;text&quot;}"/>
           <p:cNvSpPr txBox="1"/>
           <p:nvPr/>
         </p:nvSpPr>
@@ -11197,7 +11456,7 @@
   <p:cSld>
     <p:spTree>
       <p:nvGrpSpPr>
-        <p:cNvPr id="236" name="" descr="&lt;Slide style={{ width: '1280px', height: '720px', background: '#FBFCFA', position: 'relative', padding: '26px 52px', boxSizing: 'border-box', display: 'flex', flexDirection: 'column' }}&gt;&#13;&#10;  &lt;div style={{ flexShrink: 0 }}&gt;&#13;&#10;    &lt;div style={{ color: '#BD9B56', fontSize: 12, letterSpacing: '0.25em', marginBottom: 4 }}&gt;04 · 总结与展望&lt;/div&gt;&#13;&#10;    &lt;h2 style={{ fontSize: 25, fontWeight: 'bold', color: '#172133', margin: 0, lineHeight: 1.2 }}&gt;三端功能 × 实现技术：每个功能怎么做出来的&lt;/h2&gt;&#13;&#10;  &lt;/div&gt;&#13;&#10;  &lt;div style={{ flex: 1, display: 'flex', alignItems: 'stretch', gap: 18, marginTop: 10 }}&gt;&#13;&#10;    {/* 左栏：三端功能实现 */}&#13;&#10;    &lt;div style={{ flex: 1, display: 'flex', flexDirection: 'column', gap: 8 }}&gt;&#13;&#10;      {/* 业主端 */}&#13;&#10;      &lt;div style={{ background: '#fff', borderRadius: 10, padding: '10px 14px', boxShadow: '0 4px 16px rgba(23,33,51,0.06)' }}&gt;&#13;&#10;        &lt;div style={{ display: 'flex', alignItems: 'center', gap: 8, marginBottom: 6 }}&gt;&#13;&#10;          &lt;span style={{ fontSize: 14, fontWeight: 'bold', color: '#172133' }}&gt;业主端&lt;/span&gt;&#13;&#10;          &lt;span style={{ fontSize: 10.5, color: '#BD9B56', background: 'rgba(189,155,86,0.12)', padding: '2px 7px', borderRadius: 4 }}&gt;ToC · Owner&lt;/span&gt;&#13;&#10;        &lt;/div&gt;&#13;&#10;        &lt;div style={{ display: 'flex', flexDirection: 'column', gap: 3.5 }}&gt;&#13;&#10;          &lt;div style={{ display: 'flex', gap: 8, alignItems: 'baseline', fontSize: 11.5, lineHeight: 1.4 }}&gt;&lt;span style={{ color: '#172133', fontWeight: 'bold', minWidth: 56 }}&gt;AI 助手&lt;/span&gt;&lt;span style={{ color: '#6b7075' }}&gt;LangGraph 多 Agent：Personal 对话 → Router 意图识别 → Domain 工具调用&lt;/span&gt;&lt;/div&gt;&#13;&#10;          &lt;div style={{ display: 'flex', gap: 8, alignItems: 'baseline', fontSize: 11.5, lineHeight: 1.4 }}&gt;&lt;span style={{ color: '#172133', fontWeight: 'bold', minWidth: 56 }}&gt;对话报修&lt;/span&gt;&lt;span style={{ color: '#6b7075' }}&gt;Repair Agent · 多轮状态机补全房屋/类型 · 自动派单（技能+在岗+工号）&lt;/span&gt;&lt;/div&gt;&#13;&#10;          &lt;div style={{ display: 'flex', gap: 8, alignItems: 'baseline', fontSize: 11.5, lineHeight: 1.4 }}&gt;&lt;span style={{ color: '#172133', fontWeight: 'bold', minWidth: 56 }}&gt;缴费查询&lt;/span&gt;&lt;span style={{ color: '#6b7075' }}&gt;Fee Agent 查 fee_bills 账单表 · 返回金额/状态/截止日&lt;/span&gt;&lt;/div&gt;&#13;&#10;          &lt;div style={{ display: 'flex', gap: 8, alignItems: 'baseline', fontSize: 11.5, lineHeight: 1.4 }}&gt;&lt;span style={{ color: '#172133', fontWeight: 'bold', minWidth: 56 }}&gt;公告&lt;/span&gt;&lt;span style={{ color: '#6b7075' }}&gt;公告列表 + AI 摘要（LLM 提炼要点）&lt;/span&gt;&lt;/div&gt;&#13;&#10;          &lt;div style={{ display: 'flex', gap: 8, alignItems: 'baseline', fontSize: 11.5, lineHeight: 1.4 }}&gt;&lt;span style={{ color: '#172133', fontWeight: 'bold', minWidth: 56 }}&gt;我的工单&lt;/span&gt;&lt;span style={{ color: '#6b7075' }}&gt;repair_order 状态追踪（创建→派单→接单→完成→关闭）&lt;/span&gt;&lt;/div&gt;&#13;&#10;          &lt;div style={{ display: 'flex', gap: 8, alignItems: 'baseline', fontSize: 11.5, lineHeight: 1.4 }}&gt;&lt;span style={{ color: '#172133', fontWeight: 'bold', minWidth: 56 }}&gt;问题上报&lt;/span&gt;&lt;span style={{ color: '#6b7075' }}&gt;IssueReport 上报 · 附图片 · 物业答复&lt;/span&gt;&lt;/div&gt;&#13;&#10;        &lt;/div&gt;&#13;&#10;      &lt;/div&gt;&#13;&#10;      {/* 物业端 */}&#13;&#10;      &lt;div style={{ background: '#fff', borderRadius: 10, padding: '10px 14px', boxShadow: '0 4px 16px rgba(23,33,51,0.06)' }}&gt;&#13;&#10;        &lt;div style={{ display: 'flex', alignItems: 'center', gap: 8, marginBottom: 6 }}&gt;&#13;&#10;          &lt;span style={{ fontSize: 14, fontWeight: 'bold', color: '#172133' }}&gt;物业端&lt;/span&gt;&#13;&#10;          &lt;span style={{ fontSize: 10.5, color: '#BD9B56', background: 'rgba(189,155,86,0.12)', padding: '2px 7px', borderRadius: 4 }}&gt;ToB · Admin/Staff&lt;/span&gt;&#13;&#10;        &lt;/div&gt;&#13;&#10;        &lt;div style={{ display: 'flex', flexDirection: 'column', gap: 3.5 }}&gt;&#13;&#10;          &lt;div style={{ display: 'flex', gap: 8, alignItems: 'baseline', fontSize: 11.5, lineHeight: 1.4 }}&gt;&lt;span style={{ color: '#172133', fontWeight: 'bold', minWidth: 56 }}&gt;数据看板&lt;/span&gt;&lt;span style={{ color: '#6b7075' }}&gt;统计聚合 API · 今日报修/处理中/已完成实时汇总&lt;/span&gt;&lt;/div&gt;&#13;&#10;          &lt;div style={{ display: 'flex', gap: 8, alignItems: 'baseline', fontSize: 11.5, lineHeight: 1.4 }}&gt;&lt;span style={{ color: '#172133', fontWeight: 'bold', minWidth: 56 }}&gt;工单管理&lt;/span&gt;&lt;span style={{ color: '#6b7075' }}&gt;repair_order CRUD · 状态流转 · 人工派单/改派&lt;/span&gt;&lt;/div&gt;&#13;&#10;          &lt;div style={{ display: 'flex', gap: 8, alignItems: 'baseline', fontSize: 11.5, lineHeight: 1.4 }}&gt;&lt;span style={{ color: '#172133', fontWeight: 'bold', minWidth: 56 }}&gt;用户/房屋&lt;/span&gt;&lt;span style={{ color: '#6b7075' }}&gt;user / house / house_binding 绑定关系管理&lt;/span&gt;&lt;/div&gt;&#13;&#10;          &lt;div style={{ display: 'flex', gap: 8, alignItems: 'baseline', fontSize: 11.5, lineHeight: 1.4 }}&gt;&lt;span style={{ color: '#172133', fontWeight: 'bold', minWidth: 56 }}&gt;公告 AI 生成&lt;/span&gt;&lt;span style={{ color: '#6b7075' }}&gt;Notice Agent + LLM 生成标题/正文/影响范围 · 人工审核发布&lt;/span&gt;&lt;/div&gt;&#13;&#10;          &lt;div style={{ display: 'flex', gap: 8, alignItems: 'baseline', fontSize: 11.5, lineHeight: 1.4 }}&gt;&lt;span style={{ color: '#172133', fontWeight: 'bold', minWidth: 56 }}&gt;巡检管理&lt;/span&gt;&lt;span style={{ color: '#6b7075' }}&gt;摄像头抓拍 → 视觉模型识别异常 → 巡检记录 + 告警&lt;/span&gt;&lt;/div&gt;&#13;&#10;          &lt;div style={{ display: 'flex', gap: 8, alignItems: 'baseline', fontSize: 11.5, lineHeight: 1.4 }}&gt;&lt;span style={{ color: '#172133', fontWeight: 'bold', minWidth: 56 }}&gt;知识缺口审核&lt;/span&gt;&lt;span style={{ color: '#6b7075' }}&gt;knowledge_gap 审核 → 通过自动写入 pgvector 知识库&lt;/span&gt;&lt;/div&gt;&#13;&#10;        &lt;/div&gt;&#13;&#10;      &lt;/div&gt;&#13;&#10;      {/* 维修端 */}&#13;&#10;      &lt;div style={{ background: '#fff', borderRadius: 10, padding: '10px 14px', boxShadow: '0 4px 16px rgba(23,33,51,0.06)' }}&gt;&#13;&#10;        &lt;div style={{ display: 'flex', alignItems: 'center', gap: 8, marginBottom: 6 }}&gt;&#13;&#10;          &lt;span style={{ fontSize: 14, fontWeight: 'bold', color: '#172133' }}&gt;维修端&lt;/span&gt;&#13;&#10;          &lt;span style={{ fontSize: 10.5, color: '#BD9B56', background: 'rgba(189,155,86,0.12)', padding: '2px 7px', borderRadius: 4 }}&gt;ToC · Worker&lt;/span&gt;&#13;&#10;        &lt;/div&gt;&#13;&#10;        &lt;div style={{ display: 'flex', flexDirection: 'column', gap: 3.5 }}&gt;&#13;&#10;          &lt;div style={{ display: 'flex', gap: 8, alignItems: 'baseline', fontSize: 11.5, lineHeight: 1.4 }}&gt;&lt;span style={{ color: '#172133', fontWeight: 'bold', minWidth: 56 }}&gt;任务列表&lt;/span&gt;&lt;span style={{ color: '#6b7075' }}&gt;自动派单后查询「我的待处理」工单&lt;/span&gt;&lt;/div&gt;&#13;&#10;          &lt;div style={{ display: 'flex', gap: 8, alignItems: 'baseline', fontSize: 11.5, lineHeight: 1.4 }}&gt;&lt;span style={{ color: '#172133', fontWeight: 'bold', minWidth: 56 }}&gt;接单/处理/完成&lt;/span&gt;&lt;span style={{ color: '#6b7075' }}&gt;状态机流转 · 每步触发实时通知&lt;/span&gt;&lt;/div&gt;&#13;&#10;          &lt;div style={{ display: 'flex', gap: 8, alignItems: 'baseline', fontSize: 11.5, lineHeight: 1.4 }}&gt;&lt;span style={{ color: '#172133', fontWeight: 'bold', minWidth: 56 }}&gt;消息&lt;/span&gt;&lt;span style={{ color: '#6b7075' }}&gt;事件驱动通知（派单/答复/完成）&lt;/span&gt;&lt;/div&gt;&#13;&#10;          &lt;div style={{ display: 'flex', gap: 8, alignItems: 'baseline', fontSize: 11.5, lineHeight: 1.4 }}&gt;&lt;span style={{ color: '#172133', fontWeight: 'bold', minWidth: 56 }}&gt;巡检任务&lt;/span&gt;&lt;span style={{ color: '#6b7075' }}&gt;巡检记录查看 · 异常处理&lt;/span&gt;&lt;/div&gt;&#13;&#10;        &lt;/div&gt;&#13;&#10;      &lt;/div&gt;&#13;&#10;    &lt;/div&gt;&#13;&#10;    {/* 右栏：自维护 + Demo */}&#13;&#10;    &lt;div style={{ flex: '0 0 285px', display: 'flex', flexDirection: 'column', gap: 10 }}&gt;&#13;&#10;      &lt;div style={{ background: 'linear-gradient(135deg, #172133 0%, #22395E 100%)', borderRadius: 12, padding: '16px 18px', color: '#FBFCFA', display: 'flex', flexDirection: 'column', gap: 9 }}&gt;&#13;&#10;        &lt;div style={{ color: '#BD9B56', fontSize: 12, letterSpacing: '0.2em' }}&gt;系统自维护自更新&lt;/div&gt;&#13;&#10;        &lt;div style={{ display: 'flex', flexDirection: 'column', gap: 6, fontSize: 11.5, lineHeight: 1.45 }}&gt;&#13;&#10;          &lt;div&gt;&lt;span style={{ color: '#BD9B56', fontWeight: 'bold' }}&gt;定时清理&lt;/span&gt;&lt;span style={{ color: 'rgba(251,252,250,0.8)' }}&gt;　APScheduler 每日清过期数据/孤儿文件&lt;/span&gt;&lt;/div&gt;&#13;&#10;          &lt;div&gt;&lt;span style={{ color: '#BD9B56', fontWeight: 'bold' }}&gt;巡检自动化&lt;/span&gt;&lt;span style={{ color: 'rgba(251,252,250,0.8)' }}&gt;　定时抓拍 + 视觉识别异常&lt;/span&gt;&lt;/div&gt;&#13;&#10;          &lt;div&gt;&lt;span style={{ color: '#BD9B56', fontWeight: 'bold' }}&gt;知识自进化&lt;/span&gt;&lt;span style={{ color: 'rgba(251,252,250,0.8)' }}&gt;　反馈→知识缺口→审核→入库&lt;/span&gt;&lt;/div&gt;&#13;&#10;          &lt;div&gt;&lt;span style={{ color: '#BD9B56', fontWeight: 'bold' }}&gt;监控告警&lt;/span&gt;&lt;span style={{ color: 'rgba(251,252,250,0.8)' }}&gt;　Prometheus + Grafana&lt;/span&gt;&lt;/div&gt;&#13;&#10;          &lt;div&gt;&lt;span style={{ color: '#BD9B56', fontWeight: 'bold' }}&gt;持续交付&lt;/span&gt;&lt;span style={{ color: 'rgba(251,252,250,0.8)' }}&gt;　GitHub Actions 自动测试+发布&lt;/span&gt;&lt;/div&gt;&#13;&#10;        &lt;/div&gt;&#13;&#10;        &lt;div style={{ fontSize: 11, color: 'rgba(251,252,250,0.6)', lineHeight: 1.5, paddingTop: 7, borderTop: '1px solid rgba(189,155,86,0.3)' }}&gt;无需人工值守，越用越准、越用越稳&lt;/div&gt;&#13;&#10;      &lt;/div&gt;&#13;&#10;      &lt;div style={{ background: '#fff', borderRadius: 12, padding: '14px 16px', boxShadow: '0 4px 16px rgba(23,33,51,0.06)' }}&gt;&#13;&#10;        &lt;div style={{ color: '#BD9B56', fontSize: 11.5, letterSpacing: '0.2em', marginBottom: 8 }}&gt;ONLINE DEMO&lt;/div&gt;&#13;&#10;        &lt;div style={{ fontSize: 15, fontFamily: 'Inter, sans-serif', color: '#172133', lineHeight: 1.4 }}&gt;http://119.91.236.85&lt;/div&gt;&#13;&#10;        &lt;div style={{ fontSize: 11, color: '#6b7075', lineHeight: 1.6, marginTop: 6 }}&gt;&#13;&#10;          业主 guoyi378 · 物业 mayun420&lt;br/&gt;维修 yangfei423　&lt;span style={{ color: '#BD9B56' }}&gt;密码 123456&lt;/span&gt;&#13;&#10;        &lt;/div&gt;&#13;&#10;        &lt;div style={{ fontSize: 10.5, color: '#a09b8c', marginTop: 6, paddingTop: 6, borderTop: '1px solid rgba(34,57,94,0.1)' }}&gt;GitHub：Xuuuukkk/ai-property-community-agent · MIT&lt;/div&gt;&#13;&#10;      &lt;/div&gt;&#13;&#10;    &lt;/div&gt;&#13;&#10;  &lt;/div&gt;&#13;&#10;  &lt;div style={{ flexShrink: 0, height: 30, display: 'flex', alignItems: 'flex-end', justifyContent: 'space-between' }}&gt;&#13;&#10;    &lt;span style={{ color: '#BD9B56', fontSize: 12, letterSpacing: '0.1em' }}&gt;云溪花园 · 智慧社区&lt;/span&gt;&#13;&#10;    &lt;span style={{ color: '#a09b8c', fontSize: 12 }}&gt;18 / 19&lt;/span&gt;&#13;&#10;  &lt;/div&gt;&#13;&#10;&lt;/Slide&gt;"/>
+        <p:cNvPr id="246" name="" descr="&lt;Slide style={{ width: '1280px', height: '720px', background: '#FBFCFA', position: 'relative', padding: '26px 52px', boxSizing: 'border-box', display: 'flex', flexDirection: 'column' }}&gt;&#13;&#10;  &lt;div style={{ flexShrink: 0 }}&gt;&#13;&#10;    &lt;div style={{ color: '#BD9B56', fontSize: 12, letterSpacing: '0.25em', marginBottom: 4 }}&gt;04 · 总结与展望&lt;/div&gt;&#13;&#10;    &lt;h2 style={{ fontSize: 25, fontWeight: 'bold', color: '#172133', margin: 0, lineHeight: 1.2 }}&gt;三端功能 × 实现技术：每个功能怎么做出来的&lt;/h2&gt;&#13;&#10;  &lt;/div&gt;&#13;&#10;  &lt;div style={{ flex: 1, display: 'flex', alignItems: 'stretch', gap: 18, marginTop: 10 }}&gt;&#13;&#10;    {/* 左栏：三端功能实现 */}&#13;&#10;    &lt;div style={{ flex: 1, display: 'flex', flexDirection: 'column', gap: 8 }}&gt;&#13;&#10;      {/* 业主端 */}&#13;&#10;      &lt;div style={{ background: '#fff', borderRadius: 10, padding: '10px 14px', boxShadow: '0 4px 16px rgba(23,33,51,0.06)' }}&gt;&#13;&#10;        &lt;div style={{ display: 'flex', alignItems: 'center', gap: 8, marginBottom: 6 }}&gt;&#13;&#10;          &lt;span style={{ fontSize: 14, fontWeight: 'bold', color: '#172133' }}&gt;业主端&lt;/span&gt;&#13;&#10;          &lt;span style={{ fontSize: 10.5, color: '#BD9B56', background: 'rgba(189,155,86,0.12)', padding: '2px 7px', borderRadius: 4 }}&gt;ToC · Owner&lt;/span&gt;&#13;&#10;        &lt;/div&gt;&#13;&#10;        &lt;div style={{ display: 'flex', flexDirection: 'column', gap: 3.5 }}&gt;&#13;&#10;          &lt;div style={{ display: 'flex', gap: 8, alignItems: 'baseline', fontSize: 11.5, lineHeight: 1.4 }}&gt;&lt;span style={{ color: '#172133', fontWeight: 'bold', minWidth: 56 }}&gt;AI 助手&lt;/span&gt;&lt;span style={{ color: '#6b7075' }}&gt;LangGraph 多 Agent：Personal 对话 → Router 意图识别 → Domain 工具调用&lt;/span&gt;&lt;/div&gt;&#13;&#10;          &lt;div style={{ display: 'flex', gap: 8, alignItems: 'baseline', fontSize: 11.5, lineHeight: 1.4 }}&gt;&lt;span style={{ color: '#172133', fontWeight: 'bold', minWidth: 56 }}&gt;对话报修&lt;/span&gt;&lt;span style={{ color: '#6b7075' }}&gt;Repair Agent · 多轮状态机补全房屋/类型 · 自动派单（技能+在岗+工号）&lt;/span&gt;&lt;/div&gt;&#13;&#10;          &lt;div style={{ display: 'flex', gap: 8, alignItems: 'baseline', fontSize: 11.5, lineHeight: 1.4 }}&gt;&lt;span style={{ color: '#172133', fontWeight: 'bold', minWidth: 56 }}&gt;缴费查询&lt;/span&gt;&lt;span style={{ color: '#6b7075' }}&gt;Fee Agent 查 fee_bills 账单表 · 返回金额/状态/截止日&lt;/span&gt;&lt;/div&gt;&#13;&#10;          &lt;div style={{ display: 'flex', gap: 8, alignItems: 'baseline', fontSize: 11.5, lineHeight: 1.4 }}&gt;&lt;span style={{ color: '#172133', fontWeight: 'bold', minWidth: 56 }}&gt;公告&lt;/span&gt;&lt;span style={{ color: '#6b7075' }}&gt;公告列表 + AI 摘要（LLM 提炼要点）&lt;/span&gt;&lt;/div&gt;&#13;&#10;          &lt;div style={{ display: 'flex', gap: 8, alignItems: 'baseline', fontSize: 11.5, lineHeight: 1.4 }}&gt;&lt;span style={{ color: '#172133', fontWeight: 'bold', minWidth: 56 }}&gt;我的工单&lt;/span&gt;&lt;span style={{ color: '#6b7075' }}&gt;repair_order 状态追踪（创建→派单→接单→完成→关闭）&lt;/span&gt;&lt;/div&gt;&#13;&#10;          &lt;div style={{ display: 'flex', gap: 8, alignItems: 'baseline', fontSize: 11.5, lineHeight: 1.4 }}&gt;&lt;span style={{ color: '#172133', fontWeight: 'bold', minWidth: 56 }}&gt;问题上报&lt;/span&gt;&lt;span style={{ color: '#6b7075' }}&gt;IssueReport 上报 · 附图片 · 物业答复&lt;/span&gt;&lt;/div&gt;&#13;&#10;        &lt;/div&gt;&#13;&#10;      &lt;/div&gt;&#13;&#10;      {/* 物业端 */}&#13;&#10;      &lt;div style={{ background: '#fff', borderRadius: 10, padding: '10px 14px', boxShadow: '0 4px 16px rgba(23,33,51,0.06)' }}&gt;&#13;&#10;        &lt;div style={{ display: 'flex', alignItems: 'center', gap: 8, marginBottom: 6 }}&gt;&#13;&#10;          &lt;span style={{ fontSize: 14, fontWeight: 'bold', color: '#172133' }}&gt;物业端&lt;/span&gt;&#13;&#10;          &lt;span style={{ fontSize: 10.5, color: '#BD9B56', background: 'rgba(189,155,86,0.12)', padding: '2px 7px', borderRadius: 4 }}&gt;ToB · Admin/Staff&lt;/span&gt;&#13;&#10;        &lt;/div&gt;&#13;&#10;        &lt;div style={{ display: 'flex', flexDirection: 'column', gap: 3.5 }}&gt;&#13;&#10;          &lt;div style={{ display: 'flex', gap: 8, alignItems: 'baseline', fontSize: 11.5, lineHeight: 1.4 }}&gt;&lt;span style={{ color: '#172133', fontWeight: 'bold', minWidth: 56 }}&gt;数据看板&lt;/span&gt;&lt;span style={{ color: '#6b7075' }}&gt;统计聚合 API · 今日报修/处理中/已完成实时汇总&lt;/span&gt;&lt;/div&gt;&#13;&#10;          &lt;div style={{ display: 'flex', gap: 8, alignItems: 'baseline', fontSize: 11.5, lineHeight: 1.4 }}&gt;&lt;span style={{ color: '#172133', fontWeight: 'bold', minWidth: 56 }}&gt;工单管理&lt;/span&gt;&lt;span style={{ color: '#6b7075' }}&gt;repair_order CRUD · 状态流转 · 人工派单/改派&lt;/span&gt;&lt;/div&gt;&#13;&#10;          &lt;div style={{ display: 'flex', gap: 8, alignItems: 'baseline', fontSize: 11.5, lineHeight: 1.4 }}&gt;&lt;span style={{ color: '#172133', fontWeight: 'bold', minWidth: 56 }}&gt;用户/房屋&lt;/span&gt;&lt;span style={{ color: '#6b7075' }}&gt;user / house / house_binding 绑定关系管理&lt;/span&gt;&lt;/div&gt;&#13;&#10;          &lt;div style={{ display: 'flex', gap: 8, alignItems: 'baseline', fontSize: 11.5, lineHeight: 1.4 }}&gt;&lt;span style={{ color: '#172133', fontWeight: 'bold', minWidth: 56 }}&gt;公告 AI 生成&lt;/span&gt;&lt;span style={{ color: '#6b7075' }}&gt;Notice Agent + LLM 生成标题/正文/影响范围 · 人工审核发布&lt;/span&gt;&lt;/div&gt;&#13;&#10;          &lt;div style={{ display: 'flex', gap: 8, alignItems: 'baseline', fontSize: 11.5, lineHeight: 1.4 }}&gt;&lt;span style={{ color: '#172133', fontWeight: 'bold', minWidth: 56 }}&gt;巡检管理&lt;/span&gt;&lt;span style={{ color: '#6b7075' }}&gt;摄像头抓拍 → 视觉模型识别异常 → 巡检记录 + 告警&lt;/span&gt;&lt;/div&gt;&#13;&#10;          &lt;div style={{ display: 'flex', gap: 8, alignItems: 'baseline', fontSize: 11.5, lineHeight: 1.4 }}&gt;&lt;span style={{ color: '#172133', fontWeight: 'bold', minWidth: 56 }}&gt;知识缺口审核&lt;/span&gt;&lt;span style={{ color: '#6b7075' }}&gt;knowledge_gap 审核 → 通过自动写入 pgvector 知识库&lt;/span&gt;&lt;/div&gt;&#13;&#10;        &lt;/div&gt;&#13;&#10;      &lt;/div&gt;&#13;&#10;      {/* 维修端 */}&#13;&#10;      &lt;div style={{ background: '#fff', borderRadius: 10, padding: '10px 14px', boxShadow: '0 4px 16px rgba(23,33,51,0.06)' }}&gt;&#13;&#10;        &lt;div style={{ display: 'flex', alignItems: 'center', gap: 8, marginBottom: 6 }}&gt;&#13;&#10;          &lt;span style={{ fontSize: 14, fontWeight: 'bold', color: '#172133' }}&gt;维修端&lt;/span&gt;&#13;&#10;          &lt;span style={{ fontSize: 10.5, color: '#BD9B56', background: 'rgba(189,155,86,0.12)', padding: '2px 7px', borderRadius: 4 }}&gt;ToC · Worker&lt;/span&gt;&#13;&#10;        &lt;/div&gt;&#13;&#10;        &lt;div style={{ display: 'flex', flexDirection: 'column', gap: 3.5 }}&gt;&#13;&#10;          &lt;div style={{ display: 'flex', gap: 8, alignItems: 'baseline', fontSize: 11.5, lineHeight: 1.4 }}&gt;&lt;span style={{ color: '#172133', fontWeight: 'bold', minWidth: 56 }}&gt;任务列表&lt;/span&gt;&lt;span style={{ color: '#6b7075' }}&gt;自动派单后查询「我的待处理」工单&lt;/span&gt;&lt;/div&gt;&#13;&#10;          &lt;div style={{ display: 'flex', gap: 8, alignItems: 'baseline', fontSize: 11.5, lineHeight: 1.4 }}&gt;&lt;span style={{ color: '#172133', fontWeight: 'bold', minWidth: 56 }}&gt;接单/处理/完成&lt;/span&gt;&lt;span style={{ color: '#6b7075' }}&gt;状态机流转 · 每步触发实时通知&lt;/span&gt;&lt;/div&gt;&#13;&#10;          &lt;div style={{ display: 'flex', gap: 8, alignItems: 'baseline', fontSize: 11.5, lineHeight: 1.4 }}&gt;&lt;span style={{ color: '#172133', fontWeight: 'bold', minWidth: 56 }}&gt;消息&lt;/span&gt;&lt;span style={{ color: '#6b7075' }}&gt;事件驱动通知（派单/答复/完成）&lt;/span&gt;&lt;/div&gt;&#13;&#10;          &lt;div style={{ display: 'flex', gap: 8, alignItems: 'baseline', fontSize: 11.5, lineHeight: 1.4 }}&gt;&lt;span style={{ color: '#172133', fontWeight: 'bold', minWidth: 56 }}&gt;巡检任务&lt;/span&gt;&lt;span style={{ color: '#6b7075' }}&gt;巡检记录查看 · 异常处理&lt;/span&gt;&lt;/div&gt;&#13;&#10;        &lt;/div&gt;&#13;&#10;      &lt;/div&gt;&#13;&#10;    &lt;/div&gt;&#13;&#10;    {/* 右栏：自维护 + Demo */}&#13;&#10;    &lt;div style={{ flex: '0 0 285px', display: 'flex', flexDirection: 'column', gap: 10 }}&gt;&#13;&#10;      &lt;div style={{ background: 'linear-gradient(135deg, #172133 0%, #22395E 100%)', borderRadius: 12, padding: '16px 18px', color: '#FBFCFA', display: 'flex', flexDirection: 'column', gap: 9 }}&gt;&#13;&#10;        &lt;div style={{ color: '#BD9B56', fontSize: 12, letterSpacing: '0.2em' }}&gt;系统自维护自更新&lt;/div&gt;&#13;&#10;        &lt;div style={{ display: 'flex', flexDirection: 'column', gap: 6, fontSize: 11.5, lineHeight: 1.45 }}&gt;&#13;&#10;          &lt;div&gt;&lt;span style={{ color: '#BD9B56', fontWeight: 'bold' }}&gt;定时清理&lt;/span&gt;&lt;span style={{ color: 'rgba(251,252,250,0.8)' }}&gt;　APScheduler 每日清过期数据/孤儿文件&lt;/span&gt;&lt;/div&gt;&#13;&#10;          &lt;div&gt;&lt;span style={{ color: '#BD9B56', fontWeight: 'bold' }}&gt;巡检自动化&lt;/span&gt;&lt;span style={{ color: 'rgba(251,252,250,0.8)' }}&gt;　定时抓拍 + 视觉识别异常&lt;/span&gt;&lt;/div&gt;&#13;&#10;          &lt;div&gt;&lt;span style={{ color: '#BD9B56', fontWeight: 'bold' }}&gt;知识自进化&lt;/span&gt;&lt;span style={{ color: 'rgba(251,252,250,0.8)' }}&gt;　反馈→知识缺口→审核→入库&lt;/span&gt;&lt;/div&gt;&#13;&#10;          &lt;div&gt;&lt;span style={{ color: '#BD9B56', fontWeight: 'bold' }}&gt;监控告警&lt;/span&gt;&lt;span style={{ color: 'rgba(251,252,250,0.8)' }}&gt;　Prometheus + Grafana&lt;/span&gt;&lt;/div&gt;&#13;&#10;          &lt;div&gt;&lt;span style={{ color: '#BD9B56', fontWeight: 'bold' }}&gt;持续交付&lt;/span&gt;&lt;span style={{ color: 'rgba(251,252,250,0.8)' }}&gt;　GitHub Actions 自动测试+发布&lt;/span&gt;&lt;/div&gt;&#13;&#10;        &lt;/div&gt;&#13;&#10;        &lt;div style={{ fontSize: 11, color: 'rgba(251,252,250,0.6)', lineHeight: 1.5, paddingTop: 7, borderTop: '1px solid rgba(189,155,86,0.3)' }}&gt;无需人工值守，越用越准、越用越稳&lt;/div&gt;&#13;&#10;      &lt;/div&gt;&#13;&#10;      &lt;div style={{ background: '#fff', borderRadius: 12, padding: '14px 16px', boxShadow: '0 4px 16px rgba(23,33,51,0.06)' }}&gt;&#13;&#10;        &lt;div style={{ color: '#BD9B56', fontSize: 11.5, letterSpacing: '0.2em', marginBottom: 8 }}&gt;ONLINE DEMO&lt;/div&gt;&#13;&#10;        &lt;div style={{ fontSize: 15, fontFamily: 'Inter, sans-serif', color: '#172133', lineHeight: 1.4 }}&gt;http://119.91.236.85&lt;/div&gt;&#13;&#10;        &lt;div style={{ fontSize: 11, color: '#6b7075', lineHeight: 1.6, marginTop: 6 }}&gt;&#13;&#10;          业主 guoyi378 · 物业 mayun420&lt;br/&gt;维修 yangfei423　&lt;span style={{ color: '#BD9B56' }}&gt;密码 123456&lt;/span&gt;&#13;&#10;        &lt;/div&gt;&#13;&#10;        &lt;div style={{ fontSize: 10.5, color: '#a09b8c', marginTop: 6, paddingTop: 6, borderTop: '1px solid rgba(34,57,94,0.1)' }}&gt;GitHub：Xuuuukkk/ai-property-community-agent · MIT&lt;/div&gt;&#13;&#10;      &lt;/div&gt;&#13;&#10;    &lt;/div&gt;&#13;&#10;  &lt;/div&gt;&#13;&#10;  &lt;div style={{ flexShrink: 0, height: 30, display: 'flex', alignItems: 'flex-end', justifyContent: 'space-between' }}&gt;&#13;&#10;    &lt;span style={{ color: '#BD9B56', fontSize: 12, letterSpacing: '0.1em' }}&gt;云溪花园 · 智慧社区&lt;/span&gt;&#13;&#10;    &lt;span style={{ color: '#a09b8c', fontSize: 12 }}&gt;18 / 19&lt;/span&gt;&#13;&#10;  &lt;/div&gt;&#13;&#10;&lt;/Slide&gt;"/>
         <p:cNvGrpSpPr/>
         <p:nvPr/>
       </p:nvGrpSpPr>
@@ -11211,7 +11470,7 @@
       </p:grpSpPr>
       <p:sp>
         <p:nvSpPr>
-          <p:cNvPr id="237" name=""/>
+          <p:cNvPr id="247" name=""/>
           <p:cNvSpPr/>
           <p:nvPr/>
         </p:nvSpPr>
@@ -11235,7 +11494,7 @@
       </p:sp>
       <p:sp>
         <p:nvSpPr>
-          <p:cNvPr id="238" name="" descr="{&quot;isTemplate&quot;:true,&quot;type&quot;:&quot;text&quot;}"/>
+          <p:cNvPr id="248" name="" descr="{&quot;isTemplate&quot;:true,&quot;type&quot;:&quot;text&quot;}"/>
           <p:cNvSpPr txBox="1"/>
           <p:nvPr/>
         </p:nvSpPr>
@@ -11280,7 +11539,7 @@
       </p:sp>
       <p:sp>
         <p:nvSpPr>
-          <p:cNvPr id="239" name="" descr="{&quot;isTemplate&quot;:true,&quot;type&quot;:&quot;text&quot;}"/>
+          <p:cNvPr id="249" name="" descr="{&quot;isTemplate&quot;:true,&quot;type&quot;:&quot;text&quot;}"/>
           <p:cNvSpPr txBox="1"/>
           <p:nvPr/>
         </p:nvSpPr>
@@ -11335,7 +11594,7 @@
       </p:sp>
       <p:sp>
         <p:nvSpPr>
-          <p:cNvPr id="240" name=""/>
+          <p:cNvPr id="250" name=""/>
           <p:cNvSpPr/>
           <p:nvPr/>
         </p:nvSpPr>
@@ -11368,7 +11627,7 @@
       </p:sp>
       <p:sp>
         <p:nvSpPr>
-          <p:cNvPr id="241" name="" descr="{&quot;isTemplate&quot;:true,&quot;type&quot;:&quot;text&quot;}"/>
+          <p:cNvPr id="251" name="" descr="{&quot;isTemplate&quot;:true,&quot;type&quot;:&quot;text&quot;}"/>
           <p:cNvSpPr txBox="1"/>
           <p:nvPr/>
         </p:nvSpPr>
@@ -11403,7 +11662,7 @@
       </p:sp>
       <p:sp>
         <p:nvSpPr>
-          <p:cNvPr id="242" name=""/>
+          <p:cNvPr id="252" name=""/>
           <p:cNvSpPr/>
           <p:nvPr/>
         </p:nvSpPr>
@@ -11431,7 +11690,7 @@
       </p:sp>
       <p:sp>
         <p:nvSpPr>
-          <p:cNvPr id="243" name="" descr="{&quot;isTemplate&quot;:true,&quot;type&quot;:&quot;text&quot;}"/>
+          <p:cNvPr id="253" name="" descr="{&quot;isTemplate&quot;:true,&quot;type&quot;:&quot;text&quot;}"/>
           <p:cNvSpPr txBox="1"/>
           <p:nvPr/>
         </p:nvSpPr>
@@ -11471,7 +11730,7 @@
       </p:sp>
       <p:sp>
         <p:nvSpPr>
-          <p:cNvPr id="244" name="" descr="{&quot;isTemplate&quot;:true,&quot;type&quot;:&quot;text&quot;}"/>
+          <p:cNvPr id="254" name="" descr="{&quot;isTemplate&quot;:true,&quot;type&quot;:&quot;text&quot;}"/>
           <p:cNvSpPr txBox="1"/>
           <p:nvPr/>
         </p:nvSpPr>
@@ -11516,7 +11775,7 @@
       </p:sp>
       <p:sp>
         <p:nvSpPr>
-          <p:cNvPr id="245" name="" descr="{&quot;isTemplate&quot;:true,&quot;type&quot;:&quot;text&quot;}"/>
+          <p:cNvPr id="255" name="" descr="{&quot;isTemplate&quot;:true,&quot;type&quot;:&quot;text&quot;}"/>
           <p:cNvSpPr txBox="1"/>
           <p:nvPr/>
         </p:nvSpPr>
@@ -11641,7 +11900,7 @@
       </p:sp>
       <p:sp>
         <p:nvSpPr>
-          <p:cNvPr id="246" name="" descr="{&quot;isTemplate&quot;:true,&quot;type&quot;:&quot;text&quot;}"/>
+          <p:cNvPr id="256" name="" descr="{&quot;isTemplate&quot;:true,&quot;type&quot;:&quot;text&quot;}"/>
           <p:cNvSpPr txBox="1"/>
           <p:nvPr/>
         </p:nvSpPr>
@@ -11676,7 +11935,7 @@
       </p:sp>
       <p:sp>
         <p:nvSpPr>
-          <p:cNvPr id="247" name="" descr="{&quot;isTemplate&quot;:true,&quot;type&quot;:&quot;text&quot;}"/>
+          <p:cNvPr id="257" name="" descr="{&quot;isTemplate&quot;:true,&quot;type&quot;:&quot;text&quot;}"/>
           <p:cNvSpPr txBox="1"/>
           <p:nvPr/>
         </p:nvSpPr>
@@ -11801,7 +12060,7 @@
       </p:sp>
       <p:sp>
         <p:nvSpPr>
-          <p:cNvPr id="248" name="" descr="{&quot;isTemplate&quot;:true,&quot;type&quot;:&quot;text&quot;}"/>
+          <p:cNvPr id="258" name="" descr="{&quot;isTemplate&quot;:true,&quot;type&quot;:&quot;text&quot;}"/>
           <p:cNvSpPr txBox="1"/>
           <p:nvPr/>
         </p:nvSpPr>
@@ -11836,7 +12095,7 @@
       </p:sp>
       <p:sp>
         <p:nvSpPr>
-          <p:cNvPr id="249" name="" descr="{&quot;isTemplate&quot;:true,&quot;type&quot;:&quot;text&quot;}"/>
+          <p:cNvPr id="259" name="" descr="{&quot;isTemplate&quot;:true,&quot;type&quot;:&quot;text&quot;}"/>
           <p:cNvSpPr txBox="1"/>
           <p:nvPr/>
         </p:nvSpPr>
@@ -11961,7 +12220,7 @@
       </p:sp>
       <p:sp>
         <p:nvSpPr>
-          <p:cNvPr id="250" name="" descr="{&quot;isTemplate&quot;:true,&quot;type&quot;:&quot;text&quot;}"/>
+          <p:cNvPr id="260" name="" descr="{&quot;isTemplate&quot;:true,&quot;type&quot;:&quot;text&quot;}"/>
           <p:cNvSpPr txBox="1"/>
           <p:nvPr/>
         </p:nvSpPr>
@@ -11996,7 +12255,7 @@
       </p:sp>
       <p:sp>
         <p:nvSpPr>
-          <p:cNvPr id="251" name="" descr="{&quot;isTemplate&quot;:true,&quot;type&quot;:&quot;text&quot;}"/>
+          <p:cNvPr id="261" name="" descr="{&quot;isTemplate&quot;:true,&quot;type&quot;:&quot;text&quot;}"/>
           <p:cNvSpPr txBox="1"/>
           <p:nvPr/>
         </p:nvSpPr>
@@ -12071,7 +12330,7 @@
       </p:sp>
       <p:sp>
         <p:nvSpPr>
-          <p:cNvPr id="252" name="" descr="{&quot;isTemplate&quot;:true,&quot;type&quot;:&quot;text&quot;}"/>
+          <p:cNvPr id="262" name="" descr="{&quot;isTemplate&quot;:true,&quot;type&quot;:&quot;text&quot;}"/>
           <p:cNvSpPr txBox="1"/>
           <p:nvPr/>
         </p:nvSpPr>
@@ -12106,7 +12365,7 @@
       </p:sp>
       <p:sp>
         <p:nvSpPr>
-          <p:cNvPr id="253" name="" descr="{&quot;isTemplate&quot;:true,&quot;type&quot;:&quot;text&quot;}"/>
+          <p:cNvPr id="263" name="" descr="{&quot;isTemplate&quot;:true,&quot;type&quot;:&quot;text&quot;}"/>
           <p:cNvSpPr txBox="1"/>
           <p:nvPr/>
         </p:nvSpPr>
@@ -12151,7 +12410,7 @@
       </p:sp>
       <p:sp>
         <p:nvSpPr>
-          <p:cNvPr id="254" name="" descr="{&quot;isTemplate&quot;:true,&quot;type&quot;:&quot;text&quot;}"/>
+          <p:cNvPr id="264" name="" descr="{&quot;isTemplate&quot;:true,&quot;type&quot;:&quot;text&quot;}"/>
           <p:cNvSpPr txBox="1"/>
           <p:nvPr/>
         </p:nvSpPr>
@@ -12186,7 +12445,7 @@
       </p:sp>
       <p:sp>
         <p:nvSpPr>
-          <p:cNvPr id="255" name="" descr="{&quot;isTemplate&quot;:true,&quot;type&quot;:&quot;text&quot;}"/>
+          <p:cNvPr id="265" name="" descr="{&quot;isTemplate&quot;:true,&quot;type&quot;:&quot;text&quot;}"/>
           <p:cNvSpPr txBox="1"/>
           <p:nvPr/>
         </p:nvSpPr>
@@ -12271,7 +12530,7 @@
       </p:sp>
       <p:sp>
         <p:nvSpPr>
-          <p:cNvPr id="256" name=""/>
+          <p:cNvPr id="266" name=""/>
           <p:cNvSpPr/>
           <p:nvPr/>
         </p:nvSpPr>
@@ -12304,7 +12563,7 @@
       </p:sp>
       <p:sp>
         <p:nvSpPr>
-          <p:cNvPr id="257" name="" descr="{&quot;isTemplate&quot;:true,&quot;type&quot;:&quot;text&quot;}"/>
+          <p:cNvPr id="267" name="" descr="{&quot;isTemplate&quot;:true,&quot;type&quot;:&quot;text&quot;}"/>
           <p:cNvSpPr txBox="1"/>
           <p:nvPr/>
         </p:nvSpPr>
@@ -12339,7 +12598,7 @@
       </p:sp>
       <p:sp>
         <p:nvSpPr>
-          <p:cNvPr id="258" name=""/>
+          <p:cNvPr id="268" name=""/>
           <p:cNvSpPr/>
           <p:nvPr/>
         </p:nvSpPr>
@@ -12367,7 +12626,7 @@
       </p:sp>
       <p:sp>
         <p:nvSpPr>
-          <p:cNvPr id="259" name="" descr="{&quot;isTemplate&quot;:true,&quot;type&quot;:&quot;text&quot;}"/>
+          <p:cNvPr id="269" name="" descr="{&quot;isTemplate&quot;:true,&quot;type&quot;:&quot;text&quot;}"/>
           <p:cNvSpPr txBox="1"/>
           <p:nvPr/>
         </p:nvSpPr>
@@ -12407,7 +12666,7 @@
       </p:sp>
       <p:sp>
         <p:nvSpPr>
-          <p:cNvPr id="260" name="" descr="{&quot;isTemplate&quot;:true,&quot;type&quot;:&quot;text&quot;}"/>
+          <p:cNvPr id="270" name="" descr="{&quot;isTemplate&quot;:true,&quot;type&quot;:&quot;text&quot;}"/>
           <p:cNvSpPr txBox="1"/>
           <p:nvPr/>
         </p:nvSpPr>
@@ -12442,7 +12701,7 @@
       </p:sp>
       <p:sp>
         <p:nvSpPr>
-          <p:cNvPr id="261" name="" descr="{&quot;isTemplate&quot;:true,&quot;type&quot;:&quot;text&quot;}"/>
+          <p:cNvPr id="271" name="" descr="{&quot;isTemplate&quot;:true,&quot;type&quot;:&quot;text&quot;}"/>
           <p:cNvSpPr txBox="1"/>
           <p:nvPr/>
         </p:nvSpPr>
@@ -12537,7 +12796,7 @@
       </p:sp>
       <p:sp>
         <p:nvSpPr>
-          <p:cNvPr id="262" name="" descr="{&quot;isTemplate&quot;:true,&quot;type&quot;:&quot;text&quot;}"/>
+          <p:cNvPr id="272" name="" descr="{&quot;isTemplate&quot;:true,&quot;type&quot;:&quot;text&quot;}"/>
           <p:cNvSpPr txBox="1"/>
           <p:nvPr/>
         </p:nvSpPr>
@@ -12572,7 +12831,7 @@
       </p:sp>
       <p:sp>
         <p:nvSpPr>
-          <p:cNvPr id="263" name="" descr="{&quot;isTemplate&quot;:true,&quot;type&quot;:&quot;text&quot;}"/>
+          <p:cNvPr id="273" name="" descr="{&quot;isTemplate&quot;:true,&quot;type&quot;:&quot;text&quot;}"/>
           <p:cNvSpPr txBox="1"/>
           <p:nvPr/>
         </p:nvSpPr>
@@ -12657,7 +12916,7 @@
       </p:sp>
       <p:sp>
         <p:nvSpPr>
-          <p:cNvPr id="264" name="" descr="{&quot;isTemplate&quot;:true,&quot;type&quot;:&quot;text&quot;}"/>
+          <p:cNvPr id="274" name="" descr="{&quot;isTemplate&quot;:true,&quot;type&quot;:&quot;text&quot;}"/>
           <p:cNvSpPr txBox="1"/>
           <p:nvPr/>
         </p:nvSpPr>
@@ -12712,7 +12971,7 @@
       </p:sp>
       <p:sp>
         <p:nvSpPr>
-          <p:cNvPr id="265" name="" descr="{&quot;isTemplate&quot;:true,&quot;type&quot;:&quot;text&quot;}"/>
+          <p:cNvPr id="275" name="" descr="{&quot;isTemplate&quot;:true,&quot;type&quot;:&quot;text&quot;}"/>
           <p:cNvSpPr txBox="1"/>
           <p:nvPr/>
         </p:nvSpPr>
@@ -12757,7 +13016,7 @@
       </p:sp>
       <p:sp>
         <p:nvSpPr>
-          <p:cNvPr id="266" name="" descr="{&quot;isTemplate&quot;:true,&quot;type&quot;:&quot;text&quot;}"/>
+          <p:cNvPr id="276" name="" descr="{&quot;isTemplate&quot;:true,&quot;type&quot;:&quot;text&quot;}"/>
           <p:cNvSpPr txBox="1"/>
           <p:nvPr/>
         </p:nvSpPr>
@@ -12812,7 +13071,7 @@
       </p:sp>
       <p:sp>
         <p:nvSpPr>
-          <p:cNvPr id="267" name="" descr="{&quot;isTemplate&quot;:true,&quot;type&quot;:&quot;text&quot;}"/>
+          <p:cNvPr id="277" name="" descr="{&quot;isTemplate&quot;:true,&quot;type&quot;:&quot;text&quot;}"/>
           <p:cNvSpPr txBox="1"/>
           <p:nvPr/>
         </p:nvSpPr>
@@ -12917,7 +13176,7 @@
       </p:sp>
       <p:sp>
         <p:nvSpPr>
-          <p:cNvPr id="268" name="" descr="{&quot;isTemplate&quot;:true,&quot;type&quot;:&quot;text&quot;}"/>
+          <p:cNvPr id="278" name="" descr="{&quot;isTemplate&quot;:true,&quot;type&quot;:&quot;text&quot;}"/>
           <p:cNvSpPr txBox="1"/>
           <p:nvPr/>
         </p:nvSpPr>
@@ -12952,7 +13211,7 @@
       </p:sp>
       <p:sp>
         <p:nvSpPr>
-          <p:cNvPr id="269" name="" descr="{&quot;isTemplate&quot;:true,&quot;type&quot;:&quot;text&quot;}"/>
+          <p:cNvPr id="279" name="" descr="{&quot;isTemplate&quot;:true,&quot;type&quot;:&quot;text&quot;}"/>
           <p:cNvSpPr txBox="1"/>
           <p:nvPr/>
         </p:nvSpPr>
@@ -13047,7 +13306,7 @@
       </p:sp>
       <p:sp>
         <p:nvSpPr>
-          <p:cNvPr id="270" name="" descr="{&quot;isTemplate&quot;:true,&quot;type&quot;:&quot;text&quot;}"/>
+          <p:cNvPr id="280" name="" descr="{&quot;isTemplate&quot;:true,&quot;type&quot;:&quot;text&quot;}"/>
           <p:cNvSpPr txBox="1"/>
           <p:nvPr/>
         </p:nvSpPr>
@@ -13082,7 +13341,7 @@
       </p:sp>
       <p:sp>
         <p:nvSpPr>
-          <p:cNvPr id="271" name="" descr="{&quot;isTemplate&quot;:true,&quot;type&quot;:&quot;text&quot;}"/>
+          <p:cNvPr id="281" name="" descr="{&quot;isTemplate&quot;:true,&quot;type&quot;:&quot;text&quot;}"/>
           <p:cNvSpPr txBox="1"/>
           <p:nvPr/>
         </p:nvSpPr>
@@ -13167,7 +13426,7 @@
       </p:sp>
       <p:sp>
         <p:nvSpPr>
-          <p:cNvPr id="272" name=""/>
+          <p:cNvPr id="282" name=""/>
           <p:cNvSpPr/>
           <p:nvPr/>
         </p:nvSpPr>
@@ -13200,7 +13459,7 @@
       </p:sp>
       <p:sp>
         <p:nvSpPr>
-          <p:cNvPr id="273" name="" descr="{&quot;isTemplate&quot;:true,&quot;type&quot;:&quot;text&quot;}"/>
+          <p:cNvPr id="283" name="" descr="{&quot;isTemplate&quot;:true,&quot;type&quot;:&quot;text&quot;}"/>
           <p:cNvSpPr txBox="1"/>
           <p:nvPr/>
         </p:nvSpPr>
@@ -13235,7 +13494,7 @@
       </p:sp>
       <p:sp>
         <p:nvSpPr>
-          <p:cNvPr id="274" name=""/>
+          <p:cNvPr id="284" name=""/>
           <p:cNvSpPr/>
           <p:nvPr/>
         </p:nvSpPr>
@@ -13263,7 +13522,7 @@
       </p:sp>
       <p:sp>
         <p:nvSpPr>
-          <p:cNvPr id="275" name="" descr="{&quot;isTemplate&quot;:true,&quot;type&quot;:&quot;text&quot;}"/>
+          <p:cNvPr id="285" name="" descr="{&quot;isTemplate&quot;:true,&quot;type&quot;:&quot;text&quot;}"/>
           <p:cNvSpPr txBox="1"/>
           <p:nvPr/>
         </p:nvSpPr>
@@ -13303,7 +13562,7 @@
       </p:sp>
       <p:sp>
         <p:nvSpPr>
-          <p:cNvPr id="276" name="" descr="{&quot;isTemplate&quot;:true,&quot;type&quot;:&quot;text&quot;}"/>
+          <p:cNvPr id="286" name="" descr="{&quot;isTemplate&quot;:true,&quot;type&quot;:&quot;text&quot;}"/>
           <p:cNvSpPr txBox="1"/>
           <p:nvPr/>
         </p:nvSpPr>
@@ -13338,7 +13597,7 @@
       </p:sp>
       <p:sp>
         <p:nvSpPr>
-          <p:cNvPr id="277" name="" descr="{&quot;isTemplate&quot;:true,&quot;type&quot;:&quot;text&quot;}"/>
+          <p:cNvPr id="287" name="" descr="{&quot;isTemplate&quot;:true,&quot;type&quot;:&quot;text&quot;}"/>
           <p:cNvSpPr txBox="1"/>
           <p:nvPr/>
         </p:nvSpPr>
@@ -13373,7 +13632,7 @@
       </p:sp>
       <p:sp>
         <p:nvSpPr>
-          <p:cNvPr id="278" name="" descr="{&quot;isTemplate&quot;:true,&quot;type&quot;:&quot;text&quot;}"/>
+          <p:cNvPr id="288" name="" descr="{&quot;isTemplate&quot;:true,&quot;type&quot;:&quot;text&quot;}"/>
           <p:cNvSpPr txBox="1"/>
           <p:nvPr/>
         </p:nvSpPr>
@@ -13448,7 +13707,7 @@
       </p:sp>
       <p:sp>
         <p:nvSpPr>
-          <p:cNvPr id="279" name="" descr="{&quot;isTemplate&quot;:true,&quot;type&quot;:&quot;text&quot;}"/>
+          <p:cNvPr id="289" name="" descr="{&quot;isTemplate&quot;:true,&quot;type&quot;:&quot;text&quot;}"/>
           <p:cNvSpPr txBox="1"/>
           <p:nvPr/>
         </p:nvSpPr>
@@ -13503,7 +13762,7 @@
       </p:sp>
       <p:sp>
         <p:nvSpPr>
-          <p:cNvPr id="280" name="" descr="{&quot;isTemplate&quot;:true,&quot;type&quot;:&quot;text&quot;}"/>
+          <p:cNvPr id="290" name="" descr="{&quot;isTemplate&quot;:true,&quot;type&quot;:&quot;text&quot;}"/>
           <p:cNvSpPr txBox="1"/>
           <p:nvPr/>
         </p:nvSpPr>
@@ -13538,7 +13797,7 @@
       </p:sp>
       <p:sp>
         <p:nvSpPr>
-          <p:cNvPr id="281" name="" descr="{&quot;isTemplate&quot;:true,&quot;type&quot;:&quot;text&quot;}"/>
+          <p:cNvPr id="291" name="" descr="{&quot;isTemplate&quot;:true,&quot;type&quot;:&quot;text&quot;}"/>
           <p:cNvSpPr txBox="1"/>
           <p:nvPr/>
         </p:nvSpPr>
@@ -13613,7 +13872,7 @@
       </p:sp>
       <p:sp>
         <p:nvSpPr>
-          <p:cNvPr id="282" name="" descr="{&quot;isTemplate&quot;:true,&quot;type&quot;:&quot;text&quot;}"/>
+          <p:cNvPr id="292" name="" descr="{&quot;isTemplate&quot;:true,&quot;type&quot;:&quot;text&quot;}"/>
           <p:cNvSpPr txBox="1"/>
           <p:nvPr/>
         </p:nvSpPr>
@@ -13648,7 +13907,7 @@
       </p:sp>
       <p:sp>
         <p:nvSpPr>
-          <p:cNvPr id="283" name="" descr="{&quot;isTemplate&quot;:true,&quot;type&quot;:&quot;text&quot;}"/>
+          <p:cNvPr id="293" name="" descr="{&quot;isTemplate&quot;:true,&quot;type&quot;:&quot;text&quot;}"/>
           <p:cNvSpPr txBox="1"/>
           <p:nvPr/>
         </p:nvSpPr>
@@ -13703,7 +13962,7 @@
       </p:sp>
       <p:sp>
         <p:nvSpPr>
-          <p:cNvPr id="284" name=""/>
+          <p:cNvPr id="294" name=""/>
           <p:cNvSpPr/>
           <p:nvPr/>
         </p:nvSpPr>
@@ -13737,7 +13996,7 @@
       </p:sp>
       <p:sp>
         <p:nvSpPr>
-          <p:cNvPr id="285" name="" descr="{&quot;isTemplate&quot;:true,&quot;type&quot;:&quot;text&quot;}"/>
+          <p:cNvPr id="295" name="" descr="{&quot;isTemplate&quot;:true,&quot;type&quot;:&quot;text&quot;}"/>
           <p:cNvSpPr txBox="1"/>
           <p:nvPr/>
         </p:nvSpPr>
@@ -13772,7 +14031,7 @@
       </p:sp>
       <p:sp>
         <p:nvSpPr>
-          <p:cNvPr id="286" name="" descr="{&quot;isTemplate&quot;:true,&quot;type&quot;:&quot;text&quot;}"/>
+          <p:cNvPr id="296" name="" descr="{&quot;isTemplate&quot;:true,&quot;type&quot;:&quot;text&quot;}"/>
           <p:cNvSpPr txBox="1"/>
           <p:nvPr/>
         </p:nvSpPr>
@@ -13807,7 +14066,7 @@
       </p:sp>
       <p:sp>
         <p:nvSpPr>
-          <p:cNvPr id="287" name="" descr="{&quot;isTemplate&quot;:true,&quot;type&quot;:&quot;text&quot;}"/>
+          <p:cNvPr id="297" name="" descr="{&quot;isTemplate&quot;:true,&quot;type&quot;:&quot;text&quot;}"/>
           <p:cNvSpPr txBox="1"/>
           <p:nvPr/>
         </p:nvSpPr>
@@ -13892,7 +14151,7 @@
       </p:sp>
       <p:sp>
         <p:nvSpPr>
-          <p:cNvPr id="288" name="" descr="{&quot;isTemplate&quot;:true,&quot;type&quot;:&quot;text&quot;}"/>
+          <p:cNvPr id="298" name="" descr="{&quot;isTemplate&quot;:true,&quot;type&quot;:&quot;text&quot;}"/>
           <p:cNvSpPr txBox="1"/>
           <p:nvPr/>
         </p:nvSpPr>
@@ -13927,7 +14186,7 @@
       </p:sp>
       <p:sp>
         <p:nvSpPr>
-          <p:cNvPr id="289" name="" descr="{&quot;isTemplate&quot;:true,&quot;type&quot;:&quot;text&quot;}"/>
+          <p:cNvPr id="299" name="" descr="{&quot;isTemplate&quot;:true,&quot;type&quot;:&quot;text&quot;}"/>
           <p:cNvSpPr txBox="1"/>
           <p:nvPr/>
         </p:nvSpPr>
@@ -13988,7 +14247,7 @@
       </p:sp>
       <p:sp>
         <p:nvSpPr>
-          <p:cNvPr id="290" name="" descr="{&quot;isTemplate&quot;:true,&quot;type&quot;:&quot;text&quot;}"/>
+          <p:cNvPr id="300" name="" descr="{&quot;isTemplate&quot;:true,&quot;type&quot;:&quot;text&quot;}"/>
           <p:cNvSpPr txBox="1"/>
           <p:nvPr/>
         </p:nvSpPr>
@@ -14023,7 +14282,7 @@
       </p:sp>
       <p:sp>
         <p:nvSpPr>
-          <p:cNvPr id="291" name="" descr="{&quot;isTemplate&quot;:true,&quot;type&quot;:&quot;text&quot;}"/>
+          <p:cNvPr id="301" name="" descr="{&quot;isTemplate&quot;:true,&quot;type&quot;:&quot;text&quot;}"/>
           <p:cNvSpPr txBox="1"/>
           <p:nvPr/>
         </p:nvSpPr>
@@ -14060,7 +14319,7 @@
       </p:sp>
       <p:sp>
         <p:nvSpPr>
-          <p:cNvPr id="292" name="" descr="{&quot;isTemplate&quot;:true,&quot;type&quot;:&quot;text&quot;}"/>
+          <p:cNvPr id="302" name="" descr="{&quot;isTemplate&quot;:true,&quot;type&quot;:&quot;text&quot;}"/>
           <p:cNvSpPr txBox="1"/>
           <p:nvPr/>
         </p:nvSpPr>
@@ -14095,7 +14354,7 @@
       </p:sp>
       <p:sp>
         <p:nvSpPr>
-          <p:cNvPr id="293" name="" descr="{&quot;isTemplate&quot;:true,&quot;type&quot;:&quot;text&quot;}"/>
+          <p:cNvPr id="303" name="" descr="{&quot;isTemplate&quot;:true,&quot;type&quot;:&quot;text&quot;}"/>
           <p:cNvSpPr txBox="1"/>
           <p:nvPr/>
         </p:nvSpPr>
@@ -14144,7 +14403,7 @@
       </p:sp>
       <p:sp>
         <p:nvSpPr>
-          <p:cNvPr id="294" name="" descr="{&quot;isTemplate&quot;:true,&quot;type&quot;:&quot;text&quot;}"/>
+          <p:cNvPr id="304" name="" descr="{&quot;isTemplate&quot;:true,&quot;type&quot;:&quot;text&quot;}"/>
           <p:cNvSpPr txBox="1"/>
           <p:nvPr/>
         </p:nvSpPr>
@@ -14179,7 +14438,7 @@
       </p:sp>
       <p:sp>
         <p:nvSpPr>
-          <p:cNvPr id="295" name="" descr="{&quot;isTemplate&quot;:true,&quot;type&quot;:&quot;text&quot;}"/>
+          <p:cNvPr id="305" name="" descr="{&quot;isTemplate&quot;:true,&quot;type&quot;:&quot;text&quot;}"/>
           <p:cNvSpPr txBox="1"/>
           <p:nvPr/>
         </p:nvSpPr>
@@ -14264,7 +14523,7 @@
       </p:sp>
       <p:sp>
         <p:nvSpPr>
-          <p:cNvPr id="296" name=""/>
+          <p:cNvPr id="306" name=""/>
           <p:cNvSpPr/>
           <p:nvPr/>
         </p:nvSpPr>
@@ -14306,7 +14565,7 @@
       </p:sp>
       <p:sp>
         <p:nvSpPr>
-          <p:cNvPr id="297" name="" descr="{&quot;isTemplate&quot;:true,&quot;type&quot;:&quot;text&quot;}"/>
+          <p:cNvPr id="307" name="" descr="{&quot;isTemplate&quot;:true,&quot;type&quot;:&quot;text&quot;}"/>
           <p:cNvSpPr txBox="1"/>
           <p:nvPr/>
         </p:nvSpPr>
@@ -14343,7 +14602,7 @@
       </p:sp>
       <p:sp>
         <p:nvSpPr>
-          <p:cNvPr id="298" name=""/>
+          <p:cNvPr id="308" name=""/>
           <p:cNvSpPr/>
           <p:nvPr/>
         </p:nvSpPr>
@@ -14376,7 +14635,7 @@
       </p:sp>
       <p:sp>
         <p:nvSpPr>
-          <p:cNvPr id="299" name="" descr="{&quot;isTemplate&quot;:true,&quot;type&quot;:&quot;text&quot;}"/>
+          <p:cNvPr id="309" name="" descr="{&quot;isTemplate&quot;:true,&quot;type&quot;:&quot;text&quot;}"/>
           <p:cNvSpPr txBox="1"/>
           <p:nvPr/>
         </p:nvSpPr>
@@ -14411,7 +14670,7 @@
       </p:sp>
       <p:sp>
         <p:nvSpPr>
-          <p:cNvPr id="300" name="" descr="{&quot;isTemplate&quot;:true,&quot;type&quot;:&quot;text&quot;}"/>
+          <p:cNvPr id="310" name="" descr="{&quot;isTemplate&quot;:true,&quot;type&quot;:&quot;text&quot;}"/>
           <p:cNvSpPr txBox="1"/>
           <p:nvPr/>
         </p:nvSpPr>
@@ -14446,7 +14705,7 @@
       </p:sp>
       <p:sp>
         <p:nvSpPr>
-          <p:cNvPr id="301" name="" descr="{&quot;isTemplate&quot;:true,&quot;type&quot;:&quot;text&quot;}"/>
+          <p:cNvPr id="311" name="" descr="{&quot;isTemplate&quot;:true,&quot;type&quot;:&quot;text&quot;}"/>
           <p:cNvSpPr txBox="1"/>
           <p:nvPr/>
         </p:nvSpPr>
@@ -14467,7 +14726,7 @@
       </p:sp>
       <p:sp>
         <p:nvSpPr>
-          <p:cNvPr id="302" name="" descr="{&quot;isTemplate&quot;:true,&quot;type&quot;:&quot;text&quot;}"/>
+          <p:cNvPr id="312" name="" descr="{&quot;isTemplate&quot;:true,&quot;type&quot;:&quot;text&quot;}"/>
           <p:cNvSpPr txBox="1"/>
           <p:nvPr/>
         </p:nvSpPr>
@@ -14512,7 +14771,7 @@
       </p:sp>
       <p:sp>
         <p:nvSpPr>
-          <p:cNvPr id="303" name=""/>
+          <p:cNvPr id="313" name=""/>
           <p:cNvSpPr/>
           <p:nvPr/>
         </p:nvSpPr>
@@ -14554,7 +14813,7 @@
       </p:sp>
       <p:sp>
         <p:nvSpPr>
-          <p:cNvPr id="304" name="" descr="{&quot;isTemplate&quot;:true,&quot;type&quot;:&quot;text&quot;}"/>
+          <p:cNvPr id="314" name="" descr="{&quot;isTemplate&quot;:true,&quot;type&quot;:&quot;text&quot;}"/>
           <p:cNvSpPr txBox="1"/>
           <p:nvPr/>
         </p:nvSpPr>
@@ -14611,7 +14870,7 @@
       </p:sp>
       <p:sp>
         <p:nvSpPr>
-          <p:cNvPr id="305" name="" descr="{&quot;isTemplate&quot;:true,&quot;type&quot;:&quot;text&quot;}"/>
+          <p:cNvPr id="315" name="" descr="{&quot;isTemplate&quot;:true,&quot;type&quot;:&quot;text&quot;}"/>
           <p:cNvSpPr txBox="1"/>
           <p:nvPr/>
         </p:nvSpPr>
@@ -14666,7 +14925,7 @@
       </p:sp>
       <p:sp>
         <p:nvSpPr>
-          <p:cNvPr id="306" name="" descr="{&quot;isTemplate&quot;:true,&quot;type&quot;:&quot;text&quot;}"/>
+          <p:cNvPr id="316" name="" descr="{&quot;isTemplate&quot;:true,&quot;type&quot;:&quot;text&quot;}"/>
           <p:cNvSpPr txBox="1"/>
           <p:nvPr/>
         </p:nvSpPr>
@@ -14709,7 +14968,7 @@
   <p:cSld>
     <p:spTree>
       <p:nvGrpSpPr>
-        <p:cNvPr id="307" name="" descr="&lt;Slide style={{ width: '1280px', height: '720px', background: 'linear-gradient(135deg, #172133 0%, #22395E 100%)', position: 'relative' }}&gt;&#13;&#10;  &lt;div style={{ position: 'absolute', inset: 0, display: 'flex', flexDirection: 'column', alignItems: 'center', justifyContent: 'center', color: '#FBFCFA' }}&gt;&#13;&#10;    &lt;div style={{ color: '#BD9B56', fontSize: 26, marginBottom: 22, letterSpacing: '0.4em' }}&gt;◆&lt;/div&gt;&#13;&#10;    &lt;h1 style={{ fontSize: 56, fontWeight: 'bold', margin: 0, color: '#FBFCFA', letterSpacing: '0.12em' }}&gt;感谢聆听&lt;/h1&gt;&#13;&#10;    &lt;div style={{ width: 80, height: 3, background: '#BD9B56', marginTop: 26, marginBottom: 26 }} /&gt;&#13;&#10;    &lt;p style={{ fontSize: 20, color: 'rgba(189,155,86,0.9)', margin: 0, letterSpacing: '0.15em' }}&gt;让 AI 真正走进社区&lt;/p&gt;&#13;&#10;    &lt;div style={{ marginTop: 56, padding: '20px 40px', background: 'rgba(189,155,86,0.08)', border: '1px solid rgba(189,155,86,0.3)', borderRadius: 8, textAlign: 'center' }}&gt;&#13;&#10;      &lt;div style={{ fontSize: 12, color: '#BD9B56', letterSpacing: '0.25em', marginBottom: 10 }}&gt;ONLINE DEMO&lt;/div&gt;&#13;&#10;      &lt;div style={{ fontSize: 17, color: '#FBFCFA', fontFamily: 'Inter, sans-serif', marginBottom: 4 }}&gt;http://119.91.236.85&lt;/div&gt;&#13;&#10;      &lt;div style={{ fontSize: 12, color: 'rgba(251,252,250,0.7)' }}&gt;业主 guoyi378 · 物业 mayun420 · 维修 yangfei423（密码 123456）&lt;/div&gt;&#13;&#10;    &lt;/div&gt;&#13;&#10;  &lt;/div&gt;&#13;&#10;  &lt;div style={{ position: 'absolute', left: 64, bottom: 28, color: '#BD9B56', fontSize: 13, letterSpacing: '0.12em' }}&gt;云溪花园 · 智慧社区&lt;/div&gt;&#13;&#10;  &lt;div style={{ position: 'absolute', right: 28, bottom: 28, color: 'rgba(189,155,86,0.75)', fontSize: 13 }}&gt;19 / 19&lt;/div&gt;&#13;&#10;&lt;/Slide&gt;"/>
+        <p:cNvPr id="317" name="" descr="&lt;Slide style={{ width: '1280px', height: '720px', background: 'linear-gradient(135deg, #172133 0%, #22395E 100%)', position: 'relative' }}&gt;&#13;&#10;  &lt;div style={{ position: 'absolute', inset: 0, display: 'flex', flexDirection: 'column', alignItems: 'center', justifyContent: 'center', color: '#FBFCFA' }}&gt;&#13;&#10;    &lt;div style={{ color: '#BD9B56', fontSize: 26, marginBottom: 22, letterSpacing: '0.4em' }}&gt;◆&lt;/div&gt;&#13;&#10;    &lt;h1 style={{ fontSize: 56, fontWeight: 'bold', margin: 0, color: '#FBFCFA', letterSpacing: '0.12em' }}&gt;感谢聆听&lt;/h1&gt;&#13;&#10;    &lt;div style={{ width: 80, height: 3, background: '#BD9B56', marginTop: 26, marginBottom: 26 }} /&gt;&#13;&#10;    &lt;p style={{ fontSize: 20, color: 'rgba(189,155,86,0.9)', margin: 0, letterSpacing: '0.15em' }}&gt;让 AI 真正走进社区&lt;/p&gt;&#13;&#10;    &lt;div style={{ marginTop: 56, padding: '20px 40px', background: 'rgba(189,155,86,0.08)', border: '1px solid rgba(189,155,86,0.3)', borderRadius: 8, textAlign: 'center' }}&gt;&#13;&#10;      &lt;div style={{ fontSize: 12, color: '#BD9B56', letterSpacing: '0.25em', marginBottom: 10 }}&gt;ONLINE DEMO&lt;/div&gt;&#13;&#10;      &lt;div style={{ fontSize: 17, color: '#FBFCFA', fontFamily: 'Inter, sans-serif', marginBottom: 4 }}&gt;http://119.91.236.85&lt;/div&gt;&#13;&#10;      &lt;div style={{ fontSize: 12, color: 'rgba(251,252,250,0.7)' }}&gt;业主 guoyi378 · 物业 mayun420 · 维修 yangfei423（密码 123456）&lt;/div&gt;&#13;&#10;    &lt;/div&gt;&#13;&#10;  &lt;/div&gt;&#13;&#10;  &lt;div style={{ position: 'absolute', left: 64, bottom: 28, color: '#BD9B56', fontSize: 13, letterSpacing: '0.12em' }}&gt;云溪花园 · 智慧社区&lt;/div&gt;&#13;&#10;  &lt;div style={{ position: 'absolute', right: 28, bottom: 28, color: 'rgba(189,155,86,0.75)', fontSize: 13 }}&gt;19 / 19&lt;/div&gt;&#13;&#10;&lt;/Slide&gt;"/>
         <p:cNvGrpSpPr/>
         <p:nvPr/>
       </p:nvGrpSpPr>
@@ -14723,7 +14982,7 @@
       </p:grpSpPr>
       <p:sp>
         <p:nvSpPr>
-          <p:cNvPr id="308" name=""/>
+          <p:cNvPr id="318" name=""/>
           <p:cNvSpPr/>
           <p:nvPr/>
         </p:nvSpPr>
@@ -14755,7 +15014,7 @@
       </p:sp>
       <p:sp>
         <p:nvSpPr>
-          <p:cNvPr id="309" name="" descr="{&quot;isTemplate&quot;:true,&quot;type&quot;:&quot;text&quot;}"/>
+          <p:cNvPr id="319" name="" descr="{&quot;isTemplate&quot;:true,&quot;type&quot;:&quot;text&quot;}"/>
           <p:cNvSpPr txBox="1"/>
           <p:nvPr/>
         </p:nvSpPr>
@@ -14790,7 +15049,7 @@
       </p:sp>
       <p:sp>
         <p:nvSpPr>
-          <p:cNvPr id="310" name="" descr="{&quot;isTemplate&quot;:true,&quot;type&quot;:&quot;text&quot;}"/>
+          <p:cNvPr id="320" name="" descr="{&quot;isTemplate&quot;:true,&quot;type&quot;:&quot;text&quot;}"/>
           <p:cNvSpPr txBox="1"/>
           <p:nvPr/>
         </p:nvSpPr>
@@ -14825,7 +15084,7 @@
       </p:sp>
       <p:sp>
         <p:nvSpPr>
-          <p:cNvPr id="311" name=""/>
+          <p:cNvPr id="321" name=""/>
           <p:cNvSpPr/>
           <p:nvPr/>
         </p:nvSpPr>
@@ -14849,7 +15108,7 @@
       </p:sp>
       <p:sp>
         <p:nvSpPr>
-          <p:cNvPr id="312" name="" descr="{&quot;isTemplate&quot;:true,&quot;type&quot;:&quot;text&quot;}"/>
+          <p:cNvPr id="322" name="" descr="{&quot;isTemplate&quot;:true,&quot;type&quot;:&quot;text&quot;}"/>
           <p:cNvSpPr txBox="1"/>
           <p:nvPr/>
         </p:nvSpPr>
@@ -14910,7 +15169,7 @@
       </p:sp>
       <p:sp>
         <p:nvSpPr>
-          <p:cNvPr id="313" name=""/>
+          <p:cNvPr id="323" name=""/>
           <p:cNvSpPr/>
           <p:nvPr/>
         </p:nvSpPr>
@@ -14945,7 +15204,7 @@
       </p:sp>
       <p:sp>
         <p:nvSpPr>
-          <p:cNvPr id="314" name="" descr="{&quot;isTemplate&quot;:true,&quot;type&quot;:&quot;text&quot;}"/>
+          <p:cNvPr id="324" name="" descr="{&quot;isTemplate&quot;:true,&quot;type&quot;:&quot;text&quot;}"/>
           <p:cNvSpPr txBox="1"/>
           <p:nvPr/>
         </p:nvSpPr>
@@ -14980,7 +15239,7 @@
       </p:sp>
       <p:sp>
         <p:nvSpPr>
-          <p:cNvPr id="315" name="" descr="{&quot;isTemplate&quot;:true,&quot;type&quot;:&quot;text&quot;}"/>
+          <p:cNvPr id="325" name="" descr="{&quot;isTemplate&quot;:true,&quot;type&quot;:&quot;text&quot;}"/>
           <p:cNvSpPr txBox="1"/>
           <p:nvPr/>
         </p:nvSpPr>
@@ -15015,7 +15274,7 @@
       </p:sp>
       <p:sp>
         <p:nvSpPr>
-          <p:cNvPr id="316" name="" descr="{&quot;isTemplate&quot;:true,&quot;type&quot;:&quot;text&quot;}"/>
+          <p:cNvPr id="326" name="" descr="{&quot;isTemplate&quot;:true,&quot;type&quot;:&quot;text&quot;}"/>
           <p:cNvSpPr txBox="1"/>
           <p:nvPr/>
         </p:nvSpPr>
@@ -15148,7 +15407,7 @@
       </p:sp>
       <p:sp>
         <p:nvSpPr>
-          <p:cNvPr id="317" name="" descr="{&quot;isTemplate&quot;:true,&quot;type&quot;:&quot;text&quot;}"/>
+          <p:cNvPr id="327" name="" descr="{&quot;isTemplate&quot;:true,&quot;type&quot;:&quot;text&quot;}"/>
           <p:cNvSpPr txBox="1"/>
           <p:nvPr/>
         </p:nvSpPr>
@@ -15203,7 +15462,7 @@
       </p:sp>
       <p:sp>
         <p:nvSpPr>
-          <p:cNvPr id="318" name="" descr="{&quot;isTemplate&quot;:true,&quot;type&quot;:&quot;text&quot;}"/>
+          <p:cNvPr id="328" name="" descr="{&quot;isTemplate&quot;:true,&quot;type&quot;:&quot;text&quot;}"/>
           <p:cNvSpPr txBox="1"/>
           <p:nvPr/>
         </p:nvSpPr>
@@ -15248,7 +15507,7 @@
   <p:cSld>
     <p:spTree>
       <p:nvGrpSpPr>
-        <p:cNvPr id="319" name="" descr="&lt;Slide style={{ width: '1280px', height: '720px', background: '#FBFCFA', position: 'relative', padding: '40px 64px', boxSizing: 'border-box', display: 'flex', flexDirection: 'column' }}&gt;&#13;&#10;  &lt;div style={{ flexShrink: 0 }}&gt;&#13;&#10;    &lt;div style={{ color: '#BD9B56', fontSize: 14, letterSpacing: '0.3em', marginBottom: 10 }}&gt;CONTENTS&lt;/div&gt;&#13;&#10;    &lt;h2 style={{ fontSize: 34, fontWeight: 'bold', color: '#172133', margin: 0 }}&gt;目录&lt;/h2&gt;&#13;&#10;    &lt;div style={{ width: 64, height: 3, background: '#BD9B56', marginTop: 16 }} /&gt;&#13;&#10;  &lt;/div&gt;&#13;&#10;  &lt;div style={{ flex: 1, display: 'flex', alignItems: 'center' }}&gt;&#13;&#10;    &lt;div style={{ width: '100%', display: 'flex', flexDirection: 'column', gap: 20 }}&gt;&#13;&#10;      &lt;div style={{ display: 'flex', alignItems: 'center', gap: 28, paddingBottom: 18, borderBottom: '1px solid rgba(34,57,94,0.12)' }}&gt;&#13;&#10;        &lt;span style={{ color: '#BD9B56', fontSize: 40, fontWeight: 'bold', lineHeight: 1, minWidth: 72, fontFamily: 'Inter, sans-serif' }}&gt;01&lt;/span&gt;&#13;&#10;        &lt;div style={{ flex: 1 }}&gt;&#13;&#10;          &lt;div style={{ fontSize: 22, fontWeight: 'bold', color: '#172133' }}&gt;项目背景与规模&lt;/div&gt;&#13;&#10;          &lt;div style={{ fontSize: 14, color: '#6b7075', marginTop: 6 }}&gt;传统物业痛点 · 虚拟社区「云溪花园」数据资产&lt;/div&gt;&#13;&#10;        &lt;/div&gt;&#13;&#10;      &lt;/div&gt;&#13;&#10;      &lt;div style={{ display: 'flex', alignItems: 'center', gap: 28, paddingBottom: 18, borderBottom: '1px solid rgba(34,57,94,0.12)' }}&gt;&#13;&#10;        &lt;span style={{ color: '#BD9B56', fontSize: 40, fontWeight: 'bold', lineHeight: 1, minWidth: 72, fontFamily: 'Inter, sans-serif' }}&gt;02&lt;/span&gt;&#13;&#10;        &lt;div style={{ flex: 1 }}&gt;&#13;&#10;          &lt;div style={{ fontSize: 22, fontWeight: 'bold', color: '#172133' }}&gt;技术构建过程&lt;/div&gt;&#13;&#10;          &lt;div style={{ fontSize: 14, color: '#6b7075', marginTop: 6 }}&gt;数据库设计 → 后端 → 前端 → AI Agent → RAG 知识库&lt;/div&gt;&#13;&#10;        &lt;/div&gt;&#13;&#10;      &lt;/div&gt;&#13;&#10;      &lt;div style={{ display: 'flex', alignItems: 'center', gap: 28, paddingBottom: 18, borderBottom: '1px solid rgba(34,57,94,0.12)' }}&gt;&#13;&#10;        &lt;span style={{ color: '#BD9B56', fontSize: 40, fontWeight: 'bold', lineHeight: 1, minWidth: 72, fontFamily: 'Inter, sans-serif' }}&gt;03&lt;/span&gt;&#13;&#10;        &lt;div style={{ flex: 1 }}&gt;&#13;&#10;          &lt;div style={{ fontSize: 22, fontWeight: 'bold', color: '#172133' }}&gt;成果与验证&lt;/div&gt;&#13;&#10;          &lt;div style={{ fontSize: 14, color: '#6b7075', marginTop: 6 }}&gt;三条功能闭环 · 量化评估指标&lt;/div&gt;&#13;&#10;        &lt;/div&gt;&#13;&#10;      &lt;/div&gt;&#13;&#10;      &lt;div style={{ display: 'flex', alignItems: 'center', gap: 28 }}&gt;&#13;&#10;        &lt;span style={{ color: '#BD9B56', fontSize: 40, fontWeight: 'bold', lineHeight: 1, minWidth: 72, fontFamily: 'Inter, sans-serif' }}&gt;04&lt;/span&gt;&#13;&#10;        &lt;div style={{ flex: 1 }}&gt;&#13;&#10;          &lt;div style={{ fontSize: 22, fontWeight: 'bold', color: '#172133' }}&gt;总结与展望&lt;/div&gt;&#13;&#10;          &lt;div style={{ fontSize: 14, color: '#6b7075', marginTop: 6 }}&gt;项目价值 · 在线演示入口&lt;/div&gt;&#13;&#10;        &lt;/div&gt;&#13;&#10;      &lt;/div&gt;&#13;&#10;    &lt;/div&gt;&#13;&#10;  &lt;/div&gt;&#13;&#10;  &lt;div style={{ flexShrink: 0, height: 44, display: 'flex', alignItems: 'flex-end', justifyContent: 'space-between' }}&gt;&#13;&#10;    &lt;span style={{ color: '#BD9B56', fontSize: 12, letterSpacing: '0.1em' }}&gt;云溪花园 · 智慧社区&lt;/span&gt;&#13;&#10;    &lt;span style={{ color: '#a09b8c', fontSize: 12 }}&gt;02 / 19&lt;/span&gt;&#13;&#10;  &lt;/div&gt;&#13;&#10;&lt;/Slide&gt;"/>
+        <p:cNvPr id="329" name="" descr="&lt;Slide style={{ width: '1280px', height: '720px', background: '#FBFCFA', position: 'relative', padding: '40px 64px', boxSizing: 'border-box', display: 'flex', flexDirection: 'column' }}&gt;&#13;&#10;  &lt;div style={{ flexShrink: 0 }}&gt;&#13;&#10;    &lt;div style={{ color: '#BD9B56', fontSize: 14, letterSpacing: '0.3em', marginBottom: 10 }}&gt;CONTENTS&lt;/div&gt;&#13;&#10;    &lt;h2 style={{ fontSize: 34, fontWeight: 'bold', color: '#172133', margin: 0 }}&gt;目录&lt;/h2&gt;&#13;&#10;    &lt;div style={{ width: 64, height: 3, background: '#BD9B56', marginTop: 16 }} /&gt;&#13;&#10;  &lt;/div&gt;&#13;&#10;  &lt;div style={{ flex: 1, display: 'flex', alignItems: 'center' }}&gt;&#13;&#10;    &lt;div style={{ width: '100%', display: 'flex', flexDirection: 'column', gap: 20 }}&gt;&#13;&#10;      &lt;div style={{ display: 'flex', alignItems: 'center', gap: 28, paddingBottom: 18, borderBottom: '1px solid rgba(34,57,94,0.12)' }}&gt;&#13;&#10;        &lt;span style={{ color: '#BD9B56', fontSize: 40, fontWeight: 'bold', lineHeight: 1, minWidth: 72, fontFamily: 'Inter, sans-serif' }}&gt;01&lt;/span&gt;&#13;&#10;        &lt;div style={{ flex: 1 }}&gt;&#13;&#10;          &lt;div style={{ fontSize: 22, fontWeight: 'bold', color: '#172133' }}&gt;项目背景与规模&lt;/div&gt;&#13;&#10;          &lt;div style={{ fontSize: 14, color: '#6b7075', marginTop: 6 }}&gt;传统物业痛点 · 虚拟社区「云溪花园」数据资产&lt;/div&gt;&#13;&#10;        &lt;/div&gt;&#13;&#10;      &lt;/div&gt;&#13;&#10;      &lt;div style={{ display: 'flex', alignItems: 'center', gap: 28, paddingBottom: 18, borderBottom: '1px solid rgba(34,57,94,0.12)' }}&gt;&#13;&#10;        &lt;span style={{ color: '#BD9B56', fontSize: 40, fontWeight: 'bold', lineHeight: 1, minWidth: 72, fontFamily: 'Inter, sans-serif' }}&gt;02&lt;/span&gt;&#13;&#10;        &lt;div style={{ flex: 1 }}&gt;&#13;&#10;          &lt;div style={{ fontSize: 22, fontWeight: 'bold', color: '#172133' }}&gt;技术构建过程&lt;/div&gt;&#13;&#10;          &lt;div style={{ fontSize: 14, color: '#6b7075', marginTop: 6 }}&gt;数据库设计 → 后端 → 前端 → AI Agent → RAG 知识库&lt;/div&gt;&#13;&#10;        &lt;/div&gt;&#13;&#10;      &lt;/div&gt;&#13;&#10;      &lt;div style={{ display: 'flex', alignItems: 'center', gap: 28, paddingBottom: 18, borderBottom: '1px solid rgba(34,57,94,0.12)' }}&gt;&#13;&#10;        &lt;span style={{ color: '#BD9B56', fontSize: 40, fontWeight: 'bold', lineHeight: 1, minWidth: 72, fontFamily: 'Inter, sans-serif' }}&gt;03&lt;/span&gt;&#13;&#10;        &lt;div style={{ flex: 1 }}&gt;&#13;&#10;          &lt;div style={{ fontSize: 22, fontWeight: 'bold', color: '#172133' }}&gt;成果与验证&lt;/div&gt;&#13;&#10;          &lt;div style={{ fontSize: 14, color: '#6b7075', marginTop: 6 }}&gt;三条功能闭环 · 量化评估指标&lt;/div&gt;&#13;&#10;        &lt;/div&gt;&#13;&#10;      &lt;/div&gt;&#13;&#10;      &lt;div style={{ display: 'flex', alignItems: 'center', gap: 28 }}&gt;&#13;&#10;        &lt;span style={{ color: '#BD9B56', fontSize: 40, fontWeight: 'bold', lineHeight: 1, minWidth: 72, fontFamily: 'Inter, sans-serif' }}&gt;04&lt;/span&gt;&#13;&#10;        &lt;div style={{ flex: 1 }}&gt;&#13;&#10;          &lt;div style={{ fontSize: 22, fontWeight: 'bold', color: '#172133' }}&gt;总结与展望&lt;/div&gt;&#13;&#10;          &lt;div style={{ fontSize: 14, color: '#6b7075', marginTop: 6 }}&gt;项目价值 · 在线演示入口&lt;/div&gt;&#13;&#10;        &lt;/div&gt;&#13;&#10;      &lt;/div&gt;&#13;&#10;    &lt;/div&gt;&#13;&#10;  &lt;/div&gt;&#13;&#10;  &lt;div style={{ flexShrink: 0, height: 44, display: 'flex', alignItems: 'flex-end', justifyContent: 'space-between' }}&gt;&#13;&#10;    &lt;span style={{ color: '#BD9B56', fontSize: 12, letterSpacing: '0.1em' }}&gt;云溪花园 · 智慧社区&lt;/span&gt;&#13;&#10;    &lt;span style={{ color: '#a09b8c', fontSize: 12 }}&gt;02 / 19&lt;/span&gt;&#13;&#10;  &lt;/div&gt;&#13;&#10;&lt;/Slide&gt;"/>
         <p:cNvGrpSpPr/>
         <p:nvPr/>
       </p:nvGrpSpPr>
@@ -15262,7 +15521,7 @@
       </p:grpSpPr>
       <p:sp>
         <p:nvSpPr>
-          <p:cNvPr id="320" name=""/>
+          <p:cNvPr id="330" name=""/>
           <p:cNvSpPr/>
           <p:nvPr/>
         </p:nvSpPr>
@@ -15286,7 +15545,7 @@
       </p:sp>
       <p:sp>
         <p:nvSpPr>
-          <p:cNvPr id="321" name="" descr="{&quot;isTemplate&quot;:true,&quot;type&quot;:&quot;text&quot;}"/>
+          <p:cNvPr id="331" name="" descr="{&quot;isTemplate&quot;:true,&quot;type&quot;:&quot;text&quot;}"/>
           <p:cNvSpPr txBox="1"/>
           <p:nvPr/>
         </p:nvSpPr>
@@ -15321,7 +15580,7 @@
       </p:sp>
       <p:sp>
         <p:nvSpPr>
-          <p:cNvPr id="322" name="" descr="{&quot;isTemplate&quot;:true,&quot;type&quot;:&quot;text&quot;}"/>
+          <p:cNvPr id="332" name="" descr="{&quot;isTemplate&quot;:true,&quot;type&quot;:&quot;text&quot;}"/>
           <p:cNvSpPr txBox="1"/>
           <p:nvPr/>
         </p:nvSpPr>
@@ -15356,7 +15615,7 @@
       </p:sp>
       <p:sp>
         <p:nvSpPr>
-          <p:cNvPr id="323" name=""/>
+          <p:cNvPr id="333" name=""/>
           <p:cNvSpPr/>
           <p:nvPr/>
         </p:nvSpPr>
@@ -15380,7 +15639,7 @@
       </p:sp>
       <p:sp>
         <p:nvSpPr>
-          <p:cNvPr id="324" name=""/>
+          <p:cNvPr id="334" name=""/>
           <p:cNvSpPr/>
           <p:nvPr/>
         </p:nvSpPr>
@@ -15422,7 +15681,7 @@
       </p:sp>
       <p:sp>
         <p:nvSpPr>
-          <p:cNvPr id="325" name="" descr="{&quot;isTemplate&quot;:true,&quot;type&quot;:&quot;text&quot;}"/>
+          <p:cNvPr id="335" name="" descr="{&quot;isTemplate&quot;:true,&quot;type&quot;:&quot;text&quot;}"/>
           <p:cNvSpPr txBox="1"/>
           <p:nvPr/>
         </p:nvSpPr>
@@ -15457,7 +15716,7 @@
       </p:sp>
       <p:sp>
         <p:nvSpPr>
-          <p:cNvPr id="326" name="" descr="{&quot;isTemplate&quot;:true,&quot;type&quot;:&quot;text&quot;}"/>
+          <p:cNvPr id="336" name="" descr="{&quot;isTemplate&quot;:true,&quot;type&quot;:&quot;text&quot;}"/>
           <p:cNvSpPr txBox="1"/>
           <p:nvPr/>
         </p:nvSpPr>
@@ -15492,7 +15751,7 @@
       </p:sp>
       <p:sp>
         <p:nvSpPr>
-          <p:cNvPr id="327" name="" descr="{&quot;isTemplate&quot;:true,&quot;type&quot;:&quot;text&quot;}"/>
+          <p:cNvPr id="337" name="" descr="{&quot;isTemplate&quot;:true,&quot;type&quot;:&quot;text&quot;}"/>
           <p:cNvSpPr txBox="1"/>
           <p:nvPr/>
         </p:nvSpPr>
@@ -15547,7 +15806,7 @@
       </p:sp>
       <p:sp>
         <p:nvSpPr>
-          <p:cNvPr id="328" name=""/>
+          <p:cNvPr id="338" name=""/>
           <p:cNvSpPr/>
           <p:nvPr/>
         </p:nvSpPr>
@@ -15589,7 +15848,7 @@
       </p:sp>
       <p:sp>
         <p:nvSpPr>
-          <p:cNvPr id="329" name="" descr="{&quot;isTemplate&quot;:true,&quot;type&quot;:&quot;text&quot;}"/>
+          <p:cNvPr id="339" name="" descr="{&quot;isTemplate&quot;:true,&quot;type&quot;:&quot;text&quot;}"/>
           <p:cNvSpPr txBox="1"/>
           <p:nvPr/>
         </p:nvSpPr>
@@ -15624,7 +15883,7 @@
       </p:sp>
       <p:sp>
         <p:nvSpPr>
-          <p:cNvPr id="330" name="" descr="{&quot;isTemplate&quot;:true,&quot;type&quot;:&quot;text&quot;}"/>
+          <p:cNvPr id="340" name="" descr="{&quot;isTemplate&quot;:true,&quot;type&quot;:&quot;text&quot;}"/>
           <p:cNvSpPr txBox="1"/>
           <p:nvPr/>
         </p:nvSpPr>
@@ -15659,7 +15918,7 @@
       </p:sp>
       <p:sp>
         <p:nvSpPr>
-          <p:cNvPr id="331" name="" descr="{&quot;isTemplate&quot;:true,&quot;type&quot;:&quot;text&quot;}"/>
+          <p:cNvPr id="341" name="" descr="{&quot;isTemplate&quot;:true,&quot;type&quot;:&quot;text&quot;}"/>
           <p:cNvSpPr txBox="1"/>
           <p:nvPr/>
         </p:nvSpPr>
@@ -15754,7 +16013,7 @@
       </p:sp>
       <p:sp>
         <p:nvSpPr>
-          <p:cNvPr id="332" name=""/>
+          <p:cNvPr id="342" name=""/>
           <p:cNvSpPr/>
           <p:nvPr/>
         </p:nvSpPr>
@@ -15796,7 +16055,7 @@
       </p:sp>
       <p:sp>
         <p:nvSpPr>
-          <p:cNvPr id="333" name="" descr="{&quot;isTemplate&quot;:true,&quot;type&quot;:&quot;text&quot;}"/>
+          <p:cNvPr id="343" name="" descr="{&quot;isTemplate&quot;:true,&quot;type&quot;:&quot;text&quot;}"/>
           <p:cNvSpPr txBox="1"/>
           <p:nvPr/>
         </p:nvSpPr>
@@ -15831,7 +16090,7 @@
       </p:sp>
       <p:sp>
         <p:nvSpPr>
-          <p:cNvPr id="334" name="" descr="{&quot;isTemplate&quot;:true,&quot;type&quot;:&quot;text&quot;}"/>
+          <p:cNvPr id="344" name="" descr="{&quot;isTemplate&quot;:true,&quot;type&quot;:&quot;text&quot;}"/>
           <p:cNvSpPr txBox="1"/>
           <p:nvPr/>
         </p:nvSpPr>
@@ -15866,7 +16125,7 @@
       </p:sp>
       <p:sp>
         <p:nvSpPr>
-          <p:cNvPr id="335" name="" descr="{&quot;isTemplate&quot;:true,&quot;type&quot;:&quot;text&quot;}"/>
+          <p:cNvPr id="345" name="" descr="{&quot;isTemplate&quot;:true,&quot;type&quot;:&quot;text&quot;}"/>
           <p:cNvSpPr txBox="1"/>
           <p:nvPr/>
         </p:nvSpPr>
@@ -15921,7 +16180,7 @@
       </p:sp>
       <p:sp>
         <p:nvSpPr>
-          <p:cNvPr id="336" name="" descr="{&quot;isTemplate&quot;:true,&quot;type&quot;:&quot;text&quot;}"/>
+          <p:cNvPr id="346" name="" descr="{&quot;isTemplate&quot;:true,&quot;type&quot;:&quot;text&quot;}"/>
           <p:cNvSpPr txBox="1"/>
           <p:nvPr/>
         </p:nvSpPr>
@@ -15956,7 +16215,7 @@
       </p:sp>
       <p:sp>
         <p:nvSpPr>
-          <p:cNvPr id="337" name="" descr="{&quot;isTemplate&quot;:true,&quot;type&quot;:&quot;text&quot;}"/>
+          <p:cNvPr id="347" name="" descr="{&quot;isTemplate&quot;:true,&quot;type&quot;:&quot;text&quot;}"/>
           <p:cNvSpPr txBox="1"/>
           <p:nvPr/>
         </p:nvSpPr>
@@ -15991,7 +16250,7 @@
       </p:sp>
       <p:sp>
         <p:nvSpPr>
-          <p:cNvPr id="338" name="" descr="{&quot;isTemplate&quot;:true,&quot;type&quot;:&quot;text&quot;}"/>
+          <p:cNvPr id="348" name="" descr="{&quot;isTemplate&quot;:true,&quot;type&quot;:&quot;text&quot;}"/>
           <p:cNvSpPr txBox="1"/>
           <p:nvPr/>
         </p:nvSpPr>
@@ -16046,7 +16305,7 @@
       </p:sp>
       <p:sp>
         <p:nvSpPr>
-          <p:cNvPr id="339" name="" descr="{&quot;isTemplate&quot;:true,&quot;type&quot;:&quot;text&quot;}"/>
+          <p:cNvPr id="349" name="" descr="{&quot;isTemplate&quot;:true,&quot;type&quot;:&quot;text&quot;}"/>
           <p:cNvSpPr txBox="1"/>
           <p:nvPr/>
         </p:nvSpPr>
@@ -16101,7 +16360,7 @@
       </p:sp>
       <p:sp>
         <p:nvSpPr>
-          <p:cNvPr id="340" name="" descr="{&quot;isTemplate&quot;:true,&quot;type&quot;:&quot;text&quot;}"/>
+          <p:cNvPr id="350" name="" descr="{&quot;isTemplate&quot;:true,&quot;type&quot;:&quot;text&quot;}"/>
           <p:cNvSpPr txBox="1"/>
           <p:nvPr/>
         </p:nvSpPr>
@@ -16144,7 +16403,7 @@
   <p:cSld>
     <p:spTree>
       <p:nvGrpSpPr>
-        <p:cNvPr id="341" name="" descr="&lt;Slide style={{ width: '1280px', height: '720px', background: 'linear-gradient(135deg, #172133 0%, #22395E 100%)', position: 'relative', display: 'flex', flexDirection: 'column', justifyContent: 'center', padding: '0 96px' }}&gt;&#10;  &lt;div style={{ color: '#BD9B56', fontSize: 15, letterSpacing: '0.35em', marginBottom: 24 }}&gt;SECTION 01&lt;/div&gt;&#10;  &lt;div style={{ display: 'flex', alignItems: 'baseline', gap: 28 }}&gt;&#10;    &lt;span style={{ fontSize: 110, fontWeight: 'bold', color: 'rgba(189,155,86,0.28)', fontFamily: 'Inter, sans-serif', lineHeight: 1 }}&gt;01&lt;/span&gt;&#10;    &lt;span style={{ fontSize: 46, fontWeight: 'bold', color: '#FBFCFA', letterSpacing: '0.02em' }}&gt;项目背景与规模&lt;/span&gt;&#10;  &lt;/div&gt;&#10;  &lt;div style={{ width: 72, height: 3, background: '#BD9B56', margin: '28px 0 20px' }} /&gt;&#10;  &lt;div style={{ fontSize: 16, color: 'rgba(251,252,250,0.72)', letterSpacing: '0.04em' }}&gt;传统物业痛点 · 虚拟社区「云溪花园」数据资产&lt;/div&gt;&#10;  &lt;div style={{ position: 'absolute', bottom: 42, right: 96, color: 'rgba(251,252,250,0.4)', fontSize: 13, fontFamily: 'Inter, sans-serif' }}&gt;03 / 19&lt;/div&gt;&#10;&lt;/Slide&gt;"/>
+        <p:cNvPr id="351" name="" descr="&lt;Slide style={{ width: '1280px', height: '720px', background: 'linear-gradient(135deg, #172133 0%, #22395E 100%)', position: 'relative', display: 'flex', flexDirection: 'column', justifyContent: 'center', padding: '0 96px' }}&gt;&#10;  &lt;div style={{ color: '#BD9B56', fontSize: 15, letterSpacing: '0.35em', marginBottom: 24 }}&gt;SECTION 01&lt;/div&gt;&#10;  &lt;div style={{ display: 'flex', alignItems: 'center', gap: 36 }}&gt;&#10;    &lt;span style={{ fontSize: 160, fontWeight: 'bold', color: '#BD9B56', lineHeight: 1 }}&gt;01&lt;/span&gt;&#10;    &lt;div&gt;&#10;      &lt;div style={{ fontSize: 50, fontWeight: 'bold', color: '#FBFCFA', letterSpacing: '0.02em', lineHeight: 1.15 }}&gt;项目背景与规模&lt;/div&gt;&#10;      &lt;div style={{ fontSize: 17, color: 'rgba(251,252,250,0.55)', marginTop: 12, letterSpacing: '0.06em' }}&gt;PROJECT BACKGROUND &amp;amp; SCALE&lt;/div&gt;&#10;    &lt;/div&gt;&#10;  &lt;/div&gt;&#10;  &lt;div style={{ width: 80, height: 3, background: '#BD9B56', margin: '32px 0 24px' }} /&gt;&#10;  &lt;div style={{ display: 'flex', gap: 14 }}&gt;&#10;    &lt;span style={{ fontSize: 15, color: 'rgba(251,252,250,0.88)', border: '1px solid rgba(189,155,86,0.65)', padding: '9px 20px', borderRadius: 22 }}&gt;传统物业痛点&lt;/span&gt;&#10;    &lt;span style={{ fontSize: 15, color: 'rgba(251,252,250,0.88)', border: '1px solid rgba(189,155,86,0.65)', padding: '9px 20px', borderRadius: 22 }}&gt;AI Native 方案定位&lt;/span&gt;&#10;    &lt;span style={{ fontSize: 15, color: 'rgba(251,252,250,0.88)', border: '1px solid rgba(189,155,86,0.65)', padding: '9px 20px', borderRadius: 22 }}&gt;虚拟社区「云溪花园」&lt;/span&gt;&#10;  &lt;/div&gt;&#10;  &lt;div style={{ position: 'absolute', bottom: 42, right: 96, color: 'rgba(251,252,250,0.4)', fontSize: 13 }}&gt;03 / 19&lt;/div&gt;&#10;&lt;/Slide&gt;"/>
         <p:cNvGrpSpPr/>
         <p:nvPr/>
       </p:nvGrpSpPr>
@@ -16158,7 +16417,7 @@
       </p:grpSpPr>
       <p:sp>
         <p:nvSpPr>
-          <p:cNvPr id="342" name=""/>
+          <p:cNvPr id="352" name=""/>
           <p:cNvSpPr/>
           <p:nvPr/>
         </p:nvSpPr>
@@ -16190,14 +16449,49 @@
       </p:sp>
       <p:sp>
         <p:nvSpPr>
-          <p:cNvPr id="343" name="" descr="{&quot;isTemplate&quot;:true,&quot;type&quot;:&quot;text&quot;}"/>
+          <p:cNvPr id="353" name="" descr="{&quot;isTemplate&quot;:true,&quot;type&quot;:&quot;text&quot;}"/>
+          <p:cNvSpPr txBox="1"/>
+          <p:nvPr/>
+        </p:nvSpPr>
+        <p:spPr>
+          <a:xfrm rot="0" flipH="0" flipV="0">
+            <a:off x="914400" y="1866900"/>
+            <a:ext cx="10363200" cy="171450"/>
+          </a:xfrm>
+          <a:prstGeom prst="rect"/>
+        </p:spPr>
+        <p:txBody>
+          <a:bodyPr wrap="none" lIns="0" tIns="0" rIns="0" bIns="0"/>
+          <a:p>
+            <a:pPr>
+              <a:lnSpc>
+                <a:spcPct val="100000"/>
+              </a:lnSpc>
+            </a:pPr>
+            <a:r>
+              <a:rPr lang="en-US" sz="1125" spc="-9223372036854775808">
+                <a:solidFill>
+                  <a:srgbClr val="BD9B56"/>
+                </a:solidFill>
+                <a:latin typeface="Microsoft YaHei"/>
+                <a:ea typeface="Microsoft YaHei"/>
+              </a:rPr>
+              <a:t>SECTION 01</a:t>
+            </a:r>
+            <a:endParaRPr/>
+          </a:p>
+        </p:txBody>
+      </p:sp>
+      <p:sp>
+        <p:nvSpPr>
+          <p:cNvPr id="354" name="" descr="{&quot;isTemplate&quot;:true,&quot;type&quot;:&quot;text&quot;}"/>
           <p:cNvSpPr txBox="1"/>
           <p:nvPr/>
         </p:nvSpPr>
         <p:spPr>
           <a:xfrm rot="0" flipH="0" flipV="0">
             <a:off x="914400" y="2266950"/>
-            <a:ext cx="10363200" cy="171450"/>
+            <a:ext cx="1885950" cy="1828800"/>
           </a:xfrm>
           <a:prstGeom prst="rect"/>
         </p:spPr>
@@ -16210,29 +16504,64 @@
               </a:lnSpc>
             </a:pPr>
             <a:r>
-              <a:rPr lang="en-US" sz="1125" spc="-9223372036854775808">
+              <a:rPr lang="en-US" sz="12000" b="1">
                 <a:solidFill>
                   <a:srgbClr val="BD9B56"/>
                 </a:solidFill>
                 <a:latin typeface="Microsoft YaHei"/>
                 <a:ea typeface="Microsoft YaHei"/>
               </a:rPr>
-              <a:t>SECTION 01</a:t>
-            </a:r>
-            <a:endParaRPr/>
-          </a:p>
-        </p:txBody>
-      </p:sp>
-      <p:sp>
-        <p:nvSpPr>
-          <p:cNvPr id="344" name="" descr="{&quot;isTemplate&quot;:true,&quot;type&quot;:&quot;text&quot;}"/>
-          <p:cNvSpPr txBox="1"/>
-          <p:nvPr/>
-        </p:nvSpPr>
-        <p:spPr>
-          <a:xfrm rot="0" flipH="0" flipV="0">
-            <a:off x="914400" y="2667000"/>
-            <a:ext cx="1343025" cy="1257300"/>
+              <a:t>01</a:t>
+            </a:r>
+            <a:endParaRPr/>
+          </a:p>
+        </p:txBody>
+      </p:sp>
+      <p:sp>
+        <p:nvSpPr>
+          <p:cNvPr id="355" name="" descr="{&quot;isTemplate&quot;:true,&quot;type&quot;:&quot;text&quot;}"/>
+          <p:cNvSpPr txBox="1"/>
+          <p:nvPr/>
+        </p:nvSpPr>
+        <p:spPr>
+          <a:xfrm rot="0" flipH="0" flipV="0">
+            <a:off x="3143250" y="2695575"/>
+            <a:ext cx="3333750" cy="657225"/>
+          </a:xfrm>
+          <a:prstGeom prst="rect"/>
+        </p:spPr>
+        <p:txBody>
+          <a:bodyPr wrap="none" lIns="0" tIns="0" rIns="0" bIns="0"/>
+          <a:p>
+            <a:pPr>
+              <a:lnSpc>
+                <a:spcPct val="114999"/>
+              </a:lnSpc>
+            </a:pPr>
+            <a:r>
+              <a:rPr lang="zh-CN" sz="3750" spc="-9223372036854775808">
+                <a:solidFill>
+                  <a:srgbClr val="FBFCFA"/>
+                </a:solidFill>
+                <a:latin typeface="Microsoft YaHei"/>
+                <a:ea typeface="Microsoft YaHei"/>
+              </a:rPr>
+              <a:t>项目背景与规模</a:t>
+            </a:r>
+            <a:endParaRPr/>
+          </a:p>
+        </p:txBody>
+      </p:sp>
+      <p:sp>
+        <p:nvSpPr>
+          <p:cNvPr id="356" name="" descr="{&quot;isTemplate&quot;:true,&quot;type&quot;:&quot;text&quot;}"/>
+          <p:cNvSpPr txBox="1"/>
+          <p:nvPr/>
+        </p:nvSpPr>
+        <p:spPr>
+          <a:xfrm rot="0" flipH="0" flipV="0">
+            <a:off x="3143250" y="3467100"/>
+            <a:ext cx="3333750" cy="200025"/>
           </a:xfrm>
           <a:prstGeom prst="rect"/>
         </p:spPr>
@@ -16245,66 +16574,31 @@
               </a:lnSpc>
             </a:pPr>
             <a:r>
-              <a:rPr lang="en-US" sz="8250" b="1">
-                <a:solidFill>
-                  <a:srgbClr val="BD9B56">
-                    <a:alpha val="28000"/>
+              <a:rPr lang="en-US" sz="1275" spc="-9223372036854775808">
+                <a:solidFill>
+                  <a:srgbClr val="FBFCFA">
+                    <a:alpha val="55000"/>
                   </a:srgbClr>
                 </a:solidFill>
-                <a:latin typeface="Inter"/>
-                <a:ea typeface="Inter"/>
-              </a:rPr>
-              <a:t>01</a:t>
-            </a:r>
-            <a:endParaRPr/>
-          </a:p>
-        </p:txBody>
-      </p:sp>
-      <p:sp>
-        <p:nvSpPr>
-          <p:cNvPr id="345" name="" descr="{&quot;isTemplate&quot;:true,&quot;type&quot;:&quot;text&quot;}"/>
-          <p:cNvSpPr txBox="1"/>
-          <p:nvPr/>
-        </p:nvSpPr>
-        <p:spPr>
-          <a:xfrm rot="0" flipH="0" flipV="0">
-            <a:off x="2524125" y="2667000"/>
-            <a:ext cx="3067050" cy="1257300"/>
-          </a:xfrm>
-          <a:prstGeom prst="rect"/>
-        </p:spPr>
-        <p:txBody>
-          <a:bodyPr wrap="none" lIns="0" tIns="0" rIns="0" bIns="0"/>
-          <a:p>
-            <a:pPr>
-              <a:lnSpc>
-                <a:spcPct val="100000"/>
-              </a:lnSpc>
-            </a:pPr>
-            <a:r>
-              <a:rPr lang="zh-CN" sz="3450" b="1">
-                <a:solidFill>
-                  <a:srgbClr val="FBFCFA"/>
-                </a:solidFill>
-                <a:latin typeface="Microsoft YaHei"/>
-                <a:ea typeface="Microsoft YaHei"/>
-              </a:rPr>
-              <a:t>项目背景与规模</a:t>
-            </a:r>
-            <a:endParaRPr/>
-          </a:p>
-        </p:txBody>
-      </p:sp>
-      <p:sp>
-        <p:nvSpPr>
-          <p:cNvPr id="346" name=""/>
+                <a:latin typeface="Microsoft YaHei"/>
+                <a:ea typeface="Microsoft YaHei"/>
+              </a:rPr>
+              <a:t>PROJECT BACKGROUND &amp; SCALE</a:t>
+            </a:r>
+            <a:endParaRPr/>
+          </a:p>
+        </p:txBody>
+      </p:sp>
+      <p:sp>
+        <p:nvSpPr>
+          <p:cNvPr id="357" name=""/>
           <p:cNvSpPr/>
           <p:nvPr/>
         </p:nvSpPr>
         <p:spPr>
           <a:xfrm rot="0" flipH="0" flipV="0">
-            <a:off x="914400" y="4191000"/>
-            <a:ext cx="685800" cy="28575"/>
+            <a:off x="914400" y="4400550"/>
+            <a:ext cx="762000" cy="28575"/>
           </a:xfrm>
           <a:prstGeom prst="rect">
             <a:avLst/>
@@ -16321,19 +16615,49 @@
       </p:sp>
       <p:sp>
         <p:nvSpPr>
-          <p:cNvPr id="347" name="" descr="{&quot;isTemplate&quot;:true,&quot;type&quot;:&quot;text&quot;}"/>
-          <p:cNvSpPr txBox="1"/>
-          <p:nvPr/>
-        </p:nvSpPr>
-        <p:spPr>
-          <a:xfrm rot="0" flipH="0" flipV="0">
-            <a:off x="914400" y="4410075"/>
-            <a:ext cx="10363200" cy="190500"/>
-          </a:xfrm>
-          <a:prstGeom prst="rect"/>
-        </p:spPr>
-        <p:txBody>
-          <a:bodyPr wrap="none" lIns="0" tIns="0" rIns="0" bIns="0"/>
+          <p:cNvPr id="358" name=""/>
+          <p:cNvSpPr/>
+          <p:nvPr/>
+        </p:nvSpPr>
+        <p:spPr>
+          <a:xfrm rot="0" flipH="0" flipV="0">
+            <a:off x="914400" y="4657725"/>
+            <a:ext cx="1238250" cy="342900"/>
+          </a:xfrm>
+          <a:prstGeom prst="roundRect">
+            <a:avLst>
+              <a:gd name="adj" fmla="val 61111"/>
+            </a:avLst>
+          </a:prstGeom>
+          <a:ln w="12700">
+            <a:solidFill>
+              <a:srgbClr val="BD9B56">
+                <a:alpha val="65000"/>
+              </a:srgbClr>
+            </a:solidFill>
+            <a:prstDash val="solid"/>
+          </a:ln>
+        </p:spPr>
+        <p:txBody>
+          <a:bodyPr/>
+          <a:p/>
+        </p:txBody>
+      </p:sp>
+      <p:sp>
+        <p:nvSpPr>
+          <p:cNvPr id="359" name="" descr="{&quot;isTemplate&quot;:true,&quot;type&quot;:&quot;text&quot;}"/>
+          <p:cNvSpPr txBox="1"/>
+          <p:nvPr/>
+        </p:nvSpPr>
+        <p:spPr>
+          <a:xfrm rot="0" flipH="0" flipV="0">
+            <a:off x="914400" y="4657725"/>
+            <a:ext cx="1238250" cy="342900"/>
+          </a:xfrm>
+          <a:prstGeom prst="rect"/>
+        </p:spPr>
+        <p:txBody>
+          <a:bodyPr wrap="none" lIns="142875" tIns="64294" rIns="142875" bIns="64294"/>
           <a:p>
             <a:pPr>
               <a:lnSpc>
@@ -16341,10 +16665,10 @@
               </a:lnSpc>
             </a:pPr>
             <a:r>
-              <a:rPr lang="zh-CN" sz="1200" spc="-9223372036854775808">
+              <a:rPr lang="zh-CN" sz="1125">
                 <a:solidFill>
                   <a:srgbClr val="FBFCFA">
-                    <a:alpha val="72000"/>
+                    <a:alpha val="88000"/>
                   </a:srgbClr>
                 </a:solidFill>
                 <a:latin typeface="Microsoft YaHei"/>
@@ -16352,44 +16676,166 @@
               </a:rPr>
               <a:t>传统物业痛点</a:t>
             </a:r>
-            <a:r>
-              <a:rPr lang="en-US" sz="1200" spc="-9223372036854775808">
+            <a:endParaRPr/>
+          </a:p>
+        </p:txBody>
+      </p:sp>
+      <p:sp>
+        <p:nvSpPr>
+          <p:cNvPr id="360" name=""/>
+          <p:cNvSpPr/>
+          <p:nvPr/>
+        </p:nvSpPr>
+        <p:spPr>
+          <a:xfrm rot="0" flipH="0" flipV="0">
+            <a:off x="2286000" y="4657725"/>
+            <a:ext cx="1628775" cy="342900"/>
+          </a:xfrm>
+          <a:prstGeom prst="roundRect">
+            <a:avLst>
+              <a:gd name="adj" fmla="val 61111"/>
+            </a:avLst>
+          </a:prstGeom>
+          <a:ln w="12700">
+            <a:solidFill>
+              <a:srgbClr val="BD9B56">
+                <a:alpha val="65000"/>
+              </a:srgbClr>
+            </a:solidFill>
+            <a:prstDash val="solid"/>
+          </a:ln>
+        </p:spPr>
+        <p:txBody>
+          <a:bodyPr/>
+          <a:p/>
+        </p:txBody>
+      </p:sp>
+      <p:sp>
+        <p:nvSpPr>
+          <p:cNvPr id="361" name="" descr="{&quot;isTemplate&quot;:true,&quot;type&quot;:&quot;text&quot;}"/>
+          <p:cNvSpPr txBox="1"/>
+          <p:nvPr/>
+        </p:nvSpPr>
+        <p:spPr>
+          <a:xfrm rot="0" flipH="0" flipV="0">
+            <a:off x="2286000" y="4657725"/>
+            <a:ext cx="1628775" cy="342900"/>
+          </a:xfrm>
+          <a:prstGeom prst="rect"/>
+        </p:spPr>
+        <p:txBody>
+          <a:bodyPr wrap="none" lIns="142875" tIns="64294" rIns="142875" bIns="64294"/>
+          <a:p>
+            <a:pPr>
+              <a:lnSpc>
+                <a:spcPct val="100000"/>
+              </a:lnSpc>
+            </a:pPr>
+            <a:r>
+              <a:rPr lang="en-US" sz="1125">
                 <a:solidFill>
                   <a:srgbClr val="FBFCFA">
-                    <a:alpha val="72000"/>
+                    <a:alpha val="88000"/>
                   </a:srgbClr>
                 </a:solidFill>
                 <a:latin typeface="Microsoft YaHei"/>
                 <a:ea typeface="Microsoft YaHei"/>
               </a:rPr>
-              <a:t> · </a:t>
-            </a:r>
-            <a:r>
-              <a:rPr lang="zh-CN" sz="1200" spc="-9223372036854775808">
+              <a:t>AI Native </a:t>
+            </a:r>
+            <a:r>
+              <a:rPr lang="zh-CN" sz="1125">
                 <a:solidFill>
                   <a:srgbClr val="FBFCFA">
-                    <a:alpha val="72000"/>
+                    <a:alpha val="88000"/>
                   </a:srgbClr>
                 </a:solidFill>
                 <a:latin typeface="Microsoft YaHei"/>
                 <a:ea typeface="Microsoft YaHei"/>
               </a:rPr>
-              <a:t>虚拟社区「云溪花园」数据资产</a:t>
-            </a:r>
-            <a:endParaRPr/>
-          </a:p>
-        </p:txBody>
-      </p:sp>
-      <p:sp>
-        <p:nvSpPr>
-          <p:cNvPr id="348" name="" descr="{&quot;isTemplate&quot;:true,&quot;type&quot;:&quot;text&quot;}"/>
-          <p:cNvSpPr txBox="1"/>
-          <p:nvPr/>
-        </p:nvSpPr>
-        <p:spPr>
-          <a:xfrm rot="0" flipH="0" flipV="0">
-            <a:off x="10877550" y="6305550"/>
-            <a:ext cx="400050" cy="152400"/>
+              <a:t>方案定位</a:t>
+            </a:r>
+            <a:endParaRPr/>
+          </a:p>
+        </p:txBody>
+      </p:sp>
+      <p:sp>
+        <p:nvSpPr>
+          <p:cNvPr id="362" name=""/>
+          <p:cNvSpPr/>
+          <p:nvPr/>
+        </p:nvSpPr>
+        <p:spPr>
+          <a:xfrm rot="0" flipH="0" flipV="0">
+            <a:off x="4048125" y="4657725"/>
+            <a:ext cx="1809750" cy="342900"/>
+          </a:xfrm>
+          <a:prstGeom prst="roundRect">
+            <a:avLst>
+              <a:gd name="adj" fmla="val 61111"/>
+            </a:avLst>
+          </a:prstGeom>
+          <a:ln w="12700">
+            <a:solidFill>
+              <a:srgbClr val="BD9B56">
+                <a:alpha val="65000"/>
+              </a:srgbClr>
+            </a:solidFill>
+            <a:prstDash val="solid"/>
+          </a:ln>
+        </p:spPr>
+        <p:txBody>
+          <a:bodyPr/>
+          <a:p/>
+        </p:txBody>
+      </p:sp>
+      <p:sp>
+        <p:nvSpPr>
+          <p:cNvPr id="363" name="" descr="{&quot;isTemplate&quot;:true,&quot;type&quot;:&quot;text&quot;}"/>
+          <p:cNvSpPr txBox="1"/>
+          <p:nvPr/>
+        </p:nvSpPr>
+        <p:spPr>
+          <a:xfrm rot="0" flipH="0" flipV="0">
+            <a:off x="4048125" y="4657725"/>
+            <a:ext cx="1809750" cy="342900"/>
+          </a:xfrm>
+          <a:prstGeom prst="rect"/>
+        </p:spPr>
+        <p:txBody>
+          <a:bodyPr wrap="none" lIns="142875" tIns="64294" rIns="142875" bIns="64294"/>
+          <a:p>
+            <a:pPr>
+              <a:lnSpc>
+                <a:spcPct val="100000"/>
+              </a:lnSpc>
+            </a:pPr>
+            <a:r>
+              <a:rPr lang="zh-CN" sz="1125">
+                <a:solidFill>
+                  <a:srgbClr val="FBFCFA">
+                    <a:alpha val="88000"/>
+                  </a:srgbClr>
+                </a:solidFill>
+                <a:latin typeface="Microsoft YaHei"/>
+                <a:ea typeface="Microsoft YaHei"/>
+              </a:rPr>
+              <a:t>虚拟社区「云溪花园」</a:t>
+            </a:r>
+            <a:endParaRPr/>
+          </a:p>
+        </p:txBody>
+      </p:sp>
+      <p:sp>
+        <p:nvSpPr>
+          <p:cNvPr id="364" name="" descr="{&quot;isTemplate&quot;:true,&quot;type&quot;:&quot;text&quot;}"/>
+          <p:cNvSpPr txBox="1"/>
+          <p:nvPr/>
+        </p:nvSpPr>
+        <p:spPr>
+          <a:xfrm rot="0" flipH="0" flipV="0">
+            <a:off x="10858500" y="6305550"/>
+            <a:ext cx="419100" cy="152400"/>
           </a:xfrm>
           <a:prstGeom prst="rect"/>
         </p:spPr>
@@ -16408,8 +16854,8 @@
                     <a:alpha val="40000"/>
                   </a:srgbClr>
                 </a:solidFill>
-                <a:latin typeface="Inter"/>
-                <a:ea typeface="Inter"/>
+                <a:latin typeface="Microsoft YaHei"/>
+                <a:ea typeface="Microsoft YaHei"/>
               </a:rPr>
               <a:t>03 / 19</a:t>
             </a:r>
@@ -16427,7 +16873,7 @@
   <p:cSld>
     <p:spTree>
       <p:nvGrpSpPr>
-        <p:cNvPr id="349" name="" descr="&lt;Slide style={{ width: '1280px', height: '720px', background: '#FBFCFA', position: 'relative', padding: '40px 64px', boxSizing: 'border-box', display: 'flex', flexDirection: 'column' }}&gt;&#13;&#10;  &lt;div style={{ flexShrink: 0 }}&gt;&#13;&#10;    &lt;div style={{ color: '#BD9B56', fontSize: 13, letterSpacing: '0.25em', marginBottom: 8 }}&gt;01 · 项目背景&lt;/div&gt;&#13;&#10;    &lt;h2 style={{ fontSize: 30, fontWeight: 'bold', color: '#172133', margin: 0, lineHeight: 1.3 }}&gt;传统物业的三重困境&lt;/h2&gt;&#13;&#10;    &lt;div style={{ fontSize: 14, color: '#6b7075', marginTop: 8 }}&gt;业务、数据、知识「三张皮」，需要用 AI 重新缝合&lt;/div&gt;&#13;&#10;  &lt;/div&gt;&#13;&#10;  &lt;div style={{ flex: 1, display: 'flex', alignItems: 'center' }}&gt;&#13;&#10;    &lt;div style={{ width: '100%', display: 'flex', flexDirection: 'column', gap: 18 }}&gt;&#13;&#10;      &lt;div style={{ display: 'flex', gap: 20, background: '#fff', borderRadius: 10, padding: '20px 24px', boxShadow: '0 4px 16px rgba(23,33,51,0.06)', borderLeft: '4px solid #BD9B56' }}&gt;&#13;&#10;        &lt;span style={{ color: '#BD9B56', fontSize: 22, lineHeight: 1.2, flexShrink: 0 }}&gt;!&lt;/span&gt;&#13;&#10;        &lt;div&gt;&#13;&#10;          &lt;div style={{ fontSize: 17, fontWeight: 'bold', color: '#172133', marginBottom: 6 }}&gt;信息孤岛&lt;/div&gt;&#13;&#10;          &lt;p style={{ fontSize: 14, color: '#5F5E5A', margin: 0, lineHeight: 1.6 }}&gt;业主报修、费用缴纳、巡检记录分散在多个系统，彼此不打通，物业无法掌握完整的社区运行状态，业主也看不到工单的处理进度。&lt;/p&gt;&#13;&#10;        &lt;/div&gt;&#13;&#10;      &lt;/div&gt;&#13;&#10;      &lt;div style={{ display: 'flex', gap: 20, background: '#fff', borderRadius: 10, padding: '20px 24px', boxShadow: '0 4px 16px rgba(23,33,51,0.06)', borderLeft: '4px solid #BD9B56' }}&gt;&#13;&#10;        &lt;span style={{ color: '#BD9B56', fontSize: 22, lineHeight: 1.2, flexShrink: 0 }}&gt;!&lt;/span&gt;&#13;&#10;        &lt;div&gt;&#13;&#10;          &lt;div style={{ fontSize: 17, fontWeight: 'bold', color: '#172133', marginBottom: 6 }}&gt;响应迟缓&lt;/div&gt;&#13;&#10;          &lt;p style={{ fontSize: 14, color: '#5F5E5A', margin: 0, lineHeight: 1.6 }}&gt;传统报修依赖电话和微信群，客服人工登记后再手动派单，从「业主报修」到「师傅上门」平均要数小时甚至隔天，响应效率低。&lt;/p&gt;&#13;&#10;        &lt;/div&gt;&#13;&#10;      &lt;/div&gt;&#13;&#10;      &lt;div style={{ display: 'flex', gap: 20, background: '#fff', borderRadius: 10, padding: '20px 24px', boxShadow: '0 4px 16px rgba(23,33,51,0.06)', borderLeft: '4px solid #BD9B56' }}&gt;&#13;&#10;        &lt;span style={{ color: '#BD9B56', fontSize: 22, lineHeight: 1.2, flexShrink: 0 }}&gt;!&lt;/span&gt;&#13;&#10;        &lt;div&gt;&#13;&#10;          &lt;div style={{ fontSize: 17, fontWeight: 'bold', color: '#172133', marginBottom: 6 }}&gt;隐性知识散落&lt;/div&gt;&#13;&#10;          &lt;p style={{ fontSize: 14, color: '#5F5E5A', margin: 0, lineHeight: 1.6 }}&gt;装修施工时间、停车规则、宠物管理等规定，往往只存在于物业员工的个人经验里，新人上岗难以快速掌握，业主咨询也得不到统一准确的答案。&lt;/p&gt;&#13;&#10;        &lt;/div&gt;&#13;&#10;      &lt;/div&gt;&#13;&#10;    &lt;/div&gt;&#13;&#10;  &lt;/div&gt;&#13;&#10;  &lt;div style={{ flexShrink: 0, height: 44, display: 'flex', alignItems: 'flex-end', justifyContent: 'space-between' }}&gt;&#13;&#10;    &lt;span style={{ color: '#BD9B56', fontSize: 12, letterSpacing: '0.1em' }}&gt;云溪花园 · 智慧社区&lt;/span&gt;&#13;&#10;    &lt;span style={{ color: '#a09b8c', fontSize: 12 }}&gt;4 / 19&lt;/span&gt;&#13;&#10;  &lt;/div&gt;&#13;&#10;&lt;/Slide&gt;"/>
+        <p:cNvPr id="365" name="" descr="&lt;Slide style={{ width: '1280px', height: '720px', background: '#FBFCFA', position: 'relative', padding: '40px 64px', boxSizing: 'border-box', display: 'flex', flexDirection: 'column' }}&gt;&#13;&#10;  &lt;div style={{ flexShrink: 0 }}&gt;&#13;&#10;    &lt;div style={{ color: '#BD9B56', fontSize: 13, letterSpacing: '0.25em', marginBottom: 8 }}&gt;01 · 项目背景&lt;/div&gt;&#13;&#10;    &lt;h2 style={{ fontSize: 30, fontWeight: 'bold', color: '#172133', margin: 0, lineHeight: 1.3 }}&gt;传统物业的三重困境&lt;/h2&gt;&#13;&#10;    &lt;div style={{ fontSize: 14, color: '#6b7075', marginTop: 8 }}&gt;业务、数据、知识「三张皮」，需要用 AI 重新缝合&lt;/div&gt;&#13;&#10;  &lt;/div&gt;&#13;&#10;  &lt;div style={{ flex: 1, display: 'flex', alignItems: 'center' }}&gt;&#13;&#10;    &lt;div style={{ width: '100%', display: 'flex', flexDirection: 'column', gap: 18 }}&gt;&#13;&#10;      &lt;div style={{ display: 'flex', gap: 20, background: '#fff', borderRadius: 10, padding: '20px 24px', boxShadow: '0 4px 16px rgba(23,33,51,0.06)', borderLeft: '4px solid #BD9B56' }}&gt;&#13;&#10;        &lt;span style={{ color: '#BD9B56', fontSize: 22, lineHeight: 1.2, flexShrink: 0 }}&gt;!&lt;/span&gt;&#13;&#10;        &lt;div&gt;&#13;&#10;          &lt;div style={{ fontSize: 17, fontWeight: 'bold', color: '#172133', marginBottom: 6 }}&gt;信息孤岛&lt;/div&gt;&#13;&#10;          &lt;p style={{ fontSize: 14, color: '#5F5E5A', margin: 0, lineHeight: 1.6 }}&gt;业主报修、费用缴纳、巡检记录分散在多个系统，彼此不打通，物业无法掌握完整的社区运行状态，业主也看不到工单的处理进度。&lt;/p&gt;&#13;&#10;        &lt;/div&gt;&#13;&#10;      &lt;/div&gt;&#13;&#10;      &lt;div style={{ display: 'flex', gap: 20, background: '#fff', borderRadius: 10, padding: '20px 24px', boxShadow: '0 4px 16px rgba(23,33,51,0.06)', borderLeft: '4px solid #BD9B56' }}&gt;&#13;&#10;        &lt;span style={{ color: '#BD9B56', fontSize: 22, lineHeight: 1.2, flexShrink: 0 }}&gt;!&lt;/span&gt;&#13;&#10;        &lt;div&gt;&#13;&#10;          &lt;div style={{ fontSize: 17, fontWeight: 'bold', color: '#172133', marginBottom: 6 }}&gt;响应迟缓&lt;/div&gt;&#13;&#10;          &lt;p style={{ fontSize: 14, color: '#5F5E5A', margin: 0, lineHeight: 1.6 }}&gt;传统报修依赖电话和微信群，客服人工登记后再手动派单，从「业主报修」到「师傅上门」平均要数小时甚至隔天，响应效率低。&lt;/p&gt;&#13;&#10;        &lt;/div&gt;&#13;&#10;      &lt;/div&gt;&#13;&#10;      &lt;div style={{ display: 'flex', gap: 20, background: '#fff', borderRadius: 10, padding: '20px 24px', boxShadow: '0 4px 16px rgba(23,33,51,0.06)', borderLeft: '4px solid #BD9B56' }}&gt;&#13;&#10;        &lt;span style={{ color: '#BD9B56', fontSize: 22, lineHeight: 1.2, flexShrink: 0 }}&gt;!&lt;/span&gt;&#13;&#10;        &lt;div&gt;&#13;&#10;          &lt;div style={{ fontSize: 17, fontWeight: 'bold', color: '#172133', marginBottom: 6 }}&gt;隐性知识散落&lt;/div&gt;&#13;&#10;          &lt;p style={{ fontSize: 14, color: '#5F5E5A', margin: 0, lineHeight: 1.6 }}&gt;装修施工时间、停车规则、宠物管理等规定，往往只存在于物业员工的个人经验里，新人上岗难以快速掌握，业主咨询也得不到统一准确的答案。&lt;/p&gt;&#13;&#10;        &lt;/div&gt;&#13;&#10;      &lt;/div&gt;&#13;&#10;    &lt;/div&gt;&#13;&#10;  &lt;/div&gt;&#13;&#10;  &lt;div style={{ flexShrink: 0, height: 44, display: 'flex', alignItems: 'flex-end', justifyContent: 'space-between' }}&gt;&#13;&#10;    &lt;span style={{ color: '#BD9B56', fontSize: 12, letterSpacing: '0.1em' }}&gt;云溪花园 · 智慧社区&lt;/span&gt;&#13;&#10;    &lt;span style={{ color: '#a09b8c', fontSize: 12 }}&gt;4 / 19&lt;/span&gt;&#13;&#10;  &lt;/div&gt;&#13;&#10;&lt;/Slide&gt;"/>
         <p:cNvGrpSpPr/>
         <p:nvPr/>
       </p:nvGrpSpPr>
@@ -16441,7 +16887,7 @@
       </p:grpSpPr>
       <p:sp>
         <p:nvSpPr>
-          <p:cNvPr id="350" name=""/>
+          <p:cNvPr id="366" name=""/>
           <p:cNvSpPr/>
           <p:nvPr/>
         </p:nvSpPr>
@@ -16465,7 +16911,7 @@
       </p:sp>
       <p:sp>
         <p:nvSpPr>
-          <p:cNvPr id="351" name="" descr="{&quot;isTemplate&quot;:true,&quot;type&quot;:&quot;text&quot;}"/>
+          <p:cNvPr id="367" name="" descr="{&quot;isTemplate&quot;:true,&quot;type&quot;:&quot;text&quot;}"/>
           <p:cNvSpPr txBox="1"/>
           <p:nvPr/>
         </p:nvSpPr>
@@ -16510,7 +16956,7 @@
       </p:sp>
       <p:sp>
         <p:nvSpPr>
-          <p:cNvPr id="352" name="" descr="{&quot;isTemplate&quot;:true,&quot;type&quot;:&quot;text&quot;}"/>
+          <p:cNvPr id="368" name="" descr="{&quot;isTemplate&quot;:true,&quot;type&quot;:&quot;text&quot;}"/>
           <p:cNvSpPr txBox="1"/>
           <p:nvPr/>
         </p:nvSpPr>
@@ -16545,7 +16991,7 @@
       </p:sp>
       <p:sp>
         <p:nvSpPr>
-          <p:cNvPr id="353" name="" descr="{&quot;isTemplate&quot;:true,&quot;type&quot;:&quot;text&quot;}"/>
+          <p:cNvPr id="369" name="" descr="{&quot;isTemplate&quot;:true,&quot;type&quot;:&quot;text&quot;}"/>
           <p:cNvSpPr txBox="1"/>
           <p:nvPr/>
         </p:nvSpPr>
@@ -16600,7 +17046,7 @@
       </p:sp>
       <p:sp>
         <p:nvSpPr>
-          <p:cNvPr id="354" name=""/>
+          <p:cNvPr id="370" name=""/>
           <p:cNvSpPr/>
           <p:nvPr/>
         </p:nvSpPr>
@@ -16633,7 +17079,7 @@
       </p:sp>
       <p:sp>
         <p:nvSpPr>
-          <p:cNvPr id="355" name=""/>
+          <p:cNvPr id="371" name=""/>
           <p:cNvSpPr/>
           <p:nvPr/>
         </p:nvSpPr>
@@ -16690,7 +17136,7 @@
       </p:sp>
       <p:sp>
         <p:nvSpPr>
-          <p:cNvPr id="356" name="" descr="{&quot;isTemplate&quot;:true,&quot;type&quot;:&quot;text&quot;}"/>
+          <p:cNvPr id="372" name="" descr="{&quot;isTemplate&quot;:true,&quot;type&quot;:&quot;text&quot;}"/>
           <p:cNvSpPr txBox="1"/>
           <p:nvPr/>
         </p:nvSpPr>
@@ -16725,7 +17171,7 @@
       </p:sp>
       <p:sp>
         <p:nvSpPr>
-          <p:cNvPr id="357" name="" descr="{&quot;isTemplate&quot;:true,&quot;type&quot;:&quot;text&quot;}"/>
+          <p:cNvPr id="373" name="" descr="{&quot;isTemplate&quot;:true,&quot;type&quot;:&quot;text&quot;}"/>
           <p:cNvSpPr txBox="1"/>
           <p:nvPr/>
         </p:nvSpPr>
@@ -16760,7 +17206,7 @@
       </p:sp>
       <p:sp>
         <p:nvSpPr>
-          <p:cNvPr id="358" name="" descr="{&quot;isTemplate&quot;:true,&quot;type&quot;:&quot;text&quot;}"/>
+          <p:cNvPr id="374" name="" descr="{&quot;isTemplate&quot;:true,&quot;type&quot;:&quot;text&quot;}"/>
           <p:cNvSpPr txBox="1"/>
           <p:nvPr/>
         </p:nvSpPr>
@@ -16795,7 +17241,7 @@
       </p:sp>
       <p:sp>
         <p:nvSpPr>
-          <p:cNvPr id="359" name=""/>
+          <p:cNvPr id="375" name=""/>
           <p:cNvSpPr/>
           <p:nvPr/>
         </p:nvSpPr>
@@ -16828,7 +17274,7 @@
       </p:sp>
       <p:sp>
         <p:nvSpPr>
-          <p:cNvPr id="360" name=""/>
+          <p:cNvPr id="376" name=""/>
           <p:cNvSpPr/>
           <p:nvPr/>
         </p:nvSpPr>
@@ -16885,7 +17331,7 @@
       </p:sp>
       <p:sp>
         <p:nvSpPr>
-          <p:cNvPr id="361" name="" descr="{&quot;isTemplate&quot;:true,&quot;type&quot;:&quot;text&quot;}"/>
+          <p:cNvPr id="377" name="" descr="{&quot;isTemplate&quot;:true,&quot;type&quot;:&quot;text&quot;}"/>
           <p:cNvSpPr txBox="1"/>
           <p:nvPr/>
         </p:nvSpPr>
@@ -16920,7 +17366,7 @@
       </p:sp>
       <p:sp>
         <p:nvSpPr>
-          <p:cNvPr id="362" name="" descr="{&quot;isTemplate&quot;:true,&quot;type&quot;:&quot;text&quot;}"/>
+          <p:cNvPr id="378" name="" descr="{&quot;isTemplate&quot;:true,&quot;type&quot;:&quot;text&quot;}"/>
           <p:cNvSpPr txBox="1"/>
           <p:nvPr/>
         </p:nvSpPr>
@@ -16955,7 +17401,7 @@
       </p:sp>
       <p:sp>
         <p:nvSpPr>
-          <p:cNvPr id="363" name="" descr="{&quot;isTemplate&quot;:true,&quot;type&quot;:&quot;text&quot;}"/>
+          <p:cNvPr id="379" name="" descr="{&quot;isTemplate&quot;:true,&quot;type&quot;:&quot;text&quot;}"/>
           <p:cNvSpPr txBox="1"/>
           <p:nvPr/>
         </p:nvSpPr>
@@ -16990,7 +17436,7 @@
       </p:sp>
       <p:sp>
         <p:nvSpPr>
-          <p:cNvPr id="364" name=""/>
+          <p:cNvPr id="380" name=""/>
           <p:cNvSpPr/>
           <p:nvPr/>
         </p:nvSpPr>
@@ -17023,7 +17469,7 @@
       </p:sp>
       <p:sp>
         <p:nvSpPr>
-          <p:cNvPr id="365" name=""/>
+          <p:cNvPr id="381" name=""/>
           <p:cNvSpPr/>
           <p:nvPr/>
         </p:nvSpPr>
@@ -17080,7 +17526,7 @@
       </p:sp>
       <p:sp>
         <p:nvSpPr>
-          <p:cNvPr id="366" name="" descr="{&quot;isTemplate&quot;:true,&quot;type&quot;:&quot;text&quot;}"/>
+          <p:cNvPr id="382" name="" descr="{&quot;isTemplate&quot;:true,&quot;type&quot;:&quot;text&quot;}"/>
           <p:cNvSpPr txBox="1"/>
           <p:nvPr/>
         </p:nvSpPr>
@@ -17115,7 +17561,7 @@
       </p:sp>
       <p:sp>
         <p:nvSpPr>
-          <p:cNvPr id="367" name="" descr="{&quot;isTemplate&quot;:true,&quot;type&quot;:&quot;text&quot;}"/>
+          <p:cNvPr id="383" name="" descr="{&quot;isTemplate&quot;:true,&quot;type&quot;:&quot;text&quot;}"/>
           <p:cNvSpPr txBox="1"/>
           <p:nvPr/>
         </p:nvSpPr>
@@ -17150,7 +17596,7 @@
       </p:sp>
       <p:sp>
         <p:nvSpPr>
-          <p:cNvPr id="368" name="" descr="{&quot;isTemplate&quot;:true,&quot;type&quot;:&quot;text&quot;}"/>
+          <p:cNvPr id="384" name="" descr="{&quot;isTemplate&quot;:true,&quot;type&quot;:&quot;text&quot;}"/>
           <p:cNvSpPr txBox="1"/>
           <p:nvPr/>
         </p:nvSpPr>
@@ -17185,7 +17631,7 @@
       </p:sp>
       <p:sp>
         <p:nvSpPr>
-          <p:cNvPr id="369" name="" descr="{&quot;isTemplate&quot;:true,&quot;type&quot;:&quot;text&quot;}"/>
+          <p:cNvPr id="385" name="" descr="{&quot;isTemplate&quot;:true,&quot;type&quot;:&quot;text&quot;}"/>
           <p:cNvSpPr txBox="1"/>
           <p:nvPr/>
         </p:nvSpPr>
@@ -17240,7 +17686,7 @@
       </p:sp>
       <p:sp>
         <p:nvSpPr>
-          <p:cNvPr id="370" name="" descr="{&quot;isTemplate&quot;:true,&quot;type&quot;:&quot;text&quot;}"/>
+          <p:cNvPr id="386" name="" descr="{&quot;isTemplate&quot;:true,&quot;type&quot;:&quot;text&quot;}"/>
           <p:cNvSpPr txBox="1"/>
           <p:nvPr/>
         </p:nvSpPr>
@@ -17283,7 +17729,7 @@
   <p:cSld>
     <p:spTree>
       <p:nvGrpSpPr>
-        <p:cNvPr id="371" name="" descr="&lt;Slide style={{ width: '1280px', height: '720px', background: '#FBFCFA', position: 'relative', padding: '32px 64px', boxSizing: 'border-box', display: 'flex', flexDirection: 'column' }}&gt;&#13;&#10;  &lt;div style={{ flexShrink: 0 }}&gt;&#13;&#10;    &lt;div style={{ color: '#BD9B56', fontSize: 13, letterSpacing: '0.25em', marginBottom: 6 }}&gt;01 · 项目目标&lt;/div&gt;&#13;&#10;    &lt;h2 style={{ fontSize: 30, fontWeight: 'bold', color: '#172133', margin: 0, lineHeight: 1.3 }}&gt;本项目要验证的四件事&lt;/h2&gt;&#13;&#10;  &lt;/div&gt;&#13;&#10;  &lt;div style={{ flex: 1, display: 'flex', alignItems: 'center', minHeight: 0 }}&gt;&#13;&#10;    &lt;div style={{ width: '100%', display: 'grid', gridTemplateColumns: '1fr 1fr', gap: 16 }}&gt;&#13;&#10;      &lt;div style={{ background: '#fff', borderRadius: 10, padding: '18px 22px', boxShadow: '0 4px 16px rgba(23,33,51,0.06)', borderTop: '3px solid #BD9B56' }}&gt;&#13;&#10;        &lt;div style={{ fontSize: 17, fontWeight: 'bold', color: '#172133', marginBottom: 6 }}&gt;1.  AI 能否理解业务意图&lt;/div&gt;&#13;&#10;        &lt;p style={{ fontSize: 14, color: '#5F5E5A', margin: 0, lineHeight: 1.55 }}&gt;用户说一句「厨房漏水了」，系统能否准确识别为报修需求，而非闲聊或误判。&lt;/p&gt;&#13;&#10;      &lt;/div&gt;&#13;&#10;      &lt;div style={{ background: '#fff', borderRadius: 10, padding: '18px 22px', boxShadow: '0 4px 16px rgba(23,33,51,0.06)', borderTop: '3px solid #BD9B56' }}&gt;&#13;&#10;        &lt;div style={{ fontSize: 17, fontWeight: 'bold', color: '#172133', marginBottom: 6 }}&gt;2.  Agent 能否调用业务工具&lt;/div&gt;&#13;&#10;        &lt;p style={{ fontSize: 14, color: '#5F5E5A', margin: 0, lineHeight: 1.55 }}&gt;识别意图后，能否自动创建工单、查询费用、检索知识，而不是停留在「回答」层面。&lt;/p&gt;&#13;&#10;      &lt;/div&gt;&#13;&#10;      &lt;div style={{ background: '#fff', borderRadius: 10, padding: '18px 22px', boxShadow: '0 4px 16px rgba(23,33,51,0.06)', borderTop: '3px solid #BD9B56' }}&gt;&#13;&#10;        &lt;div style={{ fontSize: 17, fontWeight: 'bold', color: '#172133', marginBottom: 6 }}&gt;3.  能否跑通业务闭环&lt;/div&gt;&#13;&#10;        &lt;p style={{ fontSize: 14, color: '#5F5E5A', margin: 0, lineHeight: 1.55 }}&gt;从报修到派单到完成，AI 是否真正参与了业务流程，而非只在前端加了一个聊天窗口。&lt;/p&gt;&#13;&#10;      &lt;/div&gt;&#13;&#10;      &lt;div style={{ background: '#fff', borderRadius: 10, padding: '18px 22px', boxShadow: '0 4px 16px rgba(23,33,51,0.06)', borderTop: '3px solid #BD9B56' }}&gt;&#13;&#10;        &lt;div style={{ fontSize: 17, fontWeight: 'bold', color: '#172133', marginBottom: 6 }}&gt;4.  RAG 能否准确回答&lt;/div&gt;&#13;&#10;        &lt;p style={{ fontSize: 14, color: '#5F5E5A', margin: 0, lineHeight: 1.55 }}&gt;对「装修几点施工」这类制度问题，能否检索到正确依据并给出准确、有出处的答案。&lt;/p&gt;&#13;&#10;      &lt;/div&gt;&#13;&#10;    &lt;/div&gt;&#13;&#10;  &lt;/div&gt;&#13;&#10;  &lt;div style={{ flexShrink: 0, height: 40, display: 'flex', alignItems: 'flex-end', justifyContent: 'space-between' }}&gt;&#13;&#10;    &lt;span style={{ color: '#BD9B56', fontSize: 12, letterSpacing: '0.1em' }}&gt;云溪花园 · 智慧社区&lt;/span&gt;&#13;&#10;    &lt;span style={{ color: '#a09b8c', fontSize: 12 }}&gt;5 / 19&lt;/span&gt;&#13;&#10;  &lt;/div&gt;&#13;&#10;&lt;/Slide&gt;"/>
+        <p:cNvPr id="387" name="" descr="&lt;Slide style={{ width: '1280px', height: '720px', background: '#FBFCFA', position: 'relative', padding: '32px 64px', boxSizing: 'border-box', display: 'flex', flexDirection: 'column' }}&gt;&#13;&#10;  &lt;div style={{ flexShrink: 0 }}&gt;&#13;&#10;    &lt;div style={{ color: '#BD9B56', fontSize: 13, letterSpacing: '0.25em', marginBottom: 6 }}&gt;01 · 项目目标&lt;/div&gt;&#13;&#10;    &lt;h2 style={{ fontSize: 30, fontWeight: 'bold', color: '#172133', margin: 0, lineHeight: 1.3 }}&gt;本项目要验证的四件事&lt;/h2&gt;&#13;&#10;  &lt;/div&gt;&#13;&#10;  &lt;div style={{ flex: 1, display: 'flex', alignItems: 'center', minHeight: 0 }}&gt;&#13;&#10;    &lt;div style={{ width: '100%', display: 'grid', gridTemplateColumns: '1fr 1fr', gap: 16 }}&gt;&#13;&#10;      &lt;div style={{ background: '#fff', borderRadius: 10, padding: '18px 22px', boxShadow: '0 4px 16px rgba(23,33,51,0.06)', borderTop: '3px solid #BD9B56' }}&gt;&#13;&#10;        &lt;div style={{ fontSize: 17, fontWeight: 'bold', color: '#172133', marginBottom: 6 }}&gt;1.  AI 能否理解业务意图&lt;/div&gt;&#13;&#10;        &lt;p style={{ fontSize: 14, color: '#5F5E5A', margin: 0, lineHeight: 1.55 }}&gt;用户说一句「厨房漏水了」，系统能否准确识别为报修需求，而非闲聊或误判。&lt;/p&gt;&#13;&#10;      &lt;/div&gt;&#13;&#10;      &lt;div style={{ background: '#fff', borderRadius: 10, padding: '18px 22px', boxShadow: '0 4px 16px rgba(23,33,51,0.06)', borderTop: '3px solid #BD9B56' }}&gt;&#13;&#10;        &lt;div style={{ fontSize: 17, fontWeight: 'bold', color: '#172133', marginBottom: 6 }}&gt;2.  Agent 能否调用业务工具&lt;/div&gt;&#13;&#10;        &lt;p style={{ fontSize: 14, color: '#5F5E5A', margin: 0, lineHeight: 1.55 }}&gt;识别意图后，能否自动创建工单、查询费用、检索知识，而不是停留在「回答」层面。&lt;/p&gt;&#13;&#10;      &lt;/div&gt;&#13;&#10;      &lt;div style={{ background: '#fff', borderRadius: 10, padding: '18px 22px', boxShadow: '0 4px 16px rgba(23,33,51,0.06)', borderTop: '3px solid #BD9B56' }}&gt;&#13;&#10;        &lt;div style={{ fontSize: 17, fontWeight: 'bold', color: '#172133', marginBottom: 6 }}&gt;3.  能否跑通业务闭环&lt;/div&gt;&#13;&#10;        &lt;p style={{ fontSize: 14, color: '#5F5E5A', margin: 0, lineHeight: 1.55 }}&gt;从报修到派单到完成，AI 是否真正参与了业务流程，而非只在前端加了一个聊天窗口。&lt;/p&gt;&#13;&#10;      &lt;/div&gt;&#13;&#10;      &lt;div style={{ background: '#fff', borderRadius: 10, padding: '18px 22px', boxShadow: '0 4px 16px rgba(23,33,51,0.06)', borderTop: '3px solid #BD9B56' }}&gt;&#13;&#10;        &lt;div style={{ fontSize: 17, fontWeight: 'bold', color: '#172133', marginBottom: 6 }}&gt;4.  RAG 能否准确回答&lt;/div&gt;&#13;&#10;        &lt;p style={{ fontSize: 14, color: '#5F5E5A', margin: 0, lineHeight: 1.55 }}&gt;对「装修几点施工」这类制度问题，能否检索到正确依据并给出准确、有出处的答案。&lt;/p&gt;&#13;&#10;      &lt;/div&gt;&#13;&#10;    &lt;/div&gt;&#13;&#10;  &lt;/div&gt;&#13;&#10;  &lt;div style={{ flexShrink: 0, height: 40, display: 'flex', alignItems: 'flex-end', justifyContent: 'space-between' }}&gt;&#13;&#10;    &lt;span style={{ color: '#BD9B56', fontSize: 12, letterSpacing: '0.1em' }}&gt;云溪花园 · 智慧社区&lt;/span&gt;&#13;&#10;    &lt;span style={{ color: '#a09b8c', fontSize: 12 }}&gt;5 / 19&lt;/span&gt;&#13;&#10;  &lt;/div&gt;&#13;&#10;&lt;/Slide&gt;"/>
         <p:cNvGrpSpPr/>
         <p:nvPr/>
       </p:nvGrpSpPr>
@@ -17297,7 +17743,7 @@
       </p:grpSpPr>
       <p:sp>
         <p:nvSpPr>
-          <p:cNvPr id="372" name=""/>
+          <p:cNvPr id="388" name=""/>
           <p:cNvSpPr/>
           <p:nvPr/>
         </p:nvSpPr>
@@ -17321,7 +17767,7 @@
       </p:sp>
       <p:sp>
         <p:nvSpPr>
-          <p:cNvPr id="373" name="" descr="{&quot;isTemplate&quot;:true,&quot;type&quot;:&quot;text&quot;}"/>
+          <p:cNvPr id="389" name="" descr="{&quot;isTemplate&quot;:true,&quot;type&quot;:&quot;text&quot;}"/>
           <p:cNvSpPr txBox="1"/>
           <p:nvPr/>
         </p:nvSpPr>
@@ -17366,7 +17812,7 @@
       </p:sp>
       <p:sp>
         <p:nvSpPr>
-          <p:cNvPr id="374" name="" descr="{&quot;isTemplate&quot;:true,&quot;type&quot;:&quot;text&quot;}"/>
+          <p:cNvPr id="390" name="" descr="{&quot;isTemplate&quot;:true,&quot;type&quot;:&quot;text&quot;}"/>
           <p:cNvSpPr txBox="1"/>
           <p:nvPr/>
         </p:nvSpPr>
@@ -17401,7 +17847,7 @@
       </p:sp>
       <p:sp>
         <p:nvSpPr>
-          <p:cNvPr id="375" name=""/>
+          <p:cNvPr id="391" name=""/>
           <p:cNvSpPr/>
           <p:nvPr/>
         </p:nvSpPr>
@@ -17434,7 +17880,7 @@
       </p:sp>
       <p:sp>
         <p:nvSpPr>
-          <p:cNvPr id="376" name=""/>
+          <p:cNvPr id="392" name=""/>
           <p:cNvSpPr/>
           <p:nvPr/>
         </p:nvSpPr>
@@ -17491,7 +17937,7 @@
       </p:sp>
       <p:sp>
         <p:nvSpPr>
-          <p:cNvPr id="377" name="" descr="{&quot;isTemplate&quot;:true,&quot;type&quot;:&quot;text&quot;}"/>
+          <p:cNvPr id="393" name="" descr="{&quot;isTemplate&quot;:true,&quot;type&quot;:&quot;text&quot;}"/>
           <p:cNvSpPr txBox="1"/>
           <p:nvPr/>
         </p:nvSpPr>
@@ -17536,7 +17982,7 @@
       </p:sp>
       <p:sp>
         <p:nvSpPr>
-          <p:cNvPr id="378" name="" descr="{&quot;isTemplate&quot;:true,&quot;type&quot;:&quot;text&quot;}"/>
+          <p:cNvPr id="394" name="" descr="{&quot;isTemplate&quot;:true,&quot;type&quot;:&quot;text&quot;}"/>
           <p:cNvSpPr txBox="1"/>
           <p:nvPr/>
         </p:nvSpPr>
@@ -17571,7 +18017,7 @@
       </p:sp>
       <p:sp>
         <p:nvSpPr>
-          <p:cNvPr id="379" name=""/>
+          <p:cNvPr id="395" name=""/>
           <p:cNvSpPr/>
           <p:nvPr/>
         </p:nvSpPr>
@@ -17604,7 +18050,7 @@
       </p:sp>
       <p:sp>
         <p:nvSpPr>
-          <p:cNvPr id="380" name=""/>
+          <p:cNvPr id="396" name=""/>
           <p:cNvSpPr/>
           <p:nvPr/>
         </p:nvSpPr>
@@ -17661,7 +18107,7 @@
       </p:sp>
       <p:sp>
         <p:nvSpPr>
-          <p:cNvPr id="381" name="" descr="{&quot;isTemplate&quot;:true,&quot;type&quot;:&quot;text&quot;}"/>
+          <p:cNvPr id="397" name="" descr="{&quot;isTemplate&quot;:true,&quot;type&quot;:&quot;text&quot;}"/>
           <p:cNvSpPr txBox="1"/>
           <p:nvPr/>
         </p:nvSpPr>
@@ -17706,7 +18152,7 @@
       </p:sp>
       <p:sp>
         <p:nvSpPr>
-          <p:cNvPr id="382" name="" descr="{&quot;isTemplate&quot;:true,&quot;type&quot;:&quot;text&quot;}"/>
+          <p:cNvPr id="398" name="" descr="{&quot;isTemplate&quot;:true,&quot;type&quot;:&quot;text&quot;}"/>
           <p:cNvSpPr txBox="1"/>
           <p:nvPr/>
         </p:nvSpPr>
@@ -17741,7 +18187,7 @@
       </p:sp>
       <p:sp>
         <p:nvSpPr>
-          <p:cNvPr id="383" name=""/>
+          <p:cNvPr id="399" name=""/>
           <p:cNvSpPr/>
           <p:nvPr/>
         </p:nvSpPr>
@@ -17774,7 +18220,7 @@
       </p:sp>
       <p:sp>
         <p:nvSpPr>
-          <p:cNvPr id="384" name=""/>
+          <p:cNvPr id="400" name=""/>
           <p:cNvSpPr/>
           <p:nvPr/>
         </p:nvSpPr>
@@ -17831,7 +18277,7 @@
       </p:sp>
       <p:sp>
         <p:nvSpPr>
-          <p:cNvPr id="385" name="" descr="{&quot;isTemplate&quot;:true,&quot;type&quot;:&quot;text&quot;}"/>
+          <p:cNvPr id="401" name="" descr="{&quot;isTemplate&quot;:true,&quot;type&quot;:&quot;text&quot;}"/>
           <p:cNvSpPr txBox="1"/>
           <p:nvPr/>
         </p:nvSpPr>
@@ -17876,7 +18322,7 @@
       </p:sp>
       <p:sp>
         <p:nvSpPr>
-          <p:cNvPr id="386" name="" descr="{&quot;isTemplate&quot;:true,&quot;type&quot;:&quot;text&quot;}"/>
+          <p:cNvPr id="402" name="" descr="{&quot;isTemplate&quot;:true,&quot;type&quot;:&quot;text&quot;}"/>
           <p:cNvSpPr txBox="1"/>
           <p:nvPr/>
         </p:nvSpPr>
@@ -17931,7 +18377,7 @@
       </p:sp>
       <p:sp>
         <p:nvSpPr>
-          <p:cNvPr id="387" name=""/>
+          <p:cNvPr id="403" name=""/>
           <p:cNvSpPr/>
           <p:nvPr/>
         </p:nvSpPr>
@@ -17964,7 +18410,7 @@
       </p:sp>
       <p:sp>
         <p:nvSpPr>
-          <p:cNvPr id="388" name=""/>
+          <p:cNvPr id="404" name=""/>
           <p:cNvSpPr/>
           <p:nvPr/>
         </p:nvSpPr>
@@ -18021,7 +18467,7 @@
       </p:sp>
       <p:sp>
         <p:nvSpPr>
-          <p:cNvPr id="389" name="" descr="{&quot;isTemplate&quot;:true,&quot;type&quot;:&quot;text&quot;}"/>
+          <p:cNvPr id="405" name="" descr="{&quot;isTemplate&quot;:true,&quot;type&quot;:&quot;text&quot;}"/>
           <p:cNvSpPr txBox="1"/>
           <p:nvPr/>
         </p:nvSpPr>
@@ -18066,7 +18512,7 @@
       </p:sp>
       <p:sp>
         <p:nvSpPr>
-          <p:cNvPr id="390" name="" descr="{&quot;isTemplate&quot;:true,&quot;type&quot;:&quot;text&quot;}"/>
+          <p:cNvPr id="406" name="" descr="{&quot;isTemplate&quot;:true,&quot;type&quot;:&quot;text&quot;}"/>
           <p:cNvSpPr txBox="1"/>
           <p:nvPr/>
         </p:nvSpPr>
@@ -18101,7 +18547,7 @@
       </p:sp>
       <p:sp>
         <p:nvSpPr>
-          <p:cNvPr id="391" name="" descr="{&quot;isTemplate&quot;:true,&quot;type&quot;:&quot;text&quot;}"/>
+          <p:cNvPr id="407" name="" descr="{&quot;isTemplate&quot;:true,&quot;type&quot;:&quot;text&quot;}"/>
           <p:cNvSpPr txBox="1"/>
           <p:nvPr/>
         </p:nvSpPr>
@@ -18156,7 +18602,7 @@
       </p:sp>
       <p:sp>
         <p:nvSpPr>
-          <p:cNvPr id="392" name="" descr="{&quot;isTemplate&quot;:true,&quot;type&quot;:&quot;text&quot;}"/>
+          <p:cNvPr id="408" name="" descr="{&quot;isTemplate&quot;:true,&quot;type&quot;:&quot;text&quot;}"/>
           <p:cNvSpPr txBox="1"/>
           <p:nvPr/>
         </p:nvSpPr>
@@ -18199,7 +18645,7 @@
   <p:cSld>
     <p:spTree>
       <p:nvGrpSpPr>
-        <p:cNvPr id="393" name="" descr="&lt;Slide style={{ width: '1280px', height: '720px', background: '#FBFCFA', position: 'relative', padding: '32px 64px', boxSizing: 'border-box', display: 'flex', flexDirection: 'column' }}&gt;&#13;&#10;  &lt;div style={{ flexShrink: 0 }}&gt;&#13;&#10;    &lt;div style={{ color: '#BD9B56', fontSize: 13, letterSpacing: '0.25em', marginBottom: 6 }}&gt;01 · 项目规模&lt;/div&gt;&#13;&#10;    &lt;h2 style={{ fontSize: 30, fontWeight: 'bold', color: '#172133', margin: 0, lineHeight: 1.3 }}&gt;虚拟社区数据资产：云溪花园&lt;/h2&gt;&#13;&#10;    &lt;div style={{ fontSize: 14, color: '#6b7075', marginTop: 6 }}&gt;以一个社区为根，向下延伸出空间、人员、业务、知识四类数据资产&lt;/div&gt;&#13;&#10;  &lt;/div&gt;&#13;&#10;  &lt;div style={{ flex: 1, display: 'flex', alignItems: 'center', justifyContent: 'center' }}&gt;&#13;&#10;    &lt;svg width=&quot;1150&quot; height=&quot;470&quot; viewBox=&quot;0 0 1150 470&quot;&gt;&#13;&#10;      &lt;g fontFamily=&quot;Inter, sans-serif&quot;&gt;&#13;&#10;        {/* 根节点 community */}&#13;&#10;        &lt;rect x=&quot;450&quot; y=&quot;14&quot; width=&quot;250&quot; height=&quot;58&quot; rx=&quot;10&quot; fill=&quot;#172133&quot; /&gt;&#13;&#10;        &lt;text x=&quot;575&quot; y=&quot;38&quot; textAnchor=&quot;middle&quot; fontSize=&quot;15&quot; fontWeight=&quot;bold&quot; fill=&quot;#FBFCFA&quot;&gt;community 云溪花园&lt;/text&gt;&#13;&#10;        &lt;text x=&quot;575&quot; y=&quot;58&quot; textAnchor=&quot;middle&quot; fontSize=&quot;11&quot; fill=&quot;#BD9B56&quot;&gt;1 个小区 · 上海浦东张江路1268号&lt;/text&gt;&#13;&#10;        {/* 根节点连接线 */}&#13;&#10;        &lt;line x1=&quot;575&quot; y1=&quot;72&quot; x2=&quot;575&quot; y2=&quot;92&quot; stroke=&quot;#BD9B56&quot; strokeWidth=&quot;1.5&quot; /&gt;&#13;&#10;        &lt;line x1=&quot;150&quot; y1=&quot;92&quot; x2=&quot;1015&quot; y2=&quot;92&quot; stroke=&quot;#BD9B56&quot; strokeWidth=&quot;1.5&quot; /&gt;&#13;&#10;        &lt;line x1=&quot;150&quot; y1=&quot;92&quot; x2=&quot;150&quot; y2=&quot;108&quot; stroke=&quot;#BD9B56&quot; strokeWidth=&quot;1.5&quot; /&gt;&#13;&#10;        &lt;line x1=&quot;438&quot; y1=&quot;92&quot; x2=&quot;438&quot; y2=&quot;108&quot; stroke=&quot;#BD9B56&quot; strokeWidth=&quot;1.5&quot; /&gt;&#13;&#10;        &lt;line x1=&quot;726&quot; y1=&quot;92&quot; x2=&quot;726&quot; y2=&quot;108&quot; stroke=&quot;#BD9B56&quot; strokeWidth=&quot;1.5&quot; /&gt;&#13;&#10;        &lt;line x1=&quot;1015&quot; y1=&quot;92&quot; x2=&quot;1015&quot; y2=&quot;108&quot; stroke=&quot;#BD9B56&quot; strokeWidth=&quot;1.5&quot; /&gt;&#13;&#10;&#13;&#10;        {/* 分组1：空间资产 */}&#13;&#10;        &lt;text x=&quot;150&quot; y=&quot;128&quot; textAnchor=&quot;middle&quot; fontSize=&quot;12&quot; fontWeight=&quot;bold&quot; fill=&quot;#BD9B56&quot;&gt;空间资产&lt;/text&gt;&#13;&#10;        &lt;rect x=&quot;20&quot; y=&quot;138&quot; width=&quot;260&quot; height=&quot;56&quot; rx=&quot;8&quot; fill=&quot;rgba(34,57,94,0.06)&quot; stroke=&quot;#22395E&quot; strokeWidth=&quot;1.5&quot; /&gt;&#13;&#10;        &lt;text x=&quot;150&quot; y=&quot;162&quot; textAnchor=&quot;middle&quot; fontSize=&quot;14&quot; fontWeight=&quot;bold&quot; fill=&quot;#172133&quot;&gt;building 楼栋 ×8&lt;/text&gt;&#13;&#10;        &lt;text x=&quot;150&quot; y=&quot;182&quot; textAnchor=&quot;middle&quot; fontSize=&quot;11&quot; fill=&quot;#5F5E5A&quot;&gt;每栋 26 层 · 2 单元 · 4 户/层&lt;/text&gt;&#13;&#10;        &lt;line x1=&quot;150&quot; y1=&quot;194&quot; x2=&quot;150&quot; y2=&quot;206&quot; stroke=&quot;#BD9B56&quot; strokeWidth=&quot;1.2&quot; /&gt;&#13;&#10;        &lt;rect x=&quot;20&quot; y=&quot;210&quot; width=&quot;260&quot; height=&quot;56&quot; rx=&quot;8&quot; fill=&quot;rgba(34,57,94,0.06)&quot; stroke=&quot;#22395E&quot; strokeWidth=&quot;1.5&quot; /&gt;&#13;&#10;        &lt;text x=&quot;150&quot; y=&quot;234&quot; textAnchor=&quot;middle&quot; fontSize=&quot;14&quot; fontWeight=&quot;bold&quot; fill=&quot;#172133&quot;&gt;house 房屋 ×1664&lt;/text&gt;&#13;&#10;        &lt;text x=&quot;150&quot; y=&quot;254&quot; textAnchor=&quot;middle&quot; fontSize=&quot;11&quot; fill=&quot;#5F5E5A&quot;&gt;入住约 1200 户 · 800 车位&lt;/text&gt;&#13;&#10;&#13;&#10;        {/* 分组2：人员资产 */}&#13;&#10;        &lt;text x=&quot;438&quot; y=&quot;128&quot; textAnchor=&quot;middle&quot; fontSize=&quot;12&quot; fontWeight=&quot;bold&quot; fill=&quot;#BD9B56&quot;&gt;人员资产&lt;/text&gt;&#13;&#10;        &lt;rect x=&quot;308&quot; y=&quot;138&quot; width=&quot;260&quot; height=&quot;56&quot; rx=&quot;8&quot; fill=&quot;rgba(189,155,86,0.10)&quot; stroke=&quot;#BD9B56&quot; strokeWidth=&quot;1.5&quot; /&gt;&#13;&#10;        &lt;text x=&quot;438&quot; y=&quot;162&quot; textAnchor=&quot;middle&quot; fontSize=&quot;14&quot; fontWeight=&quot;bold&quot; fill=&quot;#172133&quot;&gt;user 业主 ×200&lt;/text&gt;&#13;&#10;        &lt;text x=&quot;438&quot; y=&quot;182&quot; textAnchor=&quot;middle&quot; fontSize=&quot;11&quot; fill=&quot;#5F5E5A&quot;&gt;house_binding 绑定 200 套&lt;/text&gt;&#13;&#10;        &lt;line x1=&quot;438&quot; y1=&quot;194&quot; x2=&quot;438&quot; y2=&quot;206&quot; stroke=&quot;#BD9B56&quot; strokeWidth=&quot;1.2&quot; /&gt;&#13;&#10;        &lt;rect x=&quot;308&quot; y=&quot;210&quot; width=&quot;260&quot; height=&quot;56&quot; rx=&quot;8&quot; fill=&quot;rgba(189,155,86,0.10)&quot; stroke=&quot;#BD9B56&quot; strokeWidth=&quot;1.5&quot; /&gt;&#13;&#10;        &lt;text x=&quot;438&quot; y=&quot;234&quot; textAnchor=&quot;middle&quot; fontSize=&quot;14&quot; fontWeight=&quot;bold&quot; fill=&quot;#172133&quot;&gt;worker 物业 ×75&lt;/text&gt;&#13;&#10;        &lt;text x=&quot;438&quot; y=&quot;254&quot; textAnchor=&quot;middle&quot; fontSize=&quot;11&quot; fill=&quot;#5F5E5A&quot;&gt;10 管理 / 15 维修 / 50 一线&lt;/text&gt;&#13;&#10;&#13;&#10;        {/* 分组3：业务数据 */}&#13;&#10;        &lt;text x=&quot;726&quot; y=&quot;128&quot; textAnchor=&quot;middle&quot; fontSize=&quot;12&quot; fontWeight=&quot;bold&quot; fill=&quot;#BD9B56&quot;&gt;业务数据&lt;/text&gt;&#13;&#10;        &lt;rect x=&quot;596&quot; y=&quot;138&quot; width=&quot;260&quot; height=&quot;40&quot; rx=&quot;8&quot; fill=&quot;rgba(34,57,94,0.06)&quot; stroke=&quot;#22395E&quot; strokeWidth=&quot;1.5&quot; /&gt;&#13;&#10;        &lt;text x=&quot;726&quot; y=&quot;163&quot; textAnchor=&quot;middle&quot; fontSize=&quot;13&quot; fontWeight=&quot;bold&quot; fill=&quot;#172133&quot;&gt;repair_order 工单 ×50&lt;/text&gt;&#13;&#10;        &lt;rect x=&quot;596&quot; y=&quot;186&quot; width=&quot;260&quot; height=&quot;40&quot; rx=&quot;8&quot; fill=&quot;rgba(34,57,94,0.06)&quot; stroke=&quot;#22395E&quot; strokeWidth=&quot;1.5&quot; /&gt;&#13;&#10;        &lt;text x=&quot;726&quot; y=&quot;211&quot; textAnchor=&quot;middle&quot; fontSize=&quot;13&quot; fontWeight=&quot;bold&quot; fill=&quot;#172133&quot;&gt;fee_bill 账单 ×746&lt;/text&gt;&#13;&#10;        &lt;rect x=&quot;596&quot; y=&quot;234&quot; width=&quot;260&quot; height=&quot;40&quot; rx=&quot;8&quot; fill=&quot;rgba(34,57,94,0.06)&quot; stroke=&quot;#22395E&quot; strokeWidth=&quot;1.5&quot; /&gt;&#13;&#10;        &lt;text x=&quot;726&quot; y=&quot;259&quot; textAnchor=&quot;middle&quot; fontSize=&quot;13&quot; fontWeight=&quot;bold&quot; fill=&quot;#172133&quot;&gt;notice 公告 ×24&lt;/text&gt;&#13;&#10;&#13;&#10;        {/* 分组4：知识资产 */}&#13;&#10;        &lt;text x=&quot;1015&quot; y=&quot;128&quot; textAnchor=&quot;middle&quot; fontSize=&quot;12&quot; fontWeight=&quot;bold&quot; fill=&quot;#BD9B56&quot;&gt;知识资产&lt;/text&gt;&#13;&#10;        &lt;rect x=&quot;885&quot; y=&quot;138&quot; width=&quot;260&quot; height=&quot;56&quot; rx=&quot;8&quot; fill=&quot;#22395E&quot; /&gt;&#13;&#10;        &lt;text x=&quot;1015&quot; y=&quot;162&quot; textAnchor=&quot;middle&quot; fontSize=&quot;14&quot; fontWeight=&quot;bold&quot; fill=&quot;#FBFCFA&quot;&gt;knowledge 文档 ×22&lt;/text&gt;&#13;&#10;        &lt;text x=&quot;1015&quot; y=&quot;182&quot; textAnchor=&quot;middle&quot; fontSize=&quot;11&quot; fill=&quot;#BD9B56&quot;&gt;7 个分类（规约/装修/停车…）&lt;/text&gt;&#13;&#10;        &lt;line x1=&quot;1015&quot; y1=&quot;194&quot; x2=&quot;1015&quot; y2=&quot;206&quot; stroke=&quot;#BD9B56&quot; strokeWidth=&quot;1.2&quot; /&gt;&#13;&#10;        &lt;rect x=&quot;885&quot; y=&quot;210&quot; width=&quot;260&quot; height=&quot;56&quot; rx=&quot;8&quot; fill=&quot;rgba(34,57,94,0.06)&quot; stroke=&quot;#BD9B56&quot; strokeWidth=&quot;1.5&quot; /&gt;&#13;&#10;        &lt;text x=&quot;1015&quot; y=&quot;234&quot; textAnchor=&quot;middle&quot; fontSize=&quot;14&quot; fontWeight=&quot;bold&quot; fill=&quot;#172133&quot;&gt;chunk 切片 ×99&lt;/text&gt;&#13;&#10;        &lt;text x=&quot;1015&quot; y=&quot;254&quot; textAnchor=&quot;middle&quot; fontSize=&quot;11&quot; fill=&quot;#5F5E5A&quot;&gt;pgvector 1024 维向量&lt;/text&gt;&#13;&#10;&#13;&#10;        {/* 底部关系说明 */}&#13;&#10;        &lt;rect x=&quot;300&quot; y=&quot;290&quot; width=&quot;550&quot; height=&quot;48&quot; rx=&quot;8&quot; fill=&quot;rgba(189,155,86,0.10)&quot; /&gt;&#13;&#10;        &lt;text x=&quot;575&quot; y=&quot;318&quot; textAnchor=&quot;middle&quot; fontSize=&quot;12&quot; fill=&quot;#172133&quot;&gt;repair_order → user + house + worker · fee_bill → house + user · 外键关联&lt;/text&gt;&#13;&#10;        &lt;text x=&quot;575&quot; y=&quot;334&quot; textAnchor=&quot;middle&quot; fontSize=&quot;11&quot; fill=&quot;#5F5E5A&quot;&gt;8 个 SQL 种子文件 · 一键导入可复现&lt;/text&gt;&#13;&#10;      &lt;/g&gt;&#13;&#10;    &lt;/svg&gt;&#13;&#10;  &lt;/div&gt;&#13;&#10;  &lt;div style={{ flexShrink: 0, height: 40, display: 'flex', alignItems: 'flex-end', justifyContent: 'space-between' }}&gt;&#13;&#10;    &lt;span style={{ color: '#BD9B56', fontSize: 12, letterSpacing: '0.1em' }}&gt;云溪花园 · 智慧社区&lt;/span&gt;&#13;&#10;    &lt;span style={{ color: '#a09b8c', fontSize: 12 }}&gt;6 / 19&lt;/span&gt;&#13;&#10;  &lt;/div&gt;&#13;&#10;&lt;/Slide&gt;"/>
+        <p:cNvPr id="409" name="" descr="&lt;Slide style={{ width: '1280px', height: '720px', background: '#FBFCFA', position: 'relative', padding: '32px 64px', boxSizing: 'border-box', display: 'flex', flexDirection: 'column' }}&gt;&#13;&#10;  &lt;div style={{ flexShrink: 0 }}&gt;&#13;&#10;    &lt;div style={{ color: '#BD9B56', fontSize: 13, letterSpacing: '0.25em', marginBottom: 6 }}&gt;01 · 项目规模&lt;/div&gt;&#13;&#10;    &lt;h2 style={{ fontSize: 30, fontWeight: 'bold', color: '#172133', margin: 0, lineHeight: 1.3 }}&gt;虚拟社区数据资产：云溪花园&lt;/h2&gt;&#13;&#10;    &lt;div style={{ fontSize: 14, color: '#6b7075', marginTop: 6 }}&gt;以一个社区为根，向下延伸出空间、人员、业务、知识四类数据资产&lt;/div&gt;&#13;&#10;  &lt;/div&gt;&#13;&#10;  &lt;div style={{ flex: 1, display: 'flex', alignItems: 'center', justifyContent: 'center' }}&gt;&#13;&#10;    &lt;svg width=&quot;1150&quot; height=&quot;470&quot; viewBox=&quot;0 0 1150 470&quot;&gt;&#13;&#10;      &lt;g fontFamily=&quot;Inter, sans-serif&quot;&gt;&#13;&#10;        {/* 根节点 community */}&#13;&#10;        &lt;rect x=&quot;450&quot; y=&quot;14&quot; width=&quot;250&quot; height=&quot;58&quot; rx=&quot;10&quot; fill=&quot;#172133&quot; /&gt;&#13;&#10;        &lt;text x=&quot;575&quot; y=&quot;38&quot; textAnchor=&quot;middle&quot; fontSize=&quot;15&quot; fontWeight=&quot;bold&quot; fill=&quot;#FBFCFA&quot;&gt;community 云溪花园&lt;/text&gt;&#13;&#10;        &lt;text x=&quot;575&quot; y=&quot;58&quot; textAnchor=&quot;middle&quot; fontSize=&quot;11&quot; fill=&quot;#BD9B56&quot;&gt;1 个小区 · 上海浦东张江路1268号&lt;/text&gt;&#13;&#10;        {/* 根节点连接线 */}&#13;&#10;        &lt;line x1=&quot;575&quot; y1=&quot;72&quot; x2=&quot;575&quot; y2=&quot;92&quot; stroke=&quot;#BD9B56&quot; strokeWidth=&quot;1.5&quot; /&gt;&#13;&#10;        &lt;line x1=&quot;150&quot; y1=&quot;92&quot; x2=&quot;1015&quot; y2=&quot;92&quot; stroke=&quot;#BD9B56&quot; strokeWidth=&quot;1.5&quot; /&gt;&#13;&#10;        &lt;line x1=&quot;150&quot; y1=&quot;92&quot; x2=&quot;150&quot; y2=&quot;108&quot; stroke=&quot;#BD9B56&quot; strokeWidth=&quot;1.5&quot; /&gt;&#13;&#10;        &lt;line x1=&quot;438&quot; y1=&quot;92&quot; x2=&quot;438&quot; y2=&quot;108&quot; stroke=&quot;#BD9B56&quot; strokeWidth=&quot;1.5&quot; /&gt;&#13;&#10;        &lt;line x1=&quot;726&quot; y1=&quot;92&quot; x2=&quot;726&quot; y2=&quot;108&quot; stroke=&quot;#BD9B56&quot; strokeWidth=&quot;1.5&quot; /&gt;&#13;&#10;        &lt;line x1=&quot;1015&quot; y1=&quot;92&quot; x2=&quot;1015&quot; y2=&quot;108&quot; stroke=&quot;#BD9B56&quot; strokeWidth=&quot;1.5&quot; /&gt;&#13;&#10;&#13;&#10;        {/* 分组1：空间资产 */}&#13;&#10;        &lt;text x=&quot;150&quot; y=&quot;128&quot; textAnchor=&quot;middle&quot; fontSize=&quot;12&quot; fontWeight=&quot;bold&quot; fill=&quot;#BD9B56&quot;&gt;空间资产&lt;/text&gt;&#13;&#10;        &lt;rect x=&quot;20&quot; y=&quot;138&quot; width=&quot;260&quot; height=&quot;56&quot; rx=&quot;8&quot; fill=&quot;rgba(34,57,94,0.06)&quot; stroke=&quot;#22395E&quot; strokeWidth=&quot;1.5&quot; /&gt;&#13;&#10;        &lt;text x=&quot;150&quot; y=&quot;162&quot; textAnchor=&quot;middle&quot; fontSize=&quot;14&quot; fontWeight=&quot;bold&quot; fill=&quot;#172133&quot;&gt;building 楼栋 ×8&lt;/text&gt;&#13;&#10;        &lt;text x=&quot;150&quot; y=&quot;182&quot; textAnchor=&quot;middle&quot; fontSize=&quot;11&quot; fill=&quot;#5F5E5A&quot;&gt;每栋 26 层 · 2 单元 · 4 户/层&lt;/text&gt;&#13;&#10;        &lt;line x1=&quot;150&quot; y1=&quot;194&quot; x2=&quot;150&quot; y2=&quot;206&quot; stroke=&quot;#BD9B56&quot; strokeWidth=&quot;1.2&quot; /&gt;&#13;&#10;        &lt;rect x=&quot;20&quot; y=&quot;210&quot; width=&quot;260&quot; height=&quot;56&quot; rx=&quot;8&quot; fill=&quot;rgba(34,57,94,0.06)&quot; stroke=&quot;#22395E&quot; strokeWidth=&quot;1.5&quot; /&gt;&#13;&#10;        &lt;text x=&quot;150&quot; y=&quot;234&quot; textAnchor=&quot;middle&quot; fontSize=&quot;14&quot; fontWeight=&quot;bold&quot; fill=&quot;#172133&quot;&gt;house 房屋 ×1664&lt;/text&gt;&#13;&#10;        &lt;text x=&quot;150&quot; y=&quot;254&quot; textAnchor=&quot;middle&quot; fontSize=&quot;11&quot; fill=&quot;#5F5E5A&quot;&gt;入住约 1200 户 · 800 车位&lt;/text&gt;&#13;&#10;&#13;&#10;        {/* 分组2：人员资产 */}&#13;&#10;        &lt;text x=&quot;438&quot; y=&quot;128&quot; textAnchor=&quot;middle&quot; fontSize=&quot;12&quot; fontWeight=&quot;bold&quot; fill=&quot;#BD9B56&quot;&gt;人员资产&lt;/text&gt;&#13;&#10;        &lt;rect x=&quot;308&quot; y=&quot;138&quot; width=&quot;260&quot; height=&quot;56&quot; rx=&quot;8&quot; fill=&quot;rgba(189,155,86,0.10)&quot; stroke=&quot;#BD9B56&quot; strokeWidth=&quot;1.5&quot; /&gt;&#13;&#10;        &lt;text x=&quot;438&quot; y=&quot;162&quot; textAnchor=&quot;middle&quot; fontSize=&quot;14&quot; fontWeight=&quot;bold&quot; fill=&quot;#172133&quot;&gt;user 业主 ×200&lt;/text&gt;&#13;&#10;        &lt;text x=&quot;438&quot; y=&quot;182&quot; textAnchor=&quot;middle&quot; fontSize=&quot;11&quot; fill=&quot;#5F5E5A&quot;&gt;house_binding 绑定 200 套&lt;/text&gt;&#13;&#10;        &lt;line x1=&quot;438&quot; y1=&quot;194&quot; x2=&quot;438&quot; y2=&quot;206&quot; stroke=&quot;#BD9B56&quot; strokeWidth=&quot;1.2&quot; /&gt;&#13;&#10;        &lt;rect x=&quot;308&quot; y=&quot;210&quot; width=&quot;260&quot; height=&quot;56&quot; rx=&quot;8&quot; fill=&quot;rgba(189,155,86,0.10)&quot; stroke=&quot;#BD9B56&quot; strokeWidth=&quot;1.5&quot; /&gt;&#13;&#10;        &lt;text x=&quot;438&quot; y=&quot;234&quot; textAnchor=&quot;middle&quot; fontSize=&quot;14&quot; fontWeight=&quot;bold&quot; fill=&quot;#172133&quot;&gt;worker 物业 ×75&lt;/text&gt;&#13;&#10;        &lt;text x=&quot;438&quot; y=&quot;254&quot; textAnchor=&quot;middle&quot; fontSize=&quot;11&quot; fill=&quot;#5F5E5A&quot;&gt;10 管理 / 15 维修 / 50 一线&lt;/text&gt;&#13;&#10;&#13;&#10;        {/* 分组3：业务数据 */}&#13;&#10;        &lt;text x=&quot;726&quot; y=&quot;128&quot; textAnchor=&quot;middle&quot; fontSize=&quot;12&quot; fontWeight=&quot;bold&quot; fill=&quot;#BD9B56&quot;&gt;业务数据&lt;/text&gt;&#13;&#10;        &lt;rect x=&quot;596&quot; y=&quot;138&quot; width=&quot;260&quot; height=&quot;40&quot; rx=&quot;8&quot; fill=&quot;rgba(34,57,94,0.06)&quot; stroke=&quot;#22395E&quot; strokeWidth=&quot;1.5&quot; /&gt;&#13;&#10;        &lt;text x=&quot;726&quot; y=&quot;163&quot; textAnchor=&quot;middle&quot; fontSize=&quot;13&quot; fontWeight=&quot;bold&quot; fill=&quot;#172133&quot;&gt;repair_order 工单 ×50&lt;/text&gt;&#13;&#10;        &lt;rect x=&quot;596&quot; y=&quot;186&quot; width=&quot;260&quot; height=&quot;40&quot; rx=&quot;8&quot; fill=&quot;rgba(34,57,94,0.06)&quot; stroke=&quot;#22395E&quot; strokeWidth=&quot;1.5&quot; /&gt;&#13;&#10;        &lt;text x=&quot;726&quot; y=&quot;211&quot; textAnchor=&quot;middle&quot; fontSize=&quot;13&quot; fontWeight=&quot;bold&quot; fill=&quot;#172133&quot;&gt;fee_bill 账单 ×746&lt;/text&gt;&#13;&#10;        &lt;rect x=&quot;596&quot; y=&quot;234&quot; width=&quot;260&quot; height=&quot;40&quot; rx=&quot;8&quot; fill=&quot;rgba(34,57,94,0.06)&quot; stroke=&quot;#22395E&quot; strokeWidth=&quot;1.5&quot; /&gt;&#13;&#10;        &lt;text x=&quot;726&quot; y=&quot;259&quot; textAnchor=&quot;middle&quot; fontSize=&quot;13&quot; fontWeight=&quot;bold&quot; fill=&quot;#172133&quot;&gt;notice 公告 ×24&lt;/text&gt;&#13;&#10;&#13;&#10;        {/* 分组4：知识资产 */}&#13;&#10;        &lt;text x=&quot;1015&quot; y=&quot;128&quot; textAnchor=&quot;middle&quot; fontSize=&quot;12&quot; fontWeight=&quot;bold&quot; fill=&quot;#BD9B56&quot;&gt;知识资产&lt;/text&gt;&#13;&#10;        &lt;rect x=&quot;885&quot; y=&quot;138&quot; width=&quot;260&quot; height=&quot;56&quot; rx=&quot;8&quot; fill=&quot;#22395E&quot; /&gt;&#13;&#10;        &lt;text x=&quot;1015&quot; y=&quot;162&quot; textAnchor=&quot;middle&quot; fontSize=&quot;14&quot; fontWeight=&quot;bold&quot; fill=&quot;#FBFCFA&quot;&gt;knowledge 文档 ×22&lt;/text&gt;&#13;&#10;        &lt;text x=&quot;1015&quot; y=&quot;182&quot; textAnchor=&quot;middle&quot; fontSize=&quot;11&quot; fill=&quot;#BD9B56&quot;&gt;7 个分类（规约/装修/停车…）&lt;/text&gt;&#13;&#10;        &lt;line x1=&quot;1015&quot; y1=&quot;194&quot; x2=&quot;1015&quot; y2=&quot;206&quot; stroke=&quot;#BD9B56&quot; strokeWidth=&quot;1.2&quot; /&gt;&#13;&#10;        &lt;rect x=&quot;885&quot; y=&quot;210&quot; width=&quot;260&quot; height=&quot;56&quot; rx=&quot;8&quot; fill=&quot;rgba(34,57,94,0.06)&quot; stroke=&quot;#BD9B56&quot; strokeWidth=&quot;1.5&quot; /&gt;&#13;&#10;        &lt;text x=&quot;1015&quot; y=&quot;234&quot; textAnchor=&quot;middle&quot; fontSize=&quot;14&quot; fontWeight=&quot;bold&quot; fill=&quot;#172133&quot;&gt;chunk 切片 ×99&lt;/text&gt;&#13;&#10;        &lt;text x=&quot;1015&quot; y=&quot;254&quot; textAnchor=&quot;middle&quot; fontSize=&quot;11&quot; fill=&quot;#5F5E5A&quot;&gt;pgvector 1024 维向量&lt;/text&gt;&#13;&#10;&#13;&#10;        {/* 底部关系说明 */}&#13;&#10;        &lt;rect x=&quot;300&quot; y=&quot;290&quot; width=&quot;550&quot; height=&quot;48&quot; rx=&quot;8&quot; fill=&quot;rgba(189,155,86,0.10)&quot; /&gt;&#13;&#10;        &lt;text x=&quot;575&quot; y=&quot;318&quot; textAnchor=&quot;middle&quot; fontSize=&quot;12&quot; fill=&quot;#172133&quot;&gt;repair_order → user + house + worker · fee_bill → house + user · 外键关联&lt;/text&gt;&#13;&#10;        &lt;text x=&quot;575&quot; y=&quot;334&quot; textAnchor=&quot;middle&quot; fontSize=&quot;11&quot; fill=&quot;#5F5E5A&quot;&gt;8 个 SQL 种子文件 · 一键导入可复现&lt;/text&gt;&#13;&#10;      &lt;/g&gt;&#13;&#10;    &lt;/svg&gt;&#13;&#10;  &lt;/div&gt;&#13;&#10;  &lt;div style={{ flexShrink: 0, height: 40, display: 'flex', alignItems: 'flex-end', justifyContent: 'space-between' }}&gt;&#13;&#10;    &lt;span style={{ color: '#BD9B56', fontSize: 12, letterSpacing: '0.1em' }}&gt;云溪花园 · 智慧社区&lt;/span&gt;&#13;&#10;    &lt;span style={{ color: '#a09b8c', fontSize: 12 }}&gt;6 / 19&lt;/span&gt;&#13;&#10;  &lt;/div&gt;&#13;&#10;&lt;/Slide&gt;"/>
         <p:cNvGrpSpPr/>
         <p:nvPr/>
       </p:nvGrpSpPr>
@@ -18213,7 +18659,7 @@
       </p:grpSpPr>
       <p:sp>
         <p:nvSpPr>
-          <p:cNvPr id="394" name=""/>
+          <p:cNvPr id="410" name=""/>
           <p:cNvSpPr/>
           <p:nvPr/>
         </p:nvSpPr>
@@ -18237,7 +18683,7 @@
       </p:sp>
       <p:sp>
         <p:nvSpPr>
-          <p:cNvPr id="395" name="" descr="{&quot;isTemplate&quot;:true,&quot;type&quot;:&quot;text&quot;}"/>
+          <p:cNvPr id="411" name="" descr="{&quot;isTemplate&quot;:true,&quot;type&quot;:&quot;text&quot;}"/>
           <p:cNvSpPr txBox="1"/>
           <p:nvPr/>
         </p:nvSpPr>
@@ -18282,7 +18728,7 @@
       </p:sp>
       <p:sp>
         <p:nvSpPr>
-          <p:cNvPr id="396" name="" descr="{&quot;isTemplate&quot;:true,&quot;type&quot;:&quot;text&quot;}"/>
+          <p:cNvPr id="412" name="" descr="{&quot;isTemplate&quot;:true,&quot;type&quot;:&quot;text&quot;}"/>
           <p:cNvSpPr txBox="1"/>
           <p:nvPr/>
         </p:nvSpPr>
@@ -18317,7 +18763,7 @@
       </p:sp>
       <p:sp>
         <p:nvSpPr>
-          <p:cNvPr id="397" name="" descr="{&quot;isTemplate&quot;:true,&quot;type&quot;:&quot;text&quot;}"/>
+          <p:cNvPr id="413" name="" descr="{&quot;isTemplate&quot;:true,&quot;type&quot;:&quot;text&quot;}"/>
           <p:cNvSpPr txBox="1"/>
           <p:nvPr/>
         </p:nvSpPr>
@@ -18352,7 +18798,7 @@
       </p:sp>
       <p:pic>
         <p:nvPicPr>
-          <p:cNvPr id="398" name=""/>
+          <p:cNvPr id="414" name=""/>
           <p:cNvPicPr>
             <a:picLocks noChangeAspect="1"/>
           </p:cNvPicPr>
@@ -18383,7 +18829,7 @@
       </p:pic>
       <p:sp>
         <p:nvSpPr>
-          <p:cNvPr id="399" name="" descr="{&quot;isTemplate&quot;:true,&quot;type&quot;:&quot;text&quot;}"/>
+          <p:cNvPr id="415" name="" descr="{&quot;isTemplate&quot;:true,&quot;type&quot;:&quot;text&quot;}"/>
           <p:cNvSpPr txBox="1"/>
           <p:nvPr/>
         </p:nvSpPr>
@@ -18438,7 +18884,7 @@
       </p:sp>
       <p:sp>
         <p:nvSpPr>
-          <p:cNvPr id="400" name="" descr="{&quot;isTemplate&quot;:true,&quot;type&quot;:&quot;text&quot;}"/>
+          <p:cNvPr id="416" name="" descr="{&quot;isTemplate&quot;:true,&quot;type&quot;:&quot;text&quot;}"/>
           <p:cNvSpPr txBox="1"/>
           <p:nvPr/>
         </p:nvSpPr>
@@ -18481,7 +18927,7 @@
   <p:cSld>
     <p:spTree>
       <p:nvGrpSpPr>
-        <p:cNvPr id="401" name="" descr="&lt;Slide style={{ width: '1280px', height: '720px', background: 'linear-gradient(135deg, #172133 0%, #22395E 100%)', position: 'relative', display: 'flex', flexDirection: 'column', justifyContent: 'center', padding: '0 96px' }}&gt;&#10;  &lt;div style={{ color: '#BD9B56', fontSize: 15, letterSpacing: '0.35em', marginBottom: 24 }}&gt;SECTION 02&lt;/div&gt;&#10;  &lt;div style={{ display: 'flex', alignItems: 'baseline', gap: 28 }}&gt;&#10;    &lt;span style={{ fontSize: 110, fontWeight: 'bold', color: 'rgba(189,155,86,0.28)', fontFamily: 'Inter, sans-serif', lineHeight: 1 }}&gt;02&lt;/span&gt;&#10;    &lt;span style={{ fontSize: 46, fontWeight: 'bold', color: '#FBFCFA', letterSpacing: '0.02em' }}&gt;技术构建过程&lt;/span&gt;&#10;  &lt;/div&gt;&#10;  &lt;div style={{ width: 72, height: 3, background: '#BD9B56', margin: '28px 0 20px' }} /&gt;&#10;  &lt;div style={{ fontSize: 16, color: 'rgba(251,252,250,0.72)', letterSpacing: '0.04em' }}&gt;数据库 → 后端 → 前端 → AI Agent → RAG 知识库&lt;/div&gt;&#10;  &lt;div style={{ position: 'absolute', bottom: 42, right: 96, color: 'rgba(251,252,250,0.4)', fontSize: 13, fontFamily: 'Inter, sans-serif' }}&gt;07 / 19&lt;/div&gt;&#10;&lt;/Slide&gt;"/>
+        <p:cNvPr id="417" name="" descr="&lt;Slide style={{ width: '1280px', height: '720px', background: 'linear-gradient(135deg, #172133 0%, #22395E 100%)', position: 'relative', display: 'flex', flexDirection: 'column', justifyContent: 'center', padding: '0 96px' }}&gt;&#10;  &lt;div style={{ color: '#BD9B56', fontSize: 15, letterSpacing: '0.35em', marginBottom: 24 }}&gt;SECTION 02&lt;/div&gt;&#10;  &lt;div style={{ display: 'flex', alignItems: 'center', gap: 36 }}&gt;&#10;    &lt;span style={{ fontSize: 160, fontWeight: 'bold', color: '#BD9B56', lineHeight: 1 }}&gt;02&lt;/span&gt;&#10;    &lt;div&gt;&#10;      &lt;div style={{ fontSize: 50, fontWeight: 'bold', color: '#FBFCFA', letterSpacing: '0.02em', lineHeight: 1.15 }}&gt;技术构建过程&lt;/div&gt;&#10;      &lt;div style={{ fontSize: 17, color: 'rgba(251,252,250,0.55)', marginTop: 12, letterSpacing: '0.06em' }}&gt;TECHNOLOGY CONSTRUCTION&lt;/div&gt;&#10;    &lt;/div&gt;&#10;  &lt;/div&gt;&#10;  &lt;div style={{ width: 80, height: 3, background: '#BD9B56', margin: '32px 0 24px' }} /&gt;&#10;  &lt;div style={{ display: 'flex', gap: 14 }}&gt;&#10;    &lt;span style={{ fontSize: 15, color: 'rgba(251,252,250,0.88)', border: '1px solid rgba(189,155,86,0.65)', padding: '9px 20px', borderRadius: 22 }}&gt;数据库设计&lt;/span&gt;&#10;    &lt;span style={{ fontSize: 15, color: 'rgba(251,252,250,0.88)', border: '1px solid rgba(189,155,86,0.65)', padding: '9px 20px', borderRadius: 22 }}&gt;后端 + 前端三端&lt;/span&gt;&#10;    &lt;span style={{ fontSize: 15, color: 'rgba(251,252,250,0.88)', border: '1px solid rgba(189,155,86,0.65)', padding: '9px 20px', borderRadius: 22 }}&gt;AI Agent&lt;/span&gt;&#10;    &lt;span style={{ fontSize: 15, color: 'rgba(251,252,250,0.88)', border: '1px solid rgba(189,155,86,0.65)', padding: '9px 20px', borderRadius: 22 }}&gt;RAG 知识库&lt;/span&gt;&#10;  &lt;/div&gt;&#10;  &lt;div style={{ position: 'absolute', bottom: 42, right: 96, color: 'rgba(251,252,250,0.4)', fontSize: 13 }}&gt;07 / 19&lt;/div&gt;&#10;&lt;/Slide&gt;"/>
         <p:cNvGrpSpPr/>
         <p:nvPr/>
       </p:nvGrpSpPr>
@@ -18495,7 +18941,7 @@
       </p:grpSpPr>
       <p:sp>
         <p:nvSpPr>
-          <p:cNvPr id="402" name=""/>
+          <p:cNvPr id="418" name=""/>
           <p:cNvSpPr/>
           <p:nvPr/>
         </p:nvSpPr>
@@ -18527,14 +18973,49 @@
       </p:sp>
       <p:sp>
         <p:nvSpPr>
-          <p:cNvPr id="403" name="" descr="{&quot;isTemplate&quot;:true,&quot;type&quot;:&quot;text&quot;}"/>
+          <p:cNvPr id="419" name="" descr="{&quot;isTemplate&quot;:true,&quot;type&quot;:&quot;text&quot;}"/>
+          <p:cNvSpPr txBox="1"/>
+          <p:nvPr/>
+        </p:nvSpPr>
+        <p:spPr>
+          <a:xfrm rot="0" flipH="0" flipV="0">
+            <a:off x="914400" y="1866900"/>
+            <a:ext cx="10363200" cy="171450"/>
+          </a:xfrm>
+          <a:prstGeom prst="rect"/>
+        </p:spPr>
+        <p:txBody>
+          <a:bodyPr wrap="none" lIns="0" tIns="0" rIns="0" bIns="0"/>
+          <a:p>
+            <a:pPr>
+              <a:lnSpc>
+                <a:spcPct val="100000"/>
+              </a:lnSpc>
+            </a:pPr>
+            <a:r>
+              <a:rPr lang="en-US" sz="1125" spc="-9223372036854775808">
+                <a:solidFill>
+                  <a:srgbClr val="BD9B56"/>
+                </a:solidFill>
+                <a:latin typeface="Microsoft YaHei"/>
+                <a:ea typeface="Microsoft YaHei"/>
+              </a:rPr>
+              <a:t>SECTION 02</a:t>
+            </a:r>
+            <a:endParaRPr/>
+          </a:p>
+        </p:txBody>
+      </p:sp>
+      <p:sp>
+        <p:nvSpPr>
+          <p:cNvPr id="420" name="" descr="{&quot;isTemplate&quot;:true,&quot;type&quot;:&quot;text&quot;}"/>
           <p:cNvSpPr txBox="1"/>
           <p:nvPr/>
         </p:nvSpPr>
         <p:spPr>
           <a:xfrm rot="0" flipH="0" flipV="0">
             <a:off x="914400" y="2266950"/>
-            <a:ext cx="10363200" cy="171450"/>
+            <a:ext cx="1885950" cy="1828800"/>
           </a:xfrm>
           <a:prstGeom prst="rect"/>
         </p:spPr>
@@ -18547,29 +19028,64 @@
               </a:lnSpc>
             </a:pPr>
             <a:r>
-              <a:rPr lang="en-US" sz="1125" spc="-9223372036854775808">
+              <a:rPr lang="en-US" sz="12000" b="1">
                 <a:solidFill>
                   <a:srgbClr val="BD9B56"/>
                 </a:solidFill>
                 <a:latin typeface="Microsoft YaHei"/>
                 <a:ea typeface="Microsoft YaHei"/>
               </a:rPr>
-              <a:t>SECTION 02</a:t>
-            </a:r>
-            <a:endParaRPr/>
-          </a:p>
-        </p:txBody>
-      </p:sp>
-      <p:sp>
-        <p:nvSpPr>
-          <p:cNvPr id="404" name="" descr="{&quot;isTemplate&quot;:true,&quot;type&quot;:&quot;text&quot;}"/>
-          <p:cNvSpPr txBox="1"/>
-          <p:nvPr/>
-        </p:nvSpPr>
-        <p:spPr>
-          <a:xfrm rot="0" flipH="0" flipV="0">
-            <a:off x="914400" y="2667000"/>
-            <a:ext cx="1343025" cy="1257300"/>
+              <a:t>02</a:t>
+            </a:r>
+            <a:endParaRPr/>
+          </a:p>
+        </p:txBody>
+      </p:sp>
+      <p:sp>
+        <p:nvSpPr>
+          <p:cNvPr id="421" name="" descr="{&quot;isTemplate&quot;:true,&quot;type&quot;:&quot;text&quot;}"/>
+          <p:cNvSpPr txBox="1"/>
+          <p:nvPr/>
+        </p:nvSpPr>
+        <p:spPr>
+          <a:xfrm rot="0" flipH="0" flipV="0">
+            <a:off x="3143250" y="2695575"/>
+            <a:ext cx="2857500" cy="657225"/>
+          </a:xfrm>
+          <a:prstGeom prst="rect"/>
+        </p:spPr>
+        <p:txBody>
+          <a:bodyPr wrap="none" lIns="0" tIns="0" rIns="0" bIns="0"/>
+          <a:p>
+            <a:pPr>
+              <a:lnSpc>
+                <a:spcPct val="114999"/>
+              </a:lnSpc>
+            </a:pPr>
+            <a:r>
+              <a:rPr lang="zh-CN" sz="3750" spc="-9223372036854775808">
+                <a:solidFill>
+                  <a:srgbClr val="FBFCFA"/>
+                </a:solidFill>
+                <a:latin typeface="Microsoft YaHei"/>
+                <a:ea typeface="Microsoft YaHei"/>
+              </a:rPr>
+              <a:t>技术构建过程</a:t>
+            </a:r>
+            <a:endParaRPr/>
+          </a:p>
+        </p:txBody>
+      </p:sp>
+      <p:sp>
+        <p:nvSpPr>
+          <p:cNvPr id="422" name="" descr="{&quot;isTemplate&quot;:true,&quot;type&quot;:&quot;text&quot;}"/>
+          <p:cNvSpPr txBox="1"/>
+          <p:nvPr/>
+        </p:nvSpPr>
+        <p:spPr>
+          <a:xfrm rot="0" flipH="0" flipV="0">
+            <a:off x="3143250" y="3467100"/>
+            <a:ext cx="2857500" cy="200025"/>
           </a:xfrm>
           <a:prstGeom prst="rect"/>
         </p:spPr>
@@ -18582,66 +19098,31 @@
               </a:lnSpc>
             </a:pPr>
             <a:r>
-              <a:rPr lang="en-US" sz="8250" b="1">
-                <a:solidFill>
-                  <a:srgbClr val="BD9B56">
-                    <a:alpha val="28000"/>
+              <a:rPr lang="en-US" sz="1275" spc="-9223372036854775808">
+                <a:solidFill>
+                  <a:srgbClr val="FBFCFA">
+                    <a:alpha val="55000"/>
                   </a:srgbClr>
                 </a:solidFill>
-                <a:latin typeface="Inter"/>
-                <a:ea typeface="Inter"/>
-              </a:rPr>
-              <a:t>02</a:t>
-            </a:r>
-            <a:endParaRPr/>
-          </a:p>
-        </p:txBody>
-      </p:sp>
-      <p:sp>
-        <p:nvSpPr>
-          <p:cNvPr id="405" name="" descr="{&quot;isTemplate&quot;:true,&quot;type&quot;:&quot;text&quot;}"/>
-          <p:cNvSpPr txBox="1"/>
-          <p:nvPr/>
-        </p:nvSpPr>
-        <p:spPr>
-          <a:xfrm rot="0" flipH="0" flipV="0">
-            <a:off x="2524125" y="2667000"/>
-            <a:ext cx="2628900" cy="1257300"/>
-          </a:xfrm>
-          <a:prstGeom prst="rect"/>
-        </p:spPr>
-        <p:txBody>
-          <a:bodyPr wrap="none" lIns="0" tIns="0" rIns="0" bIns="0"/>
-          <a:p>
-            <a:pPr>
-              <a:lnSpc>
-                <a:spcPct val="100000"/>
-              </a:lnSpc>
-            </a:pPr>
-            <a:r>
-              <a:rPr lang="zh-CN" sz="3450" b="1">
-                <a:solidFill>
-                  <a:srgbClr val="FBFCFA"/>
-                </a:solidFill>
-                <a:latin typeface="Microsoft YaHei"/>
-                <a:ea typeface="Microsoft YaHei"/>
-              </a:rPr>
-              <a:t>技术构建过程</a:t>
-            </a:r>
-            <a:endParaRPr/>
-          </a:p>
-        </p:txBody>
-      </p:sp>
-      <p:sp>
-        <p:nvSpPr>
-          <p:cNvPr id="406" name=""/>
+                <a:latin typeface="Microsoft YaHei"/>
+                <a:ea typeface="Microsoft YaHei"/>
+              </a:rPr>
+              <a:t>TECHNOLOGY CONSTRUCTION</a:t>
+            </a:r>
+            <a:endParaRPr/>
+          </a:p>
+        </p:txBody>
+      </p:sp>
+      <p:sp>
+        <p:nvSpPr>
+          <p:cNvPr id="423" name=""/>
           <p:cNvSpPr/>
           <p:nvPr/>
         </p:nvSpPr>
         <p:spPr>
           <a:xfrm rot="0" flipH="0" flipV="0">
-            <a:off x="914400" y="4191000"/>
-            <a:ext cx="685800" cy="28575"/>
+            <a:off x="914400" y="4400550"/>
+            <a:ext cx="762000" cy="28575"/>
           </a:xfrm>
           <a:prstGeom prst="rect">
             <a:avLst/>
@@ -18658,19 +19139,49 @@
       </p:sp>
       <p:sp>
         <p:nvSpPr>
-          <p:cNvPr id="407" name="" descr="{&quot;isTemplate&quot;:true,&quot;type&quot;:&quot;text&quot;}"/>
-          <p:cNvSpPr txBox="1"/>
-          <p:nvPr/>
-        </p:nvSpPr>
-        <p:spPr>
-          <a:xfrm rot="0" flipH="0" flipV="0">
-            <a:off x="914400" y="4410075"/>
-            <a:ext cx="10363200" cy="190500"/>
-          </a:xfrm>
-          <a:prstGeom prst="rect"/>
-        </p:spPr>
-        <p:txBody>
-          <a:bodyPr wrap="none" lIns="0" tIns="0" rIns="0" bIns="0"/>
+          <p:cNvPr id="424" name=""/>
+          <p:cNvSpPr/>
+          <p:nvPr/>
+        </p:nvSpPr>
+        <p:spPr>
+          <a:xfrm rot="0" flipH="0" flipV="0">
+            <a:off x="914400" y="4657725"/>
+            <a:ext cx="1095375" cy="342900"/>
+          </a:xfrm>
+          <a:prstGeom prst="roundRect">
+            <a:avLst>
+              <a:gd name="adj" fmla="val 61111"/>
+            </a:avLst>
+          </a:prstGeom>
+          <a:ln w="12700">
+            <a:solidFill>
+              <a:srgbClr val="BD9B56">
+                <a:alpha val="65000"/>
+              </a:srgbClr>
+            </a:solidFill>
+            <a:prstDash val="solid"/>
+          </a:ln>
+        </p:spPr>
+        <p:txBody>
+          <a:bodyPr/>
+          <a:p/>
+        </p:txBody>
+      </p:sp>
+      <p:sp>
+        <p:nvSpPr>
+          <p:cNvPr id="425" name="" descr="{&quot;isTemplate&quot;:true,&quot;type&quot;:&quot;text&quot;}"/>
+          <p:cNvSpPr txBox="1"/>
+          <p:nvPr/>
+        </p:nvSpPr>
+        <p:spPr>
+          <a:xfrm rot="0" flipH="0" flipV="0">
+            <a:off x="914400" y="4657725"/>
+            <a:ext cx="1095375" cy="342900"/>
+          </a:xfrm>
+          <a:prstGeom prst="rect"/>
+        </p:spPr>
+        <p:txBody>
+          <a:bodyPr wrap="none" lIns="142875" tIns="64294" rIns="142875" bIns="64294"/>
           <a:p>
             <a:pPr>
               <a:lnSpc>
@@ -18678,82 +19189,247 @@
               </a:lnSpc>
             </a:pPr>
             <a:r>
-              <a:rPr lang="zh-CN" sz="1200" spc="-9223372036854775808">
+              <a:rPr lang="zh-CN" sz="1125">
                 <a:solidFill>
                   <a:srgbClr val="FBFCFA">
-                    <a:alpha val="72000"/>
+                    <a:alpha val="88000"/>
                   </a:srgbClr>
                 </a:solidFill>
                 <a:latin typeface="Microsoft YaHei"/>
                 <a:ea typeface="Microsoft YaHei"/>
               </a:rPr>
-              <a:t>数据库</a:t>
-            </a:r>
-            <a:r>
-              <a:rPr lang="en-US" sz="1200" spc="-9223372036854775808">
+              <a:t>数据库设计</a:t>
+            </a:r>
+            <a:endParaRPr/>
+          </a:p>
+        </p:txBody>
+      </p:sp>
+      <p:sp>
+        <p:nvSpPr>
+          <p:cNvPr id="426" name=""/>
+          <p:cNvSpPr/>
+          <p:nvPr/>
+        </p:nvSpPr>
+        <p:spPr>
+          <a:xfrm rot="0" flipH="0" flipV="0">
+            <a:off x="2143125" y="4657725"/>
+            <a:ext cx="1438275" cy="342900"/>
+          </a:xfrm>
+          <a:prstGeom prst="roundRect">
+            <a:avLst>
+              <a:gd name="adj" fmla="val 61111"/>
+            </a:avLst>
+          </a:prstGeom>
+          <a:ln w="12700">
+            <a:solidFill>
+              <a:srgbClr val="BD9B56">
+                <a:alpha val="65000"/>
+              </a:srgbClr>
+            </a:solidFill>
+            <a:prstDash val="solid"/>
+          </a:ln>
+        </p:spPr>
+        <p:txBody>
+          <a:bodyPr/>
+          <a:p/>
+        </p:txBody>
+      </p:sp>
+      <p:sp>
+        <p:nvSpPr>
+          <p:cNvPr id="427" name="" descr="{&quot;isTemplate&quot;:true,&quot;type&quot;:&quot;text&quot;}"/>
+          <p:cNvSpPr txBox="1"/>
+          <p:nvPr/>
+        </p:nvSpPr>
+        <p:spPr>
+          <a:xfrm rot="0" flipH="0" flipV="0">
+            <a:off x="2143125" y="4657725"/>
+            <a:ext cx="1438275" cy="342900"/>
+          </a:xfrm>
+          <a:prstGeom prst="rect"/>
+        </p:spPr>
+        <p:txBody>
+          <a:bodyPr wrap="none" lIns="142875" tIns="64294" rIns="142875" bIns="64294"/>
+          <a:p>
+            <a:pPr>
+              <a:lnSpc>
+                <a:spcPct val="100000"/>
+              </a:lnSpc>
+            </a:pPr>
+            <a:r>
+              <a:rPr lang="zh-CN" sz="1125">
                 <a:solidFill>
                   <a:srgbClr val="FBFCFA">
-                    <a:alpha val="72000"/>
+                    <a:alpha val="88000"/>
                   </a:srgbClr>
                 </a:solidFill>
                 <a:latin typeface="Microsoft YaHei"/>
                 <a:ea typeface="Microsoft YaHei"/>
               </a:rPr>
-              <a:t> → </a:t>
-            </a:r>
-            <a:r>
-              <a:rPr lang="zh-CN" sz="1200" spc="-9223372036854775808">
+              <a:t>后端</a:t>
+            </a:r>
+            <a:r>
+              <a:rPr lang="en-US" sz="1125">
                 <a:solidFill>
                   <a:srgbClr val="FBFCFA">
-                    <a:alpha val="72000"/>
+                    <a:alpha val="88000"/>
                   </a:srgbClr>
                 </a:solidFill>
                 <a:latin typeface="Microsoft YaHei"/>
                 <a:ea typeface="Microsoft YaHei"/>
               </a:rPr>
-              <a:t>后端</a:t>
-            </a:r>
-            <a:r>
-              <a:rPr lang="en-US" sz="1200" spc="-9223372036854775808">
+              <a:t> + </a:t>
+            </a:r>
+            <a:r>
+              <a:rPr lang="zh-CN" sz="1125">
                 <a:solidFill>
                   <a:srgbClr val="FBFCFA">
-                    <a:alpha val="72000"/>
+                    <a:alpha val="88000"/>
                   </a:srgbClr>
                 </a:solidFill>
                 <a:latin typeface="Microsoft YaHei"/>
                 <a:ea typeface="Microsoft YaHei"/>
               </a:rPr>
-              <a:t> → </a:t>
-            </a:r>
-            <a:r>
-              <a:rPr lang="zh-CN" sz="1200" spc="-9223372036854775808">
+              <a:t>前端三端</a:t>
+            </a:r>
+            <a:endParaRPr/>
+          </a:p>
+        </p:txBody>
+      </p:sp>
+      <p:sp>
+        <p:nvSpPr>
+          <p:cNvPr id="428" name=""/>
+          <p:cNvSpPr/>
+          <p:nvPr/>
+        </p:nvSpPr>
+        <p:spPr>
+          <a:xfrm rot="0" flipH="0" flipV="0">
+            <a:off x="3714750" y="4657725"/>
+            <a:ext cx="981075" cy="342900"/>
+          </a:xfrm>
+          <a:prstGeom prst="roundRect">
+            <a:avLst>
+              <a:gd name="adj" fmla="val 61111"/>
+            </a:avLst>
+          </a:prstGeom>
+          <a:ln w="12700">
+            <a:solidFill>
+              <a:srgbClr val="BD9B56">
+                <a:alpha val="65000"/>
+              </a:srgbClr>
+            </a:solidFill>
+            <a:prstDash val="solid"/>
+          </a:ln>
+        </p:spPr>
+        <p:txBody>
+          <a:bodyPr/>
+          <a:p/>
+        </p:txBody>
+      </p:sp>
+      <p:sp>
+        <p:nvSpPr>
+          <p:cNvPr id="429" name="" descr="{&quot;isTemplate&quot;:true,&quot;type&quot;:&quot;text&quot;}"/>
+          <p:cNvSpPr txBox="1"/>
+          <p:nvPr/>
+        </p:nvSpPr>
+        <p:spPr>
+          <a:xfrm rot="0" flipH="0" flipV="0">
+            <a:off x="3714750" y="4657725"/>
+            <a:ext cx="981075" cy="342900"/>
+          </a:xfrm>
+          <a:prstGeom prst="rect"/>
+        </p:spPr>
+        <p:txBody>
+          <a:bodyPr wrap="none" lIns="142875" tIns="64294" rIns="142875" bIns="64294"/>
+          <a:p>
+            <a:pPr>
+              <a:lnSpc>
+                <a:spcPct val="100000"/>
+              </a:lnSpc>
+            </a:pPr>
+            <a:r>
+              <a:rPr lang="en-US" sz="1125">
                 <a:solidFill>
                   <a:srgbClr val="FBFCFA">
-                    <a:alpha val="72000"/>
+                    <a:alpha val="88000"/>
                   </a:srgbClr>
                 </a:solidFill>
                 <a:latin typeface="Microsoft YaHei"/>
                 <a:ea typeface="Microsoft YaHei"/>
               </a:rPr>
-              <a:t>前端</a:t>
-            </a:r>
-            <a:r>
-              <a:rPr lang="en-US" sz="1200" spc="-9223372036854775808">
+              <a:t>AI Agent</a:t>
+            </a:r>
+            <a:endParaRPr/>
+          </a:p>
+        </p:txBody>
+      </p:sp>
+      <p:sp>
+        <p:nvSpPr>
+          <p:cNvPr id="430" name=""/>
+          <p:cNvSpPr/>
+          <p:nvPr/>
+        </p:nvSpPr>
+        <p:spPr>
+          <a:xfrm rot="0" flipH="0" flipV="0">
+            <a:off x="4829175" y="4657725"/>
+            <a:ext cx="1152525" cy="342900"/>
+          </a:xfrm>
+          <a:prstGeom prst="roundRect">
+            <a:avLst>
+              <a:gd name="adj" fmla="val 61111"/>
+            </a:avLst>
+          </a:prstGeom>
+          <a:ln w="12700">
+            <a:solidFill>
+              <a:srgbClr val="BD9B56">
+                <a:alpha val="65000"/>
+              </a:srgbClr>
+            </a:solidFill>
+            <a:prstDash val="solid"/>
+          </a:ln>
+        </p:spPr>
+        <p:txBody>
+          <a:bodyPr/>
+          <a:p/>
+        </p:txBody>
+      </p:sp>
+      <p:sp>
+        <p:nvSpPr>
+          <p:cNvPr id="431" name="" descr="{&quot;isTemplate&quot;:true,&quot;type&quot;:&quot;text&quot;}"/>
+          <p:cNvSpPr txBox="1"/>
+          <p:nvPr/>
+        </p:nvSpPr>
+        <p:spPr>
+          <a:xfrm rot="0" flipH="0" flipV="0">
+            <a:off x="4829175" y="4657725"/>
+            <a:ext cx="1152525" cy="342900"/>
+          </a:xfrm>
+          <a:prstGeom prst="rect"/>
+        </p:spPr>
+        <p:txBody>
+          <a:bodyPr wrap="none" lIns="142875" tIns="64294" rIns="142875" bIns="64294"/>
+          <a:p>
+            <a:pPr>
+              <a:lnSpc>
+                <a:spcPct val="100000"/>
+              </a:lnSpc>
+            </a:pPr>
+            <a:r>
+              <a:rPr lang="en-US" sz="1125">
                 <a:solidFill>
                   <a:srgbClr val="FBFCFA">
-                    <a:alpha val="72000"/>
+                    <a:alpha val="88000"/>
                   </a:srgbClr>
                 </a:solidFill>
                 <a:latin typeface="Microsoft YaHei"/>
                 <a:ea typeface="Microsoft YaHei"/>
               </a:rPr>
-              <a:t> → AI Agent → RAG </a:t>
-            </a:r>
-            <a:r>
-              <a:rPr lang="zh-CN" sz="1200" spc="-9223372036854775808">
+              <a:t>RAG </a:t>
+            </a:r>
+            <a:r>
+              <a:rPr lang="zh-CN" sz="1125">
                 <a:solidFill>
                   <a:srgbClr val="FBFCFA">
-                    <a:alpha val="72000"/>
+                    <a:alpha val="88000"/>
                   </a:srgbClr>
                 </a:solidFill>
                 <a:latin typeface="Microsoft YaHei"/>
@@ -18767,14 +19443,14 @@
       </p:sp>
       <p:sp>
         <p:nvSpPr>
-          <p:cNvPr id="408" name="" descr="{&quot;isTemplate&quot;:true,&quot;type&quot;:&quot;text&quot;}"/>
-          <p:cNvSpPr txBox="1"/>
-          <p:nvPr/>
-        </p:nvSpPr>
-        <p:spPr>
-          <a:xfrm rot="0" flipH="0" flipV="0">
-            <a:off x="10877550" y="6305550"/>
-            <a:ext cx="400050" cy="152400"/>
+          <p:cNvPr id="432" name="" descr="{&quot;isTemplate&quot;:true,&quot;type&quot;:&quot;text&quot;}"/>
+          <p:cNvSpPr txBox="1"/>
+          <p:nvPr/>
+        </p:nvSpPr>
+        <p:spPr>
+          <a:xfrm rot="0" flipH="0" flipV="0">
+            <a:off x="10858500" y="6305550"/>
+            <a:ext cx="419100" cy="152400"/>
           </a:xfrm>
           <a:prstGeom prst="rect"/>
         </p:spPr>
@@ -18793,8 +19469,8 @@
                     <a:alpha val="40000"/>
                   </a:srgbClr>
                 </a:solidFill>
-                <a:latin typeface="Inter"/>
-                <a:ea typeface="Inter"/>
+                <a:latin typeface="Microsoft YaHei"/>
+                <a:ea typeface="Microsoft YaHei"/>
               </a:rPr>
               <a:t>07 / 19</a:t>
             </a:r>
@@ -18812,7 +19488,7 @@
   <p:cSld>
     <p:spTree>
       <p:nvGrpSpPr>
-        <p:cNvPr id="409" name="" descr="&lt;Slide style={{ width: '1280px', height: '720px', background: '#FBFCFA', position: 'relative', padding: '40px 64px', boxSizing: 'border-box', display: 'flex', flexDirection: 'column' }}&gt;&#13;&#10;  &lt;div style={{ flexShrink: 0 }}&gt;&#13;&#10;    &lt;div style={{ color: '#BD9B56', fontSize: 13, letterSpacing: '0.25em', marginBottom: 8 }}&gt;02 · 技术构建过程&lt;/div&gt;&#13;&#10;    &lt;h2 style={{ fontSize: 30, fontWeight: 'bold', color: '#172133', margin: 0, lineHeight: 1.3 }}&gt;技术架构：六层分离的 AI Native 系统&lt;/h2&gt;&#13;&#10;  &lt;/div&gt;&#13;&#10;  &lt;div style={{ flex: 1, display: 'flex', alignItems: 'center', gap: 32 }}&gt;&#13;&#10;    &lt;div style={{ flex: '0 0 620px', background: '#fff', borderRadius: 12, padding: '22px 24px', boxShadow: '0 6px 24px rgba(23,33,51,0.08)' }}&gt;&#13;&#10;      &lt;svg width=&quot;572&quot; height=&quot;470&quot; viewBox=&quot;0 0 572 470&quot;&gt;&#13;&#10;        &lt;defs&gt;&#13;&#10;          &lt;marker id=&quot;ar6&quot; viewBox=&quot;0 0 10 10&quot; refX=&quot;9&quot; refY=&quot;5&quot; markerWidth=&quot;6&quot; markerHeight=&quot;6&quot; orient=&quot;auto&quot;&gt;&#13;&#10;            &lt;path d=&quot;M0 0L10 5L0 10z&quot; fill=&quot;#22395E&quot; /&gt;&#13;&#10;          &lt;/marker&gt;&#13;&#10;        &lt;/defs&gt;&#13;&#10;        &lt;g fontFamily=&quot;Inter, sans-serif&quot;&gt;&#13;&#10;          &lt;rect x=&quot;36&quot; y=&quot;18&quot; width=&quot;500&quot; height=&quot;52&quot; rx=&quot;6&quot; fill=&quot;#F5F8F8&quot; stroke=&quot;#22395E&quot; strokeWidth=&quot;1.5&quot; /&gt;&#13;&#10;          &lt;text x=&quot;286&quot; y=&quot;49&quot; textAnchor=&quot;middle&quot; fontSize=&quot;14&quot; fontWeight=&quot;bold&quot; fill=&quot;#172133&quot;&gt;客户端 · 业主 / 物业 / 维修 三端&lt;/text&gt;&#13;&#10;          &lt;line x1=&quot;286&quot; y1=&quot;70&quot; x2=&quot;286&quot; y2=&quot;92&quot; stroke=&quot;#22395E&quot; strokeWidth=&quot;1.2&quot; markerEnd=&quot;url(#ar6)&quot; /&gt;&#13;&#10;          &lt;rect x=&quot;36&quot; y=&quot;96&quot; width=&quot;500&quot; height=&quot;48&quot; rx=&quot;6&quot; fill=&quot;#F5F8F8&quot; stroke=&quot;#22395E&quot; strokeWidth=&quot;1.5&quot; /&gt;&#13;&#10;          &lt;text x=&quot;286&quot; y=&quot;125&quot; textAnchor=&quot;middle&quot; fontSize=&quot;14&quot; fontWeight=&quot;bold&quot; fill=&quot;#172133&quot;&gt;API 网关 · FastAPI&lt;/text&gt;&#13;&#10;          &lt;line x1=&quot;286&quot; y1=&quot;144&quot; x2=&quot;286&quot; y2=&quot;166&quot; stroke=&quot;#22395E&quot; strokeWidth=&quot;1.2&quot; markerEnd=&quot;url(#ar6)&quot; /&gt;&#13;&#10;          &lt;rect x=&quot;36&quot; y=&quot;170&quot; width=&quot;500&quot; height=&quot;70&quot; rx=&quot;6&quot; fill=&quot;rgba(34,57,94,0.08)&quot; stroke=&quot;#22395E&quot; strokeWidth=&quot;2&quot; /&gt;&#13;&#10;          &lt;text x=&quot;64&quot; y=&quot;196&quot; fontSize=&quot;13&quot; fontWeight=&quot;bold&quot; fill=&quot;#BD9B56&quot;&gt;AI Agent 层&lt;/text&gt;&#13;&#10;          &lt;text x=&quot;286&quot; y=&quot;218&quot; textAnchor=&quot;middle&quot; fontSize=&quot;14&quot; fontWeight=&quot;bold&quot; fill=&quot;#172133&quot;&gt;Router Agent + 领域 Agent + 工具调用&lt;/text&gt;&#13;&#10;          &lt;line x1=&quot;286&quot; y1=&quot;240&quot; x2=&quot;286&quot; y2=&quot;262&quot; stroke=&quot;#22395E&quot; strokeWidth=&quot;1.2&quot; markerEnd=&quot;url(#ar6)&quot; /&gt;&#13;&#10;          &lt;rect x=&quot;36&quot; y=&quot;266&quot; width=&quot;500&quot; height=&quot;56&quot; rx=&quot;6&quot; fill=&quot;rgba(189,155,86,0.08)&quot; stroke=&quot;#BD9B56&quot; strokeWidth=&quot;1.5&quot; /&gt;&#13;&#10;          &lt;text x=&quot;64&quot; y=&quot;290&quot; fontSize=&quot;13&quot; fontWeight=&quot;bold&quot; fill=&quot;#BD9B56&quot;&gt;业务服务层&lt;/text&gt;&#13;&#10;          &lt;text x=&quot;286&quot; y=&quot;312&quot; textAnchor=&quot;middle&quot; fontSize=&quot;14&quot; fontWeight=&quot;bold&quot; fill=&quot;#172133&quot;&gt;工单 · 费用 · 巡检 · 通知 · 反馈 · 知识库&lt;/text&gt;&#13;&#10;          &lt;line x1=&quot;286&quot; y1=&quot;322&quot; x2=&quot;286&quot; y2=&quot;344&quot; stroke=&quot;#22395E&quot; strokeWidth=&quot;1.2&quot; markerEnd=&quot;url(#ar6)&quot; /&gt;&#13;&#10;          &lt;rect x=&quot;36&quot; y=&quot;348&quot; width=&quot;240&quot; height=&quot;60&quot; rx=&quot;6&quot; fill=&quot;#F5F8F8&quot; stroke=&quot;#22395E&quot; strokeWidth=&quot;1.5&quot; /&gt;&#13;&#10;          &lt;text x=&quot;156&quot; y=&quot;374&quot; textAnchor=&quot;middle&quot; fontSize=&quot;13&quot; fontWeight=&quot;bold&quot; fill=&quot;#BD9B56&quot;&gt;PostgreSQL + pgvector&lt;/text&gt;&#13;&#10;          &lt;text x=&quot;156&quot; y=&quot;394&quot; textAnchor=&quot;middle&quot; fontSize=&quot;11&quot; fill=&quot;#5F5E5A&quot;&gt;事务数据 + 向量检索&lt;/text&gt;&#13;&#10;          &lt;rect x=&quot;296&quot; y=&quot;348&quot; width=&quot;240&quot; height=&quot;60&quot; rx=&quot;6&quot; fill=&quot;#F5F8F8&quot; stroke=&quot;#22395E&quot; strokeWidth=&quot;1.5&quot; /&gt;&#13;&#10;          &lt;text x=&quot;416&quot; y=&quot;374&quot; textAnchor=&quot;middle&quot; fontSize=&quot;13&quot; fontWeight=&quot;bold&quot; fill=&quot;#BD9B56&quot;&gt;Redis + 智谱 GLM&lt;/text&gt;&#13;&#10;          &lt;text x=&quot;416&quot; y=&quot;394&quot; textAnchor=&quot;middle&quot; fontSize=&quot;11&quot; fill=&quot;#5F5E5A&quot;&gt;缓存 · LLM · embedding&lt;/text&gt;&#13;&#10;        &lt;/g&gt;&#13;&#10;      &lt;/svg&gt;&#13;&#10;    &lt;/div&gt;&#13;&#10;    &lt;div style={{ flex: 1, display: 'flex', flexDirection: 'column', gap: 18 }}&gt;&#13;&#10;      &lt;div&gt;&#13;&#10;        &lt;div style={{ fontSize: 14, color: '#BD9B56', fontWeight: 'bold', letterSpacing: '0.1em', marginBottom: 6 }}&gt;1.  Agent 与业务解耦&lt;/div&gt;&#13;&#10;        &lt;p style={{ fontSize: 14, color: '#5F5E5A', margin: 0, lineHeight: 1.65 }}&gt;AI Agent 只负责理解意图、编排工具，不直接操作数据库，严守 Agent → Tool → Service → Repository → Database 分层，杜绝 LLM 直连 SQL 的风险。&lt;/p&gt;&#13;&#10;      &lt;/div&gt;&#13;&#10;      &lt;div&gt;&#13;&#10;        &lt;div style={{ fontSize: 14, color: '#BD9B56', fontWeight: 'bold', letterSpacing: '0.1em', marginBottom: 6 }}&gt;2.  pgvector 一库双角色&lt;/div&gt;&#13;&#10;        &lt;p style={{ fontSize: 14, color: '#5F5E5A', margin: 0, lineHeight: 1.65 }}&gt;PostgreSQL 同时承载业务数据（工单、费用）和向量数据（知识切片），无需额外向量数据库，降低部署与运维复杂度。&lt;/p&gt;&#13;&#10;      &lt;/div&gt;&#13;&#10;      &lt;div&gt;&#13;&#10;        &lt;div style={{ fontSize: 14, color: '#BD9B56', fontWeight: 'bold', letterSpacing: '0.1em', marginBottom: 6 }}&gt;3.  可观测可评估&lt;/div&gt;&#13;&#10;        &lt;p style={{ fontSize: 14, color: '#5F5E5A', margin: 0, lineHeight: 1.65 }}&gt;每次 AI 对话的意图、工具调用、结果全程记录，可回放、可追踪，支撑后续的量化评估与持续迭代。&lt;/p&gt;&#13;&#10;      &lt;/div&gt;&#13;&#10;    &lt;/div&gt;&#13;&#10;  &lt;/div&gt;&#13;&#10;  &lt;div style={{ flexShrink: 0, height: 40, display: 'flex', alignItems: 'flex-end', justifyContent: 'space-between' }}&gt;&#13;&#10;    &lt;span style={{ color: '#BD9B56', fontSize: 12, letterSpacing: '0.1em' }}&gt;云溪花园 · 智慧社区&lt;/span&gt;&#13;&#10;    &lt;span style={{ color: '#a09b8c', fontSize: 12 }}&gt;8 / 19&lt;/span&gt;&#13;&#10;  &lt;/div&gt;&#13;&#10;&lt;/Slide&gt;"/>
+        <p:cNvPr id="433" name="" descr="&lt;Slide style={{ width: '1280px', height: '720px', background: '#FBFCFA', position: 'relative', padding: '40px 64px', boxSizing: 'border-box', display: 'flex', flexDirection: 'column' }}&gt;&#13;&#10;  &lt;div style={{ flexShrink: 0 }}&gt;&#13;&#10;    &lt;div style={{ color: '#BD9B56', fontSize: 13, letterSpacing: '0.25em', marginBottom: 8 }}&gt;02 · 技术构建过程&lt;/div&gt;&#13;&#10;    &lt;h2 style={{ fontSize: 30, fontWeight: 'bold', color: '#172133', margin: 0, lineHeight: 1.3 }}&gt;技术架构：六层分离的 AI Native 系统&lt;/h2&gt;&#13;&#10;  &lt;/div&gt;&#13;&#10;  &lt;div style={{ flex: 1, display: 'flex', alignItems: 'center', gap: 32 }}&gt;&#13;&#10;    &lt;div style={{ flex: '0 0 620px', background: '#fff', borderRadius: 12, padding: '22px 24px', boxShadow: '0 6px 24px rgba(23,33,51,0.08)' }}&gt;&#13;&#10;      &lt;svg width=&quot;572&quot; height=&quot;470&quot; viewBox=&quot;0 0 572 470&quot;&gt;&#13;&#10;        &lt;defs&gt;&#13;&#10;          &lt;marker id=&quot;ar6&quot; viewBox=&quot;0 0 10 10&quot; refX=&quot;9&quot; refY=&quot;5&quot; markerWidth=&quot;6&quot; markerHeight=&quot;6&quot; orient=&quot;auto&quot;&gt;&#13;&#10;            &lt;path d=&quot;M0 0L10 5L0 10z&quot; fill=&quot;#22395E&quot; /&gt;&#13;&#10;          &lt;/marker&gt;&#13;&#10;        &lt;/defs&gt;&#13;&#10;        &lt;g fontFamily=&quot;Inter, sans-serif&quot;&gt;&#13;&#10;          &lt;rect x=&quot;36&quot; y=&quot;18&quot; width=&quot;500&quot; height=&quot;52&quot; rx=&quot;6&quot; fill=&quot;#F5F8F8&quot; stroke=&quot;#22395E&quot; strokeWidth=&quot;1.5&quot; /&gt;&#13;&#10;          &lt;text x=&quot;286&quot; y=&quot;49&quot; textAnchor=&quot;middle&quot; fontSize=&quot;14&quot; fontWeight=&quot;bold&quot; fill=&quot;#172133&quot;&gt;客户端 · 业主 / 物业 / 维修 三端&lt;/text&gt;&#13;&#10;          &lt;line x1=&quot;286&quot; y1=&quot;70&quot; x2=&quot;286&quot; y2=&quot;92&quot; stroke=&quot;#22395E&quot; strokeWidth=&quot;1.2&quot; markerEnd=&quot;url(#ar6)&quot; /&gt;&#13;&#10;          &lt;rect x=&quot;36&quot; y=&quot;96&quot; width=&quot;500&quot; height=&quot;48&quot; rx=&quot;6&quot; fill=&quot;#F5F8F8&quot; stroke=&quot;#22395E&quot; strokeWidth=&quot;1.5&quot; /&gt;&#13;&#10;          &lt;text x=&quot;286&quot; y=&quot;125&quot; textAnchor=&quot;middle&quot; fontSize=&quot;14&quot; fontWeight=&quot;bold&quot; fill=&quot;#172133&quot;&gt;API 网关 · FastAPI&lt;/text&gt;&#13;&#10;          &lt;line x1=&quot;286&quot; y1=&quot;144&quot; x2=&quot;286&quot; y2=&quot;166&quot; stroke=&quot;#22395E&quot; strokeWidth=&quot;1.2&quot; markerEnd=&quot;url(#ar6)&quot; /&gt;&#13;&#10;          &lt;rect x=&quot;36&quot; y=&quot;170&quot; width=&quot;500&quot; height=&quot;70&quot; rx=&quot;6&quot; fill=&quot;rgba(34,57,94,0.08)&quot; stroke=&quot;#22395E&quot; strokeWidth=&quot;2&quot; /&gt;&#13;&#10;          &lt;text x=&quot;64&quot; y=&quot;196&quot; fontSize=&quot;13&quot; fontWeight=&quot;bold&quot; fill=&quot;#BD9B56&quot;&gt;AI Agent 层&lt;/text&gt;&#13;&#10;          &lt;text x=&quot;286&quot; y=&quot;218&quot; textAnchor=&quot;middle&quot; fontSize=&quot;14&quot; fontWeight=&quot;bold&quot; fill=&quot;#172133&quot;&gt;Router Agent + 领域 Agent + 工具调用&lt;/text&gt;&#13;&#10;          &lt;line x1=&quot;286&quot; y1=&quot;240&quot; x2=&quot;286&quot; y2=&quot;262&quot; stroke=&quot;#22395E&quot; strokeWidth=&quot;1.2&quot; markerEnd=&quot;url(#ar6)&quot; /&gt;&#13;&#10;          &lt;rect x=&quot;36&quot; y=&quot;266&quot; width=&quot;500&quot; height=&quot;56&quot; rx=&quot;6&quot; fill=&quot;rgba(189,155,86,0.08)&quot; stroke=&quot;#BD9B56&quot; strokeWidth=&quot;1.5&quot; /&gt;&#13;&#10;          &lt;text x=&quot;64&quot; y=&quot;290&quot; fontSize=&quot;13&quot; fontWeight=&quot;bold&quot; fill=&quot;#BD9B56&quot;&gt;业务服务层&lt;/text&gt;&#13;&#10;          &lt;text x=&quot;286&quot; y=&quot;312&quot; textAnchor=&quot;middle&quot; fontSize=&quot;14&quot; fontWeight=&quot;bold&quot; fill=&quot;#172133&quot;&gt;工单 · 费用 · 巡检 · 通知 · 反馈 · 知识库&lt;/text&gt;&#13;&#10;          &lt;line x1=&quot;286&quot; y1=&quot;322&quot; x2=&quot;286&quot; y2=&quot;344&quot; stroke=&quot;#22395E&quot; strokeWidth=&quot;1.2&quot; markerEnd=&quot;url(#ar6)&quot; /&gt;&#13;&#10;          &lt;rect x=&quot;36&quot; y=&quot;348&quot; width=&quot;240&quot; height=&quot;60&quot; rx=&quot;6&quot; fill=&quot;#F5F8F8&quot; stroke=&quot;#22395E&quot; strokeWidth=&quot;1.5&quot; /&gt;&#13;&#10;          &lt;text x=&quot;156&quot; y=&quot;374&quot; textAnchor=&quot;middle&quot; fontSize=&quot;13&quot; fontWeight=&quot;bold&quot; fill=&quot;#BD9B56&quot;&gt;PostgreSQL + pgvector&lt;/text&gt;&#13;&#10;          &lt;text x=&quot;156&quot; y=&quot;394&quot; textAnchor=&quot;middle&quot; fontSize=&quot;11&quot; fill=&quot;#5F5E5A&quot;&gt;事务数据 + 向量检索&lt;/text&gt;&#13;&#10;          &lt;rect x=&quot;296&quot; y=&quot;348&quot; width=&quot;240&quot; height=&quot;60&quot; rx=&quot;6&quot; fill=&quot;#F5F8F8&quot; stroke=&quot;#22395E&quot; strokeWidth=&quot;1.5&quot; /&gt;&#13;&#10;          &lt;text x=&quot;416&quot; y=&quot;374&quot; textAnchor=&quot;middle&quot; fontSize=&quot;13&quot; fontWeight=&quot;bold&quot; fill=&quot;#BD9B56&quot;&gt;Redis + 智谱 GLM&lt;/text&gt;&#13;&#10;          &lt;text x=&quot;416&quot; y=&quot;394&quot; textAnchor=&quot;middle&quot; fontSize=&quot;11&quot; fill=&quot;#5F5E5A&quot;&gt;缓存 · LLM · embedding&lt;/text&gt;&#13;&#10;        &lt;/g&gt;&#13;&#10;      &lt;/svg&gt;&#13;&#10;    &lt;/div&gt;&#13;&#10;    &lt;div style={{ flex: 1, display: 'flex', flexDirection: 'column', gap: 18 }}&gt;&#13;&#10;      &lt;div&gt;&#13;&#10;        &lt;div style={{ fontSize: 14, color: '#BD9B56', fontWeight: 'bold', letterSpacing: '0.1em', marginBottom: 6 }}&gt;1.  Agent 与业务解耦&lt;/div&gt;&#13;&#10;        &lt;p style={{ fontSize: 14, color: '#5F5E5A', margin: 0, lineHeight: 1.65 }}&gt;AI Agent 只负责理解意图、编排工具，不直接操作数据库，严守 Agent → Tool → Service → Repository → Database 分层，杜绝 LLM 直连 SQL 的风险。&lt;/p&gt;&#13;&#10;      &lt;/div&gt;&#13;&#10;      &lt;div&gt;&#13;&#10;        &lt;div style={{ fontSize: 14, color: '#BD9B56', fontWeight: 'bold', letterSpacing: '0.1em', marginBottom: 6 }}&gt;2.  pgvector 一库双角色&lt;/div&gt;&#13;&#10;        &lt;p style={{ fontSize: 14, color: '#5F5E5A', margin: 0, lineHeight: 1.65 }}&gt;PostgreSQL 同时承载业务数据（工单、费用）和向量数据（知识切片），无需额外向量数据库，降低部署与运维复杂度。&lt;/p&gt;&#13;&#10;      &lt;/div&gt;&#13;&#10;      &lt;div&gt;&#13;&#10;        &lt;div style={{ fontSize: 14, color: '#BD9B56', fontWeight: 'bold', letterSpacing: '0.1em', marginBottom: 6 }}&gt;3.  可观测可评估&lt;/div&gt;&#13;&#10;        &lt;p style={{ fontSize: 14, color: '#5F5E5A', margin: 0, lineHeight: 1.65 }}&gt;每次 AI 对话的意图、工具调用、结果全程记录，可回放、可追踪，支撑后续的量化评估与持续迭代。&lt;/p&gt;&#13;&#10;      &lt;/div&gt;&#13;&#10;    &lt;/div&gt;&#13;&#10;  &lt;/div&gt;&#13;&#10;  &lt;div style={{ flexShrink: 0, height: 40, display: 'flex', alignItems: 'flex-end', justifyContent: 'space-between' }}&gt;&#13;&#10;    &lt;span style={{ color: '#BD9B56', fontSize: 12, letterSpacing: '0.1em' }}&gt;云溪花园 · 智慧社区&lt;/span&gt;&#13;&#10;    &lt;span style={{ color: '#a09b8c', fontSize: 12 }}&gt;8 / 19&lt;/span&gt;&#13;&#10;  &lt;/div&gt;&#13;&#10;&lt;/Slide&gt;"/>
         <p:cNvGrpSpPr/>
         <p:nvPr/>
       </p:nvGrpSpPr>
@@ -18826,7 +19502,7 @@
       </p:grpSpPr>
       <p:sp>
         <p:nvSpPr>
-          <p:cNvPr id="410" name=""/>
+          <p:cNvPr id="434" name=""/>
           <p:cNvSpPr/>
           <p:nvPr/>
         </p:nvSpPr>
@@ -18850,7 +19526,7 @@
       </p:sp>
       <p:sp>
         <p:nvSpPr>
-          <p:cNvPr id="411" name="" descr="{&quot;isTemplate&quot;:true,&quot;type&quot;:&quot;text&quot;}"/>
+          <p:cNvPr id="435" name="" descr="{&quot;isTemplate&quot;:true,&quot;type&quot;:&quot;text&quot;}"/>
           <p:cNvSpPr txBox="1"/>
           <p:nvPr/>
         </p:nvSpPr>
@@ -18895,7 +19571,7 @@
       </p:sp>
       <p:sp>
         <p:nvSpPr>
-          <p:cNvPr id="412" name="" descr="{&quot;isTemplate&quot;:true,&quot;type&quot;:&quot;text&quot;}"/>
+          <p:cNvPr id="436" name="" descr="{&quot;isTemplate&quot;:true,&quot;type&quot;:&quot;text&quot;}"/>
           <p:cNvSpPr txBox="1"/>
           <p:nvPr/>
         </p:nvSpPr>
@@ -18950,7 +19626,7 @@
       </p:sp>
       <p:sp>
         <p:nvSpPr>
-          <p:cNvPr id="413" name=""/>
+          <p:cNvPr id="437" name=""/>
           <p:cNvSpPr/>
           <p:nvPr/>
         </p:nvSpPr>
@@ -18983,7 +19659,7 @@
       </p:sp>
       <p:pic>
         <p:nvPicPr>
-          <p:cNvPr id="414" name=""/>
+          <p:cNvPr id="438" name=""/>
           <p:cNvPicPr>
             <a:picLocks noChangeAspect="1"/>
           </p:cNvPicPr>
@@ -19014,7 +19690,7 @@
       </p:pic>
       <p:sp>
         <p:nvSpPr>
-          <p:cNvPr id="415" name="" descr="{&quot;isTemplate&quot;:true,&quot;type&quot;:&quot;text&quot;}"/>
+          <p:cNvPr id="439" name="" descr="{&quot;isTemplate&quot;:true,&quot;type&quot;:&quot;text&quot;}"/>
           <p:cNvSpPr txBox="1"/>
           <p:nvPr/>
         </p:nvSpPr>
@@ -19059,7 +19735,7 @@
       </p:sp>
       <p:sp>
         <p:nvSpPr>
-          <p:cNvPr id="416" name="" descr="{&quot;isTemplate&quot;:true,&quot;type&quot;:&quot;text&quot;}"/>
+          <p:cNvPr id="440" name="" descr="{&quot;isTemplate&quot;:true,&quot;type&quot;:&quot;text&quot;}"/>
           <p:cNvSpPr txBox="1"/>
           <p:nvPr/>
         </p:nvSpPr>
@@ -19166,7 +19842,7 @@
       </p:sp>
       <p:sp>
         <p:nvSpPr>
-          <p:cNvPr id="417" name="" descr="{&quot;isTemplate&quot;:true,&quot;type&quot;:&quot;text&quot;}"/>
+          <p:cNvPr id="441" name="" descr="{&quot;isTemplate&quot;:true,&quot;type&quot;:&quot;text&quot;}"/>
           <p:cNvSpPr txBox="1"/>
           <p:nvPr/>
         </p:nvSpPr>
@@ -19211,7 +19887,7 @@
       </p:sp>
       <p:sp>
         <p:nvSpPr>
-          <p:cNvPr id="418" name="" descr="{&quot;isTemplate&quot;:true,&quot;type&quot;:&quot;text&quot;}"/>
+          <p:cNvPr id="442" name="" descr="{&quot;isTemplate&quot;:true,&quot;type&quot;:&quot;text&quot;}"/>
           <p:cNvSpPr txBox="1"/>
           <p:nvPr/>
         </p:nvSpPr>
@@ -19258,7 +19934,7 @@
       </p:sp>
       <p:sp>
         <p:nvSpPr>
-          <p:cNvPr id="419" name="" descr="{&quot;isTemplate&quot;:true,&quot;type&quot;:&quot;text&quot;}"/>
+          <p:cNvPr id="443" name="" descr="{&quot;isTemplate&quot;:true,&quot;type&quot;:&quot;text&quot;}"/>
           <p:cNvSpPr txBox="1"/>
           <p:nvPr/>
         </p:nvSpPr>
@@ -19303,7 +19979,7 @@
       </p:sp>
       <p:sp>
         <p:nvSpPr>
-          <p:cNvPr id="420" name="" descr="{&quot;isTemplate&quot;:true,&quot;type&quot;:&quot;text&quot;}"/>
+          <p:cNvPr id="444" name="" descr="{&quot;isTemplate&quot;:true,&quot;type&quot;:&quot;text&quot;}"/>
           <p:cNvSpPr txBox="1"/>
           <p:nvPr/>
         </p:nvSpPr>
@@ -19360,7 +20036,7 @@
       </p:sp>
       <p:sp>
         <p:nvSpPr>
-          <p:cNvPr id="421" name="" descr="{&quot;isTemplate&quot;:true,&quot;type&quot;:&quot;text&quot;}"/>
+          <p:cNvPr id="445" name="" descr="{&quot;isTemplate&quot;:true,&quot;type&quot;:&quot;text&quot;}"/>
           <p:cNvSpPr txBox="1"/>
           <p:nvPr/>
         </p:nvSpPr>
@@ -19415,7 +20091,7 @@
       </p:sp>
       <p:sp>
         <p:nvSpPr>
-          <p:cNvPr id="422" name="" descr="{&quot;isTemplate&quot;:true,&quot;type&quot;:&quot;text&quot;}"/>
+          <p:cNvPr id="446" name="" descr="{&quot;isTemplate&quot;:true,&quot;type&quot;:&quot;text&quot;}"/>
           <p:cNvSpPr txBox="1"/>
           <p:nvPr/>
         </p:nvSpPr>
@@ -19458,7 +20134,7 @@
   <p:cSld>
     <p:spTree>
       <p:nvGrpSpPr>
-        <p:cNvPr id="423" name="" descr="&lt;Slide style={{ width: '1280px', height: '720px', background: '#FBFCFA', position: 'relative', padding: '32px 64px', boxSizing: 'border-box', display: 'flex', flexDirection: 'column' }}&gt;&#13;&#10;  &lt;div style={{ flexShrink: 0 }}&gt;&#13;&#10;    &lt;div style={{ color: '#BD9B56', fontSize: 13, letterSpacing: '0.25em', marginBottom: 6 }}&gt;02 · 技术构建过程&lt;/div&gt;&#13;&#10;    &lt;h2 style={{ fontSize: 30, fontWeight: 'bold', color: '#172133', margin: 0, lineHeight: 1.3 }}&gt;数据库设计：15+ 张表承载整个社区&lt;/h2&gt;&#13;&#10;    &lt;div style={{ fontSize: 14, color: '#6b7075', marginTop: 6 }}&gt;数据库是系统地基，通过外键建立完整 ER 关系，覆盖社区到知识库的全部实体&lt;/div&gt;&#13;&#10;  &lt;/div&gt;&#13;&#10;  &lt;div style={{ flex: 1, display: 'flex', alignItems: 'center', minHeight: 0, gap: 28 }}&gt;&#13;&#10;    &lt;div style={{ flex: '0 0 320px', background: 'linear-gradient(135deg, #172133 0%, #22395E 100%)', borderRadius: 12, padding: '24px 24px', color: '#FBFCFA' }}&gt;&#13;&#10;      &lt;div style={{ color: '#BD9B56', fontSize: 12, letterSpacing: '0.25em', marginBottom: 12 }}&gt;CORE ENTITIES&lt;/div&gt;&#13;&#10;      &lt;div style={{ fontSize: 14, color: 'rgba(251,252,250,0.9)', lineHeight: 1.9 }}&gt;&#13;&#10;        community 社区&lt;br/&gt;&#13;&#10;        building 楼栋（8）&lt;br/&gt;&#13;&#10;        house 房屋（1664）&lt;br/&gt;&#13;&#10;        user 用户（275）&lt;br/&gt;&#13;&#10;        house_binding 房屋绑定&lt;br/&gt;&#13;&#10;        worker 物业人员（75）&lt;br/&gt;&#13;&#10;        repair_order 工单&lt;br/&gt;&#13;&#10;        fee_bill 账单（746）&lt;br/&gt;&#13;&#10;        notice 公告（24）&lt;br/&gt;&#13;&#10;        conversation / message&lt;br/&gt;&#13;&#10;        agent_trace 追踪&lt;br/&gt;&#13;&#10;        &lt;span style={{ color: '#BD9B56' }}&gt;knowledge_document / chunk&lt;/span&gt;&#13;&#10;      &lt;/div&gt;&#13;&#10;    &lt;/div&gt;&#13;&#10;    &lt;div style={{ flex: 1, background: '#fff', borderRadius: 12, padding: '20px 22px', boxShadow: '0 6px 24px rgba(23,33,51,0.08)' }}&gt;&#13;&#10;      &lt;svg width=&quot;560&quot; height=&quot;470&quot; viewBox=&quot;0 0 560 470&quot;&gt;&#13;&#10;        &lt;g fontFamily=&quot;Inter, sans-serif&quot;&gt;&#13;&#10;          &lt;rect x=&quot;14&quot; y=&quot;14&quot; width=&quot;150&quot; height=&quot;50&quot; rx=&quot;6&quot; fill=&quot;rgba(34,57,94,0.08)&quot; stroke=&quot;#22395E&quot; strokeWidth=&quot;1.5&quot; /&gt;&#13;&#10;          &lt;text x=&quot;89&quot; y=&quot;44&quot; textAnchor=&quot;middle&quot; fontSize=&quot;14&quot; fontWeight=&quot;bold&quot; fill=&quot;#172133&quot;&gt;community&lt;/text&gt;&#13;&#10;          &lt;line x1=&quot;164&quot; y1=&quot;39&quot; x2=&quot;206&quot; y2=&quot;39&quot; stroke=&quot;#BD9B56&quot; strokeWidth=&quot;1.5&quot; /&gt;&#13;&#10;          &lt;rect x=&quot;210&quot; y=&quot;14&quot; width=&quot;150&quot; height=&quot;50&quot; rx=&quot;6&quot; fill=&quot;rgba(34,57,94,0.08)&quot; stroke=&quot;#22395E&quot; strokeWidth=&quot;1.5&quot; /&gt;&#13;&#10;          &lt;text x=&quot;285&quot; y=&quot;44&quot; textAnchor=&quot;middle&quot; fontSize=&quot;14&quot; fontWeight=&quot;bold&quot; fill=&quot;#172133&quot;&gt;building ×8&lt;/text&gt;&#13;&#10;          &lt;line x1=&quot;360&quot; y1=&quot;39&quot; x2=&quot;402&quot; y2=&quot;39&quot; stroke=&quot;#BD9B56&quot; strokeWidth=&quot;1.5&quot; /&gt;&#13;&#10;          &lt;rect x=&quot;406&quot; y=&quot;14&quot; width=&quot;150&quot; height=&quot;50&quot; rx=&quot;6&quot; fill=&quot;rgba(34,57,94,0.08)&quot; stroke=&quot;#22395E&quot; strokeWidth=&quot;1.5&quot; /&gt;&#13;&#10;          &lt;text x=&quot;481&quot; y=&quot;44&quot; textAnchor=&quot;middle&quot; fontSize=&quot;14&quot; fontWeight=&quot;bold&quot; fill=&quot;#172133&quot;&gt;house ×1664&lt;/text&gt;&#13;&#10;          &lt;line x1=&quot;285&quot; y1=&quot;64&quot; x2=&quot;285&quot; y2=&quot;104&quot; stroke=&quot;#BD9B56&quot; strokeWidth=&quot;1.5&quot; /&gt;&#13;&#10;          &lt;rect x=&quot;210&quot; y=&quot;108&quot; width=&quot;150&quot; height=&quot;50&quot; rx=&quot;6&quot; fill=&quot;rgba(189,155,86,0.10)&quot; stroke=&quot;#BD9B56&quot; strokeWidth=&quot;1.5&quot; /&gt;&#13;&#10;          &lt;text x=&quot;285&quot; y=&quot;138&quot; textAnchor=&quot;middle&quot; fontSize=&quot;14&quot; fontWeight=&quot;bold&quot; fill=&quot;#172133&quot;&gt;user ×275&lt;/text&gt;&#13;&#10;          &lt;line x1=&quot;210&quot; y1=&quot;133&quot; x2=&quot;164&quot; y2=&quot;133&quot; stroke=&quot;#BD9B56&quot; strokeWidth=&quot;1.5&quot; /&gt;&#13;&#10;          &lt;rect x=&quot;14&quot; y=&quot;108&quot; width=&quot;150&quot; height=&quot;50&quot; rx=&quot;6&quot; fill=&quot;rgba(189,155,86,0.10)&quot; stroke=&quot;#BD9B56&quot; strokeWidth=&quot;1.5&quot; /&gt;&#13;&#10;          &lt;text x=&quot;89&quot; y=&quot;138&quot; textAnchor=&quot;middle&quot; fontSize=&quot;14&quot; fontWeight=&quot;bold&quot; fill=&quot;#172133&quot;&gt;house_binding&lt;/text&gt;&#13;&#10;          &lt;line x1=&quot;285&quot; y1=&quot;158&quot; x2=&quot;285&quot; y2=&quot;198&quot; stroke=&quot;#BD9B56&quot; strokeWidth=&quot;1.5&quot; /&gt;&#13;&#10;          &lt;rect x=&quot;210&quot; y=&quot;202&quot; width=&quot;150&quot; height=&quot;50&quot; rx=&quot;6&quot; fill=&quot;rgba(34,57,94,0.08)&quot; stroke=&quot;#22395E&quot; strokeWidth=&quot;1.5&quot; /&gt;&#13;&#10;          &lt;text x=&quot;285&quot; y=&quot;232&quot; textAnchor=&quot;middle&quot; fontSize=&quot;14&quot; fontWeight=&quot;bold&quot; fill=&quot;#172133&quot;&gt;worker ×75&lt;/text&gt;&#13;&#10;          &lt;line x1=&quot;285&quot; y1=&quot;252&quot; x2=&quot;285&quot; y2=&quot;292&quot; stroke=&quot;#BD9B56&quot; strokeWidth=&quot;1.5&quot; /&gt;&#13;&#10;          &lt;rect x=&quot;160&quot; y=&quot;296&quot; width=&quot;130&quot; height=&quot;50&quot; rx=&quot;6&quot; fill=&quot;rgba(34,57,94,0.08)&quot; stroke=&quot;#22395E&quot; strokeWidth=&quot;1.5&quot; /&gt;&#13;&#10;          &lt;text x=&quot;225&quot; y=&quot;326&quot; textAnchor=&quot;middle&quot; fontSize=&quot;13&quot; fontWeight=&quot;bold&quot; fill=&quot;#172133&quot;&gt;repair_order&lt;/text&gt;&#13;&#10;          &lt;rect x=&quot;306&quot; y=&quot;296&quot; width=&quot;130&quot; height=&quot;50&quot; rx=&quot;6&quot; fill=&quot;rgba(34,57,94,0.08)&quot; stroke=&quot;#22395E&quot; strokeWidth=&quot;1.5&quot; /&gt;&#13;&#10;          &lt;text x=&quot;371&quot; y=&quot;326&quot; textAnchor=&quot;middle&quot; fontSize=&quot;13&quot; fontWeight=&quot;bold&quot; fill=&quot;#172133&quot;&gt;fee_bill ×746&lt;/text&gt;&#13;&#10;          &lt;line x1=&quot;225&quot; y1=&quot;346&quot; x2=&quot;225&quot; y2=&quot;386&quot; stroke=&quot;#BD9B56&quot; strokeWidth=&quot;1.5&quot; /&gt;&#13;&#10;          &lt;rect x=&quot;160&quot; y=&quot;390&quot; width=&quot;130&quot; height=&quot;50&quot; rx=&quot;6&quot; fill=&quot;rgba(34,57,94,0.08)&quot; stroke=&quot;#22395E&quot; strokeWidth=&quot;1.5&quot; /&gt;&#13;&#10;          &lt;text x=&quot;225&quot; y=&quot;420&quot; textAnchor=&quot;middle&quot; fontSize=&quot;13&quot; fontWeight=&quot;bold&quot; fill=&quot;#172133&quot;&gt;notice ×24&lt;/text&gt;&#13;&#10;          &lt;rect x=&quot;306&quot; y=&quot;390&quot; width=&quot;130&quot; height=&quot;50&quot; rx=&quot;6&quot; fill=&quot;#172133&quot; stroke=&quot;#BD9B56&quot; strokeWidth=&quot;1.5&quot; /&gt;&#13;&#10;          &lt;text x=&quot;371&quot; y=&quot;416&quot; textAnchor=&quot;middle&quot; fontSize=&quot;12&quot; fontWeight=&quot;bold&quot; fill=&quot;#BD9B56&quot;&gt;knowledge&lt;/text&gt;&#13;&#10;          &lt;text x=&quot;371&quot; y=&quot;434&quot; textAnchor=&quot;middle&quot; fontSize=&quot;10&quot; fill=&quot;#FBFCFA&quot;&gt;document + chunk&lt;/text&gt;&#13;&#10;        &lt;/g&gt;&#13;&#10;      &lt;/svg&gt;&#13;&#10;    &lt;/div&gt;&#13;&#10;  &lt;/div&gt;&#13;&#10;  &lt;div style={{ flexShrink: 0, height: 40, display: 'flex', alignItems: 'flex-end', justifyContent: 'space-between' }}&gt;&#13;&#10;    &lt;span style={{ color: '#BD9B56', fontSize: 12, letterSpacing: '0.1em' }}&gt;云溪花园 · 智慧社区&lt;/span&gt;&#13;&#10;    &lt;span style={{ color: '#a09b8c', fontSize: 12 }}&gt;9 / 19&lt;/span&gt;&#13;&#10;  &lt;/div&gt;&#13;&#10;&lt;/Slide&gt;"/>
+        <p:cNvPr id="447" name="" descr="&lt;Slide style={{ width: '1280px', height: '720px', background: '#FBFCFA', position: 'relative', padding: '32px 64px', boxSizing: 'border-box', display: 'flex', flexDirection: 'column' }}&gt;&#13;&#10;  &lt;div style={{ flexShrink: 0 }}&gt;&#13;&#10;    &lt;div style={{ color: '#BD9B56', fontSize: 13, letterSpacing: '0.25em', marginBottom: 6 }}&gt;02 · 技术构建过程&lt;/div&gt;&#13;&#10;    &lt;h2 style={{ fontSize: 30, fontWeight: 'bold', color: '#172133', margin: 0, lineHeight: 1.3 }}&gt;数据库设计：15+ 张表承载整个社区&lt;/h2&gt;&#13;&#10;    &lt;div style={{ fontSize: 14, color: '#6b7075', marginTop: 6 }}&gt;数据库是系统地基，通过外键建立完整 ER 关系，覆盖社区到知识库的全部实体&lt;/div&gt;&#13;&#10;  &lt;/div&gt;&#13;&#10;  &lt;div style={{ flex: 1, display: 'flex', alignItems: 'center', minHeight: 0, gap: 28 }}&gt;&#13;&#10;    &lt;div style={{ flex: '0 0 320px', background: 'linear-gradient(135deg, #172133 0%, #22395E 100%)', borderRadius: 12, padding: '24px 24px', color: '#FBFCFA' }}&gt;&#13;&#10;      &lt;div style={{ color: '#BD9B56', fontSize: 12, letterSpacing: '0.25em', marginBottom: 12 }}&gt;CORE ENTITIES&lt;/div&gt;&#13;&#10;      &lt;div style={{ fontSize: 14, color: 'rgba(251,252,250,0.9)', lineHeight: 1.9 }}&gt;&#13;&#10;        community 社区&lt;br/&gt;&#13;&#10;        building 楼栋（8）&lt;br/&gt;&#13;&#10;        house 房屋（1664）&lt;br/&gt;&#13;&#10;        user 用户（275）&lt;br/&gt;&#13;&#10;        house_binding 房屋绑定&lt;br/&gt;&#13;&#10;        worker 物业人员（75）&lt;br/&gt;&#13;&#10;        repair_order 工单&lt;br/&gt;&#13;&#10;        fee_bill 账单（746）&lt;br/&gt;&#13;&#10;        notice 公告（24）&lt;br/&gt;&#13;&#10;        conversation / message&lt;br/&gt;&#13;&#10;        agent_trace 追踪&lt;br/&gt;&#13;&#10;        &lt;span style={{ color: '#BD9B56' }}&gt;knowledge_document / chunk&lt;/span&gt;&#13;&#10;      &lt;/div&gt;&#13;&#10;    &lt;/div&gt;&#13;&#10;    &lt;div style={{ flex: 1, background: '#fff', borderRadius: 12, padding: '20px 22px', boxShadow: '0 6px 24px rgba(23,33,51,0.08)' }}&gt;&#13;&#10;      &lt;svg width=&quot;560&quot; height=&quot;470&quot; viewBox=&quot;0 0 560 470&quot;&gt;&#13;&#10;        &lt;g fontFamily=&quot;Inter, sans-serif&quot;&gt;&#13;&#10;          &lt;rect x=&quot;14&quot; y=&quot;14&quot; width=&quot;150&quot; height=&quot;50&quot; rx=&quot;6&quot; fill=&quot;rgba(34,57,94,0.08)&quot; stroke=&quot;#22395E&quot; strokeWidth=&quot;1.5&quot; /&gt;&#13;&#10;          &lt;text x=&quot;89&quot; y=&quot;44&quot; textAnchor=&quot;middle&quot; fontSize=&quot;14&quot; fontWeight=&quot;bold&quot; fill=&quot;#172133&quot;&gt;community&lt;/text&gt;&#13;&#10;          &lt;line x1=&quot;164&quot; y1=&quot;39&quot; x2=&quot;206&quot; y2=&quot;39&quot; stroke=&quot;#BD9B56&quot; strokeWidth=&quot;1.5&quot; /&gt;&#13;&#10;          &lt;rect x=&quot;210&quot; y=&quot;14&quot; width=&quot;150&quot; height=&quot;50&quot; rx=&quot;6&quot; fill=&quot;rgba(34,57,94,0.08)&quot; stroke=&quot;#22395E&quot; strokeWidth=&quot;1.5&quot; /&gt;&#13;&#10;          &lt;text x=&quot;285&quot; y=&quot;44&quot; textAnchor=&quot;middle&quot; fontSize=&quot;14&quot; fontWeight=&quot;bold&quot; fill=&quot;#172133&quot;&gt;building ×8&lt;/text&gt;&#13;&#10;          &lt;line x1=&quot;360&quot; y1=&quot;39&quot; x2=&quot;402&quot; y2=&quot;39&quot; stroke=&quot;#BD9B56&quot; strokeWidth=&quot;1.5&quot; /&gt;&#13;&#10;          &lt;rect x=&quot;406&quot; y=&quot;14&quot; width=&quot;150&quot; height=&quot;50&quot; rx=&quot;6&quot; fill=&quot;rgba(34,57,94,0.08)&quot; stroke=&quot;#22395E&quot; strokeWidth=&quot;1.5&quot; /&gt;&#13;&#10;          &lt;text x=&quot;481&quot; y=&quot;44&quot; textAnchor=&quot;middle&quot; fontSize=&quot;14&quot; fontWeight=&quot;bold&quot; fill=&quot;#172133&quot;&gt;house ×1664&lt;/text&gt;&#13;&#10;          &lt;line x1=&quot;285&quot; y1=&quot;64&quot; x2=&quot;285&quot; y2=&quot;104&quot; stroke=&quot;#BD9B56&quot; strokeWidth=&quot;1.5&quot; /&gt;&#13;&#10;          &lt;rect x=&quot;210&quot; y=&quot;108&quot; width=&quot;150&quot; height=&quot;50&quot; rx=&quot;6&quot; fill=&quot;rgba(189,155,86,0.10)&quot; stroke=&quot;#BD9B56&quot; strokeWidth=&quot;1.5&quot; /&gt;&#13;&#10;          &lt;text x=&quot;285&quot; y=&quot;138&quot; textAnchor=&quot;middle&quot; fontSize=&quot;14&quot; fontWeight=&quot;bold&quot; fill=&quot;#172133&quot;&gt;user ×275&lt;/text&gt;&#13;&#10;          &lt;line x1=&quot;210&quot; y1=&quot;133&quot; x2=&quot;164&quot; y2=&quot;133&quot; stroke=&quot;#BD9B56&quot; strokeWidth=&quot;1.5&quot; /&gt;&#13;&#10;          &lt;rect x=&quot;14&quot; y=&quot;108&quot; width=&quot;150&quot; height=&quot;50&quot; rx=&quot;6&quot; fill=&quot;rgba(189,155,86,0.10)&quot; stroke=&quot;#BD9B56&quot; strokeWidth=&quot;1.5&quot; /&gt;&#13;&#10;          &lt;text x=&quot;89&quot; y=&quot;138&quot; textAnchor=&quot;middle&quot; fontSize=&quot;14&quot; fontWeight=&quot;bold&quot; fill=&quot;#172133&quot;&gt;house_binding&lt;/text&gt;&#13;&#10;          &lt;line x1=&quot;285&quot; y1=&quot;158&quot; x2=&quot;285&quot; y2=&quot;198&quot; stroke=&quot;#BD9B56&quot; strokeWidth=&quot;1.5&quot; /&gt;&#13;&#10;          &lt;rect x=&quot;210&quot; y=&quot;202&quot; width=&quot;150&quot; height=&quot;50&quot; rx=&quot;6&quot; fill=&quot;rgba(34,57,94,0.08)&quot; stroke=&quot;#22395E&quot; strokeWidth=&quot;1.5&quot; /&gt;&#13;&#10;          &lt;text x=&quot;285&quot; y=&quot;232&quot; textAnchor=&quot;middle&quot; fontSize=&quot;14&quot; fontWeight=&quot;bold&quot; fill=&quot;#172133&quot;&gt;worker ×75&lt;/text&gt;&#13;&#10;          &lt;line x1=&quot;285&quot; y1=&quot;252&quot; x2=&quot;285&quot; y2=&quot;292&quot; stroke=&quot;#BD9B56&quot; strokeWidth=&quot;1.5&quot; /&gt;&#13;&#10;          &lt;rect x=&quot;160&quot; y=&quot;296&quot; width=&quot;130&quot; height=&quot;50&quot; rx=&quot;6&quot; fill=&quot;rgba(34,57,94,0.08)&quot; stroke=&quot;#22395E&quot; strokeWidth=&quot;1.5&quot; /&gt;&#13;&#10;          &lt;text x=&quot;225&quot; y=&quot;326&quot; textAnchor=&quot;middle&quot; fontSize=&quot;13&quot; fontWeight=&quot;bold&quot; fill=&quot;#172133&quot;&gt;repair_order&lt;/text&gt;&#13;&#10;          &lt;rect x=&quot;306&quot; y=&quot;296&quot; width=&quot;130&quot; height=&quot;50&quot; rx=&quot;6&quot; fill=&quot;rgba(34,57,94,0.08)&quot; stroke=&quot;#22395E&quot; strokeWidth=&quot;1.5&quot; /&gt;&#13;&#10;          &lt;text x=&quot;371&quot; y=&quot;326&quot; textAnchor=&quot;middle&quot; fontSize=&quot;13&quot; fontWeight=&quot;bold&quot; fill=&quot;#172133&quot;&gt;fee_bill ×746&lt;/text&gt;&#13;&#10;          &lt;line x1=&quot;225&quot; y1=&quot;346&quot; x2=&quot;225&quot; y2=&quot;386&quot; stroke=&quot;#BD9B56&quot; strokeWidth=&quot;1.5&quot; /&gt;&#13;&#10;          &lt;rect x=&quot;160&quot; y=&quot;390&quot; width=&quot;130&quot; height=&quot;50&quot; rx=&quot;6&quot; fill=&quot;rgba(34,57,94,0.08)&quot; stroke=&quot;#22395E&quot; strokeWidth=&quot;1.5&quot; /&gt;&#13;&#10;          &lt;text x=&quot;225&quot; y=&quot;420&quot; textAnchor=&quot;middle&quot; fontSize=&quot;13&quot; fontWeight=&quot;bold&quot; fill=&quot;#172133&quot;&gt;notice ×24&lt;/text&gt;&#13;&#10;          &lt;rect x=&quot;306&quot; y=&quot;390&quot; width=&quot;130&quot; height=&quot;50&quot; rx=&quot;6&quot; fill=&quot;#172133&quot; stroke=&quot;#BD9B56&quot; strokeWidth=&quot;1.5&quot; /&gt;&#13;&#10;          &lt;text x=&quot;371&quot; y=&quot;416&quot; textAnchor=&quot;middle&quot; fontSize=&quot;12&quot; fontWeight=&quot;bold&quot; fill=&quot;#BD9B56&quot;&gt;knowledge&lt;/text&gt;&#13;&#10;          &lt;text x=&quot;371&quot; y=&quot;434&quot; textAnchor=&quot;middle&quot; fontSize=&quot;10&quot; fill=&quot;#FBFCFA&quot;&gt;document + chunk&lt;/text&gt;&#13;&#10;        &lt;/g&gt;&#13;&#10;      &lt;/svg&gt;&#13;&#10;    &lt;/div&gt;&#13;&#10;  &lt;/div&gt;&#13;&#10;  &lt;div style={{ flexShrink: 0, height: 40, display: 'flex', alignItems: 'flex-end', justifyContent: 'space-between' }}&gt;&#13;&#10;    &lt;span style={{ color: '#BD9B56', fontSize: 12, letterSpacing: '0.1em' }}&gt;云溪花园 · 智慧社区&lt;/span&gt;&#13;&#10;    &lt;span style={{ color: '#a09b8c', fontSize: 12 }}&gt;9 / 19&lt;/span&gt;&#13;&#10;  &lt;/div&gt;&#13;&#10;&lt;/Slide&gt;"/>
         <p:cNvGrpSpPr/>
         <p:nvPr/>
       </p:nvGrpSpPr>
@@ -19472,7 +20148,7 @@
       </p:grpSpPr>
       <p:sp>
         <p:nvSpPr>
-          <p:cNvPr id="424" name=""/>
+          <p:cNvPr id="448" name=""/>
           <p:cNvSpPr/>
           <p:nvPr/>
         </p:nvSpPr>
@@ -19496,7 +20172,7 @@
       </p:sp>
       <p:sp>
         <p:nvSpPr>
-          <p:cNvPr id="425" name="" descr="{&quot;isTemplate&quot;:true,&quot;type&quot;:&quot;text&quot;}"/>
+          <p:cNvPr id="449" name="" descr="{&quot;isTemplate&quot;:true,&quot;type&quot;:&quot;text&quot;}"/>
           <p:cNvSpPr txBox="1"/>
           <p:nvPr/>
         </p:nvSpPr>
@@ -19541,7 +20217,7 @@
       </p:sp>
       <p:sp>
         <p:nvSpPr>
-          <p:cNvPr id="426" name="" descr="{&quot;isTemplate&quot;:true,&quot;type&quot;:&quot;text&quot;}"/>
+          <p:cNvPr id="450" name="" descr="{&quot;isTemplate&quot;:true,&quot;type&quot;:&quot;text&quot;}"/>
           <p:cNvSpPr txBox="1"/>
           <p:nvPr/>
         </p:nvSpPr>
@@ -19596,7 +20272,7 @@
       </p:sp>
       <p:sp>
         <p:nvSpPr>
-          <p:cNvPr id="427" name="" descr="{&quot;isTemplate&quot;:true,&quot;type&quot;:&quot;text&quot;}"/>
+          <p:cNvPr id="451" name="" descr="{&quot;isTemplate&quot;:true,&quot;type&quot;:&quot;text&quot;}"/>
           <p:cNvSpPr txBox="1"/>
           <p:nvPr/>
         </p:nvSpPr>
@@ -19651,7 +20327,7 @@
       </p:sp>
       <p:sp>
         <p:nvSpPr>
-          <p:cNvPr id="428" name=""/>
+          <p:cNvPr id="452" name=""/>
           <p:cNvSpPr/>
           <p:nvPr/>
         </p:nvSpPr>
@@ -19685,7 +20361,7 @@
       </p:sp>
       <p:sp>
         <p:nvSpPr>
-          <p:cNvPr id="429" name="" descr="{&quot;isTemplate&quot;:true,&quot;type&quot;:&quot;text&quot;}"/>
+          <p:cNvPr id="453" name="" descr="{&quot;isTemplate&quot;:true,&quot;type&quot;:&quot;text&quot;}"/>
           <p:cNvSpPr txBox="1"/>
           <p:nvPr/>
         </p:nvSpPr>
@@ -19720,7 +20396,7 @@
       </p:sp>
       <p:sp>
         <p:nvSpPr>
-          <p:cNvPr id="430" name="" descr="{&quot;isTemplate&quot;:true,&quot;type&quot;:&quot;text&quot;}"/>
+          <p:cNvPr id="454" name="" descr="{&quot;isTemplate&quot;:true,&quot;type&quot;:&quot;text&quot;}"/>
           <p:cNvSpPr txBox="1"/>
           <p:nvPr/>
         </p:nvSpPr>
@@ -19741,7 +20417,7 @@
       </p:sp>
       <p:sp>
         <p:nvSpPr>
-          <p:cNvPr id="431" name="" descr="{&quot;isTemplate&quot;:true,&quot;type&quot;:&quot;text&quot;}"/>
+          <p:cNvPr id="455" name="" descr="{&quot;isTemplate&quot;:true,&quot;type&quot;:&quot;text&quot;}"/>
           <p:cNvSpPr txBox="1"/>
           <p:nvPr/>
         </p:nvSpPr>
@@ -19762,7 +20438,7 @@
       </p:sp>
       <p:sp>
         <p:nvSpPr>
-          <p:cNvPr id="432" name="" descr="{&quot;isTemplate&quot;:true,&quot;type&quot;:&quot;text&quot;}"/>
+          <p:cNvPr id="456" name="" descr="{&quot;isTemplate&quot;:true,&quot;type&quot;:&quot;text&quot;}"/>
           <p:cNvSpPr txBox="1"/>
           <p:nvPr/>
         </p:nvSpPr>
@@ -19783,7 +20459,7 @@
       </p:sp>
       <p:sp>
         <p:nvSpPr>
-          <p:cNvPr id="433" name="" descr="{&quot;isTemplate&quot;:true,&quot;type&quot;:&quot;text&quot;}"/>
+          <p:cNvPr id="457" name="" descr="{&quot;isTemplate&quot;:true,&quot;type&quot;:&quot;text&quot;}"/>
           <p:cNvSpPr txBox="1"/>
           <p:nvPr/>
         </p:nvSpPr>
@@ -19804,7 +20480,7 @@
       </p:sp>
       <p:sp>
         <p:nvSpPr>
-          <p:cNvPr id="434" name="" descr="{&quot;isTemplate&quot;:true,&quot;type&quot;:&quot;text&quot;}"/>
+          <p:cNvPr id="458" name="" descr="{&quot;isTemplate&quot;:true,&quot;type&quot;:&quot;text&quot;}"/>
           <p:cNvSpPr txBox="1"/>
           <p:nvPr/>
         </p:nvSpPr>
@@ -19825,7 +20501,7 @@
       </p:sp>
       <p:sp>
         <p:nvSpPr>
-          <p:cNvPr id="435" name="" descr="{&quot;isTemplate&quot;:true,&quot;type&quot;:&quot;text&quot;}"/>
+          <p:cNvPr id="459" name="" descr="{&quot;isTemplate&quot;:true,&quot;type&quot;:&quot;text&quot;}"/>
           <p:cNvSpPr txBox="1"/>
           <p:nvPr/>
         </p:nvSpPr>
@@ -19846,7 +20522,7 @@
       </p:sp>
       <p:sp>
         <p:nvSpPr>
-          <p:cNvPr id="436" name="" descr="{&quot;isTemplate&quot;:true,&quot;type&quot;:&quot;text&quot;}"/>
+          <p:cNvPr id="460" name="" descr="{&quot;isTemplate&quot;:true,&quot;type&quot;:&quot;text&quot;}"/>
           <p:cNvSpPr txBox="1"/>
           <p:nvPr/>
         </p:nvSpPr>
@@ -19867,7 +20543,7 @@
       </p:sp>
       <p:sp>
         <p:nvSpPr>
-          <p:cNvPr id="437" name="" descr="{&quot;isTemplate&quot;:true,&quot;type&quot;:&quot;text&quot;}"/>
+          <p:cNvPr id="461" name="" descr="{&quot;isTemplate&quot;:true,&quot;type&quot;:&quot;text&quot;}"/>
           <p:cNvSpPr txBox="1"/>
           <p:nvPr/>
         </p:nvSpPr>
@@ -19888,7 +20564,7 @@
       </p:sp>
       <p:sp>
         <p:nvSpPr>
-          <p:cNvPr id="438" name="" descr="{&quot;isTemplate&quot;:true,&quot;type&quot;:&quot;text&quot;}"/>
+          <p:cNvPr id="462" name="" descr="{&quot;isTemplate&quot;:true,&quot;type&quot;:&quot;text&quot;}"/>
           <p:cNvSpPr txBox="1"/>
           <p:nvPr/>
         </p:nvSpPr>
@@ -19909,7 +20585,7 @@
       </p:sp>
       <p:sp>
         <p:nvSpPr>
-          <p:cNvPr id="439" name="" descr="{&quot;isTemplate&quot;:true,&quot;type&quot;:&quot;text&quot;}"/>
+          <p:cNvPr id="463" name="" descr="{&quot;isTemplate&quot;:true,&quot;type&quot;:&quot;text&quot;}"/>
           <p:cNvSpPr txBox="1"/>
           <p:nvPr/>
         </p:nvSpPr>
@@ -19930,7 +20606,7 @@
       </p:sp>
       <p:sp>
         <p:nvSpPr>
-          <p:cNvPr id="440" name="" descr="{&quot;isTemplate&quot;:true,&quot;type&quot;:&quot;text&quot;}"/>
+          <p:cNvPr id="464" name="" descr="{&quot;isTemplate&quot;:true,&quot;type&quot;:&quot;text&quot;}"/>
           <p:cNvSpPr txBox="1"/>
           <p:nvPr/>
         </p:nvSpPr>
@@ -19951,7 +20627,7 @@
       </p:sp>
       <p:sp>
         <p:nvSpPr>
-          <p:cNvPr id="441" name="" descr="{&quot;isTemplate&quot;:true,&quot;type&quot;:&quot;text&quot;}"/>
+          <p:cNvPr id="465" name="" descr="{&quot;isTemplate&quot;:true,&quot;type&quot;:&quot;text&quot;}"/>
           <p:cNvSpPr txBox="1"/>
           <p:nvPr/>
         </p:nvSpPr>
@@ -19986,7 +20662,7 @@
       </p:sp>
       <p:sp>
         <p:nvSpPr>
-          <p:cNvPr id="442" name=""/>
+          <p:cNvPr id="466" name=""/>
           <p:cNvSpPr/>
           <p:nvPr/>
         </p:nvSpPr>
@@ -20019,7 +20695,7 @@
       </p:sp>
       <p:pic>
         <p:nvPicPr>
-          <p:cNvPr id="443" name=""/>
+          <p:cNvPr id="467" name=""/>
           <p:cNvPicPr>
             <a:picLocks noChangeAspect="1"/>
           </p:cNvPicPr>
@@ -20050,7 +20726,7 @@
       </p:pic>
       <p:sp>
         <p:nvSpPr>
-          <p:cNvPr id="444" name="" descr="{&quot;isTemplate&quot;:true,&quot;type&quot;:&quot;text&quot;}"/>
+          <p:cNvPr id="468" name="" descr="{&quot;isTemplate&quot;:true,&quot;type&quot;:&quot;text&quot;}"/>
           <p:cNvSpPr txBox="1"/>
           <p:nvPr/>
         </p:nvSpPr>
@@ -20105,7 +20781,7 @@
       </p:sp>
       <p:sp>
         <p:nvSpPr>
-          <p:cNvPr id="445" name="" descr="{&quot;isTemplate&quot;:true,&quot;type&quot;:&quot;text&quot;}"/>
+          <p:cNvPr id="469" name="" descr="{&quot;isTemplate&quot;:true,&quot;type&quot;:&quot;text&quot;}"/>
           <p:cNvSpPr txBox="1"/>
           <p:nvPr/>
         </p:nvSpPr>

</xml_diff>